<commit_message>
Diapositivas para la rubrica de 20 minutos (21), con capturas del tablero en oro
</commit_message>
<xml_diff>
--- a/presentacion/sustentacion_otif.pptx
+++ b/presentacion/sustentacion_otif.pptx
@@ -15106,7 +15106,7 @@
         <p:spPr>
           <a:xfrm>
             <a:off x="468000" y="1296000"/>
-            <a:ext cx="4104000" cy="2565000"/>
+            <a:ext cx="3888000" cy="2430000"/>
           </a:xfrm>
           <a:prstGeom prst="rect">
             <a:avLst/>
@@ -15122,7 +15122,7 @@
         <p:spPr>
           <a:xfrm>
             <a:off x="468000" y="1116000"/>
-            <a:ext cx="4104000" cy="162000"/>
+            <a:ext cx="3888000" cy="162000"/>
           </a:xfrm>
           <a:prstGeom prst="rect">
             <a:avLst/>

</xml_diff>

<commit_message>
Diapositiva 17 y guia de sustentacion con DeLong, Cliff y BCa de las 112
</commit_message>
<xml_diff>
--- a/presentacion/sustentacion_otif.pptx
+++ b/presentacion/sustentacion_otif.pptx
@@ -1082,7 +1082,7 @@
           <a:lstStyle/>
           <a:p>
             <a:r>
-              <a:t>[1:00 · criterio 5 · expone A] En vivo: la predicción la sirve hoy el modelo base (logística), con sus contribuciones. Pruebas: Friedman rechaza la igualdad; Nemenyi es conservador con 8 bloques; el Wilcoxon pareado con Holm separa porque XGBoost gana en cada bloque.</a:t>
+              <a:t>[1:00 · criterio 5 · expone A] En vivo: la predicción la sirve hoy el modelo base (logística), con sus contribuciones. Pruebas: Friedman rechaza la igualdad; Nemenyi es conservador con 8 bloques; el Wilcoxon pareado con Holm separa porque XGBoost gana en cada bloque. DeLong mira dentro de cada bloque (validado contra pROC); como supone filas independientes, se lee con el BCa que remuestrea órdenes. Cliff con el bosque: pequeño (0,25).</a:t>
             </a:r>
           </a:p>
         </p:txBody>
@@ -15251,8 +15251,8 @@
         </p:blipFill>
         <p:spPr>
           <a:xfrm>
-            <a:off x="4824000" y="1152000"/>
-            <a:ext cx="3888000" cy="2471054"/>
+            <a:off x="4896000" y="972000"/>
+            <a:ext cx="3744000" cy="2379533"/>
           </a:xfrm>
           <a:prstGeom prst="rect">
             <a:avLst/>
@@ -15267,8 +15267,8 @@
         </p:nvSpPr>
         <p:spPr>
           <a:xfrm>
-            <a:off x="4824000" y="3816000"/>
-            <a:ext cx="3888000" cy="936000"/>
+            <a:off x="4824000" y="3564000"/>
+            <a:ext cx="3888000" cy="1224000"/>
           </a:xfrm>
           <a:prstGeom prst="rect">
             <a:avLst/>
@@ -15283,11 +15283,11 @@
           <a:p>
             <a:pPr algn="l">
               <a:spcAft>
-                <a:spcPts val="400"/>
+                <a:spcPts val="300"/>
               </a:spcAft>
             </a:pPr>
             <a:r>
-              <a:rPr sz="1050" b="1">
+              <a:rPr sz="1000" b="1">
                 <a:solidFill>
                   <a:srgbClr val="1A1A1A"/>
                 </a:solidFill>
@@ -15299,17 +15299,33 @@
           <a:p>
             <a:pPr algn="l">
               <a:spcAft>
-                <a:spcPts val="400"/>
+                <a:spcPts val="300"/>
               </a:spcAft>
             </a:pPr>
             <a:r>
-              <a:rPr sz="1050" b="0">
+              <a:rPr sz="1000" b="0">
                 <a:solidFill>
                   <a:srgbClr val="1A1A1A"/>
                 </a:solidFill>
                 <a:latin typeface="Calibri"/>
               </a:rPr>
               <a:t>Nemenyi no separa a XGBoost de la logística ni del bosque (diferencia crítica 3,19); Wilcoxon por pares sí: gana los 8 bloques, p de Holm = 0,047.</a:t>
+            </a:r>
+          </a:p>
+          <a:p>
+            <a:pPr algn="l">
+              <a:spcAft>
+                <a:spcPts val="300"/>
+              </a:spcAft>
+            </a:pPr>
+            <a:r>
+              <a:rPr sz="1000" b="0">
+                <a:solidFill>
+                  <a:srgbClr val="1A1A1A"/>
+                </a:solidFill>
+                <a:latin typeface="Calibri"/>
+              </a:rPr>
+              <a:t>Dentro de cada bloque, DeLong con Holm: supera al bosque en 6 de 8 y a la logística en 7, sin perder en ninguno. Ventaja 0,009-0,012 de AUC, con BCa por órdenes lejos de cero.</a:t>
             </a:r>
           </a:p>
         </p:txBody>
@@ -15388,7 +15404,7 @@
                 </a:solidFill>
                 <a:latin typeface="Calibri"/>
               </a:rPr>
-              <a:t>Fuente: tablero, página Modelos; data/modelos/friedman.csv, wilcoxon.csv, rangos.csv</a:t>
+              <a:t>Fuente: tablero, página Modelos; data/modelos/friedman.csv, wilcoxon.csv; resultados/pruebas/resumen.csv</a:t>
             </a:r>
           </a:p>
         </p:txBody>

</xml_diff>

<commit_message>
Mejor modelo en 2026 (XGBoost con Platt, servido en el tablero, SHAP), por que XGBoost y no la logistica, modelo original y 2x2, semillas, convergencia y calibracion en validacion
</commit_message>
<xml_diff>
--- a/presentacion/sustentacion_otif.pptx
+++ b/presentacion/sustentacion_otif.pptx
@@ -26,6 +26,7 @@
     <p:sldId id="274" r:id="rId26"/>
     <p:sldId id="275" r:id="rId27"/>
     <p:sldId id="276" r:id="rId28"/>
+    <p:sldId id="277" r:id="rId29"/>
   </p:sldIdLst>
   <p:sldSz cx="9144000" cy="5144400" type="screen4x3"/>
   <p:notesSz cx="6858000" cy="9144000"/>
@@ -802,7 +803,7 @@
           <a:lstStyle/>
           <a:p>
             <a:r>
-              <a:t>[1:00 · criterio 4 · expone B] Validación anidada: el externo mide, el interno elige. Mismo presupuesto para comparar optimizadores de forma justa. La prueba 2026 se mira una vez, al final.</a:t>
+              <a:t>[0:45 · criterio 4 · expone B] Validación anidada: el externo mide, el interno elige. Mismo presupuesto para comparar optimizadores de forma justa. La prueba 2026 se mira una vez, al final.</a:t>
             </a:r>
           </a:p>
         </p:txBody>
@@ -872,7 +873,7 @@
           <a:lstStyle/>
           <a:p>
             <a:r>
-              <a:t>[1:00 · criterio 4 · expone B] Por qué ese espacio: rangos usuales de la literatura, escala logarítmica donde el efecto es multiplicativo (tasa, peso mínimo). Decisiones computacionales: matrices preprocesadas en disco, SMOTE calculado una vez por ventana.</a:t>
+              <a:t>[0:45 · criterio 4 · expone B] Por qué ese espacio: rangos usuales de la literatura, escala logarítmica donde el efecto es multiplicativo (tasa, peso mínimo). Decisiones computacionales: matrices preprocesadas en disco, SMOTE calculado una vez por ventana.</a:t>
             </a:r>
           </a:p>
         </p:txBody>
@@ -942,7 +943,7 @@
           <a:lstStyle/>
           <a:p>
             <a:r>
-              <a:t>[1:00 · criterio 4 · expone A] Optuna (TPE) aprende de los ensayos y propone donde la mejora esperada es mayor; DEAP llega tarde pero llega. Con poco presupuesto conviene Optuna; con 20 la superficie es plana.</a:t>
+              <a:t>[0:45 · criterio 4 · expone A] Optuna (TPE) aprende de los ensayos y propone donde la mejora esperada es mayor; DEAP llega tarde pero llega. Con poco presupuesto conviene Optuna; con 20 la superficie es plana.</a:t>
             </a:r>
           </a:p>
         </p:txBody>
@@ -1012,7 +1013,7 @@
           <a:lstStyle/>
           <a:p>
             <a:r>
-              <a:t>[1:00 · criterio 5 · expone B] Por qué cada métrica. La ganancia de XGBoost es de una centésima de AUC frente al bosque y la logística: real pero pequeña. La comparación en 2026 llega con la evaluación final.</a:t>
+              <a:t>[1:00 · criterio 5 · expone B] Por qué cada métrica. En los bloques la ganancia es de una centésima frente al bosque y la logística. En 2026, medido una vez con lo congelado en 2025, XGBoost da 0,848 y le saca 0,023 a la logística. La brecha no muestra caída de la validación a la prueba.</a:t>
             </a:r>
           </a:p>
         </p:txBody>
@@ -1082,7 +1083,7 @@
           <a:lstStyle/>
           <a:p>
             <a:r>
-              <a:t>[1:00 · criterio 5 · expone A] En vivo: la predicción la sirve hoy el modelo base (logística), con sus contribuciones. Pruebas: Friedman rechaza la igualdad; Nemenyi es conservador con 8 bloques; el Wilcoxon pareado con Holm separa porque XGBoost gana en cada bloque. DeLong mira dentro de cada bloque (validado contra pROC); como supone filas independientes, se lee con el BCa que remuestrea órdenes. Cliff con el bosque: pequeño (0,25).</a:t>
+              <a:t>[1:00 · criterio 5 · expone A] En vivo: la predicción la sirve XGBoost con Platt, con sus contribuciones SHAP exactas. Pruebas: Friedman rechaza la igualdad; Nemenyi es conservador con 8 bloques; el Wilcoxon pareado con Holm separa porque XGBoost gana en cada bloque. DeLong mira dentro de cada bloque (validado contra pROC); como supone filas independientes, se lee con el BCa que remuestrea órdenes. Cliff con el bosque: pequeño (0,25).</a:t>
             </a:r>
           </a:p>
         </p:txBody>
@@ -1152,7 +1153,7 @@
           <a:lstStyle/>
           <a:p>
             <a:r>
-              <a:t>[1:00 · criterio 5 · expone B] Sobreajuste en dos vistas: interno contra externo por bloque y la curva de aprendizaje. Lo que falta del análisis de errores depende de la evaluación final en 2026; no se adelanta.</a:t>
+              <a:t>[0:45 · criterio 5 · expone B] Sobreajuste en dos vistas: interno contra externo por bloque y la curva de aprendizaje. En 2026, el error se concentra en las órdenes con entidades nuevas y en ganadería; el falso negativo típico no se podía ver al liberar.</a:t>
             </a:r>
           </a:p>
         </p:txBody>
@@ -1222,7 +1223,7 @@
           <a:lstStyle/>
           <a:p>
             <a:r>
-              <a:t>[1:00 · criterio 6 · expone A] Responder la pregunta con cifras y el veredicto de cada objetivo, sin adelantar lo que depende de 2026.</a:t>
+              <a:t>[1:00 · criterio 5 · expone A] Cinco razones con cifras. Si el negocio pusiera explicar cada coeficiente por encima de atrapar tardías, la logística sería defendible: pierde 0,023 de AUC y unas 35 tardías por mes. Precisión: las tardías de más caen en órdenes que ya tenían otra alerta.</a:t>
             </a:r>
           </a:p>
         </p:txBody>
@@ -1362,7 +1363,7 @@
           <a:lstStyle/>
           <a:p>
             <a:r>
-              <a:t>[1:00 · criterio 6 · expone B] Separar lo teórico (supuestos del modelo) de lo empírico (los datos). Las mejoras apuntan al modelo original.</a:t>
+              <a:t>[1:00 · criterio 6 · expone A] Responder la pregunta con cifras y el veredicto de cada objetivo. La propuesta del Entregable 3 le gana a XGBoost por 0,012 en 2026; se presenta aparte.</a:t>
             </a:r>
           </a:p>
         </p:txBody>
@@ -1388,6 +1389,76 @@
 </file>
 
 <file path=ppt/notesSlides/notesSlide21.xml><?xml version="1.0" encoding="utf-8"?>
+<p:notes xmlns:a="http://schemas.openxmlformats.org/drawingml/2006/main" xmlns:p="http://schemas.openxmlformats.org/presentationml/2006/main" xmlns:r="http://schemas.openxmlformats.org/officeDocument/2006/relationships">
+  <p:cSld>
+    <p:spTree>
+      <p:nvGrpSpPr>
+        <p:cNvPr id="1" name=""/>
+        <p:cNvGrpSpPr/>
+        <p:nvPr/>
+      </p:nvGrpSpPr>
+      <p:grpSpPr>
+        <a:xfrm>
+          <a:off x="0" y="0"/>
+          <a:ext cx="0" cy="0"/>
+          <a:chOff x="0" y="0"/>
+          <a:chExt cx="0" cy="0"/>
+        </a:xfrm>
+      </p:grpSpPr>
+      <p:sp>
+        <p:nvSpPr>
+          <p:cNvPr id="2" name="Slide Image Placeholder 1"/>
+          <p:cNvSpPr>
+            <a:spLocks noGrp="1"/>
+          </p:cNvSpPr>
+          <p:nvPr>
+            <p:ph type="sldImg" idx="2"/>
+          </p:nvPr>
+        </p:nvSpPr>
+        <p:spPr/>
+      </p:sp>
+      <p:sp>
+        <p:nvSpPr>
+          <p:cNvPr id="3" name="Notes Placeholder 2"/>
+          <p:cNvSpPr>
+            <a:spLocks noGrp="1"/>
+          </p:cNvSpPr>
+          <p:nvPr>
+            <p:ph type="body" idx="3" sz="quarter"/>
+          </p:nvPr>
+        </p:nvSpPr>
+        <p:spPr/>
+        <p:txBody>
+          <a:bodyPr/>
+          <a:lstStyle/>
+          <a:p>
+            <a:r>
+              <a:t>[1:00 · criterio 6 · expone B] Separar lo teórico (supuestos del modelo) de lo empírico (los datos). Las mejoras apuntan al modelo original.</a:t>
+            </a:r>
+          </a:p>
+        </p:txBody>
+      </p:sp>
+      <p:sp>
+        <p:nvSpPr>
+          <p:cNvPr id="4" name="Slide Number Placeholder 3"/>
+          <p:cNvSpPr>
+            <a:spLocks noGrp="1"/>
+          </p:cNvSpPr>
+          <p:nvPr>
+            <p:ph type="sldNum" idx="5" sz="quarter"/>
+          </p:nvPr>
+        </p:nvSpPr>
+        <p:spPr/>
+      </p:sp>
+    </p:spTree>
+  </p:cSld>
+  <p:clrMapOvr>
+    <a:masterClrMapping/>
+  </p:clrMapOvr>
+</p:notes>
+</file>
+
+<file path=ppt/notesSlides/notesSlide22.xml><?xml version="1.0" encoding="utf-8"?>
 <p:notes xmlns:a="http://schemas.openxmlformats.org/drawingml/2006/main" xmlns:p="http://schemas.openxmlformats.org/presentationml/2006/main" xmlns:r="http://schemas.openxmlformats.org/officeDocument/2006/relationships">
   <p:cSld>
     <p:spTree>
@@ -6326,7 +6397,7 @@
                 </a:solidFill>
                 <a:latin typeface="Calibri"/>
               </a:rPr>
-              <a:t>10 / 20</a:t>
+              <a:t>10 / 21</a:t>
             </a:r>
           </a:p>
         </p:txBody>
@@ -7149,7 +7220,7 @@
                 </a:solidFill>
                 <a:latin typeface="Calibri"/>
               </a:rPr>
-              <a:t>11 / 20</a:t>
+              <a:t>11 / 21</a:t>
             </a:r>
           </a:p>
         </p:txBody>
@@ -8449,7 +8520,7 @@
                 </a:solidFill>
                 <a:latin typeface="Calibri"/>
               </a:rPr>
-              <a:t>12 / 20</a:t>
+              <a:t>12 / 21</a:t>
             </a:r>
           </a:p>
         </p:txBody>
@@ -10534,7 +10605,7 @@
                 </a:solidFill>
                 <a:latin typeface="Calibri"/>
               </a:rPr>
-              <a:t>13 / 20</a:t>
+              <a:t>13 / 21</a:t>
             </a:r>
           </a:p>
         </p:txBody>
@@ -11830,7 +11901,7 @@
                 </a:solidFill>
                 <a:latin typeface="Calibri"/>
               </a:rPr>
-              <a:t>14 / 20</a:t>
+              <a:t>14 / 21</a:t>
             </a:r>
           </a:p>
         </p:txBody>
@@ -12831,7 +12902,7 @@
                 </a:solidFill>
                 <a:latin typeface="Calibri"/>
               </a:rPr>
-              <a:t>15 / 20</a:t>
+              <a:t>15 / 21</a:t>
             </a:r>
           </a:p>
         </p:txBody>
@@ -14105,8 +14176,8 @@
         </p:nvSpPr>
         <p:spPr>
           <a:xfrm>
-            <a:off x="468000" y="3384000"/>
-            <a:ext cx="4896000" cy="396000"/>
+            <a:off x="468000" y="3311999"/>
+            <a:ext cx="4896000" cy="360000"/>
           </a:xfrm>
           <a:prstGeom prst="rect">
             <a:avLst/>
@@ -14121,7 +14192,7 @@
           <a:p>
             <a:pPr algn="l"/>
             <a:r>
-              <a:rPr sz="1000" b="0">
+              <a:rPr sz="950" b="0">
                 <a:solidFill>
                   <a:srgbClr val="5A5A5A"/>
                 </a:solidFill>
@@ -14141,8 +14212,8 @@
           <p:nvPr/>
         </p:nvGraphicFramePr>
         <p:xfrm>
-          <a:off x="468000" y="3816000"/>
-          <a:ext cx="4895997" cy="900000"/>
+          <a:off x="468000" y="3671999"/>
+          <a:ext cx="4895998" cy="1080000"/>
         </p:xfrm>
         <a:graphic>
           <a:graphicData uri="http://schemas.openxmlformats.org/drawingml/2006/table">
@@ -14151,12 +14222,12 @@
                 <a:tableStyleId>{5C22544A-7EE6-4342-B048-85BDC9FD1C3A}</a:tableStyleId>
               </a:tblPr>
               <a:tblGrid>
-                <a:gridCol w="2363586"/>
-                <a:gridCol w="844137"/>
-                <a:gridCol w="844137"/>
-                <a:gridCol w="844137"/>
+                <a:gridCol w="2006557"/>
+                <a:gridCol w="1444721"/>
+                <a:gridCol w="722360"/>
+                <a:gridCol w="722360"/>
               </a:tblGrid>
-              <a:tr h="300000">
+              <a:tr h="270000">
                 <a:tc>
                   <a:txBody>
                     <a:bodyPr wrap="square"/>
@@ -14170,7 +14241,7 @@
                           </a:solidFill>
                           <a:latin typeface="Calibri"/>
                         </a:rPr>
-                        <a:t>prueba 2026 (línea base)</a:t>
+                        <a:t>prueba 2026</a:t>
                       </a:r>
                     </a:p>
                   </a:txBody>
@@ -14193,7 +14264,7 @@
                           </a:solidFill>
                           <a:latin typeface="Calibri"/>
                         </a:rPr>
-                        <a:t>AUC</a:t>
+                        <a:t>AUC [BCa 95 %]</a:t>
                       </a:r>
                     </a:p>
                   </a:txBody>
@@ -14239,7 +14310,7 @@
                           </a:solidFill>
                           <a:latin typeface="Calibri"/>
                         </a:rPr>
-                        <a:t>Brier</a:t>
+                        <a:t>ECE</a:t>
                       </a:r>
                     </a:p>
                   </a:txBody>
@@ -14250,7 +14321,7 @@
                   </a:tcPr>
                 </a:tc>
               </a:tr>
-              <a:tr h="300000">
+              <a:tr h="270000">
                 <a:tc>
                   <a:txBody>
                     <a:bodyPr wrap="square"/>
@@ -14258,7 +14329,7 @@
                     <a:p>
                       <a:pPr algn="l"/>
                       <a:r>
-                        <a:rPr sz="1000" b="1">
+                        <a:rPr sz="950" b="1">
                           <a:solidFill>
                             <a:srgbClr val="1A1A1A"/>
                           </a:solidFill>
@@ -14281,7 +14352,7 @@
                     <a:p>
                       <a:pPr algn="ctr"/>
                       <a:r>
-                        <a:rPr sz="1000" b="0">
+                        <a:rPr sz="950" b="0">
                           <a:solidFill>
                             <a:srgbClr val="1A1A1A"/>
                           </a:solidFill>
@@ -14304,7 +14375,7 @@
                     <a:p>
                       <a:pPr algn="ctr"/>
                       <a:r>
-                        <a:rPr sz="1000" b="0">
+                        <a:rPr sz="950" b="0">
                           <a:solidFill>
                             <a:srgbClr val="1A1A1A"/>
                           </a:solidFill>
@@ -14327,13 +14398,13 @@
                     <a:p>
                       <a:pPr algn="ctr"/>
                       <a:r>
-                        <a:rPr sz="1000" b="0">
+                        <a:rPr sz="950" b="0">
                           <a:solidFill>
                             <a:srgbClr val="1A1A1A"/>
                           </a:solidFill>
                           <a:latin typeface="Calibri"/>
                         </a:rPr>
-                        <a:t>0,202</a:t>
+                        <a:t>0,055</a:t>
                       </a:r>
                     </a:p>
                   </a:txBody>
@@ -14344,7 +14415,7 @@
                   </a:tcPr>
                 </a:tc>
               </a:tr>
-              <a:tr h="300000">
+              <a:tr h="270000">
                 <a:tc>
                   <a:txBody>
                     <a:bodyPr wrap="square"/>
@@ -14352,7 +14423,7 @@
                     <a:p>
                       <a:pPr algn="l"/>
                       <a:r>
-                        <a:rPr sz="1000" b="1">
+                        <a:rPr sz="950" b="1">
                           <a:solidFill>
                             <a:srgbClr val="1A1A1A"/>
                           </a:solidFill>
@@ -14375,7 +14446,7 @@
                     <a:p>
                       <a:pPr algn="ctr"/>
                       <a:r>
-                        <a:rPr sz="1000" b="0">
+                        <a:rPr sz="950" b="0">
                           <a:solidFill>
                             <a:srgbClr val="1A1A1A"/>
                           </a:solidFill>
@@ -14398,7 +14469,7 @@
                     <a:p>
                       <a:pPr algn="ctr"/>
                       <a:r>
-                        <a:rPr sz="1000" b="0">
+                        <a:rPr sz="950" b="0">
                           <a:solidFill>
                             <a:srgbClr val="1A1A1A"/>
                           </a:solidFill>
@@ -14421,13 +14492,13 @@
                     <a:p>
                       <a:pPr algn="ctr"/>
                       <a:r>
-                        <a:rPr sz="1000" b="0">
+                        <a:rPr sz="950" b="0">
                           <a:solidFill>
                             <a:srgbClr val="1A1A1A"/>
                           </a:solidFill>
                           <a:latin typeface="Calibri"/>
                         </a:rPr>
-                        <a:t>0,149</a:t>
+                        <a:t>0,021</a:t>
                       </a:r>
                     </a:p>
                   </a:txBody>
@@ -14438,6 +14509,100 @@
                   </a:tcPr>
                 </a:tc>
               </a:tr>
+              <a:tr h="270000">
+                <a:tc>
+                  <a:txBody>
+                    <a:bodyPr wrap="square"/>
+                    <a:lstStyle/>
+                    <a:p>
+                      <a:pPr algn="l"/>
+                      <a:r>
+                        <a:rPr sz="950" b="1">
+                          <a:solidFill>
+                            <a:srgbClr val="1A1A1A"/>
+                          </a:solidFill>
+                          <a:latin typeface="Calibri"/>
+                        </a:rPr>
+                        <a:t>XGBoost, con Platt</a:t>
+                      </a:r>
+                    </a:p>
+                  </a:txBody>
+                  <a:tcPr marL="57600" marR="57600" marT="14400" marB="14400" anchor="ctr">
+                    <a:solidFill>
+                      <a:srgbClr val="FFFFFF"/>
+                    </a:solidFill>
+                  </a:tcPr>
+                </a:tc>
+                <a:tc>
+                  <a:txBody>
+                    <a:bodyPr wrap="square"/>
+                    <a:lstStyle/>
+                    <a:p>
+                      <a:pPr algn="ctr"/>
+                      <a:r>
+                        <a:rPr sz="950" b="0">
+                          <a:solidFill>
+                            <a:srgbClr val="1A1A1A"/>
+                          </a:solidFill>
+                          <a:latin typeface="Calibri"/>
+                        </a:rPr>
+                        <a:t>0,848 [0,835; 0,860]</a:t>
+                      </a:r>
+                    </a:p>
+                  </a:txBody>
+                  <a:tcPr marL="57600" marR="57600" marT="14400" marB="14400" anchor="ctr">
+                    <a:solidFill>
+                      <a:srgbClr val="FFFFFF"/>
+                    </a:solidFill>
+                  </a:tcPr>
+                </a:tc>
+                <a:tc>
+                  <a:txBody>
+                    <a:bodyPr wrap="square"/>
+                    <a:lstStyle/>
+                    <a:p>
+                      <a:pPr algn="ctr"/>
+                      <a:r>
+                        <a:rPr sz="950" b="0">
+                          <a:solidFill>
+                            <a:srgbClr val="1A1A1A"/>
+                          </a:solidFill>
+                          <a:latin typeface="Calibri"/>
+                        </a:rPr>
+                        <a:t>0,675</a:t>
+                      </a:r>
+                    </a:p>
+                  </a:txBody>
+                  <a:tcPr marL="57600" marR="57600" marT="14400" marB="14400" anchor="ctr">
+                    <a:solidFill>
+                      <a:srgbClr val="FFFFFF"/>
+                    </a:solidFill>
+                  </a:tcPr>
+                </a:tc>
+                <a:tc>
+                  <a:txBody>
+                    <a:bodyPr wrap="square"/>
+                    <a:lstStyle/>
+                    <a:p>
+                      <a:pPr algn="ctr"/>
+                      <a:r>
+                        <a:rPr sz="950" b="0">
+                          <a:solidFill>
+                            <a:srgbClr val="1A1A1A"/>
+                          </a:solidFill>
+                          <a:latin typeface="Calibri"/>
+                        </a:rPr>
+                        <a:t>0,022</a:t>
+                      </a:r>
+                    </a:p>
+                  </a:txBody>
+                  <a:tcPr marL="57600" marR="57600" marT="14400" marB="14400" anchor="ctr">
+                    <a:solidFill>
+                      <a:srgbClr val="FFFFFF"/>
+                    </a:solidFill>
+                  </a:tcPr>
+                </a:tc>
+              </a:tr>
             </a:tbl>
           </a:graphicData>
         </a:graphic>
@@ -14595,7 +14760,7 @@
             <a:avLst/>
           </a:prstGeom>
           <a:solidFill>
-            <a:srgbClr val="ECECEC"/>
+            <a:srgbClr val="E8F0EB"/>
           </a:solidFill>
           <a:ln>
             <a:noFill/>
@@ -14632,8 +14797,8 @@
         </p:nvSpPr>
         <p:spPr>
           <a:xfrm>
-            <a:off x="5760000" y="3834000"/>
-            <a:ext cx="2808000" cy="828000"/>
+            <a:off x="5778000" y="3852000"/>
+            <a:ext cx="2771999" cy="288000"/>
           </a:xfrm>
           <a:prstGeom prst="rect">
             <a:avLst/>
@@ -14646,42 +14811,57 @@
           </a:bodyPr>
           <a:lstStyle/>
           <a:p>
-            <a:pPr algn="l">
-              <a:spcAft>
-                <a:spcPts val="300"/>
-              </a:spcAft>
-            </a:pPr>
-            <a:r>
-              <a:rPr sz="1150" b="1">
-                <a:solidFill>
-                  <a:srgbClr val="5A5A5A"/>
+            <a:pPr algn="l"/>
+            <a:r>
+              <a:rPr sz="1300" b="1">
+                <a:solidFill>
+                  <a:srgbClr val="405731"/>
                 </a:solidFill>
                 <a:latin typeface="Calibri"/>
               </a:rPr>
-              <a:t>Pendiente: evaluación final 2026</a:t>
-            </a:r>
-          </a:p>
-          <a:p>
-            <a:pPr algn="l">
-              <a:spcAft>
-                <a:spcPts val="300"/>
-              </a:spcAft>
-            </a:pPr>
-            <a:r>
-              <a:rPr sz="1050" b="0">
-                <a:solidFill>
-                  <a:srgbClr val="5A5A5A"/>
+              <a:t>De la validación a 2026</a:t>
+            </a:r>
+          </a:p>
+        </p:txBody>
+      </p:sp>
+      <p:sp>
+        <p:nvSpPr>
+          <p:cNvPr id="17" name="TextBox 16"/>
+          <p:cNvSpPr txBox="1"/>
+          <p:nvPr/>
+        </p:nvSpPr>
+        <p:spPr>
+          <a:xfrm>
+            <a:off x="5778000" y="4111200"/>
+            <a:ext cx="2771999" cy="558000"/>
+          </a:xfrm>
+          <a:prstGeom prst="rect">
+            <a:avLst/>
+          </a:prstGeom>
+          <a:noFill/>
+        </p:spPr>
+        <p:txBody>
+          <a:bodyPr wrap="square" lIns="0" rIns="0" tIns="0" bIns="0" anchor="t">
+            <a:spAutoFit/>
+          </a:bodyPr>
+          <a:lstStyle/>
+          <a:p>
+            <a:pPr algn="l"/>
+            <a:r>
+              <a:rPr sz="1000" b="0">
+                <a:solidFill>
+                  <a:srgbClr val="1A1A1A"/>
                 </a:solidFill>
                 <a:latin typeface="Calibri"/>
               </a:rPr>
-              <a:t>XGBoost en la prueba 2026 y la tabla de brecha validación-prueba de cada modelo.</a:t>
-            </a:r>
-          </a:p>
-        </p:txBody>
-      </p:sp>
-      <p:sp>
-        <p:nvSpPr>
-          <p:cNvPr id="17" name="Rectangle 16"/>
+              <a:t>AUC interno 0,854, bloques externos 0,852, prueba 2026 0,848: no cae.</a:t>
+            </a:r>
+          </a:p>
+        </p:txBody>
+      </p:sp>
+      <p:sp>
+        <p:nvSpPr>
+          <p:cNvPr id="18" name="Rectangle 17"/>
           <p:cNvSpPr/>
           <p:nvPr/>
         </p:nvSpPr>
@@ -14725,7 +14905,7 @@
       </p:sp>
       <p:sp>
         <p:nvSpPr>
-          <p:cNvPr id="18" name="TextBox 17"/>
+          <p:cNvPr id="19" name="TextBox 18"/>
           <p:cNvSpPr txBox="1"/>
           <p:nvPr/>
         </p:nvSpPr>
@@ -14753,14 +14933,14 @@
                 </a:solidFill>
                 <a:latin typeface="Calibri"/>
               </a:rPr>
-              <a:t>Fuente: libro, capítulos 4 y 5: data/modelos/lideres.csv, metricas.csv</a:t>
-            </a:r>
-          </a:p>
-        </p:txBody>
-      </p:sp>
-      <p:sp>
-        <p:nvSpPr>
-          <p:cNvPr id="19" name="TextBox 18"/>
+              <a:t>Fuente: libro, capítulos 5 y 6: data/modelos/lideres.csv; resultados/prueba_2026/metricas.csv, brecha.csv</a:t>
+            </a:r>
+          </a:p>
+        </p:txBody>
+      </p:sp>
+      <p:sp>
+        <p:nvSpPr>
+          <p:cNvPr id="20" name="TextBox 19"/>
           <p:cNvSpPr txBox="1"/>
           <p:nvPr/>
         </p:nvSpPr>
@@ -14788,7 +14968,7 @@
                 </a:solidFill>
                 <a:latin typeface="Calibri"/>
               </a:rPr>
-              <a:t>16 / 20</a:t>
+              <a:t>16 / 21</a:t>
             </a:r>
           </a:p>
         </p:txBody>
@@ -15439,7 +15619,7 @@
                 </a:solidFill>
                 <a:latin typeface="Calibri"/>
               </a:rPr>
-              <a:t>17 / 20</a:t>
+              <a:t>17 / 21</a:t>
             </a:r>
           </a:p>
         </p:txBody>
@@ -15891,13 +16071,13 @@
         <p:spPr>
           <a:xfrm>
             <a:off x="468000" y="3996000"/>
-            <a:ext cx="8243999" cy="720000"/>
+            <a:ext cx="8243999" cy="612000"/>
           </a:xfrm>
           <a:prstGeom prst="rect">
             <a:avLst/>
           </a:prstGeom>
           <a:solidFill>
-            <a:srgbClr val="ECECEC"/>
+            <a:srgbClr val="405731"/>
           </a:solidFill>
           <a:ln>
             <a:noFill/>
@@ -15934,8 +16114,8 @@
         </p:nvSpPr>
         <p:spPr>
           <a:xfrm>
-            <a:off x="612000" y="4086000"/>
-            <a:ext cx="7955999" cy="576000"/>
+            <a:off x="648000" y="4060800"/>
+            <a:ext cx="7883999" cy="503999"/>
           </a:xfrm>
           <a:prstGeom prst="rect">
             <a:avLst/>
@@ -15943,40 +16123,28 @@
           <a:noFill/>
         </p:spPr>
         <p:txBody>
-          <a:bodyPr wrap="square" lIns="0" rIns="0" tIns="0" bIns="0" anchor="t">
+          <a:bodyPr wrap="square" lIns="0" rIns="0" tIns="0" bIns="0">
             <a:spAutoFit/>
           </a:bodyPr>
           <a:lstStyle/>
           <a:p>
-            <a:pPr algn="l">
-              <a:spcAft>
-                <a:spcPts val="300"/>
-              </a:spcAft>
-            </a:pPr>
-            <a:r>
-              <a:rPr sz="1150" b="1">
-                <a:solidFill>
-                  <a:srgbClr val="5A5A5A"/>
+            <a:r>
+              <a:rPr sz="1050" b="1">
+                <a:solidFill>
+                  <a:srgbClr val="F2E3BE"/>
                 </a:solidFill>
                 <a:latin typeface="Calibri"/>
               </a:rPr>
-              <a:t>Pendiente: evaluación final 2026</a:t>
-            </a:r>
-          </a:p>
-          <a:p>
-            <a:pPr algn="l">
-              <a:spcAft>
-                <a:spcPts val="300"/>
-              </a:spcAft>
-            </a:pPr>
+              <a:t>Errores de XGBoost en 2026:  </a:t>
+            </a:r>
             <a:r>
               <a:rPr sz="1050" b="0">
                 <a:solidFill>
-                  <a:srgbClr val="5A5A5A"/>
+                  <a:srgbClr val="FFFFFF"/>
                 </a:solidFill>
                 <a:latin typeface="Calibri"/>
               </a:rPr>
-              <a:t>para el mejor modelo en 2026: matriz de confusión por línea de negocio, errores con entidades nuevas frente a conocidas, un falso negativo típico y SHAP (qué variables mueven cada predicción).</a:t>
+              <a:t>de 16.374 tardías marcó 11.341 (69 %), con 5.889 falsas alarmas. AUC 0,856 con todo conocido y 0,821 con alguna entidad nueva; ganadería, 0,712. El falso negativo típico tenía plazo amplio y un proveedor puntual: el retraso se decide en la ejecución.</a:t>
             </a:r>
           </a:p>
         </p:txBody>
@@ -16055,7 +16223,7 @@
                 </a:solidFill>
                 <a:latin typeface="Calibri"/>
               </a:rPr>
-              <a:t>Fuente: libro, capítulos 4 y 5: resultados/experimentos/por_bloque.csv, data/modelos/curva_aprendizaje.csv</a:t>
+              <a:t>Fuente: libro, capítulos 5 y 6: resultados/experimentos/por_bloque.csv, resultados/prueba_2026/segmentos.csv</a:t>
             </a:r>
           </a:p>
         </p:txBody>
@@ -16090,7 +16258,7 @@
                 </a:solidFill>
                 <a:latin typeface="Calibri"/>
               </a:rPr>
-              <a:t>18 / 20</a:t>
+              <a:t>18 / 21</a:t>
             </a:r>
           </a:p>
         </p:txBody>
@@ -16307,7 +16475,7 @@
                 </a:solidFill>
                 <a:latin typeface="Calibri"/>
               </a:rPr>
-              <a:t>El retraso se puede anticipar el día de la liberación</a:t>
+              <a:t>Por qué XGBoost y no la logística, que es más simple</a:t>
             </a:r>
           </a:p>
         </p:txBody>
@@ -16342,7 +16510,7 @@
                 </a:solidFill>
                 <a:latin typeface="Calibri"/>
               </a:rPr>
-              <a:t>CRITERIO 6  ·  CONCLUSIONES</a:t>
+              <a:t>CRITERIO 5  ·  PARSIMONIA CON CIFRAS</a:t>
             </a:r>
           </a:p>
         </p:txBody>
@@ -16399,7 +16567,7 @@
         </p:nvSpPr>
         <p:spPr>
           <a:xfrm>
-            <a:off x="468000" y="1281600"/>
+            <a:off x="468000" y="1245600"/>
             <a:ext cx="72000" cy="72000"/>
           </a:xfrm>
           <a:prstGeom prst="rect">
@@ -16443,8 +16611,8 @@
         </p:nvSpPr>
         <p:spPr>
           <a:xfrm>
-            <a:off x="684000" y="1224000"/>
-            <a:ext cx="4608000" cy="648000"/>
+            <a:off x="684000" y="1188000"/>
+            <a:ext cx="4248000" cy="684000"/>
           </a:xfrm>
           <a:prstGeom prst="rect">
             <a:avLst/>
@@ -16459,13 +16627,13 @@
           <a:p>
             <a:pPr algn="l"/>
             <a:r>
-              <a:rPr sz="1150" b="0">
+              <a:rPr sz="1050" b="0">
                 <a:solidFill>
                   <a:srgbClr val="1A1A1A"/>
                 </a:solidFill>
                 <a:latin typeface="Calibri"/>
               </a:rPr>
-              <a:t>Se puede ordenar por riesgo al liberar: AUC 0,852 medido hacia adelante en el tiempo, contra 0,670 de la regla del proveedor en 2026.</a:t>
+              <a:t>Significativa. 2026: 0,848 contra 0,825, Δ 0,023 [0,017; 0,030], DeLong z = 22,5. Bloques: gana 8 de 8, Wilcoxon-Holm p = 0,047, Cliff 0,34.</a:t>
             </a:r>
           </a:p>
         </p:txBody>
@@ -16478,7 +16646,7 @@
         </p:nvSpPr>
         <p:spPr>
           <a:xfrm>
-            <a:off x="468000" y="1965600"/>
+            <a:off x="468000" y="1947600"/>
             <a:ext cx="72000" cy="72000"/>
           </a:xfrm>
           <a:prstGeom prst="rect">
@@ -16522,8 +16690,8 @@
         </p:nvSpPr>
         <p:spPr>
           <a:xfrm>
-            <a:off x="684000" y="1908000"/>
-            <a:ext cx="4608000" cy="648000"/>
+            <a:off x="684000" y="1890000"/>
+            <a:ext cx="4248000" cy="684000"/>
           </a:xfrm>
           <a:prstGeom prst="rect">
             <a:avLst/>
@@ -16538,13 +16706,13 @@
           <a:p>
             <a:pPr algn="l"/>
             <a:r>
-              <a:rPr sz="1150" b="0">
+              <a:rPr sz="1050" b="0">
                 <a:solidFill>
                   <a:srgbClr val="1A1A1A"/>
                 </a:solidFill>
                 <a:latin typeface="Calibri"/>
               </a:rPr>
-              <a:t>La señal está en el plazo, el historial del proveedor y las entidades; ninguna variable sola basta.</a:t>
+              <a:t>Material. Con el 20 % de alertas atrapa 8.242 tardías contra 7.895: 35 más por mes. F1 0,675 contra 0,649.</a:t>
             </a:r>
           </a:p>
         </p:txBody>
@@ -16601,8 +16769,8 @@
         </p:nvSpPr>
         <p:spPr>
           <a:xfrm>
-            <a:off x="684000" y="2591999"/>
-            <a:ext cx="4608000" cy="648000"/>
+            <a:off x="684000" y="2592000"/>
+            <a:ext cx="4248000" cy="684000"/>
           </a:xfrm>
           <a:prstGeom prst="rect">
             <a:avLst/>
@@ -16617,13 +16785,2032 @@
           <a:p>
             <a:pPr algn="l"/>
             <a:r>
-              <a:rPr sz="1150" b="0">
+              <a:rPr sz="1050" b="0">
                 <a:solidFill>
                   <a:srgbClr val="1A1A1A"/>
                 </a:solidFill>
                 <a:latin typeface="Calibri"/>
               </a:rPr>
-              <a:t>XGBoost gana, pero por una centésima: la logística, más simple y calibrada, es una alternativa defendible.</a:t>
+              <a:t>Forma. Sin plazo, el riesgo sube 3,4 de logit en Generales y 2,4 en Producción Cluster; la logística da una sola pendiente y una caída suave cerca de cero.</a:t>
+            </a:r>
+          </a:p>
+        </p:txBody>
+      </p:sp>
+      <p:sp>
+        <p:nvSpPr>
+          <p:cNvPr id="15" name="Rectangle 14"/>
+          <p:cNvSpPr/>
+          <p:nvPr/>
+        </p:nvSpPr>
+        <p:spPr>
+          <a:xfrm>
+            <a:off x="468000" y="3351600"/>
+            <a:ext cx="72000" cy="72000"/>
+          </a:xfrm>
+          <a:prstGeom prst="rect">
+            <a:avLst/>
+          </a:prstGeom>
+          <a:solidFill>
+            <a:srgbClr val="405731"/>
+          </a:solidFill>
+          <a:ln>
+            <a:noFill/>
+          </a:ln>
+          <a:effectLst/>
+        </p:spPr>
+        <p:style>
+          <a:lnRef idx="1">
+            <a:schemeClr val="accent1"/>
+          </a:lnRef>
+          <a:fillRef idx="3">
+            <a:schemeClr val="accent1"/>
+          </a:fillRef>
+          <a:effectRef idx="2">
+            <a:schemeClr val="accent1"/>
+          </a:effectRef>
+          <a:fontRef idx="minor">
+            <a:schemeClr val="lt1"/>
+          </a:fontRef>
+        </p:style>
+        <p:txBody>
+          <a:bodyPr rtlCol="0" anchor="ctr" wrap="square"/>
+          <a:lstStyle/>
+          <a:p>
+            <a:pPr algn="ctr"/>
+          </a:p>
+        </p:txBody>
+      </p:sp>
+      <p:sp>
+        <p:nvSpPr>
+          <p:cNvPr id="16" name="TextBox 15"/>
+          <p:cNvSpPr txBox="1"/>
+          <p:nvPr/>
+        </p:nvSpPr>
+        <p:spPr>
+          <a:xfrm>
+            <a:off x="684000" y="3294000"/>
+            <a:ext cx="4248000" cy="684000"/>
+          </a:xfrm>
+          <a:prstGeom prst="rect">
+            <a:avLst/>
+          </a:prstGeom>
+          <a:noFill/>
+        </p:spPr>
+        <p:txBody>
+          <a:bodyPr wrap="square" lIns="0" rIns="0" tIns="0" bIns="0" anchor="t">
+            <a:spAutoFit/>
+          </a:bodyPr>
+          <a:lstStyle/>
+          <a:p>
+            <a:pPr algn="l"/>
+            <a:r>
+              <a:rPr sz="1050" b="0">
+                <a:solidFill>
+                  <a:srgbClr val="1A1A1A"/>
+                </a:solidFill>
+                <a:latin typeface="Calibri"/>
+              </a:rPr>
+              <a:t>Costo. Un ajuste: 3,2 min contra 12 s; mil predicciones: 17 ms contra 0,7. SHAP da la lectura.</a:t>
+            </a:r>
+          </a:p>
+        </p:txBody>
+      </p:sp>
+      <p:sp>
+        <p:nvSpPr>
+          <p:cNvPr id="17" name="Rectangle 16"/>
+          <p:cNvSpPr/>
+          <p:nvPr/>
+        </p:nvSpPr>
+        <p:spPr>
+          <a:xfrm>
+            <a:off x="468000" y="4053600"/>
+            <a:ext cx="72000" cy="72000"/>
+          </a:xfrm>
+          <a:prstGeom prst="rect">
+            <a:avLst/>
+          </a:prstGeom>
+          <a:solidFill>
+            <a:srgbClr val="405731"/>
+          </a:solidFill>
+          <a:ln>
+            <a:noFill/>
+          </a:ln>
+          <a:effectLst/>
+        </p:spPr>
+        <p:style>
+          <a:lnRef idx="1">
+            <a:schemeClr val="accent1"/>
+          </a:lnRef>
+          <a:fillRef idx="3">
+            <a:schemeClr val="accent1"/>
+          </a:fillRef>
+          <a:effectRef idx="2">
+            <a:schemeClr val="accent1"/>
+          </a:effectRef>
+          <a:fontRef idx="minor">
+            <a:schemeClr val="lt1"/>
+          </a:fontRef>
+        </p:style>
+        <p:txBody>
+          <a:bodyPr rtlCol="0" anchor="ctr" wrap="square"/>
+          <a:lstStyle/>
+          <a:p>
+            <a:pPr algn="ctr"/>
+          </a:p>
+        </p:txBody>
+      </p:sp>
+      <p:sp>
+        <p:nvSpPr>
+          <p:cNvPr id="18" name="TextBox 17"/>
+          <p:cNvSpPr txBox="1"/>
+          <p:nvPr/>
+        </p:nvSpPr>
+        <p:spPr>
+          <a:xfrm>
+            <a:off x="684000" y="3996000"/>
+            <a:ext cx="4248000" cy="684000"/>
+          </a:xfrm>
+          <a:prstGeom prst="rect">
+            <a:avLst/>
+          </a:prstGeom>
+          <a:noFill/>
+        </p:spPr>
+        <p:txBody>
+          <a:bodyPr wrap="square" lIns="0" rIns="0" tIns="0" bIns="0" anchor="t">
+            <a:spAutoFit/>
+          </a:bodyPr>
+          <a:lstStyle/>
+          <a:p>
+            <a:pPr algn="l"/>
+            <a:r>
+              <a:rPr sz="1050" b="0">
+                <a:solidFill>
+                  <a:srgbClr val="1A1A1A"/>
+                </a:solidFill>
+                <a:latin typeface="Calibri"/>
+              </a:rPr>
+              <a:t>Parsimonia. Se acepta lo complejo solo si gana significativa y materialmente: se cumple. La logística queda como base legible.</a:t>
+            </a:r>
+          </a:p>
+        </p:txBody>
+      </p:sp>
+      <p:pic>
+        <p:nvPicPr>
+          <p:cNvPr id="19" name="Picture 18" descr="forma_plazo.png"/>
+          <p:cNvPicPr>
+            <a:picLocks noChangeAspect="1"/>
+          </p:cNvPicPr>
+          <p:nvPr/>
+        </p:nvPicPr>
+        <p:blipFill>
+          <a:blip r:embed="rId3"/>
+          <a:stretch>
+            <a:fillRect/>
+          </a:stretch>
+        </p:blipFill>
+        <p:spPr>
+          <a:xfrm>
+            <a:off x="5112000" y="1152000"/>
+            <a:ext cx="3600000" cy="2640000"/>
+          </a:xfrm>
+          <a:prstGeom prst="rect">
+            <a:avLst/>
+          </a:prstGeom>
+        </p:spPr>
+      </p:pic>
+      <p:sp>
+        <p:nvSpPr>
+          <p:cNvPr id="20" name="Rectangle 19"/>
+          <p:cNvSpPr/>
+          <p:nvPr/>
+        </p:nvSpPr>
+        <p:spPr>
+          <a:xfrm>
+            <a:off x="468000" y="4842000"/>
+            <a:ext cx="8243999" cy="14400"/>
+          </a:xfrm>
+          <a:prstGeom prst="rect">
+            <a:avLst/>
+          </a:prstGeom>
+          <a:solidFill>
+            <a:srgbClr val="DDD5C0"/>
+          </a:solidFill>
+          <a:ln>
+            <a:noFill/>
+          </a:ln>
+          <a:effectLst/>
+        </p:spPr>
+        <p:style>
+          <a:lnRef idx="1">
+            <a:schemeClr val="accent1"/>
+          </a:lnRef>
+          <a:fillRef idx="3">
+            <a:schemeClr val="accent1"/>
+          </a:fillRef>
+          <a:effectRef idx="2">
+            <a:schemeClr val="accent1"/>
+          </a:effectRef>
+          <a:fontRef idx="minor">
+            <a:schemeClr val="lt1"/>
+          </a:fontRef>
+        </p:style>
+        <p:txBody>
+          <a:bodyPr rtlCol="0" anchor="ctr" wrap="square"/>
+          <a:lstStyle/>
+          <a:p>
+            <a:pPr algn="ctr"/>
+          </a:p>
+        </p:txBody>
+      </p:sp>
+      <p:sp>
+        <p:nvSpPr>
+          <p:cNvPr id="21" name="TextBox 20"/>
+          <p:cNvSpPr txBox="1"/>
+          <p:nvPr/>
+        </p:nvSpPr>
+        <p:spPr>
+          <a:xfrm>
+            <a:off x="468000" y="4896000"/>
+            <a:ext cx="5940000" cy="180000"/>
+          </a:xfrm>
+          <a:prstGeom prst="rect">
+            <a:avLst/>
+          </a:prstGeom>
+          <a:noFill/>
+        </p:spPr>
+        <p:txBody>
+          <a:bodyPr wrap="square" lIns="0" rIns="0" tIns="0" bIns="0" anchor="t">
+            <a:spAutoFit/>
+          </a:bodyPr>
+          <a:lstStyle/>
+          <a:p>
+            <a:pPr algn="l"/>
+            <a:r>
+              <a:rPr sz="850" b="0">
+                <a:solidFill>
+                  <a:srgbClr val="8C8C8C"/>
+                </a:solidFill>
+                <a:latin typeface="Calibri"/>
+              </a:rPr>
+              <a:t>Fuente: libro, capítulo 6: resultados/prueba_2026/diferencias.csv, presupuesto.csv, forma_clase.csv, costo.csv</a:t>
+            </a:r>
+          </a:p>
+        </p:txBody>
+      </p:sp>
+      <p:sp>
+        <p:nvSpPr>
+          <p:cNvPr id="22" name="TextBox 21"/>
+          <p:cNvSpPr txBox="1"/>
+          <p:nvPr/>
+        </p:nvSpPr>
+        <p:spPr>
+          <a:xfrm>
+            <a:off x="6408000" y="4896000"/>
+            <a:ext cx="2304000" cy="180000"/>
+          </a:xfrm>
+          <a:prstGeom prst="rect">
+            <a:avLst/>
+          </a:prstGeom>
+          <a:noFill/>
+        </p:spPr>
+        <p:txBody>
+          <a:bodyPr wrap="square" lIns="0" rIns="0" tIns="0" bIns="0" anchor="t">
+            <a:spAutoFit/>
+          </a:bodyPr>
+          <a:lstStyle/>
+          <a:p>
+            <a:pPr algn="r"/>
+            <a:r>
+              <a:rPr sz="850" b="0">
+                <a:solidFill>
+                  <a:srgbClr val="8C8C8C"/>
+                </a:solidFill>
+                <a:latin typeface="Calibri"/>
+              </a:rPr>
+              <a:t>19 / 21</a:t>
+            </a:r>
+          </a:p>
+        </p:txBody>
+      </p:sp>
+    </p:spTree>
+  </p:cSld>
+  <p:clrMapOvr>
+    <a:masterClrMapping/>
+  </p:clrMapOvr>
+</p:sld>
+</file>
+
+<file path=ppt/slides/slide2.xml><?xml version="1.0" encoding="utf-8"?>
+<p:sld xmlns:a="http://schemas.openxmlformats.org/drawingml/2006/main" xmlns:p="http://schemas.openxmlformats.org/presentationml/2006/main" xmlns:r="http://schemas.openxmlformats.org/officeDocument/2006/relationships">
+  <p:cSld>
+    <p:bg>
+      <p:bgPr>
+        <a:solidFill>
+          <a:srgbClr val="FFFFFF"/>
+        </a:solidFill>
+        <a:effectLst/>
+      </p:bgPr>
+    </p:bg>
+    <p:spTree>
+      <p:nvGrpSpPr>
+        <p:cNvPr id="1" name=""/>
+        <p:cNvGrpSpPr/>
+        <p:nvPr/>
+      </p:nvGrpSpPr>
+      <p:grpSpPr/>
+      <p:sp>
+        <p:nvSpPr>
+          <p:cNvPr id="2" name="Rectangle 1"/>
+          <p:cNvSpPr/>
+          <p:nvPr/>
+        </p:nvSpPr>
+        <p:spPr>
+          <a:xfrm>
+            <a:off x="0" y="0"/>
+            <a:ext cx="9144000" cy="576000"/>
+          </a:xfrm>
+          <a:prstGeom prst="rect">
+            <a:avLst/>
+          </a:prstGeom>
+          <a:solidFill>
+            <a:srgbClr val="405731"/>
+          </a:solidFill>
+          <a:ln>
+            <a:noFill/>
+          </a:ln>
+          <a:effectLst/>
+        </p:spPr>
+        <p:style>
+          <a:lnRef idx="1">
+            <a:schemeClr val="accent1"/>
+          </a:lnRef>
+          <a:fillRef idx="3">
+            <a:schemeClr val="accent1"/>
+          </a:fillRef>
+          <a:effectRef idx="2">
+            <a:schemeClr val="accent1"/>
+          </a:effectRef>
+          <a:fontRef idx="minor">
+            <a:schemeClr val="lt1"/>
+          </a:fontRef>
+        </p:style>
+        <p:txBody>
+          <a:bodyPr rtlCol="0" anchor="ctr" wrap="square"/>
+          <a:lstStyle/>
+          <a:p>
+            <a:pPr algn="ctr"/>
+          </a:p>
+        </p:txBody>
+      </p:sp>
+      <p:sp>
+        <p:nvSpPr>
+          <p:cNvPr id="3" name="Rectangle 2"/>
+          <p:cNvSpPr/>
+          <p:nvPr/>
+        </p:nvSpPr>
+        <p:spPr>
+          <a:xfrm>
+            <a:off x="0" y="576000"/>
+            <a:ext cx="9144000" cy="36000"/>
+          </a:xfrm>
+          <a:prstGeom prst="rect">
+            <a:avLst/>
+          </a:prstGeom>
+          <a:solidFill>
+            <a:srgbClr val="B08A2D"/>
+          </a:solidFill>
+          <a:ln>
+            <a:noFill/>
+          </a:ln>
+          <a:effectLst/>
+        </p:spPr>
+        <p:style>
+          <a:lnRef idx="1">
+            <a:schemeClr val="accent1"/>
+          </a:lnRef>
+          <a:fillRef idx="3">
+            <a:schemeClr val="accent1"/>
+          </a:fillRef>
+          <a:effectRef idx="2">
+            <a:schemeClr val="accent1"/>
+          </a:effectRef>
+          <a:fontRef idx="minor">
+            <a:schemeClr val="lt1"/>
+          </a:fontRef>
+        </p:style>
+        <p:txBody>
+          <a:bodyPr rtlCol="0" anchor="ctr" wrap="square"/>
+          <a:lstStyle/>
+          <a:p>
+            <a:pPr algn="ctr"/>
+          </a:p>
+        </p:txBody>
+      </p:sp>
+      <p:sp>
+        <p:nvSpPr>
+          <p:cNvPr id="4" name="Rectangle 3"/>
+          <p:cNvSpPr/>
+          <p:nvPr/>
+        </p:nvSpPr>
+        <p:spPr>
+          <a:xfrm>
+            <a:off x="144000" y="72000"/>
+            <a:ext cx="468000" cy="432000"/>
+          </a:xfrm>
+          <a:prstGeom prst="rect">
+            <a:avLst/>
+          </a:prstGeom>
+          <a:solidFill>
+            <a:srgbClr val="FFFFFF"/>
+          </a:solidFill>
+          <a:ln>
+            <a:noFill/>
+          </a:ln>
+          <a:effectLst/>
+        </p:spPr>
+        <p:style>
+          <a:lnRef idx="1">
+            <a:schemeClr val="accent1"/>
+          </a:lnRef>
+          <a:fillRef idx="3">
+            <a:schemeClr val="accent1"/>
+          </a:fillRef>
+          <a:effectRef idx="2">
+            <a:schemeClr val="accent1"/>
+          </a:effectRef>
+          <a:fontRef idx="minor">
+            <a:schemeClr val="lt1"/>
+          </a:fontRef>
+        </p:style>
+        <p:txBody>
+          <a:bodyPr rtlCol="0" anchor="ctr" wrap="square"/>
+          <a:lstStyle/>
+          <a:p>
+            <a:pPr algn="ctr"/>
+          </a:p>
+        </p:txBody>
+      </p:sp>
+      <p:pic>
+        <p:nvPicPr>
+          <p:cNvPr id="5" name="Picture 4" descr="logo.png"/>
+          <p:cNvPicPr>
+            <a:picLocks noChangeAspect="1"/>
+          </p:cNvPicPr>
+          <p:nvPr/>
+        </p:nvPicPr>
+        <p:blipFill>
+          <a:blip r:embed="rId2"/>
+          <a:stretch>
+            <a:fillRect/>
+          </a:stretch>
+        </p:blipFill>
+        <p:spPr>
+          <a:xfrm>
+            <a:off x="200160" y="145440"/>
+            <a:ext cx="355680" cy="266417"/>
+          </a:xfrm>
+          <a:prstGeom prst="rect">
+            <a:avLst/>
+          </a:prstGeom>
+        </p:spPr>
+      </p:pic>
+      <p:sp>
+        <p:nvSpPr>
+          <p:cNvPr id="6" name="TextBox 5"/>
+          <p:cNvSpPr txBox="1"/>
+          <p:nvPr/>
+        </p:nvSpPr>
+        <p:spPr>
+          <a:xfrm>
+            <a:off x="792000" y="125999"/>
+            <a:ext cx="8172000" cy="360000"/>
+          </a:xfrm>
+          <a:prstGeom prst="rect">
+            <a:avLst/>
+          </a:prstGeom>
+          <a:noFill/>
+        </p:spPr>
+        <p:txBody>
+          <a:bodyPr wrap="square" lIns="0" rIns="0" tIns="0" bIns="0" anchor="ctr">
+            <a:spAutoFit/>
+          </a:bodyPr>
+          <a:lstStyle/>
+          <a:p>
+            <a:pPr algn="l"/>
+            <a:r>
+              <a:rPr sz="2000" b="1">
+                <a:solidFill>
+                  <a:srgbClr val="FFFFFF"/>
+                </a:solidFill>
+                <a:latin typeface="Calibri"/>
+              </a:rPr>
+              <a:t>Uno de cada tres pedidos llega tarde, y se sabe cuando ya pasó</a:t>
+            </a:r>
+          </a:p>
+        </p:txBody>
+      </p:sp>
+      <p:sp>
+        <p:nvSpPr>
+          <p:cNvPr id="7" name="TextBox 6"/>
+          <p:cNvSpPr txBox="1"/>
+          <p:nvPr/>
+        </p:nvSpPr>
+        <p:spPr>
+          <a:xfrm>
+            <a:off x="468000" y="756000"/>
+            <a:ext cx="7308000" cy="251999"/>
+          </a:xfrm>
+          <a:prstGeom prst="rect">
+            <a:avLst/>
+          </a:prstGeom>
+          <a:noFill/>
+        </p:spPr>
+        <p:txBody>
+          <a:bodyPr wrap="square" lIns="0" rIns="0" tIns="0" bIns="0" anchor="t">
+            <a:spAutoFit/>
+          </a:bodyPr>
+          <a:lstStyle/>
+          <a:p>
+            <a:pPr algn="l"/>
+            <a:r>
+              <a:rPr sz="1200" b="1">
+                <a:solidFill>
+                  <a:srgbClr val="B08A2D"/>
+                </a:solidFill>
+                <a:latin typeface="Calibri"/>
+              </a:rPr>
+              <a:t>CRITERIO 1  ·  EL PROBLEMA</a:t>
+            </a:r>
+          </a:p>
+        </p:txBody>
+      </p:sp>
+      <p:sp>
+        <p:nvSpPr>
+          <p:cNvPr id="8" name="Rectangle 7"/>
+          <p:cNvSpPr/>
+          <p:nvPr/>
+        </p:nvSpPr>
+        <p:spPr>
+          <a:xfrm>
+            <a:off x="468000" y="1044000"/>
+            <a:ext cx="468000" cy="36000"/>
+          </a:xfrm>
+          <a:prstGeom prst="rect">
+            <a:avLst/>
+          </a:prstGeom>
+          <a:solidFill>
+            <a:srgbClr val="B08A2D"/>
+          </a:solidFill>
+          <a:ln>
+            <a:noFill/>
+          </a:ln>
+          <a:effectLst/>
+        </p:spPr>
+        <p:style>
+          <a:lnRef idx="1">
+            <a:schemeClr val="accent1"/>
+          </a:lnRef>
+          <a:fillRef idx="3">
+            <a:schemeClr val="accent1"/>
+          </a:fillRef>
+          <a:effectRef idx="2">
+            <a:schemeClr val="accent1"/>
+          </a:effectRef>
+          <a:fontRef idx="minor">
+            <a:schemeClr val="lt1"/>
+          </a:fontRef>
+        </p:style>
+        <p:txBody>
+          <a:bodyPr rtlCol="0" anchor="ctr" wrap="square"/>
+          <a:lstStyle/>
+          <a:p>
+            <a:pPr algn="ctr"/>
+          </a:p>
+        </p:txBody>
+      </p:sp>
+      <p:sp>
+        <p:nvSpPr>
+          <p:cNvPr id="9" name="Rectangle 8"/>
+          <p:cNvSpPr/>
+          <p:nvPr/>
+        </p:nvSpPr>
+        <p:spPr>
+          <a:xfrm>
+            <a:off x="468000" y="1224000"/>
+            <a:ext cx="1944000" cy="972000"/>
+          </a:xfrm>
+          <a:prstGeom prst="rect">
+            <a:avLst/>
+          </a:prstGeom>
+          <a:solidFill>
+            <a:srgbClr val="E8F0EB"/>
+          </a:solidFill>
+          <a:ln>
+            <a:noFill/>
+          </a:ln>
+          <a:effectLst/>
+        </p:spPr>
+        <p:style>
+          <a:lnRef idx="1">
+            <a:schemeClr val="accent1"/>
+          </a:lnRef>
+          <a:fillRef idx="3">
+            <a:schemeClr val="accent1"/>
+          </a:fillRef>
+          <a:effectRef idx="2">
+            <a:schemeClr val="accent1"/>
+          </a:effectRef>
+          <a:fontRef idx="minor">
+            <a:schemeClr val="lt1"/>
+          </a:fontRef>
+        </p:style>
+        <p:txBody>
+          <a:bodyPr rtlCol="0" anchor="ctr" wrap="square"/>
+          <a:lstStyle/>
+          <a:p>
+            <a:pPr algn="ctr"/>
+          </a:p>
+        </p:txBody>
+      </p:sp>
+      <p:sp>
+        <p:nvSpPr>
+          <p:cNvPr id="10" name="Rectangle 9"/>
+          <p:cNvSpPr/>
+          <p:nvPr/>
+        </p:nvSpPr>
+        <p:spPr>
+          <a:xfrm>
+            <a:off x="558000" y="1224000"/>
+            <a:ext cx="1764000" cy="36000"/>
+          </a:xfrm>
+          <a:prstGeom prst="rect">
+            <a:avLst/>
+          </a:prstGeom>
+          <a:solidFill>
+            <a:srgbClr val="B08A2D"/>
+          </a:solidFill>
+          <a:ln>
+            <a:noFill/>
+          </a:ln>
+          <a:effectLst/>
+        </p:spPr>
+        <p:style>
+          <a:lnRef idx="1">
+            <a:schemeClr val="accent1"/>
+          </a:lnRef>
+          <a:fillRef idx="3">
+            <a:schemeClr val="accent1"/>
+          </a:fillRef>
+          <a:effectRef idx="2">
+            <a:schemeClr val="accent1"/>
+          </a:effectRef>
+          <a:fontRef idx="minor">
+            <a:schemeClr val="lt1"/>
+          </a:fontRef>
+        </p:style>
+        <p:txBody>
+          <a:bodyPr rtlCol="0" anchor="ctr" wrap="square"/>
+          <a:lstStyle/>
+          <a:p>
+            <a:pPr algn="ctr"/>
+          </a:p>
+        </p:txBody>
+      </p:sp>
+      <p:sp>
+        <p:nvSpPr>
+          <p:cNvPr id="11" name="TextBox 10"/>
+          <p:cNvSpPr txBox="1"/>
+          <p:nvPr/>
+        </p:nvSpPr>
+        <p:spPr>
+          <a:xfrm>
+            <a:off x="468000" y="1350000"/>
+            <a:ext cx="1944000" cy="468000"/>
+          </a:xfrm>
+          <a:prstGeom prst="rect">
+            <a:avLst/>
+          </a:prstGeom>
+          <a:noFill/>
+        </p:spPr>
+        <p:txBody>
+          <a:bodyPr wrap="square" lIns="0" rIns="0" tIns="0" bIns="0" anchor="t">
+            <a:spAutoFit/>
+          </a:bodyPr>
+          <a:lstStyle/>
+          <a:p>
+            <a:pPr algn="ctr"/>
+            <a:r>
+              <a:rPr sz="3400" b="1">
+                <a:solidFill>
+                  <a:srgbClr val="405731"/>
+                </a:solidFill>
+                <a:latin typeface="Calibri"/>
+              </a:rPr>
+              <a:t>33,0 %</a:t>
+            </a:r>
+          </a:p>
+        </p:txBody>
+      </p:sp>
+      <p:sp>
+        <p:nvSpPr>
+          <p:cNvPr id="12" name="TextBox 11"/>
+          <p:cNvSpPr txBox="1"/>
+          <p:nvPr/>
+        </p:nvSpPr>
+        <p:spPr>
+          <a:xfrm>
+            <a:off x="468000" y="1854000"/>
+            <a:ext cx="1944000" cy="288000"/>
+          </a:xfrm>
+          <a:prstGeom prst="rect">
+            <a:avLst/>
+          </a:prstGeom>
+          <a:noFill/>
+        </p:spPr>
+        <p:txBody>
+          <a:bodyPr wrap="square" lIns="0" rIns="0" tIns="0" bIns="0" anchor="t">
+            <a:spAutoFit/>
+          </a:bodyPr>
+          <a:lstStyle/>
+          <a:p>
+            <a:pPr algn="ctr"/>
+            <a:r>
+              <a:rPr sz="1050" b="0">
+                <a:solidFill>
+                  <a:srgbClr val="5A5A5A"/>
+                </a:solidFill>
+                <a:latin typeface="Calibri"/>
+              </a:rPr>
+              <a:t>de las posiciones llega tarde</a:t>
+            </a:r>
+          </a:p>
+        </p:txBody>
+      </p:sp>
+      <p:sp>
+        <p:nvSpPr>
+          <p:cNvPr id="13" name="Rectangle 12"/>
+          <p:cNvSpPr/>
+          <p:nvPr/>
+        </p:nvSpPr>
+        <p:spPr>
+          <a:xfrm>
+            <a:off x="468000" y="2304000"/>
+            <a:ext cx="1944000" cy="972000"/>
+          </a:xfrm>
+          <a:prstGeom prst="rect">
+            <a:avLst/>
+          </a:prstGeom>
+          <a:solidFill>
+            <a:srgbClr val="F5EDE0"/>
+          </a:solidFill>
+          <a:ln>
+            <a:noFill/>
+          </a:ln>
+          <a:effectLst/>
+        </p:spPr>
+        <p:style>
+          <a:lnRef idx="1">
+            <a:schemeClr val="accent1"/>
+          </a:lnRef>
+          <a:fillRef idx="3">
+            <a:schemeClr val="accent1"/>
+          </a:fillRef>
+          <a:effectRef idx="2">
+            <a:schemeClr val="accent1"/>
+          </a:effectRef>
+          <a:fontRef idx="minor">
+            <a:schemeClr val="lt1"/>
+          </a:fontRef>
+        </p:style>
+        <p:txBody>
+          <a:bodyPr rtlCol="0" anchor="ctr" wrap="square"/>
+          <a:lstStyle/>
+          <a:p>
+            <a:pPr algn="ctr"/>
+          </a:p>
+        </p:txBody>
+      </p:sp>
+      <p:sp>
+        <p:nvSpPr>
+          <p:cNvPr id="14" name="Rectangle 13"/>
+          <p:cNvSpPr/>
+          <p:nvPr/>
+        </p:nvSpPr>
+        <p:spPr>
+          <a:xfrm>
+            <a:off x="558000" y="2304000"/>
+            <a:ext cx="1764000" cy="36000"/>
+          </a:xfrm>
+          <a:prstGeom prst="rect">
+            <a:avLst/>
+          </a:prstGeom>
+          <a:solidFill>
+            <a:srgbClr val="B08A2D"/>
+          </a:solidFill>
+          <a:ln>
+            <a:noFill/>
+          </a:ln>
+          <a:effectLst/>
+        </p:spPr>
+        <p:style>
+          <a:lnRef idx="1">
+            <a:schemeClr val="accent1"/>
+          </a:lnRef>
+          <a:fillRef idx="3">
+            <a:schemeClr val="accent1"/>
+          </a:fillRef>
+          <a:effectRef idx="2">
+            <a:schemeClr val="accent1"/>
+          </a:effectRef>
+          <a:fontRef idx="minor">
+            <a:schemeClr val="lt1"/>
+          </a:fontRef>
+        </p:style>
+        <p:txBody>
+          <a:bodyPr rtlCol="0" anchor="ctr" wrap="square"/>
+          <a:lstStyle/>
+          <a:p>
+            <a:pPr algn="ctr"/>
+          </a:p>
+        </p:txBody>
+      </p:sp>
+      <p:sp>
+        <p:nvSpPr>
+          <p:cNvPr id="15" name="TextBox 14"/>
+          <p:cNvSpPr txBox="1"/>
+          <p:nvPr/>
+        </p:nvSpPr>
+        <p:spPr>
+          <a:xfrm>
+            <a:off x="468000" y="2430000"/>
+            <a:ext cx="1944000" cy="468000"/>
+          </a:xfrm>
+          <a:prstGeom prst="rect">
+            <a:avLst/>
+          </a:prstGeom>
+          <a:noFill/>
+        </p:spPr>
+        <p:txBody>
+          <a:bodyPr wrap="square" lIns="0" rIns="0" tIns="0" bIns="0" anchor="t">
+            <a:spAutoFit/>
+          </a:bodyPr>
+          <a:lstStyle/>
+          <a:p>
+            <a:pPr algn="ctr"/>
+            <a:r>
+              <a:rPr sz="3400" b="1">
+                <a:solidFill>
+                  <a:srgbClr val="405731"/>
+                </a:solidFill>
+                <a:latin typeface="Calibri"/>
+              </a:rPr>
+              <a:t>41 %</a:t>
+            </a:r>
+          </a:p>
+        </p:txBody>
+      </p:sp>
+      <p:sp>
+        <p:nvSpPr>
+          <p:cNvPr id="16" name="TextBox 15"/>
+          <p:cNvSpPr txBox="1"/>
+          <p:nvPr/>
+        </p:nvSpPr>
+        <p:spPr>
+          <a:xfrm>
+            <a:off x="468000" y="2934000"/>
+            <a:ext cx="1944000" cy="288000"/>
+          </a:xfrm>
+          <a:prstGeom prst="rect">
+            <a:avLst/>
+          </a:prstGeom>
+          <a:noFill/>
+        </p:spPr>
+        <p:txBody>
+          <a:bodyPr wrap="square" lIns="0" rIns="0" tIns="0" bIns="0" anchor="t">
+            <a:spAutoFit/>
+          </a:bodyPr>
+          <a:lstStyle/>
+          <a:p>
+            <a:pPr algn="ctr"/>
+            <a:r>
+              <a:rPr sz="1050" b="0">
+                <a:solidFill>
+                  <a:srgbClr val="5A5A5A"/>
+                </a:solidFill>
+                <a:latin typeface="Calibri"/>
+              </a:rPr>
+              <a:t>en industrial; 25 % en ganaderia</a:t>
+            </a:r>
+          </a:p>
+        </p:txBody>
+      </p:sp>
+      <p:sp>
+        <p:nvSpPr>
+          <p:cNvPr id="17" name="Rectangle 16"/>
+          <p:cNvSpPr/>
+          <p:nvPr/>
+        </p:nvSpPr>
+        <p:spPr>
+          <a:xfrm>
+            <a:off x="468000" y="3384000"/>
+            <a:ext cx="1944000" cy="972000"/>
+          </a:xfrm>
+          <a:prstGeom prst="rect">
+            <a:avLst/>
+          </a:prstGeom>
+          <a:solidFill>
+            <a:srgbClr val="EEF2EA"/>
+          </a:solidFill>
+          <a:ln>
+            <a:noFill/>
+          </a:ln>
+          <a:effectLst/>
+        </p:spPr>
+        <p:style>
+          <a:lnRef idx="1">
+            <a:schemeClr val="accent1"/>
+          </a:lnRef>
+          <a:fillRef idx="3">
+            <a:schemeClr val="accent1"/>
+          </a:fillRef>
+          <a:effectRef idx="2">
+            <a:schemeClr val="accent1"/>
+          </a:effectRef>
+          <a:fontRef idx="minor">
+            <a:schemeClr val="lt1"/>
+          </a:fontRef>
+        </p:style>
+        <p:txBody>
+          <a:bodyPr rtlCol="0" anchor="ctr" wrap="square"/>
+          <a:lstStyle/>
+          <a:p>
+            <a:pPr algn="ctr"/>
+          </a:p>
+        </p:txBody>
+      </p:sp>
+      <p:sp>
+        <p:nvSpPr>
+          <p:cNvPr id="18" name="Rectangle 17"/>
+          <p:cNvSpPr/>
+          <p:nvPr/>
+        </p:nvSpPr>
+        <p:spPr>
+          <a:xfrm>
+            <a:off x="558000" y="3384000"/>
+            <a:ext cx="1764000" cy="36000"/>
+          </a:xfrm>
+          <a:prstGeom prst="rect">
+            <a:avLst/>
+          </a:prstGeom>
+          <a:solidFill>
+            <a:srgbClr val="B08A2D"/>
+          </a:solidFill>
+          <a:ln>
+            <a:noFill/>
+          </a:ln>
+          <a:effectLst/>
+        </p:spPr>
+        <p:style>
+          <a:lnRef idx="1">
+            <a:schemeClr val="accent1"/>
+          </a:lnRef>
+          <a:fillRef idx="3">
+            <a:schemeClr val="accent1"/>
+          </a:fillRef>
+          <a:effectRef idx="2">
+            <a:schemeClr val="accent1"/>
+          </a:effectRef>
+          <a:fontRef idx="minor">
+            <a:schemeClr val="lt1"/>
+          </a:fontRef>
+        </p:style>
+        <p:txBody>
+          <a:bodyPr rtlCol="0" anchor="ctr" wrap="square"/>
+          <a:lstStyle/>
+          <a:p>
+            <a:pPr algn="ctr"/>
+          </a:p>
+        </p:txBody>
+      </p:sp>
+      <p:sp>
+        <p:nvSpPr>
+          <p:cNvPr id="19" name="TextBox 18"/>
+          <p:cNvSpPr txBox="1"/>
+          <p:nvPr/>
+        </p:nvSpPr>
+        <p:spPr>
+          <a:xfrm>
+            <a:off x="468000" y="3510000"/>
+            <a:ext cx="1944000" cy="468000"/>
+          </a:xfrm>
+          <a:prstGeom prst="rect">
+            <a:avLst/>
+          </a:prstGeom>
+          <a:noFill/>
+        </p:spPr>
+        <p:txBody>
+          <a:bodyPr wrap="square" lIns="0" rIns="0" tIns="0" bIns="0" anchor="t">
+            <a:spAutoFit/>
+          </a:bodyPr>
+          <a:lstStyle/>
+          <a:p>
+            <a:pPr algn="ctr"/>
+            <a:r>
+              <a:rPr sz="3400" b="1">
+                <a:solidFill>
+                  <a:srgbClr val="405731"/>
+                </a:solidFill>
+                <a:latin typeface="Calibri"/>
+              </a:rPr>
+              <a:t>71 %</a:t>
+            </a:r>
+          </a:p>
+        </p:txBody>
+      </p:sp>
+      <p:sp>
+        <p:nvSpPr>
+          <p:cNvPr id="20" name="TextBox 19"/>
+          <p:cNvSpPr txBox="1"/>
+          <p:nvPr/>
+        </p:nvSpPr>
+        <p:spPr>
+          <a:xfrm>
+            <a:off x="468000" y="4014000"/>
+            <a:ext cx="1944000" cy="288000"/>
+          </a:xfrm>
+          <a:prstGeom prst="rect">
+            <a:avLst/>
+          </a:prstGeom>
+          <a:noFill/>
+        </p:spPr>
+        <p:txBody>
+          <a:bodyPr wrap="square" lIns="0" rIns="0" tIns="0" bIns="0" anchor="t">
+            <a:spAutoFit/>
+          </a:bodyPr>
+          <a:lstStyle/>
+          <a:p>
+            <a:pPr algn="ctr"/>
+            <a:r>
+              <a:rPr sz="1050" b="0">
+                <a:solidFill>
+                  <a:srgbClr val="5A5A5A"/>
+                </a:solidFill>
+                <a:latin typeface="Calibri"/>
+              </a:rPr>
+              <a:t>de las tardías de 2026, marcando el 38 %</a:t>
+            </a:r>
+          </a:p>
+        </p:txBody>
+      </p:sp>
+      <p:sp>
+        <p:nvSpPr>
+          <p:cNvPr id="21" name="TextBox 20"/>
+          <p:cNvSpPr txBox="1"/>
+          <p:nvPr/>
+        </p:nvSpPr>
+        <p:spPr>
+          <a:xfrm>
+            <a:off x="2736000" y="1188000"/>
+            <a:ext cx="3311999" cy="216000"/>
+          </a:xfrm>
+          <a:prstGeom prst="rect">
+            <a:avLst/>
+          </a:prstGeom>
+          <a:noFill/>
+        </p:spPr>
+        <p:txBody>
+          <a:bodyPr wrap="square" lIns="0" rIns="0" tIns="0" bIns="0" anchor="t">
+            <a:spAutoFit/>
+          </a:bodyPr>
+          <a:lstStyle/>
+          <a:p>
+            <a:pPr algn="l"/>
+            <a:r>
+              <a:rPr sz="1250" b="1">
+                <a:solidFill>
+                  <a:srgbClr val="405731"/>
+                </a:solidFill>
+                <a:latin typeface="Calibri"/>
+              </a:rPr>
+              <a:t>Por qué importa</a:t>
+            </a:r>
+          </a:p>
+        </p:txBody>
+      </p:sp>
+      <p:sp>
+        <p:nvSpPr>
+          <p:cNvPr id="22" name="TextBox 21"/>
+          <p:cNvSpPr txBox="1"/>
+          <p:nvPr/>
+        </p:nvSpPr>
+        <p:spPr>
+          <a:xfrm>
+            <a:off x="2736000" y="1440000"/>
+            <a:ext cx="3311999" cy="1296000"/>
+          </a:xfrm>
+          <a:prstGeom prst="rect">
+            <a:avLst/>
+          </a:prstGeom>
+          <a:noFill/>
+        </p:spPr>
+        <p:txBody>
+          <a:bodyPr wrap="square" lIns="0" rIns="0" tIns="0" bIns="0" anchor="t">
+            <a:spAutoFit/>
+          </a:bodyPr>
+          <a:lstStyle/>
+          <a:p>
+            <a:pPr algn="l"/>
+            <a:r>
+              <a:rPr sz="1100" b="0">
+                <a:solidFill>
+                  <a:srgbClr val="1A1A1A"/>
+                </a:solidFill>
+                <a:latin typeface="Calibri"/>
+              </a:rPr>
+              <a:t>El comprador hoy se entera del retraso cuando la mercancía no llega. Con miles de posiciones abiertas, no puede seguirlas todas: necesita saber, el día en que libera la orden, cuáles vigilar.</a:t>
+            </a:r>
+          </a:p>
+        </p:txBody>
+      </p:sp>
+      <p:sp>
+        <p:nvSpPr>
+          <p:cNvPr id="23" name="TextBox 22"/>
+          <p:cNvSpPr txBox="1"/>
+          <p:nvPr/>
+        </p:nvSpPr>
+        <p:spPr>
+          <a:xfrm>
+            <a:off x="2736000" y="2628000"/>
+            <a:ext cx="3311999" cy="216000"/>
+          </a:xfrm>
+          <a:prstGeom prst="rect">
+            <a:avLst/>
+          </a:prstGeom>
+          <a:noFill/>
+        </p:spPr>
+        <p:txBody>
+          <a:bodyPr wrap="square" lIns="0" rIns="0" tIns="0" bIns="0" anchor="t">
+            <a:spAutoFit/>
+          </a:bodyPr>
+          <a:lstStyle/>
+          <a:p>
+            <a:pPr algn="l"/>
+            <a:r>
+              <a:rPr sz="1250" b="1">
+                <a:solidFill>
+                  <a:srgbClr val="405731"/>
+                </a:solidFill>
+                <a:latin typeface="Calibri"/>
+              </a:rPr>
+              <a:t>Qué dice la literatura</a:t>
+            </a:r>
+          </a:p>
+        </p:txBody>
+      </p:sp>
+      <p:sp>
+        <p:nvSpPr>
+          <p:cNvPr id="24" name="TextBox 23"/>
+          <p:cNvSpPr txBox="1"/>
+          <p:nvPr/>
+        </p:nvSpPr>
+        <p:spPr>
+          <a:xfrm>
+            <a:off x="2736000" y="2880000"/>
+            <a:ext cx="3311999" cy="1800000"/>
+          </a:xfrm>
+          <a:prstGeom prst="rect">
+            <a:avLst/>
+          </a:prstGeom>
+          <a:noFill/>
+        </p:spPr>
+        <p:txBody>
+          <a:bodyPr wrap="square" lIns="0" rIns="0" tIns="0" bIns="0" anchor="t">
+            <a:spAutoFit/>
+          </a:bodyPr>
+          <a:lstStyle/>
+          <a:p>
+            <a:pPr algn="l"/>
+            <a:r>
+              <a:rPr sz="1050" b="0">
+                <a:solidFill>
+                  <a:srgbClr val="5A5A5A"/>
+                </a:solidFill>
+                <a:latin typeface="Calibri"/>
+              </a:rPr>
+              <a:t>En fabricantes de maquinaria y equipos llega tarde del 13 % al 14 % de los pedidos (Brintrup y otros, 2020; Steinberg y otros, 2023): aquí es más del doble.</a:t>
+            </a:r>
+          </a:p>
+          <a:p>
+            <a:pPr algn="l">
+              <a:spcBef>
+                <a:spcPts val="600"/>
+              </a:spcBef>
+            </a:pPr>
+            <a:r>
+              <a:rPr sz="1050" b="0">
+                <a:solidFill>
+                  <a:srgbClr val="5A5A5A"/>
+                </a:solidFill>
+                <a:latin typeface="Calibri"/>
+              </a:rPr>
+              <a:t>Una revisión de 26 estudios encuentra que 16 parten las filas al azar; reevaluado sin fuga y en el tiempo, un AUC de 0,96 baja a 0,73 (Raval, 2026). Este trabajo evalúa siempre hacia adelante.</a:t>
+            </a:r>
+          </a:p>
+        </p:txBody>
+      </p:sp>
+      <p:sp>
+        <p:nvSpPr>
+          <p:cNvPr id="25" name="Rectangle 24"/>
+          <p:cNvSpPr/>
+          <p:nvPr/>
+        </p:nvSpPr>
+        <p:spPr>
+          <a:xfrm>
+            <a:off x="6263999" y="1224000"/>
+            <a:ext cx="2448000" cy="3491999"/>
+          </a:xfrm>
+          <a:prstGeom prst="rect">
+            <a:avLst/>
+          </a:prstGeom>
+          <a:solidFill>
+            <a:srgbClr val="E8F0EB"/>
+          </a:solidFill>
+          <a:ln>
+            <a:noFill/>
+          </a:ln>
+          <a:effectLst/>
+        </p:spPr>
+        <p:style>
+          <a:lnRef idx="1">
+            <a:schemeClr val="accent1"/>
+          </a:lnRef>
+          <a:fillRef idx="3">
+            <a:schemeClr val="accent1"/>
+          </a:fillRef>
+          <a:effectRef idx="2">
+            <a:schemeClr val="accent1"/>
+          </a:effectRef>
+          <a:fontRef idx="minor">
+            <a:schemeClr val="lt1"/>
+          </a:fontRef>
+        </p:style>
+        <p:txBody>
+          <a:bodyPr rtlCol="0" anchor="ctr" wrap="square"/>
+          <a:lstStyle/>
+          <a:p>
+            <a:pPr algn="ctr"/>
+          </a:p>
+        </p:txBody>
+      </p:sp>
+      <p:sp>
+        <p:nvSpPr>
+          <p:cNvPr id="26" name="TextBox 25"/>
+          <p:cNvSpPr txBox="1"/>
+          <p:nvPr/>
+        </p:nvSpPr>
+        <p:spPr>
+          <a:xfrm>
+            <a:off x="6425999" y="1332000"/>
+            <a:ext cx="2124000" cy="288000"/>
+          </a:xfrm>
+          <a:prstGeom prst="rect">
+            <a:avLst/>
+          </a:prstGeom>
+          <a:noFill/>
+        </p:spPr>
+        <p:txBody>
+          <a:bodyPr wrap="square" lIns="0" rIns="0" tIns="0" bIns="0" anchor="t">
+            <a:spAutoFit/>
+          </a:bodyPr>
+          <a:lstStyle/>
+          <a:p>
+            <a:pPr algn="l"/>
+            <a:r>
+              <a:rPr sz="1300" b="1">
+                <a:solidFill>
+                  <a:srgbClr val="405731"/>
+                </a:solidFill>
+                <a:latin typeface="Calibri"/>
+              </a:rPr>
+              <a:t>Objetivos</a:t>
+            </a:r>
+          </a:p>
+        </p:txBody>
+      </p:sp>
+      <p:sp>
+        <p:nvSpPr>
+          <p:cNvPr id="27" name="TextBox 26"/>
+          <p:cNvSpPr txBox="1"/>
+          <p:nvPr/>
+        </p:nvSpPr>
+        <p:spPr>
+          <a:xfrm>
+            <a:off x="6425999" y="1591200"/>
+            <a:ext cx="2124000" cy="3077999"/>
+          </a:xfrm>
+          <a:prstGeom prst="rect">
+            <a:avLst/>
+          </a:prstGeom>
+          <a:noFill/>
+        </p:spPr>
+        <p:txBody>
+          <a:bodyPr wrap="square" lIns="0" rIns="0" tIns="0" bIns="0" anchor="t">
+            <a:spAutoFit/>
+          </a:bodyPr>
+          <a:lstStyle/>
+          <a:p>
+            <a:pPr algn="l"/>
+            <a:r>
+              <a:rPr sz="1050" b="0">
+                <a:solidFill>
+                  <a:srgbClr val="1A1A1A"/>
+                </a:solidFill>
+                <a:latin typeface="Calibri"/>
+              </a:rPr>
+              <a:t>General: ordenar las posiciones por riesgo de retraso el día de la liberación y señalar cuáles seguir.</a:t>
+            </a:r>
+          </a:p>
+          <a:p>
+            <a:pPr algn="l"/>
+            <a:r>
+              <a:rPr sz="1050" b="0">
+                <a:solidFill>
+                  <a:srgbClr val="1A1A1A"/>
+                </a:solidFill>
+                <a:latin typeface="Calibri"/>
+              </a:rPr>
+              <a:t>Específico 1: comparar 7 modelos × 4 balanceos × 4 optimizadores con el mismo presupuesto.</a:t>
+            </a:r>
+          </a:p>
+          <a:p>
+            <a:pPr algn="l"/>
+            <a:r>
+              <a:rPr sz="1050" b="0">
+                <a:solidFill>
+                  <a:srgbClr val="1A1A1A"/>
+                </a:solidFill>
+                <a:latin typeface="Calibri"/>
+              </a:rPr>
+              <a:t>Específico 2: medir cuánto cuesta decidir con entidades nuevas (proveedor o material sin historia).</a:t>
+            </a:r>
+          </a:p>
+          <a:p>
+            <a:pPr algn="l"/>
+            <a:r>
+              <a:rPr sz="1050" b="0">
+                <a:solidFill>
+                  <a:srgbClr val="1A1A1A"/>
+                </a:solidFill>
+                <a:latin typeface="Calibri"/>
+              </a:rPr>
+              <a:t>Específico 3: dejar el modelo servido en un tablero con predicción en vivo.</a:t>
+            </a:r>
+          </a:p>
+        </p:txBody>
+      </p:sp>
+      <p:sp>
+        <p:nvSpPr>
+          <p:cNvPr id="28" name="Rectangle 27"/>
+          <p:cNvSpPr/>
+          <p:nvPr/>
+        </p:nvSpPr>
+        <p:spPr>
+          <a:xfrm>
+            <a:off x="468000" y="4842000"/>
+            <a:ext cx="8243999" cy="14400"/>
+          </a:xfrm>
+          <a:prstGeom prst="rect">
+            <a:avLst/>
+          </a:prstGeom>
+          <a:solidFill>
+            <a:srgbClr val="DDD5C0"/>
+          </a:solidFill>
+          <a:ln>
+            <a:noFill/>
+          </a:ln>
+          <a:effectLst/>
+        </p:spPr>
+        <p:style>
+          <a:lnRef idx="1">
+            <a:schemeClr val="accent1"/>
+          </a:lnRef>
+          <a:fillRef idx="3">
+            <a:schemeClr val="accent1"/>
+          </a:fillRef>
+          <a:effectRef idx="2">
+            <a:schemeClr val="accent1"/>
+          </a:effectRef>
+          <a:fontRef idx="minor">
+            <a:schemeClr val="lt1"/>
+          </a:fontRef>
+        </p:style>
+        <p:txBody>
+          <a:bodyPr rtlCol="0" anchor="ctr" wrap="square"/>
+          <a:lstStyle/>
+          <a:p>
+            <a:pPr algn="ctr"/>
+          </a:p>
+        </p:txBody>
+      </p:sp>
+      <p:sp>
+        <p:nvSpPr>
+          <p:cNvPr id="29" name="TextBox 28"/>
+          <p:cNvSpPr txBox="1"/>
+          <p:nvPr/>
+        </p:nvSpPr>
+        <p:spPr>
+          <a:xfrm>
+            <a:off x="468000" y="4896000"/>
+            <a:ext cx="5940000" cy="180000"/>
+          </a:xfrm>
+          <a:prstGeom prst="rect">
+            <a:avLst/>
+          </a:prstGeom>
+          <a:noFill/>
+        </p:spPr>
+        <p:txBody>
+          <a:bodyPr wrap="square" lIns="0" rIns="0" tIns="0" bIns="0" anchor="t">
+            <a:spAutoFit/>
+          </a:bodyPr>
+          <a:lstStyle/>
+          <a:p>
+            <a:pPr algn="l"/>
+            <a:r>
+              <a:rPr sz="850" b="0">
+                <a:solidFill>
+                  <a:srgbClr val="8C8C8C"/>
+                </a:solidFill>
+                <a:latin typeface="Calibri"/>
+              </a:rPr>
+              <a:t>Fuente: libro, introducción y literatura; capítulo 4 (modelo base): data/modelos/metricas.csv</a:t>
+            </a:r>
+          </a:p>
+        </p:txBody>
+      </p:sp>
+      <p:sp>
+        <p:nvSpPr>
+          <p:cNvPr id="30" name="TextBox 29"/>
+          <p:cNvSpPr txBox="1"/>
+          <p:nvPr/>
+        </p:nvSpPr>
+        <p:spPr>
+          <a:xfrm>
+            <a:off x="6408000" y="4896000"/>
+            <a:ext cx="2304000" cy="180000"/>
+          </a:xfrm>
+          <a:prstGeom prst="rect">
+            <a:avLst/>
+          </a:prstGeom>
+          <a:noFill/>
+        </p:spPr>
+        <p:txBody>
+          <a:bodyPr wrap="square" lIns="0" rIns="0" tIns="0" bIns="0" anchor="t">
+            <a:spAutoFit/>
+          </a:bodyPr>
+          <a:lstStyle/>
+          <a:p>
+            <a:pPr algn="r"/>
+            <a:r>
+              <a:rPr sz="850" b="0">
+                <a:solidFill>
+                  <a:srgbClr val="8C8C8C"/>
+                </a:solidFill>
+                <a:latin typeface="Calibri"/>
+              </a:rPr>
+              <a:t>2 / 21</a:t>
+            </a:r>
+          </a:p>
+        </p:txBody>
+      </p:sp>
+    </p:spTree>
+  </p:cSld>
+  <p:clrMapOvr>
+    <a:masterClrMapping/>
+  </p:clrMapOvr>
+</p:sld>
+</file>
+
+<file path=ppt/slides/slide20.xml><?xml version="1.0" encoding="utf-8"?>
+<p:sld xmlns:a="http://schemas.openxmlformats.org/drawingml/2006/main" xmlns:p="http://schemas.openxmlformats.org/presentationml/2006/main" xmlns:r="http://schemas.openxmlformats.org/officeDocument/2006/relationships">
+  <p:cSld>
+    <p:bg>
+      <p:bgPr>
+        <a:solidFill>
+          <a:srgbClr val="FFFFFF"/>
+        </a:solidFill>
+        <a:effectLst/>
+      </p:bgPr>
+    </p:bg>
+    <p:spTree>
+      <p:nvGrpSpPr>
+        <p:cNvPr id="1" name=""/>
+        <p:cNvGrpSpPr/>
+        <p:nvPr/>
+      </p:nvGrpSpPr>
+      <p:grpSpPr/>
+      <p:sp>
+        <p:nvSpPr>
+          <p:cNvPr id="2" name="Rectangle 1"/>
+          <p:cNvSpPr/>
+          <p:nvPr/>
+        </p:nvSpPr>
+        <p:spPr>
+          <a:xfrm>
+            <a:off x="0" y="0"/>
+            <a:ext cx="9144000" cy="576000"/>
+          </a:xfrm>
+          <a:prstGeom prst="rect">
+            <a:avLst/>
+          </a:prstGeom>
+          <a:solidFill>
+            <a:srgbClr val="405731"/>
+          </a:solidFill>
+          <a:ln>
+            <a:noFill/>
+          </a:ln>
+          <a:effectLst/>
+        </p:spPr>
+        <p:style>
+          <a:lnRef idx="1">
+            <a:schemeClr val="accent1"/>
+          </a:lnRef>
+          <a:fillRef idx="3">
+            <a:schemeClr val="accent1"/>
+          </a:fillRef>
+          <a:effectRef idx="2">
+            <a:schemeClr val="accent1"/>
+          </a:effectRef>
+          <a:fontRef idx="minor">
+            <a:schemeClr val="lt1"/>
+          </a:fontRef>
+        </p:style>
+        <p:txBody>
+          <a:bodyPr rtlCol="0" anchor="ctr" wrap="square"/>
+          <a:lstStyle/>
+          <a:p>
+            <a:pPr algn="ctr"/>
+          </a:p>
+        </p:txBody>
+      </p:sp>
+      <p:sp>
+        <p:nvSpPr>
+          <p:cNvPr id="3" name="Rectangle 2"/>
+          <p:cNvSpPr/>
+          <p:nvPr/>
+        </p:nvSpPr>
+        <p:spPr>
+          <a:xfrm>
+            <a:off x="0" y="576000"/>
+            <a:ext cx="9144000" cy="36000"/>
+          </a:xfrm>
+          <a:prstGeom prst="rect">
+            <a:avLst/>
+          </a:prstGeom>
+          <a:solidFill>
+            <a:srgbClr val="B08A2D"/>
+          </a:solidFill>
+          <a:ln>
+            <a:noFill/>
+          </a:ln>
+          <a:effectLst/>
+        </p:spPr>
+        <p:style>
+          <a:lnRef idx="1">
+            <a:schemeClr val="accent1"/>
+          </a:lnRef>
+          <a:fillRef idx="3">
+            <a:schemeClr val="accent1"/>
+          </a:fillRef>
+          <a:effectRef idx="2">
+            <a:schemeClr val="accent1"/>
+          </a:effectRef>
+          <a:fontRef idx="minor">
+            <a:schemeClr val="lt1"/>
+          </a:fontRef>
+        </p:style>
+        <p:txBody>
+          <a:bodyPr rtlCol="0" anchor="ctr" wrap="square"/>
+          <a:lstStyle/>
+          <a:p>
+            <a:pPr algn="ctr"/>
+          </a:p>
+        </p:txBody>
+      </p:sp>
+      <p:sp>
+        <p:nvSpPr>
+          <p:cNvPr id="4" name="Rectangle 3"/>
+          <p:cNvSpPr/>
+          <p:nvPr/>
+        </p:nvSpPr>
+        <p:spPr>
+          <a:xfrm>
+            <a:off x="144000" y="72000"/>
+            <a:ext cx="468000" cy="432000"/>
+          </a:xfrm>
+          <a:prstGeom prst="rect">
+            <a:avLst/>
+          </a:prstGeom>
+          <a:solidFill>
+            <a:srgbClr val="FFFFFF"/>
+          </a:solidFill>
+          <a:ln>
+            <a:noFill/>
+          </a:ln>
+          <a:effectLst/>
+        </p:spPr>
+        <p:style>
+          <a:lnRef idx="1">
+            <a:schemeClr val="accent1"/>
+          </a:lnRef>
+          <a:fillRef idx="3">
+            <a:schemeClr val="accent1"/>
+          </a:fillRef>
+          <a:effectRef idx="2">
+            <a:schemeClr val="accent1"/>
+          </a:effectRef>
+          <a:fontRef idx="minor">
+            <a:schemeClr val="lt1"/>
+          </a:fontRef>
+        </p:style>
+        <p:txBody>
+          <a:bodyPr rtlCol="0" anchor="ctr" wrap="square"/>
+          <a:lstStyle/>
+          <a:p>
+            <a:pPr algn="ctr"/>
+          </a:p>
+        </p:txBody>
+      </p:sp>
+      <p:pic>
+        <p:nvPicPr>
+          <p:cNvPr id="5" name="Picture 4" descr="logo.png"/>
+          <p:cNvPicPr>
+            <a:picLocks noChangeAspect="1"/>
+          </p:cNvPicPr>
+          <p:nvPr/>
+        </p:nvPicPr>
+        <p:blipFill>
+          <a:blip r:embed="rId2"/>
+          <a:stretch>
+            <a:fillRect/>
+          </a:stretch>
+        </p:blipFill>
+        <p:spPr>
+          <a:xfrm>
+            <a:off x="200160" y="145440"/>
+            <a:ext cx="355680" cy="266417"/>
+          </a:xfrm>
+          <a:prstGeom prst="rect">
+            <a:avLst/>
+          </a:prstGeom>
+        </p:spPr>
+      </p:pic>
+      <p:sp>
+        <p:nvSpPr>
+          <p:cNvPr id="6" name="TextBox 5"/>
+          <p:cNvSpPr txBox="1"/>
+          <p:nvPr/>
+        </p:nvSpPr>
+        <p:spPr>
+          <a:xfrm>
+            <a:off x="792000" y="125999"/>
+            <a:ext cx="8172000" cy="360000"/>
+          </a:xfrm>
+          <a:prstGeom prst="rect">
+            <a:avLst/>
+          </a:prstGeom>
+          <a:noFill/>
+        </p:spPr>
+        <p:txBody>
+          <a:bodyPr wrap="square" lIns="0" rIns="0" tIns="0" bIns="0" anchor="ctr">
+            <a:spAutoFit/>
+          </a:bodyPr>
+          <a:lstStyle/>
+          <a:p>
+            <a:pPr algn="l"/>
+            <a:r>
+              <a:rPr sz="2000" b="1">
+                <a:solidFill>
+                  <a:srgbClr val="FFFFFF"/>
+                </a:solidFill>
+                <a:latin typeface="Calibri"/>
+              </a:rPr>
+              <a:t>El retraso se puede anticipar el día de la liberación</a:t>
+            </a:r>
+          </a:p>
+        </p:txBody>
+      </p:sp>
+      <p:sp>
+        <p:nvSpPr>
+          <p:cNvPr id="7" name="TextBox 6"/>
+          <p:cNvSpPr txBox="1"/>
+          <p:nvPr/>
+        </p:nvSpPr>
+        <p:spPr>
+          <a:xfrm>
+            <a:off x="468000" y="756000"/>
+            <a:ext cx="7308000" cy="251999"/>
+          </a:xfrm>
+          <a:prstGeom prst="rect">
+            <a:avLst/>
+          </a:prstGeom>
+          <a:noFill/>
+        </p:spPr>
+        <p:txBody>
+          <a:bodyPr wrap="square" lIns="0" rIns="0" tIns="0" bIns="0" anchor="t">
+            <a:spAutoFit/>
+          </a:bodyPr>
+          <a:lstStyle/>
+          <a:p>
+            <a:pPr algn="l"/>
+            <a:r>
+              <a:rPr sz="1200" b="1">
+                <a:solidFill>
+                  <a:srgbClr val="B08A2D"/>
+                </a:solidFill>
+                <a:latin typeface="Calibri"/>
+              </a:rPr>
+              <a:t>CRITERIO 6  ·  CONCLUSIONES</a:t>
+            </a:r>
+          </a:p>
+        </p:txBody>
+      </p:sp>
+      <p:sp>
+        <p:nvSpPr>
+          <p:cNvPr id="8" name="Rectangle 7"/>
+          <p:cNvSpPr/>
+          <p:nvPr/>
+        </p:nvSpPr>
+        <p:spPr>
+          <a:xfrm>
+            <a:off x="468000" y="1044000"/>
+            <a:ext cx="468000" cy="36000"/>
+          </a:xfrm>
+          <a:prstGeom prst="rect">
+            <a:avLst/>
+          </a:prstGeom>
+          <a:solidFill>
+            <a:srgbClr val="B08A2D"/>
+          </a:solidFill>
+          <a:ln>
+            <a:noFill/>
+          </a:ln>
+          <a:effectLst/>
+        </p:spPr>
+        <p:style>
+          <a:lnRef idx="1">
+            <a:schemeClr val="accent1"/>
+          </a:lnRef>
+          <a:fillRef idx="3">
+            <a:schemeClr val="accent1"/>
+          </a:fillRef>
+          <a:effectRef idx="2">
+            <a:schemeClr val="accent1"/>
+          </a:effectRef>
+          <a:fontRef idx="minor">
+            <a:schemeClr val="lt1"/>
+          </a:fontRef>
+        </p:style>
+        <p:txBody>
+          <a:bodyPr rtlCol="0" anchor="ctr" wrap="square"/>
+          <a:lstStyle/>
+          <a:p>
+            <a:pPr algn="ctr"/>
+          </a:p>
+        </p:txBody>
+      </p:sp>
+      <p:sp>
+        <p:nvSpPr>
+          <p:cNvPr id="9" name="Rectangle 8"/>
+          <p:cNvSpPr/>
+          <p:nvPr/>
+        </p:nvSpPr>
+        <p:spPr>
+          <a:xfrm>
+            <a:off x="468000" y="1281600"/>
+            <a:ext cx="72000" cy="72000"/>
+          </a:xfrm>
+          <a:prstGeom prst="rect">
+            <a:avLst/>
+          </a:prstGeom>
+          <a:solidFill>
+            <a:srgbClr val="405731"/>
+          </a:solidFill>
+          <a:ln>
+            <a:noFill/>
+          </a:ln>
+          <a:effectLst/>
+        </p:spPr>
+        <p:style>
+          <a:lnRef idx="1">
+            <a:schemeClr val="accent1"/>
+          </a:lnRef>
+          <a:fillRef idx="3">
+            <a:schemeClr val="accent1"/>
+          </a:fillRef>
+          <a:effectRef idx="2">
+            <a:schemeClr val="accent1"/>
+          </a:effectRef>
+          <a:fontRef idx="minor">
+            <a:schemeClr val="lt1"/>
+          </a:fontRef>
+        </p:style>
+        <p:txBody>
+          <a:bodyPr rtlCol="0" anchor="ctr" wrap="square"/>
+          <a:lstStyle/>
+          <a:p>
+            <a:pPr algn="ctr"/>
+          </a:p>
+        </p:txBody>
+      </p:sp>
+      <p:sp>
+        <p:nvSpPr>
+          <p:cNvPr id="10" name="TextBox 9"/>
+          <p:cNvSpPr txBox="1"/>
+          <p:nvPr/>
+        </p:nvSpPr>
+        <p:spPr>
+          <a:xfrm>
+            <a:off x="684000" y="1224000"/>
+            <a:ext cx="4608000" cy="648000"/>
+          </a:xfrm>
+          <a:prstGeom prst="rect">
+            <a:avLst/>
+          </a:prstGeom>
+          <a:noFill/>
+        </p:spPr>
+        <p:txBody>
+          <a:bodyPr wrap="square" lIns="0" rIns="0" tIns="0" bIns="0" anchor="t">
+            <a:spAutoFit/>
+          </a:bodyPr>
+          <a:lstStyle/>
+          <a:p>
+            <a:pPr algn="l"/>
+            <a:r>
+              <a:rPr sz="1150" b="0">
+                <a:solidFill>
+                  <a:srgbClr val="1A1A1A"/>
+                </a:solidFill>
+                <a:latin typeface="Calibri"/>
+              </a:rPr>
+              <a:t>Se puede ordenar por riesgo al liberar: AUC 0,852 medido hacia adelante en el tiempo, contra 0,670 de la regla del proveedor en 2026.</a:t>
+            </a:r>
+          </a:p>
+        </p:txBody>
+      </p:sp>
+      <p:sp>
+        <p:nvSpPr>
+          <p:cNvPr id="11" name="Rectangle 10"/>
+          <p:cNvSpPr/>
+          <p:nvPr/>
+        </p:nvSpPr>
+        <p:spPr>
+          <a:xfrm>
+            <a:off x="468000" y="1965600"/>
+            <a:ext cx="72000" cy="72000"/>
+          </a:xfrm>
+          <a:prstGeom prst="rect">
+            <a:avLst/>
+          </a:prstGeom>
+          <a:solidFill>
+            <a:srgbClr val="405731"/>
+          </a:solidFill>
+          <a:ln>
+            <a:noFill/>
+          </a:ln>
+          <a:effectLst/>
+        </p:spPr>
+        <p:style>
+          <a:lnRef idx="1">
+            <a:schemeClr val="accent1"/>
+          </a:lnRef>
+          <a:fillRef idx="3">
+            <a:schemeClr val="accent1"/>
+          </a:fillRef>
+          <a:effectRef idx="2">
+            <a:schemeClr val="accent1"/>
+          </a:effectRef>
+          <a:fontRef idx="minor">
+            <a:schemeClr val="lt1"/>
+          </a:fontRef>
+        </p:style>
+        <p:txBody>
+          <a:bodyPr rtlCol="0" anchor="ctr" wrap="square"/>
+          <a:lstStyle/>
+          <a:p>
+            <a:pPr algn="ctr"/>
+          </a:p>
+        </p:txBody>
+      </p:sp>
+      <p:sp>
+        <p:nvSpPr>
+          <p:cNvPr id="12" name="TextBox 11"/>
+          <p:cNvSpPr txBox="1"/>
+          <p:nvPr/>
+        </p:nvSpPr>
+        <p:spPr>
+          <a:xfrm>
+            <a:off x="684000" y="1908000"/>
+            <a:ext cx="4608000" cy="648000"/>
+          </a:xfrm>
+          <a:prstGeom prst="rect">
+            <a:avLst/>
+          </a:prstGeom>
+          <a:noFill/>
+        </p:spPr>
+        <p:txBody>
+          <a:bodyPr wrap="square" lIns="0" rIns="0" tIns="0" bIns="0" anchor="t">
+            <a:spAutoFit/>
+          </a:bodyPr>
+          <a:lstStyle/>
+          <a:p>
+            <a:pPr algn="l"/>
+            <a:r>
+              <a:rPr sz="1150" b="0">
+                <a:solidFill>
+                  <a:srgbClr val="1A1A1A"/>
+                </a:solidFill>
+                <a:latin typeface="Calibri"/>
+              </a:rPr>
+              <a:t>La señal está en el plazo, el historial del proveedor y las entidades; ninguna variable sola basta.</a:t>
+            </a:r>
+          </a:p>
+        </p:txBody>
+      </p:sp>
+      <p:sp>
+        <p:nvSpPr>
+          <p:cNvPr id="13" name="Rectangle 12"/>
+          <p:cNvSpPr/>
+          <p:nvPr/>
+        </p:nvSpPr>
+        <p:spPr>
+          <a:xfrm>
+            <a:off x="468000" y="2649600"/>
+            <a:ext cx="72000" cy="72000"/>
+          </a:xfrm>
+          <a:prstGeom prst="rect">
+            <a:avLst/>
+          </a:prstGeom>
+          <a:solidFill>
+            <a:srgbClr val="405731"/>
+          </a:solidFill>
+          <a:ln>
+            <a:noFill/>
+          </a:ln>
+          <a:effectLst/>
+        </p:spPr>
+        <p:style>
+          <a:lnRef idx="1">
+            <a:schemeClr val="accent1"/>
+          </a:lnRef>
+          <a:fillRef idx="3">
+            <a:schemeClr val="accent1"/>
+          </a:fillRef>
+          <a:effectRef idx="2">
+            <a:schemeClr val="accent1"/>
+          </a:effectRef>
+          <a:fontRef idx="minor">
+            <a:schemeClr val="lt1"/>
+          </a:fontRef>
+        </p:style>
+        <p:txBody>
+          <a:bodyPr rtlCol="0" anchor="ctr" wrap="square"/>
+          <a:lstStyle/>
+          <a:p>
+            <a:pPr algn="ctr"/>
+          </a:p>
+        </p:txBody>
+      </p:sp>
+      <p:sp>
+        <p:nvSpPr>
+          <p:cNvPr id="14" name="TextBox 13"/>
+          <p:cNvSpPr txBox="1"/>
+          <p:nvPr/>
+        </p:nvSpPr>
+        <p:spPr>
+          <a:xfrm>
+            <a:off x="684000" y="2591999"/>
+            <a:ext cx="4608000" cy="648000"/>
+          </a:xfrm>
+          <a:prstGeom prst="rect">
+            <a:avLst/>
+          </a:prstGeom>
+          <a:noFill/>
+        </p:spPr>
+        <p:txBody>
+          <a:bodyPr wrap="square" lIns="0" rIns="0" tIns="0" bIns="0" anchor="t">
+            <a:spAutoFit/>
+          </a:bodyPr>
+          <a:lstStyle/>
+          <a:p>
+            <a:pPr algn="l"/>
+            <a:r>
+              <a:rPr sz="1150" b="0">
+                <a:solidFill>
+                  <a:srgbClr val="1A1A1A"/>
+                </a:solidFill>
+                <a:latin typeface="Calibri"/>
+              </a:rPr>
+              <a:t>XGBoost gana de forma significativa y material: en 2026, AUC 0,848 contra 0,825 de la logística, y más tardías atrapadas con las mismas alertas.</a:t>
             </a:r>
           </a:p>
         </p:txBody>
@@ -16941,7 +19128,7 @@
                           </a:solidFill>
                           <a:latin typeface="Calibri"/>
                         </a:rPr>
-                        <a:t>pendiente: 2026</a:t>
+                        <a:t>AUC 0,82 contra 0,86</a:t>
                       </a:r>
                     </a:p>
                   </a:txBody>
@@ -16989,7 +19176,7 @@
                           </a:solidFill>
                           <a:latin typeface="Calibri"/>
                         </a:rPr>
-                        <a:t>sí, el modelo base</a:t>
+                        <a:t>sí, XGBoost</a:t>
                       </a:r>
                     </a:p>
                   </a:txBody>
@@ -17086,7 +19273,7 @@
                 </a:solidFill>
                 <a:latin typeface="Calibri"/>
               </a:rPr>
-              <a:t>marcando el 38 % de las posiciones, el modelo base ve venir el 71 % de las tardías de 2026. El comprador puede concentrar el seguimiento en un tercio de las órdenes.</a:t>
+              <a:t>marcando el 33 % de las posiciones, XGBoost ve venir el 69 % de las tardías de 2026. El comprador puede concentrar el seguimiento en un tercio de las órdenes.</a:t>
             </a:r>
           </a:p>
         </p:txBody>
@@ -17165,7 +19352,7 @@
                 </a:solidFill>
                 <a:latin typeface="Calibri"/>
               </a:rPr>
-              <a:t>Fuente: libro, capítulos 2 a 7</a:t>
+              <a:t>Fuente: libro, capítulos 2 a 9</a:t>
             </a:r>
           </a:p>
         </p:txBody>
@@ -17200,7 +19387,7 @@
                 </a:solidFill>
                 <a:latin typeface="Calibri"/>
               </a:rPr>
-              <a:t>19 / 20</a:t>
+              <a:t>20 / 21</a:t>
             </a:r>
           </a:p>
         </p:txBody>
@@ -17213,7 +19400,7 @@
 </p:sld>
 </file>
 
-<file path=ppt/slides/slide2.xml><?xml version="1.0" encoding="utf-8"?>
+<file path=ppt/slides/slide21.xml><?xml version="1.0" encoding="utf-8"?>
 <p:sld xmlns:a="http://schemas.openxmlformats.org/drawingml/2006/main" xmlns:p="http://schemas.openxmlformats.org/presentationml/2006/main" xmlns:r="http://schemas.openxmlformats.org/officeDocument/2006/relationships">
   <p:cSld>
     <p:bg>
@@ -17417,7 +19604,7 @@
                 </a:solidFill>
                 <a:latin typeface="Calibri"/>
               </a:rPr>
-              <a:t>Uno de cada tres pedidos llega tarde, y se sabe cuando ya pasó</a:t>
+              <a:t>Límites: deriva, etiqueta que madura y una sola empresa</a:t>
             </a:r>
           </a:p>
         </p:txBody>
@@ -17452,7 +19639,7 @@
                 </a:solidFill>
                 <a:latin typeface="Calibri"/>
               </a:rPr>
-              <a:t>CRITERIO 1  ·  EL PROBLEMA</a:t>
+              <a:t>CRITERIO 6  ·  LIMITACIONES Y MEJORAS</a:t>
             </a:r>
           </a:p>
         </p:txBody>
@@ -17509,8 +19696,8 @@
         </p:nvSpPr>
         <p:spPr>
           <a:xfrm>
-            <a:off x="468000" y="1224000"/>
-            <a:ext cx="1944000" cy="972000"/>
+            <a:off x="468000" y="1188000"/>
+            <a:ext cx="2664000" cy="3528000"/>
           </a:xfrm>
           <a:prstGeom prst="rect">
             <a:avLst/>
@@ -17547,58 +19734,14 @@
       </p:sp>
       <p:sp>
         <p:nvSpPr>
-          <p:cNvPr id="10" name="Rectangle 9"/>
-          <p:cNvSpPr/>
-          <p:nvPr/>
-        </p:nvSpPr>
-        <p:spPr>
-          <a:xfrm>
-            <a:off x="558000" y="1224000"/>
-            <a:ext cx="1764000" cy="36000"/>
-          </a:xfrm>
-          <a:prstGeom prst="rect">
-            <a:avLst/>
-          </a:prstGeom>
-          <a:solidFill>
-            <a:srgbClr val="B08A2D"/>
-          </a:solidFill>
-          <a:ln>
-            <a:noFill/>
-          </a:ln>
-          <a:effectLst/>
-        </p:spPr>
-        <p:style>
-          <a:lnRef idx="1">
-            <a:schemeClr val="accent1"/>
-          </a:lnRef>
-          <a:fillRef idx="3">
-            <a:schemeClr val="accent1"/>
-          </a:fillRef>
-          <a:effectRef idx="2">
-            <a:schemeClr val="accent1"/>
-          </a:effectRef>
-          <a:fontRef idx="minor">
-            <a:schemeClr val="lt1"/>
-          </a:fontRef>
-        </p:style>
-        <p:txBody>
-          <a:bodyPr rtlCol="0" anchor="ctr" wrap="square"/>
-          <a:lstStyle/>
-          <a:p>
-            <a:pPr algn="ctr"/>
-          </a:p>
-        </p:txBody>
-      </p:sp>
-      <p:sp>
-        <p:nvSpPr>
-          <p:cNvPr id="11" name="TextBox 10"/>
+          <p:cNvPr id="10" name="TextBox 9"/>
           <p:cNvSpPr txBox="1"/>
           <p:nvPr/>
         </p:nvSpPr>
         <p:spPr>
           <a:xfrm>
-            <a:off x="468000" y="1350000"/>
-            <a:ext cx="1944000" cy="468000"/>
+            <a:off x="630000" y="1295999"/>
+            <a:ext cx="2340000" cy="288000"/>
           </a:xfrm>
           <a:prstGeom prst="rect">
             <a:avLst/>
@@ -17611,29 +19754,29 @@
           </a:bodyPr>
           <a:lstStyle/>
           <a:p>
-            <a:pPr algn="ctr"/>
-            <a:r>
-              <a:rPr sz="3400" b="1">
+            <a:pPr algn="l"/>
+            <a:r>
+              <a:rPr sz="1250" b="1">
                 <a:solidFill>
                   <a:srgbClr val="405731"/>
                 </a:solidFill>
                 <a:latin typeface="Calibri"/>
               </a:rPr>
-              <a:t>33,0 %</a:t>
-            </a:r>
-          </a:p>
-        </p:txBody>
-      </p:sp>
-      <p:sp>
-        <p:nvSpPr>
-          <p:cNvPr id="12" name="TextBox 11"/>
+              <a:t>Teóricas</a:t>
+            </a:r>
+          </a:p>
+        </p:txBody>
+      </p:sp>
+      <p:sp>
+        <p:nvSpPr>
+          <p:cNvPr id="11" name="TextBox 10"/>
           <p:cNvSpPr txBox="1"/>
           <p:nvPr/>
         </p:nvSpPr>
         <p:spPr>
           <a:xfrm>
-            <a:off x="468000" y="1854000"/>
-            <a:ext cx="1944000" cy="288000"/>
+            <a:off x="630000" y="1555200"/>
+            <a:ext cx="2340000" cy="3114000"/>
           </a:xfrm>
           <a:prstGeom prst="rect">
             <a:avLst/>
@@ -17646,29 +19789,53 @@
           </a:bodyPr>
           <a:lstStyle/>
           <a:p>
-            <a:pPr algn="ctr"/>
+            <a:pPr algn="l"/>
             <a:r>
               <a:rPr sz="1050" b="0">
                 <a:solidFill>
-                  <a:srgbClr val="5A5A5A"/>
+                  <a:srgbClr val="1A1A1A"/>
                 </a:solidFill>
                 <a:latin typeface="Calibri"/>
               </a:rPr>
-              <a:t>de las posiciones llega tarde</a:t>
-            </a:r>
-          </a:p>
-        </p:txBody>
-      </p:sp>
-      <p:sp>
-        <p:nvSpPr>
-          <p:cNvPr id="13" name="Rectangle 12"/>
+              <a:t>Independencia dado x: las posiciones de una orden se parecen; se protege agrupando, no se modela.</a:t>
+            </a:r>
+          </a:p>
+          <a:p>
+            <a:pPr algn="l"/>
+            <a:r>
+              <a:rPr sz="1050" b="0">
+                <a:solidFill>
+                  <a:srgbClr val="1A1A1A"/>
+                </a:solidFill>
+                <a:latin typeface="Calibri"/>
+              </a:rPr>
+              <a:t>Estabilidad: el modelo supone que la relación de 2021-2025 vale en 2026.</a:t>
+            </a:r>
+          </a:p>
+          <a:p>
+            <a:pPr algn="l"/>
+            <a:r>
+              <a:rPr sz="1050" b="0">
+                <a:solidFill>
+                  <a:srgbClr val="1A1A1A"/>
+                </a:solidFill>
+                <a:latin typeface="Calibri"/>
+              </a:rPr>
+              <a:t>Una sola etiqueta binaria desperdicia los días de retraso.</a:t>
+            </a:r>
+          </a:p>
+        </p:txBody>
+      </p:sp>
+      <p:sp>
+        <p:nvSpPr>
+          <p:cNvPr id="12" name="Rectangle 11"/>
           <p:cNvSpPr/>
           <p:nvPr/>
         </p:nvSpPr>
         <p:spPr>
           <a:xfrm>
-            <a:off x="468000" y="2304000"/>
-            <a:ext cx="1944000" cy="972000"/>
+            <a:off x="3240000" y="1188000"/>
+            <a:ext cx="2664000" cy="3528000"/>
           </a:xfrm>
           <a:prstGeom prst="rect">
             <a:avLst/>
@@ -17705,58 +19872,14 @@
       </p:sp>
       <p:sp>
         <p:nvSpPr>
-          <p:cNvPr id="14" name="Rectangle 13"/>
-          <p:cNvSpPr/>
-          <p:nvPr/>
-        </p:nvSpPr>
-        <p:spPr>
-          <a:xfrm>
-            <a:off x="558000" y="2304000"/>
-            <a:ext cx="1764000" cy="36000"/>
-          </a:xfrm>
-          <a:prstGeom prst="rect">
-            <a:avLst/>
-          </a:prstGeom>
-          <a:solidFill>
-            <a:srgbClr val="B08A2D"/>
-          </a:solidFill>
-          <a:ln>
-            <a:noFill/>
-          </a:ln>
-          <a:effectLst/>
-        </p:spPr>
-        <p:style>
-          <a:lnRef idx="1">
-            <a:schemeClr val="accent1"/>
-          </a:lnRef>
-          <a:fillRef idx="3">
-            <a:schemeClr val="accent1"/>
-          </a:fillRef>
-          <a:effectRef idx="2">
-            <a:schemeClr val="accent1"/>
-          </a:effectRef>
-          <a:fontRef idx="minor">
-            <a:schemeClr val="lt1"/>
-          </a:fontRef>
-        </p:style>
-        <p:txBody>
-          <a:bodyPr rtlCol="0" anchor="ctr" wrap="square"/>
-          <a:lstStyle/>
-          <a:p>
-            <a:pPr algn="ctr"/>
-          </a:p>
-        </p:txBody>
-      </p:sp>
-      <p:sp>
-        <p:nvSpPr>
-          <p:cNvPr id="15" name="TextBox 14"/>
+          <p:cNvPr id="13" name="TextBox 12"/>
           <p:cNvSpPr txBox="1"/>
           <p:nvPr/>
         </p:nvSpPr>
         <p:spPr>
           <a:xfrm>
-            <a:off x="468000" y="2430000"/>
-            <a:ext cx="1944000" cy="468000"/>
+            <a:off x="3401999" y="1295999"/>
+            <a:ext cx="2340000" cy="288000"/>
           </a:xfrm>
           <a:prstGeom prst="rect">
             <a:avLst/>
@@ -17769,29 +19892,29 @@
           </a:bodyPr>
           <a:lstStyle/>
           <a:p>
-            <a:pPr algn="ctr"/>
-            <a:r>
-              <a:rPr sz="3400" b="1">
+            <a:pPr algn="l"/>
+            <a:r>
+              <a:rPr sz="1250" b="1">
                 <a:solidFill>
                   <a:srgbClr val="405731"/>
                 </a:solidFill>
                 <a:latin typeface="Calibri"/>
               </a:rPr>
-              <a:t>41 %</a:t>
-            </a:r>
-          </a:p>
-        </p:txBody>
-      </p:sp>
-      <p:sp>
-        <p:nvSpPr>
-          <p:cNvPr id="16" name="TextBox 15"/>
+              <a:t>Empíricas</a:t>
+            </a:r>
+          </a:p>
+        </p:txBody>
+      </p:sp>
+      <p:sp>
+        <p:nvSpPr>
+          <p:cNvPr id="14" name="TextBox 13"/>
           <p:cNvSpPr txBox="1"/>
           <p:nvPr/>
         </p:nvSpPr>
         <p:spPr>
           <a:xfrm>
-            <a:off x="468000" y="2934000"/>
-            <a:ext cx="1944000" cy="288000"/>
+            <a:off x="3401999" y="1555200"/>
+            <a:ext cx="2340000" cy="3114000"/>
           </a:xfrm>
           <a:prstGeom prst="rect">
             <a:avLst/>
@@ -17804,29 +19927,77 @@
           </a:bodyPr>
           <a:lstStyle/>
           <a:p>
-            <a:pPr algn="ctr"/>
+            <a:pPr algn="l"/>
             <a:r>
               <a:rPr sz="1050" b="0">
                 <a:solidFill>
-                  <a:srgbClr val="5A5A5A"/>
+                  <a:srgbClr val="1A1A1A"/>
                 </a:solidFill>
                 <a:latin typeface="Calibri"/>
               </a:rPr>
-              <a:t>en industrial; 25 % en ganaderia</a:t>
-            </a:r>
-          </a:p>
-        </p:txBody>
-      </p:sp>
-      <p:sp>
-        <p:nvSpPr>
-          <p:cNvPr id="17" name="Rectangle 16"/>
+              <a:t>Deriva: 2025 se distingue de 2021-2024 casi por completo.</a:t>
+            </a:r>
+          </a:p>
+          <a:p>
+            <a:pPr algn="l"/>
+            <a:r>
+              <a:rPr sz="1050" b="0">
+                <a:solidFill>
+                  <a:srgbClr val="1A1A1A"/>
+                </a:solidFill>
+                <a:latin typeface="Calibri"/>
+              </a:rPr>
+              <a:t>La etiqueta de lo más reciente madura tarde (censura al final del periodo).</a:t>
+            </a:r>
+          </a:p>
+          <a:p>
+            <a:pPr algn="l"/>
+            <a:r>
+              <a:rPr sz="1050" b="0">
+                <a:solidFill>
+                  <a:srgbClr val="1A1A1A"/>
+                </a:solidFill>
+                <a:latin typeface="Calibri"/>
+              </a:rPr>
+              <a:t>Maestros en foto actual, no con su vigencia histórica.</a:t>
+            </a:r>
+          </a:p>
+          <a:p>
+            <a:pPr algn="l"/>
+            <a:r>
+              <a:rPr sz="1050" b="0">
+                <a:solidFill>
+                  <a:srgbClr val="1A1A1A"/>
+                </a:solidFill>
+                <a:latin typeface="Calibri"/>
+              </a:rPr>
+              <a:t>Arranque en frío: 11,1 % de proveedores nuevos en 2026.</a:t>
+            </a:r>
+          </a:p>
+          <a:p>
+            <a:pPr algn="l"/>
+            <a:r>
+              <a:rPr sz="1050" b="0">
+                <a:solidFill>
+                  <a:srgbClr val="1A1A1A"/>
+                </a:solidFill>
+                <a:latin typeface="Calibri"/>
+              </a:rPr>
+              <a:t>Una sola empresa: la generalización a otros grupos no está probada.</a:t>
+            </a:r>
+          </a:p>
+        </p:txBody>
+      </p:sp>
+      <p:sp>
+        <p:nvSpPr>
+          <p:cNvPr id="15" name="Rectangle 14"/>
           <p:cNvSpPr/>
           <p:nvPr/>
         </p:nvSpPr>
         <p:spPr>
           <a:xfrm>
-            <a:off x="468000" y="3384000"/>
-            <a:ext cx="1944000" cy="972000"/>
+            <a:off x="6012000" y="1188000"/>
+            <a:ext cx="2700000" cy="3528000"/>
           </a:xfrm>
           <a:prstGeom prst="rect">
             <a:avLst/>
@@ -17863,58 +20034,14 @@
       </p:sp>
       <p:sp>
         <p:nvSpPr>
-          <p:cNvPr id="18" name="Rectangle 17"/>
-          <p:cNvSpPr/>
-          <p:nvPr/>
-        </p:nvSpPr>
-        <p:spPr>
-          <a:xfrm>
-            <a:off x="558000" y="3384000"/>
-            <a:ext cx="1764000" cy="36000"/>
-          </a:xfrm>
-          <a:prstGeom prst="rect">
-            <a:avLst/>
-          </a:prstGeom>
-          <a:solidFill>
-            <a:srgbClr val="B08A2D"/>
-          </a:solidFill>
-          <a:ln>
-            <a:noFill/>
-          </a:ln>
-          <a:effectLst/>
-        </p:spPr>
-        <p:style>
-          <a:lnRef idx="1">
-            <a:schemeClr val="accent1"/>
-          </a:lnRef>
-          <a:fillRef idx="3">
-            <a:schemeClr val="accent1"/>
-          </a:fillRef>
-          <a:effectRef idx="2">
-            <a:schemeClr val="accent1"/>
-          </a:effectRef>
-          <a:fontRef idx="minor">
-            <a:schemeClr val="lt1"/>
-          </a:fontRef>
-        </p:style>
-        <p:txBody>
-          <a:bodyPr rtlCol="0" anchor="ctr" wrap="square"/>
-          <a:lstStyle/>
-          <a:p>
-            <a:pPr algn="ctr"/>
-          </a:p>
-        </p:txBody>
-      </p:sp>
-      <p:sp>
-        <p:nvSpPr>
-          <p:cNvPr id="19" name="TextBox 18"/>
+          <p:cNvPr id="16" name="TextBox 15"/>
           <p:cNvSpPr txBox="1"/>
           <p:nvPr/>
         </p:nvSpPr>
         <p:spPr>
           <a:xfrm>
-            <a:off x="468000" y="3510000"/>
-            <a:ext cx="1944000" cy="468000"/>
+            <a:off x="6173999" y="1295999"/>
+            <a:ext cx="2376000" cy="288000"/>
           </a:xfrm>
           <a:prstGeom prst="rect">
             <a:avLst/>
@@ -17927,29 +20054,29 @@
           </a:bodyPr>
           <a:lstStyle/>
           <a:p>
-            <a:pPr algn="ctr"/>
-            <a:r>
-              <a:rPr sz="3400" b="1">
+            <a:pPr algn="l"/>
+            <a:r>
+              <a:rPr sz="1250" b="1">
                 <a:solidFill>
                   <a:srgbClr val="405731"/>
                 </a:solidFill>
                 <a:latin typeface="Calibri"/>
               </a:rPr>
-              <a:t>71 %</a:t>
-            </a:r>
-          </a:p>
-        </p:txBody>
-      </p:sp>
-      <p:sp>
-        <p:nvSpPr>
-          <p:cNvPr id="20" name="TextBox 19"/>
+              <a:t>Mejoras</a:t>
+            </a:r>
+          </a:p>
+        </p:txBody>
+      </p:sp>
+      <p:sp>
+        <p:nvSpPr>
+          <p:cNvPr id="17" name="TextBox 16"/>
           <p:cNvSpPr txBox="1"/>
           <p:nvPr/>
         </p:nvSpPr>
         <p:spPr>
           <a:xfrm>
-            <a:off x="468000" y="4014000"/>
-            <a:ext cx="1944000" cy="288000"/>
+            <a:off x="6173999" y="1555200"/>
+            <a:ext cx="2376000" cy="3114000"/>
           </a:xfrm>
           <a:prstGeom prst="rect">
             <a:avLst/>
@@ -17962,328 +20089,58 @@
           </a:bodyPr>
           <a:lstStyle/>
           <a:p>
-            <a:pPr algn="ctr"/>
+            <a:pPr algn="l"/>
             <a:r>
               <a:rPr sz="1050" b="0">
                 <a:solidFill>
-                  <a:srgbClr val="5A5A5A"/>
+                  <a:srgbClr val="1A1A1A"/>
                 </a:solidFill>
                 <a:latin typeface="Calibri"/>
               </a:rPr>
-              <a:t>de las tardías de 2026, marcando el 38 %</a:t>
-            </a:r>
-          </a:p>
-        </p:txBody>
-      </p:sp>
-      <p:sp>
-        <p:nvSpPr>
-          <p:cNvPr id="21" name="TextBox 20"/>
-          <p:cNvSpPr txBox="1"/>
-          <p:nvPr/>
-        </p:nvSpPr>
-        <p:spPr>
-          <a:xfrm>
-            <a:off x="2736000" y="1188000"/>
-            <a:ext cx="3311999" cy="216000"/>
-          </a:xfrm>
-          <a:prstGeom prst="rect">
-            <a:avLst/>
-          </a:prstGeom>
-          <a:noFill/>
-        </p:spPr>
-        <p:txBody>
-          <a:bodyPr wrap="square" lIns="0" rIns="0" tIns="0" bIns="0" anchor="t">
-            <a:spAutoFit/>
-          </a:bodyPr>
-          <a:lstStyle/>
+              <a:t>Reentrenar por semestre y vigilar la deriva con la validación adversaria.</a:t>
+            </a:r>
+          </a:p>
           <a:p>
             <a:pPr algn="l"/>
             <a:r>
-              <a:rPr sz="1250" b="1">
-                <a:solidFill>
-                  <a:srgbClr val="405731"/>
+              <a:rPr sz="1050" b="0">
+                <a:solidFill>
+                  <a:srgbClr val="1A1A1A"/>
                 </a:solidFill>
                 <a:latin typeface="Calibri"/>
               </a:rPr>
-              <a:t>Por qué importa</a:t>
-            </a:r>
-          </a:p>
-        </p:txBody>
-      </p:sp>
-      <p:sp>
-        <p:nvSpPr>
-          <p:cNvPr id="22" name="TextBox 21"/>
-          <p:cNvSpPr txBox="1"/>
-          <p:nvPr/>
-        </p:nvSpPr>
-        <p:spPr>
-          <a:xfrm>
-            <a:off x="2736000" y="1440000"/>
-            <a:ext cx="3311999" cy="1296000"/>
-          </a:xfrm>
-          <a:prstGeom prst="rect">
-            <a:avLst/>
-          </a:prstGeom>
-          <a:noFill/>
-        </p:spPr>
-        <p:txBody>
-          <a:bodyPr wrap="square" lIns="0" rIns="0" tIns="0" bIns="0" anchor="t">
-            <a:spAutoFit/>
-          </a:bodyPr>
-          <a:lstStyle/>
+              <a:t>Efectos aleatorios por proveedor y material para el arranque en frío.</a:t>
+            </a:r>
+          </a:p>
           <a:p>
             <a:pPr algn="l"/>
             <a:r>
-              <a:rPr sz="1100" b="0">
+              <a:rPr sz="1050" b="0">
                 <a:solidFill>
                   <a:srgbClr val="1A1A1A"/>
                 </a:solidFill>
                 <a:latin typeface="Calibri"/>
               </a:rPr>
-              <a:t>El comprador hoy se entera del retraso cuando la mercancía no llega. Con miles de posiciones abiertas, no puede seguirlas todas: necesita saber, el día en que libera la orden, cuáles vigilar.</a:t>
-            </a:r>
-          </a:p>
-        </p:txBody>
-      </p:sp>
-      <p:sp>
-        <p:nvSpPr>
-          <p:cNvPr id="23" name="TextBox 22"/>
-          <p:cNvSpPr txBox="1"/>
-          <p:nvPr/>
-        </p:nvSpPr>
-        <p:spPr>
-          <a:xfrm>
-            <a:off x="2736000" y="2628000"/>
-            <a:ext cx="3311999" cy="216000"/>
-          </a:xfrm>
-          <a:prstGeom prst="rect">
-            <a:avLst/>
-          </a:prstGeom>
-          <a:noFill/>
-        </p:spPr>
-        <p:txBody>
-          <a:bodyPr wrap="square" lIns="0" rIns="0" tIns="0" bIns="0" anchor="t">
-            <a:spAutoFit/>
-          </a:bodyPr>
-          <a:lstStyle/>
+              <a:t>Usar los días de retraso con cortes ordenados (el modelo original del Entregable 3).</a:t>
+            </a:r>
+          </a:p>
           <a:p>
             <a:pPr algn="l"/>
             <a:r>
-              <a:rPr sz="1250" b="1">
-                <a:solidFill>
-                  <a:srgbClr val="405731"/>
+              <a:rPr sz="1050" b="0">
+                <a:solidFill>
+                  <a:srgbClr val="1A1A1A"/>
                 </a:solidFill>
                 <a:latin typeface="Calibri"/>
               </a:rPr>
-              <a:t>Qué dice la literatura</a:t>
-            </a:r>
-          </a:p>
-        </p:txBody>
-      </p:sp>
-      <p:sp>
-        <p:nvSpPr>
-          <p:cNvPr id="24" name="TextBox 23"/>
-          <p:cNvSpPr txBox="1"/>
-          <p:nvPr/>
-        </p:nvSpPr>
-        <p:spPr>
-          <a:xfrm>
-            <a:off x="2736000" y="2880000"/>
-            <a:ext cx="3311999" cy="1800000"/>
-          </a:xfrm>
-          <a:prstGeom prst="rect">
-            <a:avLst/>
-          </a:prstGeom>
-          <a:noFill/>
-        </p:spPr>
-        <p:txBody>
-          <a:bodyPr wrap="square" lIns="0" rIns="0" tIns="0" bIns="0" anchor="t">
-            <a:spAutoFit/>
-          </a:bodyPr>
-          <a:lstStyle/>
-          <a:p>
-            <a:pPr algn="l"/>
-            <a:r>
-              <a:rPr sz="1050" b="0">
-                <a:solidFill>
-                  <a:srgbClr val="5A5A5A"/>
-                </a:solidFill>
-                <a:latin typeface="Calibri"/>
-              </a:rPr>
-              <a:t>En fabricantes de maquinaria y equipos llega tarde del 13 % al 14 % de los pedidos (Brintrup y otros, 2020; Steinberg y otros, 2023): aquí es más del doble.</a:t>
-            </a:r>
-          </a:p>
-          <a:p>
-            <a:pPr algn="l">
-              <a:spcBef>
-                <a:spcPts val="600"/>
-              </a:spcBef>
-            </a:pPr>
-            <a:r>
-              <a:rPr sz="1050" b="0">
-                <a:solidFill>
-                  <a:srgbClr val="5A5A5A"/>
-                </a:solidFill>
-                <a:latin typeface="Calibri"/>
-              </a:rPr>
-              <a:t>Una revisión de 26 estudios encuentra que 16 parten las filas al azar; reevaluado sin fuga y en el tiempo, un AUC de 0,96 baja a 0,73 (Raval, 2026). Este trabajo evalúa siempre hacia adelante.</a:t>
-            </a:r>
-          </a:p>
-        </p:txBody>
-      </p:sp>
-      <p:sp>
-        <p:nvSpPr>
-          <p:cNvPr id="25" name="Rectangle 24"/>
-          <p:cNvSpPr/>
-          <p:nvPr/>
-        </p:nvSpPr>
-        <p:spPr>
-          <a:xfrm>
-            <a:off x="6263999" y="1224000"/>
-            <a:ext cx="2448000" cy="3491999"/>
-          </a:xfrm>
-          <a:prstGeom prst="rect">
-            <a:avLst/>
-          </a:prstGeom>
-          <a:solidFill>
-            <a:srgbClr val="E8F0EB"/>
-          </a:solidFill>
-          <a:ln>
-            <a:noFill/>
-          </a:ln>
-          <a:effectLst/>
-        </p:spPr>
-        <p:style>
-          <a:lnRef idx="1">
-            <a:schemeClr val="accent1"/>
-          </a:lnRef>
-          <a:fillRef idx="3">
-            <a:schemeClr val="accent1"/>
-          </a:fillRef>
-          <a:effectRef idx="2">
-            <a:schemeClr val="accent1"/>
-          </a:effectRef>
-          <a:fontRef idx="minor">
-            <a:schemeClr val="lt1"/>
-          </a:fontRef>
-        </p:style>
-        <p:txBody>
-          <a:bodyPr rtlCol="0" anchor="ctr" wrap="square"/>
-          <a:lstStyle/>
-          <a:p>
-            <a:pPr algn="ctr"/>
-          </a:p>
-        </p:txBody>
-      </p:sp>
-      <p:sp>
-        <p:nvSpPr>
-          <p:cNvPr id="26" name="TextBox 25"/>
-          <p:cNvSpPr txBox="1"/>
-          <p:nvPr/>
-        </p:nvSpPr>
-        <p:spPr>
-          <a:xfrm>
-            <a:off x="6425999" y="1332000"/>
-            <a:ext cx="2124000" cy="288000"/>
-          </a:xfrm>
-          <a:prstGeom prst="rect">
-            <a:avLst/>
-          </a:prstGeom>
-          <a:noFill/>
-        </p:spPr>
-        <p:txBody>
-          <a:bodyPr wrap="square" lIns="0" rIns="0" tIns="0" bIns="0" anchor="t">
-            <a:spAutoFit/>
-          </a:bodyPr>
-          <a:lstStyle/>
-          <a:p>
-            <a:pPr algn="l"/>
-            <a:r>
-              <a:rPr sz="1300" b="1">
-                <a:solidFill>
-                  <a:srgbClr val="405731"/>
-                </a:solidFill>
-                <a:latin typeface="Calibri"/>
-              </a:rPr>
-              <a:t>Objetivos</a:t>
-            </a:r>
-          </a:p>
-        </p:txBody>
-      </p:sp>
-      <p:sp>
-        <p:nvSpPr>
-          <p:cNvPr id="27" name="TextBox 26"/>
-          <p:cNvSpPr txBox="1"/>
-          <p:nvPr/>
-        </p:nvSpPr>
-        <p:spPr>
-          <a:xfrm>
-            <a:off x="6425999" y="1591200"/>
-            <a:ext cx="2124000" cy="3077999"/>
-          </a:xfrm>
-          <a:prstGeom prst="rect">
-            <a:avLst/>
-          </a:prstGeom>
-          <a:noFill/>
-        </p:spPr>
-        <p:txBody>
-          <a:bodyPr wrap="square" lIns="0" rIns="0" tIns="0" bIns="0" anchor="t">
-            <a:spAutoFit/>
-          </a:bodyPr>
-          <a:lstStyle/>
-          <a:p>
-            <a:pPr algn="l"/>
-            <a:r>
-              <a:rPr sz="1050" b="0">
-                <a:solidFill>
-                  <a:srgbClr val="1A1A1A"/>
-                </a:solidFill>
-                <a:latin typeface="Calibri"/>
-              </a:rPr>
-              <a:t>General: ordenar las posiciones por riesgo de retraso el día de la liberación y señalar cuáles seguir.</a:t>
-            </a:r>
-          </a:p>
-          <a:p>
-            <a:pPr algn="l"/>
-            <a:r>
-              <a:rPr sz="1050" b="0">
-                <a:solidFill>
-                  <a:srgbClr val="1A1A1A"/>
-                </a:solidFill>
-                <a:latin typeface="Calibri"/>
-              </a:rPr>
-              <a:t>Específico 1: comparar 7 modelos × 4 balanceos × 4 optimizadores con el mismo presupuesto.</a:t>
-            </a:r>
-          </a:p>
-          <a:p>
-            <a:pPr algn="l"/>
-            <a:r>
-              <a:rPr sz="1050" b="0">
-                <a:solidFill>
-                  <a:srgbClr val="1A1A1A"/>
-                </a:solidFill>
-                <a:latin typeface="Calibri"/>
-              </a:rPr>
-              <a:t>Específico 2: medir cuánto cuesta decidir con entidades nuevas (proveedor o material sin historia).</a:t>
-            </a:r>
-          </a:p>
-          <a:p>
-            <a:pPr algn="l"/>
-            <a:r>
-              <a:rPr sz="1050" b="0">
-                <a:solidFill>
-                  <a:srgbClr val="1A1A1A"/>
-                </a:solidFill>
-                <a:latin typeface="Calibri"/>
-              </a:rPr>
-              <a:t>Específico 3: dejar el modelo servido en un tablero con predicción en vivo.</a:t>
-            </a:r>
-          </a:p>
-        </p:txBody>
-      </p:sp>
-      <p:sp>
-        <p:nvSpPr>
-          <p:cNvPr id="28" name="Rectangle 27"/>
+              <a:t>Maestros con vigencia por fecha.</a:t>
+            </a:r>
+          </a:p>
+        </p:txBody>
+      </p:sp>
+      <p:sp>
+        <p:nvSpPr>
+          <p:cNvPr id="18" name="Rectangle 17"/>
           <p:cNvSpPr/>
           <p:nvPr/>
         </p:nvSpPr>
@@ -18327,7 +20184,7 @@
       </p:sp>
       <p:sp>
         <p:nvSpPr>
-          <p:cNvPr id="29" name="TextBox 28"/>
+          <p:cNvPr id="19" name="TextBox 18"/>
           <p:cNvSpPr txBox="1"/>
           <p:nvPr/>
         </p:nvSpPr>
@@ -18355,14 +20212,14 @@
                 </a:solidFill>
                 <a:latin typeface="Calibri"/>
               </a:rPr>
-              <a:t>Fuente: libro, introducción y literatura; capítulo 4 (modelo base): data/modelos/metricas.csv</a:t>
-            </a:r>
-          </a:p>
-        </p:txBody>
-      </p:sp>
-      <p:sp>
-        <p:nvSpPr>
-          <p:cNvPr id="30" name="TextBox 29"/>
+              <a:t>Fuente: libro, capítulos 2c, 5 y 7</a:t>
+            </a:r>
+          </a:p>
+        </p:txBody>
+      </p:sp>
+      <p:sp>
+        <p:nvSpPr>
+          <p:cNvPr id="20" name="TextBox 19"/>
           <p:cNvSpPr txBox="1"/>
           <p:nvPr/>
         </p:nvSpPr>
@@ -18390,7 +20247,7 @@
                 </a:solidFill>
                 <a:latin typeface="Calibri"/>
               </a:rPr>
-              <a:t>2 / 20</a:t>
+              <a:t>21 / 21</a:t>
             </a:r>
           </a:p>
         </p:txBody>
@@ -18403,867 +20260,7 @@
 </p:sld>
 </file>
 
-<file path=ppt/slides/slide20.xml><?xml version="1.0" encoding="utf-8"?>
-<p:sld xmlns:a="http://schemas.openxmlformats.org/drawingml/2006/main" xmlns:p="http://schemas.openxmlformats.org/presentationml/2006/main" xmlns:r="http://schemas.openxmlformats.org/officeDocument/2006/relationships">
-  <p:cSld>
-    <p:bg>
-      <p:bgPr>
-        <a:solidFill>
-          <a:srgbClr val="FFFFFF"/>
-        </a:solidFill>
-        <a:effectLst/>
-      </p:bgPr>
-    </p:bg>
-    <p:spTree>
-      <p:nvGrpSpPr>
-        <p:cNvPr id="1" name=""/>
-        <p:cNvGrpSpPr/>
-        <p:nvPr/>
-      </p:nvGrpSpPr>
-      <p:grpSpPr/>
-      <p:sp>
-        <p:nvSpPr>
-          <p:cNvPr id="2" name="Rectangle 1"/>
-          <p:cNvSpPr/>
-          <p:nvPr/>
-        </p:nvSpPr>
-        <p:spPr>
-          <a:xfrm>
-            <a:off x="0" y="0"/>
-            <a:ext cx="9144000" cy="576000"/>
-          </a:xfrm>
-          <a:prstGeom prst="rect">
-            <a:avLst/>
-          </a:prstGeom>
-          <a:solidFill>
-            <a:srgbClr val="405731"/>
-          </a:solidFill>
-          <a:ln>
-            <a:noFill/>
-          </a:ln>
-          <a:effectLst/>
-        </p:spPr>
-        <p:style>
-          <a:lnRef idx="1">
-            <a:schemeClr val="accent1"/>
-          </a:lnRef>
-          <a:fillRef idx="3">
-            <a:schemeClr val="accent1"/>
-          </a:fillRef>
-          <a:effectRef idx="2">
-            <a:schemeClr val="accent1"/>
-          </a:effectRef>
-          <a:fontRef idx="minor">
-            <a:schemeClr val="lt1"/>
-          </a:fontRef>
-        </p:style>
-        <p:txBody>
-          <a:bodyPr rtlCol="0" anchor="ctr" wrap="square"/>
-          <a:lstStyle/>
-          <a:p>
-            <a:pPr algn="ctr"/>
-          </a:p>
-        </p:txBody>
-      </p:sp>
-      <p:sp>
-        <p:nvSpPr>
-          <p:cNvPr id="3" name="Rectangle 2"/>
-          <p:cNvSpPr/>
-          <p:nvPr/>
-        </p:nvSpPr>
-        <p:spPr>
-          <a:xfrm>
-            <a:off x="0" y="576000"/>
-            <a:ext cx="9144000" cy="36000"/>
-          </a:xfrm>
-          <a:prstGeom prst="rect">
-            <a:avLst/>
-          </a:prstGeom>
-          <a:solidFill>
-            <a:srgbClr val="B08A2D"/>
-          </a:solidFill>
-          <a:ln>
-            <a:noFill/>
-          </a:ln>
-          <a:effectLst/>
-        </p:spPr>
-        <p:style>
-          <a:lnRef idx="1">
-            <a:schemeClr val="accent1"/>
-          </a:lnRef>
-          <a:fillRef idx="3">
-            <a:schemeClr val="accent1"/>
-          </a:fillRef>
-          <a:effectRef idx="2">
-            <a:schemeClr val="accent1"/>
-          </a:effectRef>
-          <a:fontRef idx="minor">
-            <a:schemeClr val="lt1"/>
-          </a:fontRef>
-        </p:style>
-        <p:txBody>
-          <a:bodyPr rtlCol="0" anchor="ctr" wrap="square"/>
-          <a:lstStyle/>
-          <a:p>
-            <a:pPr algn="ctr"/>
-          </a:p>
-        </p:txBody>
-      </p:sp>
-      <p:sp>
-        <p:nvSpPr>
-          <p:cNvPr id="4" name="Rectangle 3"/>
-          <p:cNvSpPr/>
-          <p:nvPr/>
-        </p:nvSpPr>
-        <p:spPr>
-          <a:xfrm>
-            <a:off x="144000" y="72000"/>
-            <a:ext cx="468000" cy="432000"/>
-          </a:xfrm>
-          <a:prstGeom prst="rect">
-            <a:avLst/>
-          </a:prstGeom>
-          <a:solidFill>
-            <a:srgbClr val="FFFFFF"/>
-          </a:solidFill>
-          <a:ln>
-            <a:noFill/>
-          </a:ln>
-          <a:effectLst/>
-        </p:spPr>
-        <p:style>
-          <a:lnRef idx="1">
-            <a:schemeClr val="accent1"/>
-          </a:lnRef>
-          <a:fillRef idx="3">
-            <a:schemeClr val="accent1"/>
-          </a:fillRef>
-          <a:effectRef idx="2">
-            <a:schemeClr val="accent1"/>
-          </a:effectRef>
-          <a:fontRef idx="minor">
-            <a:schemeClr val="lt1"/>
-          </a:fontRef>
-        </p:style>
-        <p:txBody>
-          <a:bodyPr rtlCol="0" anchor="ctr" wrap="square"/>
-          <a:lstStyle/>
-          <a:p>
-            <a:pPr algn="ctr"/>
-          </a:p>
-        </p:txBody>
-      </p:sp>
-      <p:pic>
-        <p:nvPicPr>
-          <p:cNvPr id="5" name="Picture 4" descr="logo.png"/>
-          <p:cNvPicPr>
-            <a:picLocks noChangeAspect="1"/>
-          </p:cNvPicPr>
-          <p:nvPr/>
-        </p:nvPicPr>
-        <p:blipFill>
-          <a:blip r:embed="rId2"/>
-          <a:stretch>
-            <a:fillRect/>
-          </a:stretch>
-        </p:blipFill>
-        <p:spPr>
-          <a:xfrm>
-            <a:off x="200160" y="145440"/>
-            <a:ext cx="355680" cy="266417"/>
-          </a:xfrm>
-          <a:prstGeom prst="rect">
-            <a:avLst/>
-          </a:prstGeom>
-        </p:spPr>
-      </p:pic>
-      <p:sp>
-        <p:nvSpPr>
-          <p:cNvPr id="6" name="TextBox 5"/>
-          <p:cNvSpPr txBox="1"/>
-          <p:nvPr/>
-        </p:nvSpPr>
-        <p:spPr>
-          <a:xfrm>
-            <a:off x="792000" y="125999"/>
-            <a:ext cx="8172000" cy="360000"/>
-          </a:xfrm>
-          <a:prstGeom prst="rect">
-            <a:avLst/>
-          </a:prstGeom>
-          <a:noFill/>
-        </p:spPr>
-        <p:txBody>
-          <a:bodyPr wrap="square" lIns="0" rIns="0" tIns="0" bIns="0" anchor="ctr">
-            <a:spAutoFit/>
-          </a:bodyPr>
-          <a:lstStyle/>
-          <a:p>
-            <a:pPr algn="l"/>
-            <a:r>
-              <a:rPr sz="2000" b="1">
-                <a:solidFill>
-                  <a:srgbClr val="FFFFFF"/>
-                </a:solidFill>
-                <a:latin typeface="Calibri"/>
-              </a:rPr>
-              <a:t>Límites: deriva, etiqueta que madura y una sola empresa</a:t>
-            </a:r>
-          </a:p>
-        </p:txBody>
-      </p:sp>
-      <p:sp>
-        <p:nvSpPr>
-          <p:cNvPr id="7" name="TextBox 6"/>
-          <p:cNvSpPr txBox="1"/>
-          <p:nvPr/>
-        </p:nvSpPr>
-        <p:spPr>
-          <a:xfrm>
-            <a:off x="468000" y="756000"/>
-            <a:ext cx="7308000" cy="251999"/>
-          </a:xfrm>
-          <a:prstGeom prst="rect">
-            <a:avLst/>
-          </a:prstGeom>
-          <a:noFill/>
-        </p:spPr>
-        <p:txBody>
-          <a:bodyPr wrap="square" lIns="0" rIns="0" tIns="0" bIns="0" anchor="t">
-            <a:spAutoFit/>
-          </a:bodyPr>
-          <a:lstStyle/>
-          <a:p>
-            <a:pPr algn="l"/>
-            <a:r>
-              <a:rPr sz="1200" b="1">
-                <a:solidFill>
-                  <a:srgbClr val="B08A2D"/>
-                </a:solidFill>
-                <a:latin typeface="Calibri"/>
-              </a:rPr>
-              <a:t>CRITERIO 6  ·  LIMITACIONES Y MEJORAS</a:t>
-            </a:r>
-          </a:p>
-        </p:txBody>
-      </p:sp>
-      <p:sp>
-        <p:nvSpPr>
-          <p:cNvPr id="8" name="Rectangle 7"/>
-          <p:cNvSpPr/>
-          <p:nvPr/>
-        </p:nvSpPr>
-        <p:spPr>
-          <a:xfrm>
-            <a:off x="468000" y="1044000"/>
-            <a:ext cx="468000" cy="36000"/>
-          </a:xfrm>
-          <a:prstGeom prst="rect">
-            <a:avLst/>
-          </a:prstGeom>
-          <a:solidFill>
-            <a:srgbClr val="B08A2D"/>
-          </a:solidFill>
-          <a:ln>
-            <a:noFill/>
-          </a:ln>
-          <a:effectLst/>
-        </p:spPr>
-        <p:style>
-          <a:lnRef idx="1">
-            <a:schemeClr val="accent1"/>
-          </a:lnRef>
-          <a:fillRef idx="3">
-            <a:schemeClr val="accent1"/>
-          </a:fillRef>
-          <a:effectRef idx="2">
-            <a:schemeClr val="accent1"/>
-          </a:effectRef>
-          <a:fontRef idx="minor">
-            <a:schemeClr val="lt1"/>
-          </a:fontRef>
-        </p:style>
-        <p:txBody>
-          <a:bodyPr rtlCol="0" anchor="ctr" wrap="square"/>
-          <a:lstStyle/>
-          <a:p>
-            <a:pPr algn="ctr"/>
-          </a:p>
-        </p:txBody>
-      </p:sp>
-      <p:sp>
-        <p:nvSpPr>
-          <p:cNvPr id="9" name="Rectangle 8"/>
-          <p:cNvSpPr/>
-          <p:nvPr/>
-        </p:nvSpPr>
-        <p:spPr>
-          <a:xfrm>
-            <a:off x="468000" y="1188000"/>
-            <a:ext cx="2664000" cy="3528000"/>
-          </a:xfrm>
-          <a:prstGeom prst="rect">
-            <a:avLst/>
-          </a:prstGeom>
-          <a:solidFill>
-            <a:srgbClr val="E8F0EB"/>
-          </a:solidFill>
-          <a:ln>
-            <a:noFill/>
-          </a:ln>
-          <a:effectLst/>
-        </p:spPr>
-        <p:style>
-          <a:lnRef idx="1">
-            <a:schemeClr val="accent1"/>
-          </a:lnRef>
-          <a:fillRef idx="3">
-            <a:schemeClr val="accent1"/>
-          </a:fillRef>
-          <a:effectRef idx="2">
-            <a:schemeClr val="accent1"/>
-          </a:effectRef>
-          <a:fontRef idx="minor">
-            <a:schemeClr val="lt1"/>
-          </a:fontRef>
-        </p:style>
-        <p:txBody>
-          <a:bodyPr rtlCol="0" anchor="ctr" wrap="square"/>
-          <a:lstStyle/>
-          <a:p>
-            <a:pPr algn="ctr"/>
-          </a:p>
-        </p:txBody>
-      </p:sp>
-      <p:sp>
-        <p:nvSpPr>
-          <p:cNvPr id="10" name="TextBox 9"/>
-          <p:cNvSpPr txBox="1"/>
-          <p:nvPr/>
-        </p:nvSpPr>
-        <p:spPr>
-          <a:xfrm>
-            <a:off x="630000" y="1295999"/>
-            <a:ext cx="2340000" cy="288000"/>
-          </a:xfrm>
-          <a:prstGeom prst="rect">
-            <a:avLst/>
-          </a:prstGeom>
-          <a:noFill/>
-        </p:spPr>
-        <p:txBody>
-          <a:bodyPr wrap="square" lIns="0" rIns="0" tIns="0" bIns="0" anchor="t">
-            <a:spAutoFit/>
-          </a:bodyPr>
-          <a:lstStyle/>
-          <a:p>
-            <a:pPr algn="l"/>
-            <a:r>
-              <a:rPr sz="1250" b="1">
-                <a:solidFill>
-                  <a:srgbClr val="405731"/>
-                </a:solidFill>
-                <a:latin typeface="Calibri"/>
-              </a:rPr>
-              <a:t>Teóricas</a:t>
-            </a:r>
-          </a:p>
-        </p:txBody>
-      </p:sp>
-      <p:sp>
-        <p:nvSpPr>
-          <p:cNvPr id="11" name="TextBox 10"/>
-          <p:cNvSpPr txBox="1"/>
-          <p:nvPr/>
-        </p:nvSpPr>
-        <p:spPr>
-          <a:xfrm>
-            <a:off x="630000" y="1555200"/>
-            <a:ext cx="2340000" cy="3114000"/>
-          </a:xfrm>
-          <a:prstGeom prst="rect">
-            <a:avLst/>
-          </a:prstGeom>
-          <a:noFill/>
-        </p:spPr>
-        <p:txBody>
-          <a:bodyPr wrap="square" lIns="0" rIns="0" tIns="0" bIns="0" anchor="t">
-            <a:spAutoFit/>
-          </a:bodyPr>
-          <a:lstStyle/>
-          <a:p>
-            <a:pPr algn="l"/>
-            <a:r>
-              <a:rPr sz="1050" b="0">
-                <a:solidFill>
-                  <a:srgbClr val="1A1A1A"/>
-                </a:solidFill>
-                <a:latin typeface="Calibri"/>
-              </a:rPr>
-              <a:t>Independencia dado x: las posiciones de una orden se parecen; se protege agrupando, no se modela.</a:t>
-            </a:r>
-          </a:p>
-          <a:p>
-            <a:pPr algn="l"/>
-            <a:r>
-              <a:rPr sz="1050" b="0">
-                <a:solidFill>
-                  <a:srgbClr val="1A1A1A"/>
-                </a:solidFill>
-                <a:latin typeface="Calibri"/>
-              </a:rPr>
-              <a:t>Estabilidad: el modelo supone que la relación de 2021-2025 vale en 2026.</a:t>
-            </a:r>
-          </a:p>
-          <a:p>
-            <a:pPr algn="l"/>
-            <a:r>
-              <a:rPr sz="1050" b="0">
-                <a:solidFill>
-                  <a:srgbClr val="1A1A1A"/>
-                </a:solidFill>
-                <a:latin typeface="Calibri"/>
-              </a:rPr>
-              <a:t>Una sola etiqueta binaria desperdicia los días de retraso.</a:t>
-            </a:r>
-          </a:p>
-        </p:txBody>
-      </p:sp>
-      <p:sp>
-        <p:nvSpPr>
-          <p:cNvPr id="12" name="Rectangle 11"/>
-          <p:cNvSpPr/>
-          <p:nvPr/>
-        </p:nvSpPr>
-        <p:spPr>
-          <a:xfrm>
-            <a:off x="3240000" y="1188000"/>
-            <a:ext cx="2664000" cy="3528000"/>
-          </a:xfrm>
-          <a:prstGeom prst="rect">
-            <a:avLst/>
-          </a:prstGeom>
-          <a:solidFill>
-            <a:srgbClr val="F5EDE0"/>
-          </a:solidFill>
-          <a:ln>
-            <a:noFill/>
-          </a:ln>
-          <a:effectLst/>
-        </p:spPr>
-        <p:style>
-          <a:lnRef idx="1">
-            <a:schemeClr val="accent1"/>
-          </a:lnRef>
-          <a:fillRef idx="3">
-            <a:schemeClr val="accent1"/>
-          </a:fillRef>
-          <a:effectRef idx="2">
-            <a:schemeClr val="accent1"/>
-          </a:effectRef>
-          <a:fontRef idx="minor">
-            <a:schemeClr val="lt1"/>
-          </a:fontRef>
-        </p:style>
-        <p:txBody>
-          <a:bodyPr rtlCol="0" anchor="ctr" wrap="square"/>
-          <a:lstStyle/>
-          <a:p>
-            <a:pPr algn="ctr"/>
-          </a:p>
-        </p:txBody>
-      </p:sp>
-      <p:sp>
-        <p:nvSpPr>
-          <p:cNvPr id="13" name="TextBox 12"/>
-          <p:cNvSpPr txBox="1"/>
-          <p:nvPr/>
-        </p:nvSpPr>
-        <p:spPr>
-          <a:xfrm>
-            <a:off x="3401999" y="1295999"/>
-            <a:ext cx="2340000" cy="288000"/>
-          </a:xfrm>
-          <a:prstGeom prst="rect">
-            <a:avLst/>
-          </a:prstGeom>
-          <a:noFill/>
-        </p:spPr>
-        <p:txBody>
-          <a:bodyPr wrap="square" lIns="0" rIns="0" tIns="0" bIns="0" anchor="t">
-            <a:spAutoFit/>
-          </a:bodyPr>
-          <a:lstStyle/>
-          <a:p>
-            <a:pPr algn="l"/>
-            <a:r>
-              <a:rPr sz="1250" b="1">
-                <a:solidFill>
-                  <a:srgbClr val="405731"/>
-                </a:solidFill>
-                <a:latin typeface="Calibri"/>
-              </a:rPr>
-              <a:t>Empíricas</a:t>
-            </a:r>
-          </a:p>
-        </p:txBody>
-      </p:sp>
-      <p:sp>
-        <p:nvSpPr>
-          <p:cNvPr id="14" name="TextBox 13"/>
-          <p:cNvSpPr txBox="1"/>
-          <p:nvPr/>
-        </p:nvSpPr>
-        <p:spPr>
-          <a:xfrm>
-            <a:off x="3401999" y="1555200"/>
-            <a:ext cx="2340000" cy="3114000"/>
-          </a:xfrm>
-          <a:prstGeom prst="rect">
-            <a:avLst/>
-          </a:prstGeom>
-          <a:noFill/>
-        </p:spPr>
-        <p:txBody>
-          <a:bodyPr wrap="square" lIns="0" rIns="0" tIns="0" bIns="0" anchor="t">
-            <a:spAutoFit/>
-          </a:bodyPr>
-          <a:lstStyle/>
-          <a:p>
-            <a:pPr algn="l"/>
-            <a:r>
-              <a:rPr sz="1050" b="0">
-                <a:solidFill>
-                  <a:srgbClr val="1A1A1A"/>
-                </a:solidFill>
-                <a:latin typeface="Calibri"/>
-              </a:rPr>
-              <a:t>Deriva: 2025 se distingue de 2021-2024 casi por completo.</a:t>
-            </a:r>
-          </a:p>
-          <a:p>
-            <a:pPr algn="l"/>
-            <a:r>
-              <a:rPr sz="1050" b="0">
-                <a:solidFill>
-                  <a:srgbClr val="1A1A1A"/>
-                </a:solidFill>
-                <a:latin typeface="Calibri"/>
-              </a:rPr>
-              <a:t>La etiqueta de lo más reciente madura tarde (censura al final del periodo).</a:t>
-            </a:r>
-          </a:p>
-          <a:p>
-            <a:pPr algn="l"/>
-            <a:r>
-              <a:rPr sz="1050" b="0">
-                <a:solidFill>
-                  <a:srgbClr val="1A1A1A"/>
-                </a:solidFill>
-                <a:latin typeface="Calibri"/>
-              </a:rPr>
-              <a:t>Maestros en foto actual, no con su vigencia histórica.</a:t>
-            </a:r>
-          </a:p>
-          <a:p>
-            <a:pPr algn="l"/>
-            <a:r>
-              <a:rPr sz="1050" b="0">
-                <a:solidFill>
-                  <a:srgbClr val="1A1A1A"/>
-                </a:solidFill>
-                <a:latin typeface="Calibri"/>
-              </a:rPr>
-              <a:t>Arranque en frío: 11,1 % de proveedores nuevos en 2026.</a:t>
-            </a:r>
-          </a:p>
-          <a:p>
-            <a:pPr algn="l"/>
-            <a:r>
-              <a:rPr sz="1050" b="0">
-                <a:solidFill>
-                  <a:srgbClr val="1A1A1A"/>
-                </a:solidFill>
-                <a:latin typeface="Calibri"/>
-              </a:rPr>
-              <a:t>Una sola empresa: la generalización a otros grupos no está probada.</a:t>
-            </a:r>
-          </a:p>
-        </p:txBody>
-      </p:sp>
-      <p:sp>
-        <p:nvSpPr>
-          <p:cNvPr id="15" name="Rectangle 14"/>
-          <p:cNvSpPr/>
-          <p:nvPr/>
-        </p:nvSpPr>
-        <p:spPr>
-          <a:xfrm>
-            <a:off x="6012000" y="1188000"/>
-            <a:ext cx="2700000" cy="3528000"/>
-          </a:xfrm>
-          <a:prstGeom prst="rect">
-            <a:avLst/>
-          </a:prstGeom>
-          <a:solidFill>
-            <a:srgbClr val="EEF2EA"/>
-          </a:solidFill>
-          <a:ln>
-            <a:noFill/>
-          </a:ln>
-          <a:effectLst/>
-        </p:spPr>
-        <p:style>
-          <a:lnRef idx="1">
-            <a:schemeClr val="accent1"/>
-          </a:lnRef>
-          <a:fillRef idx="3">
-            <a:schemeClr val="accent1"/>
-          </a:fillRef>
-          <a:effectRef idx="2">
-            <a:schemeClr val="accent1"/>
-          </a:effectRef>
-          <a:fontRef idx="minor">
-            <a:schemeClr val="lt1"/>
-          </a:fontRef>
-        </p:style>
-        <p:txBody>
-          <a:bodyPr rtlCol="0" anchor="ctr" wrap="square"/>
-          <a:lstStyle/>
-          <a:p>
-            <a:pPr algn="ctr"/>
-          </a:p>
-        </p:txBody>
-      </p:sp>
-      <p:sp>
-        <p:nvSpPr>
-          <p:cNvPr id="16" name="TextBox 15"/>
-          <p:cNvSpPr txBox="1"/>
-          <p:nvPr/>
-        </p:nvSpPr>
-        <p:spPr>
-          <a:xfrm>
-            <a:off x="6173999" y="1295999"/>
-            <a:ext cx="2376000" cy="288000"/>
-          </a:xfrm>
-          <a:prstGeom prst="rect">
-            <a:avLst/>
-          </a:prstGeom>
-          <a:noFill/>
-        </p:spPr>
-        <p:txBody>
-          <a:bodyPr wrap="square" lIns="0" rIns="0" tIns="0" bIns="0" anchor="t">
-            <a:spAutoFit/>
-          </a:bodyPr>
-          <a:lstStyle/>
-          <a:p>
-            <a:pPr algn="l"/>
-            <a:r>
-              <a:rPr sz="1250" b="1">
-                <a:solidFill>
-                  <a:srgbClr val="405731"/>
-                </a:solidFill>
-                <a:latin typeface="Calibri"/>
-              </a:rPr>
-              <a:t>Mejoras</a:t>
-            </a:r>
-          </a:p>
-        </p:txBody>
-      </p:sp>
-      <p:sp>
-        <p:nvSpPr>
-          <p:cNvPr id="17" name="TextBox 16"/>
-          <p:cNvSpPr txBox="1"/>
-          <p:nvPr/>
-        </p:nvSpPr>
-        <p:spPr>
-          <a:xfrm>
-            <a:off x="6173999" y="1555200"/>
-            <a:ext cx="2376000" cy="3114000"/>
-          </a:xfrm>
-          <a:prstGeom prst="rect">
-            <a:avLst/>
-          </a:prstGeom>
-          <a:noFill/>
-        </p:spPr>
-        <p:txBody>
-          <a:bodyPr wrap="square" lIns="0" rIns="0" tIns="0" bIns="0" anchor="t">
-            <a:spAutoFit/>
-          </a:bodyPr>
-          <a:lstStyle/>
-          <a:p>
-            <a:pPr algn="l"/>
-            <a:r>
-              <a:rPr sz="1050" b="0">
-                <a:solidFill>
-                  <a:srgbClr val="1A1A1A"/>
-                </a:solidFill>
-                <a:latin typeface="Calibri"/>
-              </a:rPr>
-              <a:t>Reentrenar por semestre y vigilar la deriva con la validación adversaria.</a:t>
-            </a:r>
-          </a:p>
-          <a:p>
-            <a:pPr algn="l"/>
-            <a:r>
-              <a:rPr sz="1050" b="0">
-                <a:solidFill>
-                  <a:srgbClr val="1A1A1A"/>
-                </a:solidFill>
-                <a:latin typeface="Calibri"/>
-              </a:rPr>
-              <a:t>Efectos aleatorios por proveedor y material para el arranque en frío.</a:t>
-            </a:r>
-          </a:p>
-          <a:p>
-            <a:pPr algn="l"/>
-            <a:r>
-              <a:rPr sz="1050" b="0">
-                <a:solidFill>
-                  <a:srgbClr val="1A1A1A"/>
-                </a:solidFill>
-                <a:latin typeface="Calibri"/>
-              </a:rPr>
-              <a:t>Usar los días de retraso con cortes ordenados (el modelo original del Entregable 3).</a:t>
-            </a:r>
-          </a:p>
-          <a:p>
-            <a:pPr algn="l"/>
-            <a:r>
-              <a:rPr sz="1050" b="0">
-                <a:solidFill>
-                  <a:srgbClr val="1A1A1A"/>
-                </a:solidFill>
-                <a:latin typeface="Calibri"/>
-              </a:rPr>
-              <a:t>Maestros con vigencia por fecha.</a:t>
-            </a:r>
-          </a:p>
-        </p:txBody>
-      </p:sp>
-      <p:sp>
-        <p:nvSpPr>
-          <p:cNvPr id="18" name="Rectangle 17"/>
-          <p:cNvSpPr/>
-          <p:nvPr/>
-        </p:nvSpPr>
-        <p:spPr>
-          <a:xfrm>
-            <a:off x="468000" y="4842000"/>
-            <a:ext cx="8243999" cy="14400"/>
-          </a:xfrm>
-          <a:prstGeom prst="rect">
-            <a:avLst/>
-          </a:prstGeom>
-          <a:solidFill>
-            <a:srgbClr val="DDD5C0"/>
-          </a:solidFill>
-          <a:ln>
-            <a:noFill/>
-          </a:ln>
-          <a:effectLst/>
-        </p:spPr>
-        <p:style>
-          <a:lnRef idx="1">
-            <a:schemeClr val="accent1"/>
-          </a:lnRef>
-          <a:fillRef idx="3">
-            <a:schemeClr val="accent1"/>
-          </a:fillRef>
-          <a:effectRef idx="2">
-            <a:schemeClr val="accent1"/>
-          </a:effectRef>
-          <a:fontRef idx="minor">
-            <a:schemeClr val="lt1"/>
-          </a:fontRef>
-        </p:style>
-        <p:txBody>
-          <a:bodyPr rtlCol="0" anchor="ctr" wrap="square"/>
-          <a:lstStyle/>
-          <a:p>
-            <a:pPr algn="ctr"/>
-          </a:p>
-        </p:txBody>
-      </p:sp>
-      <p:sp>
-        <p:nvSpPr>
-          <p:cNvPr id="19" name="TextBox 18"/>
-          <p:cNvSpPr txBox="1"/>
-          <p:nvPr/>
-        </p:nvSpPr>
-        <p:spPr>
-          <a:xfrm>
-            <a:off x="468000" y="4896000"/>
-            <a:ext cx="5940000" cy="180000"/>
-          </a:xfrm>
-          <a:prstGeom prst="rect">
-            <a:avLst/>
-          </a:prstGeom>
-          <a:noFill/>
-        </p:spPr>
-        <p:txBody>
-          <a:bodyPr wrap="square" lIns="0" rIns="0" tIns="0" bIns="0" anchor="t">
-            <a:spAutoFit/>
-          </a:bodyPr>
-          <a:lstStyle/>
-          <a:p>
-            <a:pPr algn="l"/>
-            <a:r>
-              <a:rPr sz="850" b="0">
-                <a:solidFill>
-                  <a:srgbClr val="8C8C8C"/>
-                </a:solidFill>
-                <a:latin typeface="Calibri"/>
-              </a:rPr>
-              <a:t>Fuente: libro, capítulos 2c, 5 y 7</a:t>
-            </a:r>
-          </a:p>
-        </p:txBody>
-      </p:sp>
-      <p:sp>
-        <p:nvSpPr>
-          <p:cNvPr id="20" name="TextBox 19"/>
-          <p:cNvSpPr txBox="1"/>
-          <p:nvPr/>
-        </p:nvSpPr>
-        <p:spPr>
-          <a:xfrm>
-            <a:off x="6408000" y="4896000"/>
-            <a:ext cx="2304000" cy="180000"/>
-          </a:xfrm>
-          <a:prstGeom prst="rect">
-            <a:avLst/>
-          </a:prstGeom>
-          <a:noFill/>
-        </p:spPr>
-        <p:txBody>
-          <a:bodyPr wrap="square" lIns="0" rIns="0" tIns="0" bIns="0" anchor="t">
-            <a:spAutoFit/>
-          </a:bodyPr>
-          <a:lstStyle/>
-          <a:p>
-            <a:pPr algn="r"/>
-            <a:r>
-              <a:rPr sz="850" b="0">
-                <a:solidFill>
-                  <a:srgbClr val="8C8C8C"/>
-                </a:solidFill>
-                <a:latin typeface="Calibri"/>
-              </a:rPr>
-              <a:t>20 / 20</a:t>
-            </a:r>
-          </a:p>
-        </p:txBody>
-      </p:sp>
-    </p:spTree>
-  </p:cSld>
-  <p:clrMapOvr>
-    <a:masterClrMapping/>
-  </p:clrMapOvr>
-</p:sld>
-</file>
-
-<file path=ppt/slides/slide21.xml><?xml version="1.0" encoding="utf-8"?>
+<file path=ppt/slides/slide22.xml><?xml version="1.0" encoding="utf-8"?>
 <p:sld xmlns:a="http://schemas.openxmlformats.org/drawingml/2006/main" xmlns:p="http://schemas.openxmlformats.org/presentationml/2006/main" xmlns:r="http://schemas.openxmlformats.org/officeDocument/2006/relationships">
   <p:cSld>
     <p:bg>
@@ -20434,7 +21431,7 @@
                 </a:solidFill>
                 <a:latin typeface="Calibri"/>
               </a:rPr>
-              <a:t>3 / 20</a:t>
+              <a:t>3 / 21</a:t>
             </a:r>
           </a:p>
         </p:txBody>
@@ -21104,7 +22101,7 @@
                 </a:solidFill>
                 <a:latin typeface="Calibri"/>
               </a:rPr>
-              <a:t>4 / 20</a:t>
+              <a:t>4 / 21</a:t>
             </a:r>
           </a:p>
         </p:txBody>
@@ -22786,7 +23783,7 @@
                 </a:solidFill>
                 <a:latin typeface="Calibri"/>
               </a:rPr>
-              <a:t>5 / 20</a:t>
+              <a:t>5 / 21</a:t>
             </a:r>
           </a:p>
         </p:txBody>
@@ -24669,7 +25666,7 @@
                 </a:solidFill>
                 <a:latin typeface="Calibri"/>
               </a:rPr>
-              <a:t>6 / 20</a:t>
+              <a:t>6 / 21</a:t>
             </a:r>
           </a:p>
         </p:txBody>
@@ -25358,7 +26355,7 @@
                 </a:solidFill>
                 <a:latin typeface="Calibri"/>
               </a:rPr>
-              <a:t>7 / 20</a:t>
+              <a:t>7 / 21</a:t>
             </a:r>
           </a:p>
         </p:txBody>
@@ -25922,7 +26919,7 @@
                 </a:solidFill>
                 <a:latin typeface="Calibri"/>
               </a:rPr>
-              <a:t>8 / 20</a:t>
+              <a:t>8 / 21</a:t>
             </a:r>
           </a:p>
         </p:txBody>
@@ -26818,7 +27815,7 @@
                 </a:solidFill>
                 <a:latin typeface="Calibri"/>
               </a:rPr>
-              <a:t>9 / 20</a:t>
+              <a:t>9 / 21</a:t>
             </a:r>
           </a:p>
         </p:txBody>

</xml_diff>

<commit_message>
Por qué XGBoost y no la logística con N y M (criticas.csv), capítulo 10 con siete conjuntos públicos, lámina 19 nueva
</commit_message>
<xml_diff>
--- a/presentacion/sustentacion_otif.pptx
+++ b/presentacion/sustentacion_otif.pptx
@@ -1013,7 +1013,7 @@
           <a:lstStyle/>
           <a:p>
             <a:r>
-              <a:t>[1:00 · criterio 5 · expone B] Por qué cada métrica. En los bloques la ganancia es de una centésima frente al bosque y la logística. En 2026, medido una vez con lo congelado en 2025, XGBoost da 0,848 y le saca 0,023 a la logística. La brecha no muestra caída de la validación a la prueba.</a:t>
+              <a:t>[1:00 · criterio 5 · expone B] Por qué cada métrica. En los bloques la ganancia es de una centésima frente al bosque y la logística. En 2026, medido una vez con lo congelado en 2025, XGBoost da 0,848 y le saca 0,023 a la logística. La brecha no muestra caída de la validación a la prueba. Por qué XGBoost y no la logística: un retraso cuesta más que una falsa alarma, y con el mismo esfuerzo de revisión atrapa 347 tardías más en 2026 (BCa por órdenes [150; 569]); las de material sin stock tienen un intervalo que roza el cero. Entrenar tarda minutos: se puede reentrenar cada mes.</a:t>
             </a:r>
           </a:p>
         </p:txBody>
@@ -1223,7 +1223,7 @@
           <a:lstStyle/>
           <a:p>
             <a:r>
-              <a:t>[1:00 · criterio 5 · expone A] Cinco razones con cifras. Si el negocio pusiera explicar cada coeficiente por encima de atrapar tardías, la logística sería defendible: pierde 0,023 de AUC y unas 35 tardías por mes. Precisión: las tardías de más caen en órdenes que ya tenían otra alerta.</a:t>
+              <a:t>[1:00 · criterio 6 · expone A] Responde «¿y en otros datos?». La ganancia de la propuesta en OTIF (0,012) depende de rasgos del caso: entidades con historia en el tiempo, desenlace continuo y plazo prometido. Airlines no trae el año: su partición es por mes. No decir que generaliza: es una hipótesis con apoyo.</a:t>
             </a:r>
           </a:p>
         </p:txBody>
@@ -6362,7 +6362,7 @@
                 </a:solidFill>
                 <a:latin typeface="Calibri"/>
               </a:rPr>
-              <a:t>Fuente: libro, capítulo 7; Chen y Guestrin (2016)</a:t>
+              <a:t>Fuente: libro, capítulo 8; Chen y Guestrin (2016)</a:t>
             </a:r>
           </a:p>
         </p:txBody>
@@ -7185,7 +7185,7 @@
                 </a:solidFill>
                 <a:latin typeface="Calibri"/>
               </a:rPr>
-              <a:t>Fuente: libro, capítulo 7; Chen y Guestrin (2016)</a:t>
+              <a:t>Fuente: libro, capítulo 8; Chen y Guestrin (2016)</a:t>
             </a:r>
           </a:p>
         </p:txBody>
@@ -8485,7 +8485,7 @@
                 </a:solidFill>
                 <a:latin typeface="Calibri"/>
               </a:rPr>
-              <a:t>Fuente: libro, capítulo 7: resultados/complejidad.csv (tiempos medidos en srvgdai)</a:t>
+              <a:t>Fuente: libro, capítulo 8: resultados/complejidad.csv (tiempos medidos en srvgdai)</a:t>
             </a:r>
           </a:p>
         </p:txBody>
@@ -10570,7 +10570,7 @@
                 </a:solidFill>
                 <a:latin typeface="Calibri"/>
               </a:rPr>
-              <a:t>Fuente: libro, capítulo 5 (las 112): src/validacion.py, src/experimentos.py</a:t>
+              <a:t>Fuente: libro, capítulo 6 (las 112): src/validacion.py, src/experimentos.py</a:t>
             </a:r>
           </a:p>
         </p:txBody>
@@ -14740,7 +14740,7 @@
                 </a:solidFill>
                 <a:latin typeface="Calibri"/>
               </a:rPr>
-              <a:t>KNN predice 80 veces más lento que XGBoost: compara contra todo el entrenamiento.</a:t>
+              <a:t>Frente a la logística, con el mismo 20 % de alertas: 35 tardías más por mes, 17 de material sin stock.</a:t>
             </a:r>
           </a:p>
         </p:txBody>
@@ -14933,7 +14933,7 @@
                 </a:solidFill>
                 <a:latin typeface="Calibri"/>
               </a:rPr>
-              <a:t>Fuente: libro, capítulos 5 y 6: data/modelos/lideres.csv; resultados/prueba_2026/metricas.csv, brecha.csv</a:t>
+              <a:t>Fuente: libro, capítulos 6 y 7: data/modelos/lideres.csv; resultados/prueba_2026/metricas.csv, brecha.csv, criticas.csv</a:t>
             </a:r>
           </a:p>
         </p:txBody>
@@ -16223,7 +16223,7 @@
                 </a:solidFill>
                 <a:latin typeface="Calibri"/>
               </a:rPr>
-              <a:t>Fuente: libro, capítulos 5 y 6: resultados/experimentos/por_bloque.csv, resultados/prueba_2026/segmentos.csv</a:t>
+              <a:t>Fuente: libro, capítulos 6 y 7: resultados/experimentos/por_bloque.csv, resultados/prueba_2026/segmentos.csv</a:t>
             </a:r>
           </a:p>
         </p:txBody>
@@ -16475,7 +16475,7 @@
                 </a:solidFill>
                 <a:latin typeface="Calibri"/>
               </a:rPr>
-              <a:t>Por qué XGBoost y no la logística, que es más simple</a:t>
+              <a:t>En otros datos, la propuesta gana donde hay historia por entidad</a:t>
             </a:r>
           </a:p>
         </p:txBody>
@@ -16510,7 +16510,7 @@
                 </a:solidFill>
                 <a:latin typeface="Calibri"/>
               </a:rPr>
-              <a:t>CRITERIO 5  ·  PARSIMONIA CON CIFRAS</a:t>
+              <a:t>CRITERIO 6  ·  VALIDACIÓN EN CONJUNTOS PÚBLICOS</a:t>
             </a:r>
           </a:p>
         </p:txBody>
@@ -16559,16 +16559,1339 @@
           </a:p>
         </p:txBody>
       </p:sp>
-      <p:sp>
-        <p:nvSpPr>
-          <p:cNvPr id="9" name="Rectangle 8"/>
+      <p:graphicFrame>
+        <p:nvGraphicFramePr>
+          <p:cNvPr id="9" name="Table 8"/>
+          <p:cNvGraphicFramePr>
+            <a:graphicFrameLocks noGrp="1"/>
+          </p:cNvGraphicFramePr>
+          <p:nvPr/>
+        </p:nvGraphicFramePr>
+        <p:xfrm>
+          <a:off x="468000" y="1188000"/>
+          <a:ext cx="5183997" cy="2592000"/>
+        </p:xfrm>
+        <a:graphic>
+          <a:graphicData uri="http://schemas.openxmlformats.org/drawingml/2006/table">
+            <a:tbl>
+              <a:tblPr firstRow="1" bandRow="1">
+                <a:tableStyleId>{5C22544A-7EE6-4342-B048-85BDC9FD1C3A}</a:tableStyleId>
+              </a:tblPr>
+              <a:tblGrid>
+                <a:gridCol w="1562301"/>
+                <a:gridCol w="639123"/>
+                <a:gridCol w="568109"/>
+                <a:gridCol w="1278246"/>
+                <a:gridCol w="497095"/>
+                <a:gridCol w="639123"/>
+              </a:tblGrid>
+              <a:tr h="324000">
+                <a:tc>
+                  <a:txBody>
+                    <a:bodyPr wrap="square"/>
+                    <a:lstStyle/>
+                    <a:p>
+                      <a:pPr algn="l"/>
+                      <a:r>
+                        <a:rPr sz="1050" b="1">
+                          <a:solidFill>
+                            <a:srgbClr val="FFFFFF"/>
+                          </a:solidFill>
+                          <a:latin typeface="Calibri"/>
+                        </a:rPr>
+                        <a:t>conjunto</a:t>
+                      </a:r>
+                    </a:p>
+                  </a:txBody>
+                  <a:tcPr marL="57600" marR="57600" marT="14400" marB="14400" anchor="ctr">
+                    <a:solidFill>
+                      <a:srgbClr val="405731"/>
+                    </a:solidFill>
+                  </a:tcPr>
+                </a:tc>
+                <a:tc>
+                  <a:txBody>
+                    <a:bodyPr wrap="square"/>
+                    <a:lstStyle/>
+                    <a:p>
+                      <a:pPr algn="ctr"/>
+                      <a:r>
+                        <a:rPr sz="1050" b="1">
+                          <a:solidFill>
+                            <a:srgbClr val="FFFFFF"/>
+                          </a:solidFill>
+                          <a:latin typeface="Calibri"/>
+                        </a:rPr>
+                        <a:t>AUC XGBoost</a:t>
+                      </a:r>
+                    </a:p>
+                  </a:txBody>
+                  <a:tcPr marL="57600" marR="57600" marT="14400" marB="14400" anchor="ctr">
+                    <a:solidFill>
+                      <a:srgbClr val="405731"/>
+                    </a:solidFill>
+                  </a:tcPr>
+                </a:tc>
+                <a:tc>
+                  <a:txBody>
+                    <a:bodyPr wrap="square"/>
+                    <a:lstStyle/>
+                    <a:p>
+                      <a:pPr algn="ctr"/>
+                      <a:r>
+                        <a:rPr sz="1050" b="1">
+                          <a:solidFill>
+                            <a:srgbClr val="FFFFFF"/>
+                          </a:solidFill>
+                          <a:latin typeface="Calibri"/>
+                        </a:rPr>
+                        <a:t>AUC K3</a:t>
+                      </a:r>
+                    </a:p>
+                  </a:txBody>
+                  <a:tcPr marL="57600" marR="57600" marT="14400" marB="14400" anchor="ctr">
+                    <a:solidFill>
+                      <a:srgbClr val="405731"/>
+                    </a:solidFill>
+                  </a:tcPr>
+                </a:tc>
+                <a:tc>
+                  <a:txBody>
+                    <a:bodyPr wrap="square"/>
+                    <a:lstStyle/>
+                    <a:p>
+                      <a:pPr algn="ctr"/>
+                      <a:r>
+                        <a:rPr sz="1050" b="1">
+                          <a:solidFill>
+                            <a:srgbClr val="FFFFFF"/>
+                          </a:solidFill>
+                          <a:latin typeface="Calibri"/>
+                        </a:rPr>
+                        <a:t>Δ [IC 95 %]</a:t>
+                      </a:r>
+                    </a:p>
+                  </a:txBody>
+                  <a:tcPr marL="57600" marR="57600" marT="14400" marB="14400" anchor="ctr">
+                    <a:solidFill>
+                      <a:srgbClr val="405731"/>
+                    </a:solidFill>
+                  </a:tcPr>
+                </a:tc>
+                <a:tc>
+                  <a:txBody>
+                    <a:bodyPr wrap="square"/>
+                    <a:lstStyle/>
+                    <a:p>
+                      <a:pPr algn="ctr"/>
+                      <a:r>
+                        <a:rPr sz="1050" b="1">
+                          <a:solidFill>
+                            <a:srgbClr val="FFFFFF"/>
+                          </a:solidFill>
+                          <a:latin typeface="Calibri"/>
+                        </a:rPr>
+                        <a:t>p Holm</a:t>
+                      </a:r>
+                    </a:p>
+                  </a:txBody>
+                  <a:tcPr marL="57600" marR="57600" marT="14400" marB="14400" anchor="ctr">
+                    <a:solidFill>
+                      <a:srgbClr val="405731"/>
+                    </a:solidFill>
+                  </a:tcPr>
+                </a:tc>
+                <a:tc>
+                  <a:txBody>
+                    <a:bodyPr wrap="square"/>
+                    <a:lstStyle/>
+                    <a:p>
+                      <a:pPr algn="ctr"/>
+                      <a:r>
+                        <a:rPr sz="1050" b="1">
+                          <a:solidFill>
+                            <a:srgbClr val="FFFFFF"/>
+                          </a:solidFill>
+                          <a:latin typeface="Calibri"/>
+                        </a:rPr>
+                        <a:t>veredicto</a:t>
+                      </a:r>
+                    </a:p>
+                  </a:txBody>
+                  <a:tcPr marL="57600" marR="57600" marT="14400" marB="14400" anchor="ctr">
+                    <a:solidFill>
+                      <a:srgbClr val="405731"/>
+                    </a:solidFill>
+                  </a:tcPr>
+                </a:tc>
+              </a:tr>
+              <a:tr h="324000">
+                <a:tc>
+                  <a:txBody>
+                    <a:bodyPr wrap="square"/>
+                    <a:lstStyle/>
+                    <a:p>
+                      <a:pPr algn="l"/>
+                      <a:r>
+                        <a:rPr sz="950" b="1">
+                          <a:solidFill>
+                            <a:srgbClr val="1A1A1A"/>
+                          </a:solidFill>
+                          <a:latin typeface="Calibri"/>
+                        </a:rPr>
+                        <a:t>Vuelos (Airlines)</a:t>
+                      </a:r>
+                    </a:p>
+                  </a:txBody>
+                  <a:tcPr marL="57600" marR="57600" marT="14400" marB="14400" anchor="ctr">
+                    <a:solidFill>
+                      <a:srgbClr val="FFFFFF"/>
+                    </a:solidFill>
+                  </a:tcPr>
+                </a:tc>
+                <a:tc>
+                  <a:txBody>
+                    <a:bodyPr wrap="square"/>
+                    <a:lstStyle/>
+                    <a:p>
+                      <a:pPr algn="ctr"/>
+                      <a:r>
+                        <a:rPr sz="950" b="0">
+                          <a:solidFill>
+                            <a:srgbClr val="1A1A1A"/>
+                          </a:solidFill>
+                          <a:latin typeface="Calibri"/>
+                        </a:rPr>
+                        <a:t>0,635</a:t>
+                      </a:r>
+                    </a:p>
+                  </a:txBody>
+                  <a:tcPr marL="57600" marR="57600" marT="14400" marB="14400" anchor="ctr">
+                    <a:solidFill>
+                      <a:srgbClr val="FFFFFF"/>
+                    </a:solidFill>
+                  </a:tcPr>
+                </a:tc>
+                <a:tc>
+                  <a:txBody>
+                    <a:bodyPr wrap="square"/>
+                    <a:lstStyle/>
+                    <a:p>
+                      <a:pPr algn="ctr"/>
+                      <a:r>
+                        <a:rPr sz="950" b="0">
+                          <a:solidFill>
+                            <a:srgbClr val="1A1A1A"/>
+                          </a:solidFill>
+                          <a:latin typeface="Calibri"/>
+                        </a:rPr>
+                        <a:t>0,634</a:t>
+                      </a:r>
+                    </a:p>
+                  </a:txBody>
+                  <a:tcPr marL="57600" marR="57600" marT="14400" marB="14400" anchor="ctr">
+                    <a:solidFill>
+                      <a:srgbClr val="FFFFFF"/>
+                    </a:solidFill>
+                  </a:tcPr>
+                </a:tc>
+                <a:tc>
+                  <a:txBody>
+                    <a:bodyPr wrap="square"/>
+                    <a:lstStyle/>
+                    <a:p>
+                      <a:pPr algn="ctr"/>
+                      <a:r>
+                        <a:rPr sz="950" b="0">
+                          <a:solidFill>
+                            <a:srgbClr val="1A1A1A"/>
+                          </a:solidFill>
+                          <a:latin typeface="Calibri"/>
+                        </a:rPr>
+                        <a:t>-0,002 [-0,006; 0,003]</a:t>
+                      </a:r>
+                    </a:p>
+                  </a:txBody>
+                  <a:tcPr marL="57600" marR="57600" marT="14400" marB="14400" anchor="ctr">
+                    <a:solidFill>
+                      <a:srgbClr val="FFFFFF"/>
+                    </a:solidFill>
+                  </a:tcPr>
+                </a:tc>
+                <a:tc>
+                  <a:txBody>
+                    <a:bodyPr wrap="square"/>
+                    <a:lstStyle/>
+                    <a:p>
+                      <a:pPr algn="ctr"/>
+                      <a:r>
+                        <a:rPr sz="950" b="0">
+                          <a:solidFill>
+                            <a:srgbClr val="1A1A1A"/>
+                          </a:solidFill>
+                          <a:latin typeface="Calibri"/>
+                        </a:rPr>
+                        <a:t>0,965</a:t>
+                      </a:r>
+                    </a:p>
+                  </a:txBody>
+                  <a:tcPr marL="57600" marR="57600" marT="14400" marB="14400" anchor="ctr">
+                    <a:solidFill>
+                      <a:srgbClr val="FFFFFF"/>
+                    </a:solidFill>
+                  </a:tcPr>
+                </a:tc>
+                <a:tc>
+                  <a:txBody>
+                    <a:bodyPr wrap="square"/>
+                    <a:lstStyle/>
+                    <a:p>
+                      <a:pPr algn="ctr"/>
+                      <a:r>
+                        <a:rPr sz="950" b="0">
+                          <a:solidFill>
+                            <a:srgbClr val="1A1A1A"/>
+                          </a:solidFill>
+                          <a:latin typeface="Calibri"/>
+                        </a:rPr>
+                        <a:t>empate</a:t>
+                      </a:r>
+                    </a:p>
+                  </a:txBody>
+                  <a:tcPr marL="57600" marR="57600" marT="14400" marB="14400" anchor="ctr">
+                    <a:solidFill>
+                      <a:srgbClr val="FFFFFF"/>
+                    </a:solidFill>
+                  </a:tcPr>
+                </a:tc>
+              </a:tr>
+              <a:tr h="324000">
+                <a:tc>
+                  <a:txBody>
+                    <a:bodyPr wrap="square"/>
+                    <a:lstStyle/>
+                    <a:p>
+                      <a:pPr algn="l"/>
+                      <a:r>
+                        <a:rPr sz="950" b="1">
+                          <a:solidFill>
+                            <a:srgbClr val="1A1A1A"/>
+                          </a:solidFill>
+                          <a:latin typeface="Calibri"/>
+                        </a:rPr>
+                        <a:t>Acceso (Amazon)</a:t>
+                      </a:r>
+                    </a:p>
+                  </a:txBody>
+                  <a:tcPr marL="57600" marR="57600" marT="14400" marB="14400" anchor="ctr">
+                    <a:solidFill>
+                      <a:srgbClr val="EEF2EA"/>
+                    </a:solidFill>
+                  </a:tcPr>
+                </a:tc>
+                <a:tc>
+                  <a:txBody>
+                    <a:bodyPr wrap="square"/>
+                    <a:lstStyle/>
+                    <a:p>
+                      <a:pPr algn="ctr"/>
+                      <a:r>
+                        <a:rPr sz="950" b="0">
+                          <a:solidFill>
+                            <a:srgbClr val="1A1A1A"/>
+                          </a:solidFill>
+                          <a:latin typeface="Calibri"/>
+                        </a:rPr>
+                        <a:t>0,870</a:t>
+                      </a:r>
+                    </a:p>
+                  </a:txBody>
+                  <a:tcPr marL="57600" marR="57600" marT="14400" marB="14400" anchor="ctr">
+                    <a:solidFill>
+                      <a:srgbClr val="EEF2EA"/>
+                    </a:solidFill>
+                  </a:tcPr>
+                </a:tc>
+                <a:tc>
+                  <a:txBody>
+                    <a:bodyPr wrap="square"/>
+                    <a:lstStyle/>
+                    <a:p>
+                      <a:pPr algn="ctr"/>
+                      <a:r>
+                        <a:rPr sz="950" b="0">
+                          <a:solidFill>
+                            <a:srgbClr val="1A1A1A"/>
+                          </a:solidFill>
+                          <a:latin typeface="Calibri"/>
+                        </a:rPr>
+                        <a:t>0,856</a:t>
+                      </a:r>
+                    </a:p>
+                  </a:txBody>
+                  <a:tcPr marL="57600" marR="57600" marT="14400" marB="14400" anchor="ctr">
+                    <a:solidFill>
+                      <a:srgbClr val="EEF2EA"/>
+                    </a:solidFill>
+                  </a:tcPr>
+                </a:tc>
+                <a:tc>
+                  <a:txBody>
+                    <a:bodyPr wrap="square"/>
+                    <a:lstStyle/>
+                    <a:p>
+                      <a:pPr algn="ctr"/>
+                      <a:r>
+                        <a:rPr sz="950" b="0">
+                          <a:solidFill>
+                            <a:srgbClr val="1A1A1A"/>
+                          </a:solidFill>
+                          <a:latin typeface="Calibri"/>
+                        </a:rPr>
+                        <a:t>-0,013 [-0,022; -0,004]</a:t>
+                      </a:r>
+                    </a:p>
+                  </a:txBody>
+                  <a:tcPr marL="57600" marR="57600" marT="14400" marB="14400" anchor="ctr">
+                    <a:solidFill>
+                      <a:srgbClr val="EEF2EA"/>
+                    </a:solidFill>
+                  </a:tcPr>
+                </a:tc>
+                <a:tc>
+                  <a:txBody>
+                    <a:bodyPr wrap="square"/>
+                    <a:lstStyle/>
+                    <a:p>
+                      <a:pPr algn="ctr"/>
+                      <a:r>
+                        <a:rPr sz="950" b="0">
+                          <a:solidFill>
+                            <a:srgbClr val="1A1A1A"/>
+                          </a:solidFill>
+                          <a:latin typeface="Calibri"/>
+                        </a:rPr>
+                        <a:t>0,038</a:t>
+                      </a:r>
+                    </a:p>
+                  </a:txBody>
+                  <a:tcPr marL="57600" marR="57600" marT="14400" marB="14400" anchor="ctr">
+                    <a:solidFill>
+                      <a:srgbClr val="EEF2EA"/>
+                    </a:solidFill>
+                  </a:tcPr>
+                </a:tc>
+                <a:tc>
+                  <a:txBody>
+                    <a:bodyPr wrap="square"/>
+                    <a:lstStyle/>
+                    <a:p>
+                      <a:pPr algn="ctr"/>
+                      <a:r>
+                        <a:rPr sz="950" b="0">
+                          <a:solidFill>
+                            <a:srgbClr val="1A1A1A"/>
+                          </a:solidFill>
+                          <a:latin typeface="Calibri"/>
+                        </a:rPr>
+                        <a:t>K3 pierde</a:t>
+                      </a:r>
+                    </a:p>
+                  </a:txBody>
+                  <a:tcPr marL="57600" marR="57600" marT="14400" marB="14400" anchor="ctr">
+                    <a:solidFill>
+                      <a:srgbClr val="EEF2EA"/>
+                    </a:solidFill>
+                  </a:tcPr>
+                </a:tc>
+              </a:tr>
+              <a:tr h="324000">
+                <a:tc>
+                  <a:txBody>
+                    <a:bodyPr wrap="square"/>
+                    <a:lstStyle/>
+                    <a:p>
+                      <a:pPr algn="l"/>
+                      <a:r>
+                        <a:rPr sz="950" b="1">
+                          <a:solidFill>
+                            <a:srgbClr val="1A1A1A"/>
+                          </a:solidFill>
+                          <a:latin typeface="Calibri"/>
+                        </a:rPr>
+                        <a:t>Publicidad (Click)</a:t>
+                      </a:r>
+                    </a:p>
+                  </a:txBody>
+                  <a:tcPr marL="57600" marR="57600" marT="14400" marB="14400" anchor="ctr">
+                    <a:solidFill>
+                      <a:srgbClr val="FFFFFF"/>
+                    </a:solidFill>
+                  </a:tcPr>
+                </a:tc>
+                <a:tc>
+                  <a:txBody>
+                    <a:bodyPr wrap="square"/>
+                    <a:lstStyle/>
+                    <a:p>
+                      <a:pPr algn="ctr"/>
+                      <a:r>
+                        <a:rPr sz="950" b="0">
+                          <a:solidFill>
+                            <a:srgbClr val="1A1A1A"/>
+                          </a:solidFill>
+                          <a:latin typeface="Calibri"/>
+                        </a:rPr>
+                        <a:t>0,707</a:t>
+                      </a:r>
+                    </a:p>
+                  </a:txBody>
+                  <a:tcPr marL="57600" marR="57600" marT="14400" marB="14400" anchor="ctr">
+                    <a:solidFill>
+                      <a:srgbClr val="FFFFFF"/>
+                    </a:solidFill>
+                  </a:tcPr>
+                </a:tc>
+                <a:tc>
+                  <a:txBody>
+                    <a:bodyPr wrap="square"/>
+                    <a:lstStyle/>
+                    <a:p>
+                      <a:pPr algn="ctr"/>
+                      <a:r>
+                        <a:rPr sz="950" b="0">
+                          <a:solidFill>
+                            <a:srgbClr val="1A1A1A"/>
+                          </a:solidFill>
+                          <a:latin typeface="Calibri"/>
+                        </a:rPr>
+                        <a:t>0,699</a:t>
+                      </a:r>
+                    </a:p>
+                  </a:txBody>
+                  <a:tcPr marL="57600" marR="57600" marT="14400" marB="14400" anchor="ctr">
+                    <a:solidFill>
+                      <a:srgbClr val="FFFFFF"/>
+                    </a:solidFill>
+                  </a:tcPr>
+                </a:tc>
+                <a:tc>
+                  <a:txBody>
+                    <a:bodyPr wrap="square"/>
+                    <a:lstStyle/>
+                    <a:p>
+                      <a:pPr algn="ctr"/>
+                      <a:r>
+                        <a:rPr sz="950" b="0">
+                          <a:solidFill>
+                            <a:srgbClr val="1A1A1A"/>
+                          </a:solidFill>
+                          <a:latin typeface="Calibri"/>
+                        </a:rPr>
+                        <a:t>-0,008 [-0,014; -0,002]</a:t>
+                      </a:r>
+                    </a:p>
+                  </a:txBody>
+                  <a:tcPr marL="57600" marR="57600" marT="14400" marB="14400" anchor="ctr">
+                    <a:solidFill>
+                      <a:srgbClr val="FFFFFF"/>
+                    </a:solidFill>
+                  </a:tcPr>
+                </a:tc>
+                <a:tc>
+                  <a:txBody>
+                    <a:bodyPr wrap="square"/>
+                    <a:lstStyle/>
+                    <a:p>
+                      <a:pPr algn="ctr"/>
+                      <a:r>
+                        <a:rPr sz="950" b="0">
+                          <a:solidFill>
+                            <a:srgbClr val="1A1A1A"/>
+                          </a:solidFill>
+                          <a:latin typeface="Calibri"/>
+                        </a:rPr>
+                        <a:t>0,043</a:t>
+                      </a:r>
+                    </a:p>
+                  </a:txBody>
+                  <a:tcPr marL="57600" marR="57600" marT="14400" marB="14400" anchor="ctr">
+                    <a:solidFill>
+                      <a:srgbClr val="FFFFFF"/>
+                    </a:solidFill>
+                  </a:tcPr>
+                </a:tc>
+                <a:tc>
+                  <a:txBody>
+                    <a:bodyPr wrap="square"/>
+                    <a:lstStyle/>
+                    <a:p>
+                      <a:pPr algn="ctr"/>
+                      <a:r>
+                        <a:rPr sz="950" b="0">
+                          <a:solidFill>
+                            <a:srgbClr val="1A1A1A"/>
+                          </a:solidFill>
+                          <a:latin typeface="Calibri"/>
+                        </a:rPr>
+                        <a:t>K3 pierde</a:t>
+                      </a:r>
+                    </a:p>
+                  </a:txBody>
+                  <a:tcPr marL="57600" marR="57600" marT="14400" marB="14400" anchor="ctr">
+                    <a:solidFill>
+                      <a:srgbClr val="FFFFFF"/>
+                    </a:solidFill>
+                  </a:tcPr>
+                </a:tc>
+              </a:tr>
+              <a:tr h="324000">
+                <a:tc>
+                  <a:txBody>
+                    <a:bodyPr wrap="square"/>
+                    <a:lstStyle/>
+                    <a:p>
+                      <a:pPr algn="l"/>
+                      <a:r>
+                        <a:rPr sz="950" b="1">
+                          <a:solidFill>
+                            <a:srgbClr val="1A1A1A"/>
+                          </a:solidFill>
+                          <a:latin typeface="Calibri"/>
+                        </a:rPr>
+                        <a:t>Buses de Nueva York</a:t>
+                      </a:r>
+                    </a:p>
+                  </a:txBody>
+                  <a:tcPr marL="57600" marR="57600" marT="14400" marB="14400" anchor="ctr">
+                    <a:solidFill>
+                      <a:srgbClr val="EEF2EA"/>
+                    </a:solidFill>
+                  </a:tcPr>
+                </a:tc>
+                <a:tc>
+                  <a:txBody>
+                    <a:bodyPr wrap="square"/>
+                    <a:lstStyle/>
+                    <a:p>
+                      <a:pPr algn="ctr"/>
+                      <a:r>
+                        <a:rPr sz="950" b="0">
+                          <a:solidFill>
+                            <a:srgbClr val="1A1A1A"/>
+                          </a:solidFill>
+                          <a:latin typeface="Calibri"/>
+                        </a:rPr>
+                        <a:t>0,846</a:t>
+                      </a:r>
+                    </a:p>
+                  </a:txBody>
+                  <a:tcPr marL="57600" marR="57600" marT="14400" marB="14400" anchor="ctr">
+                    <a:solidFill>
+                      <a:srgbClr val="EEF2EA"/>
+                    </a:solidFill>
+                  </a:tcPr>
+                </a:tc>
+                <a:tc>
+                  <a:txBody>
+                    <a:bodyPr wrap="square"/>
+                    <a:lstStyle/>
+                    <a:p>
+                      <a:pPr algn="ctr"/>
+                      <a:r>
+                        <a:rPr sz="950" b="0">
+                          <a:solidFill>
+                            <a:srgbClr val="1A1A1A"/>
+                          </a:solidFill>
+                          <a:latin typeface="Calibri"/>
+                        </a:rPr>
+                        <a:t>0,844</a:t>
+                      </a:r>
+                    </a:p>
+                  </a:txBody>
+                  <a:tcPr marL="57600" marR="57600" marT="14400" marB="14400" anchor="ctr">
+                    <a:solidFill>
+                      <a:srgbClr val="EEF2EA"/>
+                    </a:solidFill>
+                  </a:tcPr>
+                </a:tc>
+                <a:tc>
+                  <a:txBody>
+                    <a:bodyPr wrap="square"/>
+                    <a:lstStyle/>
+                    <a:p>
+                      <a:pPr algn="ctr"/>
+                      <a:r>
+                        <a:rPr sz="950" b="0">
+                          <a:solidFill>
+                            <a:srgbClr val="1A1A1A"/>
+                          </a:solidFill>
+                          <a:latin typeface="Calibri"/>
+                        </a:rPr>
+                        <a:t>-0,002 [-0,004; 0,001]</a:t>
+                      </a:r>
+                    </a:p>
+                  </a:txBody>
+                  <a:tcPr marL="57600" marR="57600" marT="14400" marB="14400" anchor="ctr">
+                    <a:solidFill>
+                      <a:srgbClr val="EEF2EA"/>
+                    </a:solidFill>
+                  </a:tcPr>
+                </a:tc>
+                <a:tc>
+                  <a:txBody>
+                    <a:bodyPr wrap="square"/>
+                    <a:lstStyle/>
+                    <a:p>
+                      <a:pPr algn="ctr"/>
+                      <a:r>
+                        <a:rPr sz="950" b="0">
+                          <a:solidFill>
+                            <a:srgbClr val="1A1A1A"/>
+                          </a:solidFill>
+                          <a:latin typeface="Calibri"/>
+                        </a:rPr>
+                        <a:t>0,632</a:t>
+                      </a:r>
+                    </a:p>
+                  </a:txBody>
+                  <a:tcPr marL="57600" marR="57600" marT="14400" marB="14400" anchor="ctr">
+                    <a:solidFill>
+                      <a:srgbClr val="EEF2EA"/>
+                    </a:solidFill>
+                  </a:tcPr>
+                </a:tc>
+                <a:tc>
+                  <a:txBody>
+                    <a:bodyPr wrap="square"/>
+                    <a:lstStyle/>
+                    <a:p>
+                      <a:pPr algn="ctr"/>
+                      <a:r>
+                        <a:rPr sz="950" b="0">
+                          <a:solidFill>
+                            <a:srgbClr val="1A1A1A"/>
+                          </a:solidFill>
+                          <a:latin typeface="Calibri"/>
+                        </a:rPr>
+                        <a:t>empate</a:t>
+                      </a:r>
+                    </a:p>
+                  </a:txBody>
+                  <a:tcPr marL="57600" marR="57600" marT="14400" marB="14400" anchor="ctr">
+                    <a:solidFill>
+                      <a:srgbClr val="EEF2EA"/>
+                    </a:solidFill>
+                  </a:tcPr>
+                </a:tc>
+              </a:tr>
+              <a:tr h="324000">
+                <a:tc>
+                  <a:txBody>
+                    <a:bodyPr wrap="square"/>
+                    <a:lstStyle/>
+                    <a:p>
+                      <a:pPr algn="l"/>
+                      <a:r>
+                        <a:rPr sz="950" b="1">
+                          <a:solidFill>
+                            <a:srgbClr val="1A1A1A"/>
+                          </a:solidFill>
+                          <a:latin typeface="Calibri"/>
+                        </a:rPr>
+                        <a:t>Transporte de Zúrich</a:t>
+                      </a:r>
+                    </a:p>
+                  </a:txBody>
+                  <a:tcPr marL="57600" marR="57600" marT="14400" marB="14400" anchor="ctr">
+                    <a:solidFill>
+                      <a:srgbClr val="FFFFFF"/>
+                    </a:solidFill>
+                  </a:tcPr>
+                </a:tc>
+                <a:tc>
+                  <a:txBody>
+                    <a:bodyPr wrap="square"/>
+                    <a:lstStyle/>
+                    <a:p>
+                      <a:pPr algn="ctr"/>
+                      <a:r>
+                        <a:rPr sz="950" b="0">
+                          <a:solidFill>
+                            <a:srgbClr val="1A1A1A"/>
+                          </a:solidFill>
+                          <a:latin typeface="Calibri"/>
+                        </a:rPr>
+                        <a:t>0,832</a:t>
+                      </a:r>
+                    </a:p>
+                  </a:txBody>
+                  <a:tcPr marL="57600" marR="57600" marT="14400" marB="14400" anchor="ctr">
+                    <a:solidFill>
+                      <a:srgbClr val="FFFFFF"/>
+                    </a:solidFill>
+                  </a:tcPr>
+                </a:tc>
+                <a:tc>
+                  <a:txBody>
+                    <a:bodyPr wrap="square"/>
+                    <a:lstStyle/>
+                    <a:p>
+                      <a:pPr algn="ctr"/>
+                      <a:r>
+                        <a:rPr sz="950" b="0">
+                          <a:solidFill>
+                            <a:srgbClr val="1A1A1A"/>
+                          </a:solidFill>
+                          <a:latin typeface="Calibri"/>
+                        </a:rPr>
+                        <a:t>0,833</a:t>
+                      </a:r>
+                    </a:p>
+                  </a:txBody>
+                  <a:tcPr marL="57600" marR="57600" marT="14400" marB="14400" anchor="ctr">
+                    <a:solidFill>
+                      <a:srgbClr val="FFFFFF"/>
+                    </a:solidFill>
+                  </a:tcPr>
+                </a:tc>
+                <a:tc>
+                  <a:txBody>
+                    <a:bodyPr wrap="square"/>
+                    <a:lstStyle/>
+                    <a:p>
+                      <a:pPr algn="ctr"/>
+                      <a:r>
+                        <a:rPr sz="950" b="0">
+                          <a:solidFill>
+                            <a:srgbClr val="1A1A1A"/>
+                          </a:solidFill>
+                          <a:latin typeface="Calibri"/>
+                        </a:rPr>
+                        <a:t>0,001 [-0,008; 0,008]</a:t>
+                      </a:r>
+                    </a:p>
+                  </a:txBody>
+                  <a:tcPr marL="57600" marR="57600" marT="14400" marB="14400" anchor="ctr">
+                    <a:solidFill>
+                      <a:srgbClr val="FFFFFF"/>
+                    </a:solidFill>
+                  </a:tcPr>
+                </a:tc>
+                <a:tc>
+                  <a:txBody>
+                    <a:bodyPr wrap="square"/>
+                    <a:lstStyle/>
+                    <a:p>
+                      <a:pPr algn="ctr"/>
+                      <a:r>
+                        <a:rPr sz="950" b="0">
+                          <a:solidFill>
+                            <a:srgbClr val="1A1A1A"/>
+                          </a:solidFill>
+                          <a:latin typeface="Calibri"/>
+                        </a:rPr>
+                        <a:t>0,965</a:t>
+                      </a:r>
+                    </a:p>
+                  </a:txBody>
+                  <a:tcPr marL="57600" marR="57600" marT="14400" marB="14400" anchor="ctr">
+                    <a:solidFill>
+                      <a:srgbClr val="FFFFFF"/>
+                    </a:solidFill>
+                  </a:tcPr>
+                </a:tc>
+                <a:tc>
+                  <a:txBody>
+                    <a:bodyPr wrap="square"/>
+                    <a:lstStyle/>
+                    <a:p>
+                      <a:pPr algn="ctr"/>
+                      <a:r>
+                        <a:rPr sz="950" b="0">
+                          <a:solidFill>
+                            <a:srgbClr val="1A1A1A"/>
+                          </a:solidFill>
+                          <a:latin typeface="Calibri"/>
+                        </a:rPr>
+                        <a:t>empate</a:t>
+                      </a:r>
+                    </a:p>
+                  </a:txBody>
+                  <a:tcPr marL="57600" marR="57600" marT="14400" marB="14400" anchor="ctr">
+                    <a:solidFill>
+                      <a:srgbClr val="FFFFFF"/>
+                    </a:solidFill>
+                  </a:tcPr>
+                </a:tc>
+              </a:tr>
+              <a:tr h="324000">
+                <a:tc>
+                  <a:txBody>
+                    <a:bodyPr wrap="square"/>
+                    <a:lstStyle/>
+                    <a:p>
+                      <a:pPr algn="l"/>
+                      <a:r>
+                        <a:rPr sz="950" b="1">
+                          <a:solidFill>
+                            <a:srgbClr val="1A1A1A"/>
+                          </a:solidFill>
+                          <a:latin typeface="Calibri"/>
+                        </a:rPr>
+                        <a:t>Reingreso (Diabetes130US)</a:t>
+                      </a:r>
+                    </a:p>
+                  </a:txBody>
+                  <a:tcPr marL="57600" marR="57600" marT="14400" marB="14400" anchor="ctr">
+                    <a:solidFill>
+                      <a:srgbClr val="EEF2EA"/>
+                    </a:solidFill>
+                  </a:tcPr>
+                </a:tc>
+                <a:tc>
+                  <a:txBody>
+                    <a:bodyPr wrap="square"/>
+                    <a:lstStyle/>
+                    <a:p>
+                      <a:pPr algn="ctr"/>
+                      <a:r>
+                        <a:rPr sz="950" b="0">
+                          <a:solidFill>
+                            <a:srgbClr val="1A1A1A"/>
+                          </a:solidFill>
+                          <a:latin typeface="Calibri"/>
+                        </a:rPr>
+                        <a:t>0,659</a:t>
+                      </a:r>
+                    </a:p>
+                  </a:txBody>
+                  <a:tcPr marL="57600" marR="57600" marT="14400" marB="14400" anchor="ctr">
+                    <a:solidFill>
+                      <a:srgbClr val="EEF2EA"/>
+                    </a:solidFill>
+                  </a:tcPr>
+                </a:tc>
+                <a:tc>
+                  <a:txBody>
+                    <a:bodyPr wrap="square"/>
+                    <a:lstStyle/>
+                    <a:p>
+                      <a:pPr algn="ctr"/>
+                      <a:r>
+                        <a:rPr sz="950" b="0">
+                          <a:solidFill>
+                            <a:srgbClr val="1A1A1A"/>
+                          </a:solidFill>
+                          <a:latin typeface="Calibri"/>
+                        </a:rPr>
+                        <a:t>0,675</a:t>
+                      </a:r>
+                    </a:p>
+                  </a:txBody>
+                  <a:tcPr marL="57600" marR="57600" marT="14400" marB="14400" anchor="ctr">
+                    <a:solidFill>
+                      <a:srgbClr val="EEF2EA"/>
+                    </a:solidFill>
+                  </a:tcPr>
+                </a:tc>
+                <a:tc>
+                  <a:txBody>
+                    <a:bodyPr wrap="square"/>
+                    <a:lstStyle/>
+                    <a:p>
+                      <a:pPr algn="ctr"/>
+                      <a:r>
+                        <a:rPr sz="950" b="0">
+                          <a:solidFill>
+                            <a:srgbClr val="1A1A1A"/>
+                          </a:solidFill>
+                          <a:latin typeface="Calibri"/>
+                        </a:rPr>
+                        <a:t>0,016 [0,008; 0,024]</a:t>
+                      </a:r>
+                    </a:p>
+                  </a:txBody>
+                  <a:tcPr marL="57600" marR="57600" marT="14400" marB="14400" anchor="ctr">
+                    <a:solidFill>
+                      <a:srgbClr val="EEF2EA"/>
+                    </a:solidFill>
+                  </a:tcPr>
+                </a:tc>
+                <a:tc>
+                  <a:txBody>
+                    <a:bodyPr wrap="square"/>
+                    <a:lstStyle/>
+                    <a:p>
+                      <a:pPr algn="ctr"/>
+                      <a:r>
+                        <a:rPr sz="950" b="0">
+                          <a:solidFill>
+                            <a:srgbClr val="1A1A1A"/>
+                          </a:solidFill>
+                          <a:latin typeface="Calibri"/>
+                        </a:rPr>
+                        <a:t>0,001</a:t>
+                      </a:r>
+                    </a:p>
+                  </a:txBody>
+                  <a:tcPr marL="57600" marR="57600" marT="14400" marB="14400" anchor="ctr">
+                    <a:solidFill>
+                      <a:srgbClr val="EEF2EA"/>
+                    </a:solidFill>
+                  </a:tcPr>
+                </a:tc>
+                <a:tc>
+                  <a:txBody>
+                    <a:bodyPr wrap="square"/>
+                    <a:lstStyle/>
+                    <a:p>
+                      <a:pPr algn="ctr"/>
+                      <a:r>
+                        <a:rPr sz="950" b="0">
+                          <a:solidFill>
+                            <a:srgbClr val="1A1A1A"/>
+                          </a:solidFill>
+                          <a:latin typeface="Calibri"/>
+                        </a:rPr>
+                        <a:t>K3 gana</a:t>
+                      </a:r>
+                    </a:p>
+                  </a:txBody>
+                  <a:tcPr marL="57600" marR="57600" marT="14400" marB="14400" anchor="ctr">
+                    <a:solidFill>
+                      <a:srgbClr val="EEF2EA"/>
+                    </a:solidFill>
+                  </a:tcPr>
+                </a:tc>
+              </a:tr>
+              <a:tr h="324000">
+                <a:tc>
+                  <a:txBody>
+                    <a:bodyPr wrap="square"/>
+                    <a:lstStyle/>
+                    <a:p>
+                      <a:pPr algn="l"/>
+                      <a:r>
+                        <a:rPr sz="950" b="1">
+                          <a:solidFill>
+                            <a:srgbClr val="1A1A1A"/>
+                          </a:solidFill>
+                          <a:latin typeface="Calibri"/>
+                        </a:rPr>
+                        <a:t>Citas no asistidas</a:t>
+                      </a:r>
+                    </a:p>
+                  </a:txBody>
+                  <a:tcPr marL="57600" marR="57600" marT="14400" marB="14400" anchor="ctr">
+                    <a:solidFill>
+                      <a:srgbClr val="FFFFFF"/>
+                    </a:solidFill>
+                  </a:tcPr>
+                </a:tc>
+                <a:tc>
+                  <a:txBody>
+                    <a:bodyPr wrap="square"/>
+                    <a:lstStyle/>
+                    <a:p>
+                      <a:pPr algn="ctr"/>
+                      <a:r>
+                        <a:rPr sz="950" b="0">
+                          <a:solidFill>
+                            <a:srgbClr val="1A1A1A"/>
+                          </a:solidFill>
+                          <a:latin typeface="Calibri"/>
+                        </a:rPr>
+                        <a:t>0,732</a:t>
+                      </a:r>
+                    </a:p>
+                  </a:txBody>
+                  <a:tcPr marL="57600" marR="57600" marT="14400" marB="14400" anchor="ctr">
+                    <a:solidFill>
+                      <a:srgbClr val="FFFFFF"/>
+                    </a:solidFill>
+                  </a:tcPr>
+                </a:tc>
+                <a:tc>
+                  <a:txBody>
+                    <a:bodyPr wrap="square"/>
+                    <a:lstStyle/>
+                    <a:p>
+                      <a:pPr algn="ctr"/>
+                      <a:r>
+                        <a:rPr sz="950" b="0">
+                          <a:solidFill>
+                            <a:srgbClr val="1A1A1A"/>
+                          </a:solidFill>
+                          <a:latin typeface="Calibri"/>
+                        </a:rPr>
+                        <a:t>0,737</a:t>
+                      </a:r>
+                    </a:p>
+                  </a:txBody>
+                  <a:tcPr marL="57600" marR="57600" marT="14400" marB="14400" anchor="ctr">
+                    <a:solidFill>
+                      <a:srgbClr val="FFFFFF"/>
+                    </a:solidFill>
+                  </a:tcPr>
+                </a:tc>
+                <a:tc>
+                  <a:txBody>
+                    <a:bodyPr wrap="square"/>
+                    <a:lstStyle/>
+                    <a:p>
+                      <a:pPr algn="ctr"/>
+                      <a:r>
+                        <a:rPr sz="950" b="0">
+                          <a:solidFill>
+                            <a:srgbClr val="1A1A1A"/>
+                          </a:solidFill>
+                          <a:latin typeface="Calibri"/>
+                        </a:rPr>
+                        <a:t>0,005 [0,003; 0,008]</a:t>
+                      </a:r>
+                    </a:p>
+                  </a:txBody>
+                  <a:tcPr marL="57600" marR="57600" marT="14400" marB="14400" anchor="ctr">
+                    <a:solidFill>
+                      <a:srgbClr val="FFFFFF"/>
+                    </a:solidFill>
+                  </a:tcPr>
+                </a:tc>
+                <a:tc>
+                  <a:txBody>
+                    <a:bodyPr wrap="square"/>
+                    <a:lstStyle/>
+                    <a:p>
+                      <a:pPr algn="ctr"/>
+                      <a:r>
+                        <a:rPr sz="950" b="0">
+                          <a:solidFill>
+                            <a:srgbClr val="1A1A1A"/>
+                          </a:solidFill>
+                          <a:latin typeface="Calibri"/>
+                        </a:rPr>
+                        <a:t>&lt; 0,001</a:t>
+                      </a:r>
+                    </a:p>
+                  </a:txBody>
+                  <a:tcPr marL="57600" marR="57600" marT="14400" marB="14400" anchor="ctr">
+                    <a:solidFill>
+                      <a:srgbClr val="FFFFFF"/>
+                    </a:solidFill>
+                  </a:tcPr>
+                </a:tc>
+                <a:tc>
+                  <a:txBody>
+                    <a:bodyPr wrap="square"/>
+                    <a:lstStyle/>
+                    <a:p>
+                      <a:pPr algn="ctr"/>
+                      <a:r>
+                        <a:rPr sz="950" b="0">
+                          <a:solidFill>
+                            <a:srgbClr val="1A1A1A"/>
+                          </a:solidFill>
+                          <a:latin typeface="Calibri"/>
+                        </a:rPr>
+                        <a:t>K3 gana</a:t>
+                      </a:r>
+                    </a:p>
+                  </a:txBody>
+                  <a:tcPr marL="57600" marR="57600" marT="14400" marB="14400" anchor="ctr">
+                    <a:solidFill>
+                      <a:srgbClr val="FFFFFF"/>
+                    </a:solidFill>
+                  </a:tcPr>
+                </a:tc>
+              </a:tr>
+            </a:tbl>
+          </a:graphicData>
+        </a:graphic>
+      </p:graphicFrame>
+      <p:sp>
+        <p:nvSpPr>
+          <p:cNvPr id="10" name="TextBox 9"/>
+          <p:cNvSpPr txBox="1"/>
+          <p:nvPr/>
+        </p:nvSpPr>
+        <p:spPr>
+          <a:xfrm>
+            <a:off x="468000" y="3851999"/>
+            <a:ext cx="5184000" cy="864000"/>
+          </a:xfrm>
+          <a:prstGeom prst="rect">
+            <a:avLst/>
+          </a:prstGeom>
+          <a:noFill/>
+        </p:spPr>
+        <p:txBody>
+          <a:bodyPr wrap="square" lIns="0" rIns="0" tIns="0" bIns="0" anchor="t">
+            <a:spAutoFit/>
+          </a:bodyPr>
+          <a:lstStyle/>
+          <a:p>
+            <a:pPr algn="l"/>
+            <a:r>
+              <a:rPr sz="1000" b="0">
+                <a:solidFill>
+                  <a:srgbClr val="5A5A5A"/>
+                </a:solidFill>
+                <a:latin typeface="Calibri"/>
+              </a:rPr>
+              <a:t>Mismo protocolo para los dos: Optuna con 20 evaluaciones en validación, una medida en la prueba, DeLong pareado con Holm sobre los siete. La segunda ronda (filas 4 a 7) se eligió con un criterio fijado antes de correr. El plazo log-normal y las variables nuevas no aplican fuera de OTIF.</a:t>
+            </a:r>
+          </a:p>
+        </p:txBody>
+      </p:sp>
+      <p:sp>
+        <p:nvSpPr>
+          <p:cNvPr id="11" name="Rectangle 10"/>
           <p:cNvSpPr/>
           <p:nvPr/>
         </p:nvSpPr>
         <p:spPr>
           <a:xfrm>
-            <a:off x="468000" y="1245600"/>
-            <a:ext cx="72000" cy="72000"/>
+            <a:off x="5868000" y="1188000"/>
+            <a:ext cx="2844000" cy="2304000"/>
+          </a:xfrm>
+          <a:prstGeom prst="rect">
+            <a:avLst/>
+          </a:prstGeom>
+          <a:solidFill>
+            <a:srgbClr val="E8F0EB"/>
+          </a:solidFill>
+          <a:ln>
+            <a:noFill/>
+          </a:ln>
+          <a:effectLst/>
+        </p:spPr>
+        <p:style>
+          <a:lnRef idx="1">
+            <a:schemeClr val="accent1"/>
+          </a:lnRef>
+          <a:fillRef idx="3">
+            <a:schemeClr val="accent1"/>
+          </a:fillRef>
+          <a:effectRef idx="2">
+            <a:schemeClr val="accent1"/>
+          </a:effectRef>
+          <a:fontRef idx="minor">
+            <a:schemeClr val="lt1"/>
+          </a:fontRef>
+        </p:style>
+        <p:txBody>
+          <a:bodyPr rtlCol="0" anchor="ctr" wrap="square"/>
+          <a:lstStyle/>
+          <a:p>
+            <a:pPr algn="ctr"/>
+          </a:p>
+        </p:txBody>
+      </p:sp>
+      <p:sp>
+        <p:nvSpPr>
+          <p:cNvPr id="12" name="TextBox 11"/>
+          <p:cNvSpPr txBox="1"/>
+          <p:nvPr/>
+        </p:nvSpPr>
+        <p:spPr>
+          <a:xfrm>
+            <a:off x="6030000" y="1295999"/>
+            <a:ext cx="2520000" cy="288000"/>
+          </a:xfrm>
+          <a:prstGeom prst="rect">
+            <a:avLst/>
+          </a:prstGeom>
+          <a:noFill/>
+        </p:spPr>
+        <p:txBody>
+          <a:bodyPr wrap="square" lIns="0" rIns="0" tIns="0" bIns="0" anchor="t">
+            <a:spAutoFit/>
+          </a:bodyPr>
+          <a:lstStyle/>
+          <a:p>
+            <a:pPr algn="l"/>
+            <a:r>
+              <a:rPr sz="1300" b="1">
+                <a:solidFill>
+                  <a:srgbClr val="405731"/>
+                </a:solidFill>
+                <a:latin typeface="Calibri"/>
+              </a:rPr>
+              <a:t>Lectura</a:t>
+            </a:r>
+          </a:p>
+        </p:txBody>
+      </p:sp>
+      <p:sp>
+        <p:nvSpPr>
+          <p:cNvPr id="13" name="TextBox 12"/>
+          <p:cNvSpPr txBox="1"/>
+          <p:nvPr/>
+        </p:nvSpPr>
+        <p:spPr>
+          <a:xfrm>
+            <a:off x="6030000" y="1555200"/>
+            <a:ext cx="2520000" cy="1890000"/>
+          </a:xfrm>
+          <a:prstGeom prst="rect">
+            <a:avLst/>
+          </a:prstGeom>
+          <a:noFill/>
+        </p:spPr>
+        <p:txBody>
+          <a:bodyPr wrap="square" lIns="0" rIns="0" tIns="0" bIns="0" anchor="t">
+            <a:spAutoFit/>
+          </a:bodyPr>
+          <a:lstStyle/>
+          <a:p>
+            <a:pPr algn="l"/>
+            <a:r>
+              <a:rPr sz="1000" b="0">
+                <a:solidFill>
+                  <a:srgbClr val="1A1A1A"/>
+                </a:solidFill>
+                <a:latin typeface="Calibri"/>
+              </a:rPr>
+              <a:t>Gana 2, empata 3, pierde 2; Wilcoxon p = 0,81: no hay superioridad general.</a:t>
+            </a:r>
+          </a:p>
+          <a:p>
+            <a:pPr algn="l"/>
+            <a:r>
+              <a:rPr sz="1000" b="0">
+                <a:solidFill>
+                  <a:srgbClr val="1A1A1A"/>
+                </a:solidFill>
+                <a:latin typeface="Calibri"/>
+              </a:rPr>
+              <a:t>Gana donde la entidad vuelve (el paciente), como el proveedor en OTIF.</a:t>
+            </a:r>
+          </a:p>
+          <a:p>
+            <a:pPr algn="l"/>
+            <a:r>
+              <a:rPr sz="1000" b="0">
+                <a:solidFill>
+                  <a:srgbClr val="1A1A1A"/>
+                </a:solidFill>
+                <a:latin typeface="Calibri"/>
+              </a:rPr>
+              <a:t>Empata en transporte; pierde sin tiempo ni desenlace continuo.</a:t>
+            </a:r>
+          </a:p>
+        </p:txBody>
+      </p:sp>
+      <p:sp>
+        <p:nvSpPr>
+          <p:cNvPr id="14" name="Rectangle 13"/>
+          <p:cNvSpPr/>
+          <p:nvPr/>
+        </p:nvSpPr>
+        <p:spPr>
+          <a:xfrm>
+            <a:off x="5868000" y="3600000"/>
+            <a:ext cx="2844000" cy="1116000"/>
           </a:xfrm>
           <a:prstGeom prst="rect">
             <a:avLst/>
@@ -16605,14 +17928,14 @@
       </p:sp>
       <p:sp>
         <p:nvSpPr>
-          <p:cNvPr id="10" name="TextBox 9"/>
+          <p:cNvPr id="15" name="TextBox 14"/>
           <p:cNvSpPr txBox="1"/>
           <p:nvPr/>
         </p:nvSpPr>
         <p:spPr>
           <a:xfrm>
-            <a:off x="684000" y="1188000"/>
-            <a:ext cx="4248000" cy="684000"/>
+            <a:off x="6048000" y="3664800"/>
+            <a:ext cx="2484000" cy="1008000"/>
           </a:xfrm>
           <a:prstGeom prst="rect">
             <a:avLst/>
@@ -16620,367 +17943,35 @@
           <a:noFill/>
         </p:spPr>
         <p:txBody>
-          <a:bodyPr wrap="square" lIns="0" rIns="0" tIns="0" bIns="0" anchor="t">
+          <a:bodyPr wrap="square" lIns="0" rIns="0" tIns="0" bIns="0">
             <a:spAutoFit/>
           </a:bodyPr>
           <a:lstStyle/>
           <a:p>
-            <a:pPr algn="l"/>
-            <a:r>
-              <a:rPr sz="1050" b="0">
+            <a:r>
+              <a:rPr sz="1050" b="1">
                 <a:solidFill>
-                  <a:srgbClr val="1A1A1A"/>
+                  <a:srgbClr val="F2E3BE"/>
                 </a:solidFill>
                 <a:latin typeface="Calibri"/>
               </a:rPr>
-              <a:t>Significativa. 2026: 0,848 contra 0,825, Δ 0,023 [0,017; 0,030], DeLong z = 22,5. Bloques: gana 8 de 8, Wilcoxon-Holm p = 0,047, Cliff 0,34.</a:t>
-            </a:r>
-          </a:p>
-        </p:txBody>
-      </p:sp>
-      <p:sp>
-        <p:nvSpPr>
-          <p:cNvPr id="11" name="Rectangle 10"/>
-          <p:cNvSpPr/>
-          <p:nvPr/>
-        </p:nvSpPr>
-        <p:spPr>
-          <a:xfrm>
-            <a:off x="468000" y="1947600"/>
-            <a:ext cx="72000" cy="72000"/>
-          </a:xfrm>
-          <a:prstGeom prst="rect">
-            <a:avLst/>
-          </a:prstGeom>
-          <a:solidFill>
-            <a:srgbClr val="405731"/>
-          </a:solidFill>
-          <a:ln>
-            <a:noFill/>
-          </a:ln>
-          <a:effectLst/>
-        </p:spPr>
-        <p:style>
-          <a:lnRef idx="1">
-            <a:schemeClr val="accent1"/>
-          </a:lnRef>
-          <a:fillRef idx="3">
-            <a:schemeClr val="accent1"/>
-          </a:fillRef>
-          <a:effectRef idx="2">
-            <a:schemeClr val="accent1"/>
-          </a:effectRef>
-          <a:fontRef idx="minor">
-            <a:schemeClr val="lt1"/>
-          </a:fontRef>
-        </p:style>
-        <p:txBody>
-          <a:bodyPr rtlCol="0" anchor="ctr" wrap="square"/>
-          <a:lstStyle/>
-          <a:p>
-            <a:pPr algn="ctr"/>
-          </a:p>
-        </p:txBody>
-      </p:sp>
-      <p:sp>
-        <p:nvSpPr>
-          <p:cNvPr id="12" name="TextBox 11"/>
-          <p:cNvSpPr txBox="1"/>
-          <p:nvPr/>
-        </p:nvSpPr>
-        <p:spPr>
-          <a:xfrm>
-            <a:off x="684000" y="1890000"/>
-            <a:ext cx="4248000" cy="684000"/>
-          </a:xfrm>
-          <a:prstGeom prst="rect">
-            <a:avLst/>
-          </a:prstGeom>
-          <a:noFill/>
-        </p:spPr>
-        <p:txBody>
-          <a:bodyPr wrap="square" lIns="0" rIns="0" tIns="0" bIns="0" anchor="t">
-            <a:spAutoFit/>
-          </a:bodyPr>
-          <a:lstStyle/>
-          <a:p>
-            <a:pPr algn="l"/>
+              <a:t>Cuidado:  </a:t>
+            </a:r>
             <a:r>
               <a:rPr sz="1050" b="0">
                 <a:solidFill>
-                  <a:srgbClr val="1A1A1A"/>
+                  <a:srgbClr val="FFFFFF"/>
                 </a:solidFill>
                 <a:latin typeface="Calibri"/>
               </a:rPr>
-              <a:t>Material. Con el 20 % de alertas atrapa 8.242 tardías contra 7.895: 35 más por mes. F1 0,675 contra 0,649.</a:t>
-            </a:r>
-          </a:p>
-        </p:txBody>
-      </p:sp>
-      <p:sp>
-        <p:nvSpPr>
-          <p:cNvPr id="13" name="Rectangle 12"/>
-          <p:cNvSpPr/>
-          <p:nvPr/>
-        </p:nvSpPr>
-        <p:spPr>
-          <a:xfrm>
-            <a:off x="468000" y="2649600"/>
-            <a:ext cx="72000" cy="72000"/>
-          </a:xfrm>
-          <a:prstGeom prst="rect">
-            <a:avLst/>
-          </a:prstGeom>
-          <a:solidFill>
-            <a:srgbClr val="405731"/>
-          </a:solidFill>
-          <a:ln>
-            <a:noFill/>
-          </a:ln>
-          <a:effectLst/>
-        </p:spPr>
-        <p:style>
-          <a:lnRef idx="1">
-            <a:schemeClr val="accent1"/>
-          </a:lnRef>
-          <a:fillRef idx="3">
-            <a:schemeClr val="accent1"/>
-          </a:fillRef>
-          <a:effectRef idx="2">
-            <a:schemeClr val="accent1"/>
-          </a:effectRef>
-          <a:fontRef idx="minor">
-            <a:schemeClr val="lt1"/>
-          </a:fontRef>
-        </p:style>
-        <p:txBody>
-          <a:bodyPr rtlCol="0" anchor="ctr" wrap="square"/>
-          <a:lstStyle/>
-          <a:p>
-            <a:pPr algn="ctr"/>
-          </a:p>
-        </p:txBody>
-      </p:sp>
-      <p:sp>
-        <p:nvSpPr>
-          <p:cNvPr id="14" name="TextBox 13"/>
-          <p:cNvSpPr txBox="1"/>
-          <p:nvPr/>
-        </p:nvSpPr>
-        <p:spPr>
-          <a:xfrm>
-            <a:off x="684000" y="2592000"/>
-            <a:ext cx="4248000" cy="684000"/>
-          </a:xfrm>
-          <a:prstGeom prst="rect">
-            <a:avLst/>
-          </a:prstGeom>
-          <a:noFill/>
-        </p:spPr>
-        <p:txBody>
-          <a:bodyPr wrap="square" lIns="0" rIns="0" tIns="0" bIns="0" anchor="t">
-            <a:spAutoFit/>
-          </a:bodyPr>
-          <a:lstStyle/>
-          <a:p>
-            <a:pPr algn="l"/>
-            <a:r>
-              <a:rPr sz="1050" b="0">
-                <a:solidFill>
-                  <a:srgbClr val="1A1A1A"/>
-                </a:solidFill>
-                <a:latin typeface="Calibri"/>
-              </a:rPr>
-              <a:t>Forma. Sin plazo, el riesgo sube 3,4 de logit en Generales y 2,4 en Producción Cluster; la logística da una sola pendiente y una caída suave cerca de cero.</a:t>
-            </a:r>
-          </a:p>
-        </p:txBody>
-      </p:sp>
-      <p:sp>
-        <p:nvSpPr>
-          <p:cNvPr id="15" name="Rectangle 14"/>
-          <p:cNvSpPr/>
-          <p:nvPr/>
-        </p:nvSpPr>
-        <p:spPr>
-          <a:xfrm>
-            <a:off x="468000" y="3351600"/>
-            <a:ext cx="72000" cy="72000"/>
-          </a:xfrm>
-          <a:prstGeom prst="rect">
-            <a:avLst/>
-          </a:prstGeom>
-          <a:solidFill>
-            <a:srgbClr val="405731"/>
-          </a:solidFill>
-          <a:ln>
-            <a:noFill/>
-          </a:ln>
-          <a:effectLst/>
-        </p:spPr>
-        <p:style>
-          <a:lnRef idx="1">
-            <a:schemeClr val="accent1"/>
-          </a:lnRef>
-          <a:fillRef idx="3">
-            <a:schemeClr val="accent1"/>
-          </a:fillRef>
-          <a:effectRef idx="2">
-            <a:schemeClr val="accent1"/>
-          </a:effectRef>
-          <a:fontRef idx="minor">
-            <a:schemeClr val="lt1"/>
-          </a:fontRef>
-        </p:style>
-        <p:txBody>
-          <a:bodyPr rtlCol="0" anchor="ctr" wrap="square"/>
-          <a:lstStyle/>
-          <a:p>
-            <a:pPr algn="ctr"/>
-          </a:p>
-        </p:txBody>
-      </p:sp>
-      <p:sp>
-        <p:nvSpPr>
-          <p:cNvPr id="16" name="TextBox 15"/>
-          <p:cNvSpPr txBox="1"/>
-          <p:nvPr/>
-        </p:nvSpPr>
-        <p:spPr>
-          <a:xfrm>
-            <a:off x="684000" y="3294000"/>
-            <a:ext cx="4248000" cy="684000"/>
-          </a:xfrm>
-          <a:prstGeom prst="rect">
-            <a:avLst/>
-          </a:prstGeom>
-          <a:noFill/>
-        </p:spPr>
-        <p:txBody>
-          <a:bodyPr wrap="square" lIns="0" rIns="0" tIns="0" bIns="0" anchor="t">
-            <a:spAutoFit/>
-          </a:bodyPr>
-          <a:lstStyle/>
-          <a:p>
-            <a:pPr algn="l"/>
-            <a:r>
-              <a:rPr sz="1050" b="0">
-                <a:solidFill>
-                  <a:srgbClr val="1A1A1A"/>
-                </a:solidFill>
-                <a:latin typeface="Calibri"/>
-              </a:rPr>
-              <a:t>Costo. Un ajuste: 3,2 min contra 12 s; mil predicciones: 17 ms contra 0,7. SHAP da la lectura.</a:t>
-            </a:r>
-          </a:p>
-        </p:txBody>
-      </p:sp>
-      <p:sp>
-        <p:nvSpPr>
-          <p:cNvPr id="17" name="Rectangle 16"/>
-          <p:cNvSpPr/>
-          <p:nvPr/>
-        </p:nvSpPr>
-        <p:spPr>
-          <a:xfrm>
-            <a:off x="468000" y="4053600"/>
-            <a:ext cx="72000" cy="72000"/>
-          </a:xfrm>
-          <a:prstGeom prst="rect">
-            <a:avLst/>
-          </a:prstGeom>
-          <a:solidFill>
-            <a:srgbClr val="405731"/>
-          </a:solidFill>
-          <a:ln>
-            <a:noFill/>
-          </a:ln>
-          <a:effectLst/>
-        </p:spPr>
-        <p:style>
-          <a:lnRef idx="1">
-            <a:schemeClr val="accent1"/>
-          </a:lnRef>
-          <a:fillRef idx="3">
-            <a:schemeClr val="accent1"/>
-          </a:fillRef>
-          <a:effectRef idx="2">
-            <a:schemeClr val="accent1"/>
-          </a:effectRef>
-          <a:fontRef idx="minor">
-            <a:schemeClr val="lt1"/>
-          </a:fontRef>
-        </p:style>
-        <p:txBody>
-          <a:bodyPr rtlCol="0" anchor="ctr" wrap="square"/>
-          <a:lstStyle/>
-          <a:p>
-            <a:pPr algn="ctr"/>
-          </a:p>
-        </p:txBody>
-      </p:sp>
-      <p:sp>
-        <p:nvSpPr>
-          <p:cNvPr id="18" name="TextBox 17"/>
-          <p:cNvSpPr txBox="1"/>
-          <p:nvPr/>
-        </p:nvSpPr>
-        <p:spPr>
-          <a:xfrm>
-            <a:off x="684000" y="3996000"/>
-            <a:ext cx="4248000" cy="684000"/>
-          </a:xfrm>
-          <a:prstGeom prst="rect">
-            <a:avLst/>
-          </a:prstGeom>
-          <a:noFill/>
-        </p:spPr>
-        <p:txBody>
-          <a:bodyPr wrap="square" lIns="0" rIns="0" tIns="0" bIns="0" anchor="t">
-            <a:spAutoFit/>
-          </a:bodyPr>
-          <a:lstStyle/>
-          <a:p>
-            <a:pPr algn="l"/>
-            <a:r>
-              <a:rPr sz="1050" b="0">
-                <a:solidFill>
-                  <a:srgbClr val="1A1A1A"/>
-                </a:solidFill>
-                <a:latin typeface="Calibri"/>
-              </a:rPr>
-              <a:t>Parsimonia. Se acepta lo complejo solo si gana significativa y materialmente: se cumple. La logística queda como base legible.</a:t>
-            </a:r>
-          </a:p>
-        </p:txBody>
-      </p:sp>
-      <p:pic>
-        <p:nvPicPr>
-          <p:cNvPr id="19" name="Picture 18" descr="forma_plazo.png"/>
-          <p:cNvPicPr>
-            <a:picLocks noChangeAspect="1"/>
-          </p:cNvPicPr>
-          <p:nvPr/>
-        </p:nvPicPr>
-        <p:blipFill>
-          <a:blip r:embed="rId3"/>
-          <a:stretch>
-            <a:fillRect/>
-          </a:stretch>
-        </p:blipFill>
-        <p:spPr>
-          <a:xfrm>
-            <a:off x="5112000" y="1152000"/>
-            <a:ext cx="3600000" cy="2640000"/>
-          </a:xfrm>
-          <a:prstGeom prst="rect">
-            <a:avLst/>
-          </a:prstGeom>
-        </p:spPr>
-      </p:pic>
-      <p:sp>
-        <p:nvSpPr>
-          <p:cNvPr id="20" name="Rectangle 19"/>
+              <a:t>esa separación se vio después de la segunda ronda; confirmarla pide una tercera fijada antes de correr.</a:t>
+            </a:r>
+          </a:p>
+        </p:txBody>
+      </p:sp>
+      <p:sp>
+        <p:nvSpPr>
+          <p:cNvPr id="16" name="Rectangle 15"/>
           <p:cNvSpPr/>
           <p:nvPr/>
         </p:nvSpPr>
@@ -17024,7 +18015,7 @@
       </p:sp>
       <p:sp>
         <p:nvSpPr>
-          <p:cNvPr id="21" name="TextBox 20"/>
+          <p:cNvPr id="17" name="TextBox 16"/>
           <p:cNvSpPr txBox="1"/>
           <p:nvPr/>
         </p:nvSpPr>
@@ -17052,14 +18043,14 @@
                 </a:solidFill>
                 <a:latin typeface="Calibri"/>
               </a:rPr>
-              <a:t>Fuente: libro, capítulo 6: resultados/prueba_2026/diferencias.csv, presupuesto.csv, forma_clase.csv, costo.csv</a:t>
-            </a:r>
-          </a:p>
-        </p:txBody>
-      </p:sp>
-      <p:sp>
-        <p:nvSpPr>
-          <p:cNvPr id="22" name="TextBox 21"/>
+              <a:t>Fuente: libro, capítulo 10: original/publicos_otif_resumen.csv (OpenML)</a:t>
+            </a:r>
+          </a:p>
+        </p:txBody>
+      </p:sp>
+      <p:sp>
+        <p:nvSpPr>
+          <p:cNvPr id="18" name="TextBox 17"/>
           <p:cNvSpPr txBox="1"/>
           <p:nvPr/>
         </p:nvSpPr>
@@ -18242,7 +19233,7 @@
                 </a:solidFill>
                 <a:latin typeface="Calibri"/>
               </a:rPr>
-              <a:t>Fuente: libro, introducción y literatura; capítulo 4 (modelo base): data/modelos/metricas.csv</a:t>
+              <a:t>Fuente: libro, introducción y literatura; capítulo 5 (modelo base): data/modelos/metricas.csv</a:t>
             </a:r>
           </a:p>
         </p:txBody>
@@ -19352,7 +20343,7 @@
                 </a:solidFill>
                 <a:latin typeface="Calibri"/>
               </a:rPr>
-              <a:t>Fuente: libro, capítulos 2 a 9</a:t>
+              <a:t>Fuente: libro, capítulos 2 a 10</a:t>
             </a:r>
           </a:p>
         </p:txBody>
@@ -20212,7 +21203,7 @@
                 </a:solidFill>
                 <a:latin typeface="Calibri"/>
               </a:rPr>
-              <a:t>Fuente: libro, capítulos 2c, 5 y 7</a:t>
+              <a:t>Fuente: libro, capítulos 4, 6 y 9</a:t>
             </a:r>
           </a:p>
         </p:txBody>
@@ -21396,7 +22387,7 @@
                 </a:solidFill>
                 <a:latin typeface="Calibri"/>
               </a:rPr>
-              <a:t>Fuente: libro, capítulos 1 y 2a (definición de la etiqueta y de la población)</a:t>
+              <a:t>Fuente: libro, capítulos 1 y 2 (definición de la etiqueta y de la población)</a:t>
             </a:r>
           </a:p>
         </p:txBody>
@@ -23748,7 +24739,7 @@
                 </a:solidFill>
                 <a:latin typeface="Calibri"/>
               </a:rPr>
-              <a:t>Fuente: libro, capítulo 2a (datos); diccionario de variables en data/diccionario.csv</a:t>
+              <a:t>Fuente: libro, capítulo 2 (datos); diccionario de variables en data/diccionario.csv</a:t>
             </a:r>
           </a:p>
         </p:txBody>
@@ -25631,7 +26622,7 @@
                 </a:solidFill>
                 <a:latin typeface="Calibri"/>
               </a:rPr>
-              <a:t>Fuente: libro, capítulo 2b (EDA): resultados/eda/univariado_numericas.csv, faltantes.csv, atipicos_if.csv</a:t>
+              <a:t>Fuente: libro, capítulo 3 (EDA): resultados/eda/univariado_numericas.csv, faltantes.csv, atipicos_if.csv</a:t>
             </a:r>
           </a:p>
         </p:txBody>
@@ -26320,7 +27311,7 @@
                 </a:solidFill>
                 <a:latin typeface="Calibri"/>
               </a:rPr>
-              <a:t>Fuente: libro, capítulos 2b y 2c: resultados/eda/asociacion.csv; src/datos.py</a:t>
+              <a:t>Fuente: libro, capítulos 3 y 4: resultados/eda/asociacion.csv; src/datos.py</a:t>
             </a:r>
           </a:p>
         </p:txBody>
@@ -26884,7 +27875,7 @@
                 </a:solidFill>
                 <a:latin typeface="Calibri"/>
               </a:rPr>
-              <a:t>Fuente: libro, capítulo 2c (tiempo y fuga): resultados/eda/ y resultados/similitud/auc.csv</a:t>
+              <a:t>Fuente: libro, capítulo 4 (tiempo y fuga): resultados/eda/ y resultados/similitud/auc.csv</a:t>
             </a:r>
           </a:p>
         </p:txBody>
@@ -27780,7 +28771,7 @@
                 </a:solidFill>
                 <a:latin typeface="Calibri"/>
               </a:rPr>
-              <a:t>Fuente: libro, capítulo 7 (fundamentos); Friedman (2001), Chen y Guestrin (2016)</a:t>
+              <a:t>Fuente: libro, capítulo 8 (fundamentos); Friedman (2001), Chen y Guestrin (2016)</a:t>
             </a:r>
           </a:p>
         </p:txBody>

</xml_diff>

<commit_message>
Tablero: ?pestana= abre una pestaña de Modelos (para la captura de la predicción); láminas 17, 19 y 20 al día
</commit_message>
<xml_diff>
--- a/presentacion/sustentacion_otif.pptx
+++ b/presentacion/sustentacion_otif.pptx
@@ -1363,7 +1363,7 @@
           <a:lstStyle/>
           <a:p>
             <a:r>
-              <a:t>[1:00 · criterio 6 · expone A] Responder la pregunta con cifras y el veredicto de cada objetivo. La propuesta del Entregable 3 le gana a XGBoost por 0,012 en 2026; se presenta aparte.</a:t>
+              <a:t>[1:00 · criterio 6 · expone A] Responder la pregunta con cifras y el veredicto de cada objetivo. El modelo original del Entregable 3 le gana al óptimo de las 112 por 0,012 en 2026 (pestaña Modelo original del tablero); el tablero sirve el XGBoost porque la propuesta necesita la historia de entregas de cada entidad, que no se publica.</a:t>
             </a:r>
           </a:p>
         </p:txBody>
@@ -15401,7 +15401,7 @@
                 </a:solidFill>
                 <a:latin typeface="Calibri"/>
               </a:rPr>
-              <a:t>En vivo:  </a:t>
+              <a:t>En vivo (Modelos → Predicción):  </a:t>
             </a:r>
             <a:r>
               <a:rPr sz="1050" b="0">
@@ -18043,7 +18043,7 @@
                 </a:solidFill>
                 <a:latin typeface="Calibri"/>
               </a:rPr>
-              <a:t>Fuente: libro, capítulo 10: original/publicos_otif_resumen.csv (OpenML)</a:t>
+              <a:t>Fuente: libro, capítulo 10: original/publicos_otif_resumen.csv (OpenML); tablero: Modelos → Modelo original</a:t>
             </a:r>
           </a:p>
         </p:txBody>
@@ -19974,7 +19974,7 @@
         </p:nvGraphicFramePr>
         <p:xfrm>
           <a:off x="5544000" y="1224000"/>
-          <a:ext cx="3168000" cy="1440000"/>
+          <a:ext cx="3168000" cy="1728000"/>
         </p:xfrm>
         <a:graphic>
           <a:graphicData uri="http://schemas.openxmlformats.org/drawingml/2006/table">
@@ -19983,10 +19983,10 @@
                 <a:tableStyleId>{5C22544A-7EE6-4342-B048-85BDC9FD1C3A}</a:tableStyleId>
               </a:tblPr>
               <a:tblGrid>
-                <a:gridCol w="1980000"/>
-                <a:gridCol w="1188000"/>
+                <a:gridCol w="1742400"/>
+                <a:gridCol w="1425600"/>
               </a:tblGrid>
-              <a:tr h="360000">
+              <a:tr h="345600">
                 <a:tc>
                   <a:txBody>
                     <a:bodyPr wrap="square"/>
@@ -20034,7 +20034,7 @@
                   </a:tcPr>
                 </a:tc>
               </a:tr>
-              <a:tr h="360000">
+              <a:tr h="345600">
                 <a:tc>
                   <a:txBody>
                     <a:bodyPr wrap="square"/>
@@ -20082,7 +20082,7 @@
                   </a:tcPr>
                 </a:tc>
               </a:tr>
-              <a:tr h="360000">
+              <a:tr h="345600">
                 <a:tc>
                   <a:txBody>
                     <a:bodyPr wrap="square"/>
@@ -20130,7 +20130,7 @@
                   </a:tcPr>
                 </a:tc>
               </a:tr>
-              <a:tr h="360000">
+              <a:tr h="345600">
                 <a:tc>
                   <a:txBody>
                     <a:bodyPr wrap="square"/>
@@ -20178,6 +20178,54 @@
                   </a:tcPr>
                 </a:tc>
               </a:tr>
+              <a:tr h="345600">
+                <a:tc>
+                  <a:txBody>
+                    <a:bodyPr wrap="square"/>
+                    <a:lstStyle/>
+                    <a:p>
+                      <a:pPr algn="l"/>
+                      <a:r>
+                        <a:rPr sz="1050" b="1">
+                          <a:solidFill>
+                            <a:srgbClr val="1A1A1A"/>
+                          </a:solidFill>
+                          <a:latin typeface="Calibri"/>
+                        </a:rPr>
+                        <a:t>modelo original contra el óptimo</a:t>
+                      </a:r>
+                    </a:p>
+                  </a:txBody>
+                  <a:tcPr marL="57600" marR="57600" marT="14400" marB="14400" anchor="ctr">
+                    <a:solidFill>
+                      <a:srgbClr val="EEF2EA"/>
+                    </a:solidFill>
+                  </a:tcPr>
+                </a:tc>
+                <a:tc>
+                  <a:txBody>
+                    <a:bodyPr wrap="square"/>
+                    <a:lstStyle/>
+                    <a:p>
+                      <a:pPr algn="ctr"/>
+                      <a:r>
+                        <a:rPr sz="1050" b="0">
+                          <a:solidFill>
+                            <a:srgbClr val="1A1A1A"/>
+                          </a:solidFill>
+                          <a:latin typeface="Calibri"/>
+                        </a:rPr>
+                        <a:t>+0,012 de AUC [0,004; 0,018]</a:t>
+                      </a:r>
+                    </a:p>
+                  </a:txBody>
+                  <a:tcPr marL="57600" marR="57600" marT="14400" marB="14400" anchor="ctr">
+                    <a:solidFill>
+                      <a:srgbClr val="EEF2EA"/>
+                    </a:solidFill>
+                  </a:tcPr>
+                </a:tc>
+              </a:tr>
             </a:tbl>
           </a:graphicData>
         </a:graphic>
@@ -20190,8 +20238,8 @@
         </p:nvSpPr>
         <p:spPr>
           <a:xfrm>
-            <a:off x="5544000" y="2844000"/>
-            <a:ext cx="3168000" cy="1872000"/>
+            <a:off x="5544000" y="3096000"/>
+            <a:ext cx="3168000" cy="1620000"/>
           </a:xfrm>
           <a:prstGeom prst="rect">
             <a:avLst/>
@@ -20234,8 +20282,8 @@
         </p:nvSpPr>
         <p:spPr>
           <a:xfrm>
-            <a:off x="5724000" y="2908800"/>
-            <a:ext cx="2808000" cy="1764000"/>
+            <a:off x="5724000" y="3160800"/>
+            <a:ext cx="2808000" cy="1512000"/>
           </a:xfrm>
           <a:prstGeom prst="rect">
             <a:avLst/>

</xml_diff>

<commit_message>
Tablero: prediccion en vivo con el modelo original (y XGBoost para comparar); formulacion de cada modelo en su pestana; log-perdida interactiva; presupuesto por ordenes
</commit_message>
<xml_diff>
--- a/presentacion/sustentacion_otif.pptx
+++ b/presentacion/sustentacion_otif.pptx
@@ -27,6 +27,7 @@
     <p:sldId id="275" r:id="rId27"/>
     <p:sldId id="276" r:id="rId28"/>
     <p:sldId id="277" r:id="rId29"/>
+    <p:sldId id="278" r:id="rId30"/>
   </p:sldIdLst>
   <p:sldSz cx="9144000" cy="5144400" type="screen4x3"/>
   <p:notesSz cx="6858000" cy="9144000"/>
@@ -1223,7 +1224,7 @@
           <a:lstStyle/>
           <a:p>
             <a:r>
-              <a:t>[1:00 · criterio 6 · expone A] Responde «¿y en otros datos?». La ganancia de la propuesta en OTIF (0,012) depende de rasgos del caso: entidades con historia en el tiempo, desenlace continuo y plazo prometido. Airlines no trae el año: su partición es por mes. No decir que generaliza: es una hipótesis con apoyo.</a:t>
+              <a:t>[1:00 · criterio 6 · expone A] Qué es la propuesta y qué aporta cada parte. La 2 × 2 separa modelo de información: los efectos por entidad y el plazo real son dos caminos a la misma ganancia. Decir que es la tercera mirada a 2026 y que por eso se lee como exploratoria.</a:t>
             </a:r>
           </a:p>
         </p:txBody>
@@ -1363,7 +1364,7 @@
           <a:lstStyle/>
           <a:p>
             <a:r>
-              <a:t>[1:00 · criterio 6 · expone A] Responder la pregunta con cifras y el veredicto de cada objetivo. El modelo original del Entregable 3 le gana al óptimo de las 112 por 0,012 en 2026 (pestaña Modelo original del tablero); el tablero sirve el XGBoost porque la propuesta necesita la historia de entregas de cada entidad, que no se publica.</a:t>
+              <a:t>[1:00 · criterio 6 · expone A] Responde «¿y en otros datos?». La ganancia de la propuesta en OTIF (0,012) depende de rasgos del caso: entidades con historia en el tiempo, desenlace continuo y plazo prometido. Airlines no trae el año: su partición es por mes. No decir que generaliza: es una hipótesis con apoyo.</a:t>
             </a:r>
           </a:p>
         </p:txBody>
@@ -1433,7 +1434,7 @@
           <a:lstStyle/>
           <a:p>
             <a:r>
-              <a:t>[1:00 · criterio 6 · expone B] Separar lo teórico (supuestos del modelo) de lo empírico (los datos). Las mejoras apuntan al modelo original.</a:t>
+              <a:t>[1:00 · criterio 6 · expone A] Responder la pregunta con cifras y el veredicto de cada objetivo. El modelo original del Entregable 3 le gana al óptimo de las 112 por 0,012 en 2026 (pestaña Modelo original del tablero); el tablero sirve el XGBoost porque la propuesta necesita la historia de entregas de cada entidad, que no se publica.</a:t>
             </a:r>
           </a:p>
         </p:txBody>
@@ -1459,6 +1460,76 @@
 </file>
 
 <file path=ppt/notesSlides/notesSlide22.xml><?xml version="1.0" encoding="utf-8"?>
+<p:notes xmlns:a="http://schemas.openxmlformats.org/drawingml/2006/main" xmlns:p="http://schemas.openxmlformats.org/presentationml/2006/main" xmlns:r="http://schemas.openxmlformats.org/officeDocument/2006/relationships">
+  <p:cSld>
+    <p:spTree>
+      <p:nvGrpSpPr>
+        <p:cNvPr id="1" name=""/>
+        <p:cNvGrpSpPr/>
+        <p:nvPr/>
+      </p:nvGrpSpPr>
+      <p:grpSpPr>
+        <a:xfrm>
+          <a:off x="0" y="0"/>
+          <a:ext cx="0" cy="0"/>
+          <a:chOff x="0" y="0"/>
+          <a:chExt cx="0" cy="0"/>
+        </a:xfrm>
+      </p:grpSpPr>
+      <p:sp>
+        <p:nvSpPr>
+          <p:cNvPr id="2" name="Slide Image Placeholder 1"/>
+          <p:cNvSpPr>
+            <a:spLocks noGrp="1"/>
+          </p:cNvSpPr>
+          <p:nvPr>
+            <p:ph type="sldImg" idx="2"/>
+          </p:nvPr>
+        </p:nvSpPr>
+        <p:spPr/>
+      </p:sp>
+      <p:sp>
+        <p:nvSpPr>
+          <p:cNvPr id="3" name="Notes Placeholder 2"/>
+          <p:cNvSpPr>
+            <a:spLocks noGrp="1"/>
+          </p:cNvSpPr>
+          <p:nvPr>
+            <p:ph type="body" idx="3" sz="quarter"/>
+          </p:nvPr>
+        </p:nvSpPr>
+        <p:spPr/>
+        <p:txBody>
+          <a:bodyPr/>
+          <a:lstStyle/>
+          <a:p>
+            <a:r>
+              <a:t>[1:00 · criterio 6 · expone B] Separar lo teórico (supuestos del modelo) de lo empírico (los datos). Las mejoras apuntan al modelo original.</a:t>
+            </a:r>
+          </a:p>
+        </p:txBody>
+      </p:sp>
+      <p:sp>
+        <p:nvSpPr>
+          <p:cNvPr id="4" name="Slide Number Placeholder 3"/>
+          <p:cNvSpPr>
+            <a:spLocks noGrp="1"/>
+          </p:cNvSpPr>
+          <p:nvPr>
+            <p:ph type="sldNum" idx="5" sz="quarter"/>
+          </p:nvPr>
+        </p:nvSpPr>
+        <p:spPr/>
+      </p:sp>
+    </p:spTree>
+  </p:cSld>
+  <p:clrMapOvr>
+    <a:masterClrMapping/>
+  </p:clrMapOvr>
+</p:notes>
+</file>
+
+<file path=ppt/notesSlides/notesSlide23.xml><?xml version="1.0" encoding="utf-8"?>
 <p:notes xmlns:a="http://schemas.openxmlformats.org/drawingml/2006/main" xmlns:p="http://schemas.openxmlformats.org/presentationml/2006/main" xmlns:r="http://schemas.openxmlformats.org/officeDocument/2006/relationships">
   <p:cSld>
     <p:spTree>
@@ -6397,7 +6468,7 @@
                 </a:solidFill>
                 <a:latin typeface="Calibri"/>
               </a:rPr>
-              <a:t>10 / 21</a:t>
+              <a:t>10 / 22</a:t>
             </a:r>
           </a:p>
         </p:txBody>
@@ -7220,7 +7291,7 @@
                 </a:solidFill>
                 <a:latin typeface="Calibri"/>
               </a:rPr>
-              <a:t>11 / 21</a:t>
+              <a:t>11 / 22</a:t>
             </a:r>
           </a:p>
         </p:txBody>
@@ -8520,7 +8591,7 @@
                 </a:solidFill>
                 <a:latin typeface="Calibri"/>
               </a:rPr>
-              <a:t>12 / 21</a:t>
+              <a:t>12 / 22</a:t>
             </a:r>
           </a:p>
         </p:txBody>
@@ -10605,7 +10676,7 @@
                 </a:solidFill>
                 <a:latin typeface="Calibri"/>
               </a:rPr>
-              <a:t>13 / 21</a:t>
+              <a:t>13 / 22</a:t>
             </a:r>
           </a:p>
         </p:txBody>
@@ -11901,7 +11972,7 @@
                 </a:solidFill>
                 <a:latin typeface="Calibri"/>
               </a:rPr>
-              <a:t>14 / 21</a:t>
+              <a:t>14 / 22</a:t>
             </a:r>
           </a:p>
         </p:txBody>
@@ -12902,7 +12973,7 @@
                 </a:solidFill>
                 <a:latin typeface="Calibri"/>
               </a:rPr>
-              <a:t>15 / 21</a:t>
+              <a:t>15 / 22</a:t>
             </a:r>
           </a:p>
         </p:txBody>
@@ -14968,7 +15039,7 @@
                 </a:solidFill>
                 <a:latin typeface="Calibri"/>
               </a:rPr>
-              <a:t>16 / 21</a:t>
+              <a:t>16 / 22</a:t>
             </a:r>
           </a:p>
         </p:txBody>
@@ -15619,7 +15690,7 @@
                 </a:solidFill>
                 <a:latin typeface="Calibri"/>
               </a:rPr>
-              <a:t>17 / 21</a:t>
+              <a:t>17 / 22</a:t>
             </a:r>
           </a:p>
         </p:txBody>
@@ -16258,7 +16329,7 @@
                 </a:solidFill>
                 <a:latin typeface="Calibri"/>
               </a:rPr>
-              <a:t>18 / 21</a:t>
+              <a:t>18 / 22</a:t>
             </a:r>
           </a:p>
         </p:txBody>
@@ -16272,6 +16343,2400 @@
 </file>
 
 <file path=ppt/slides/slide19.xml><?xml version="1.0" encoding="utf-8"?>
+<p:sld xmlns:a="http://schemas.openxmlformats.org/drawingml/2006/main" xmlns:p="http://schemas.openxmlformats.org/presentationml/2006/main" xmlns:r="http://schemas.openxmlformats.org/officeDocument/2006/relationships">
+  <p:cSld>
+    <p:bg>
+      <p:bgPr>
+        <a:solidFill>
+          <a:srgbClr val="FFFFFF"/>
+        </a:solidFill>
+        <a:effectLst/>
+      </p:bgPr>
+    </p:bg>
+    <p:spTree>
+      <p:nvGrpSpPr>
+        <p:cNvPr id="1" name=""/>
+        <p:cNvGrpSpPr/>
+        <p:nvPr/>
+      </p:nvGrpSpPr>
+      <p:grpSpPr/>
+      <p:sp>
+        <p:nvSpPr>
+          <p:cNvPr id="2" name="Rectangle 1"/>
+          <p:cNvSpPr/>
+          <p:nvPr/>
+        </p:nvSpPr>
+        <p:spPr>
+          <a:xfrm>
+            <a:off x="0" y="0"/>
+            <a:ext cx="9144000" cy="576000"/>
+          </a:xfrm>
+          <a:prstGeom prst="rect">
+            <a:avLst/>
+          </a:prstGeom>
+          <a:solidFill>
+            <a:srgbClr val="405731"/>
+          </a:solidFill>
+          <a:ln>
+            <a:noFill/>
+          </a:ln>
+          <a:effectLst/>
+        </p:spPr>
+        <p:style>
+          <a:lnRef idx="1">
+            <a:schemeClr val="accent1"/>
+          </a:lnRef>
+          <a:fillRef idx="3">
+            <a:schemeClr val="accent1"/>
+          </a:fillRef>
+          <a:effectRef idx="2">
+            <a:schemeClr val="accent1"/>
+          </a:effectRef>
+          <a:fontRef idx="minor">
+            <a:schemeClr val="lt1"/>
+          </a:fontRef>
+        </p:style>
+        <p:txBody>
+          <a:bodyPr rtlCol="0" anchor="ctr" wrap="square"/>
+          <a:lstStyle/>
+          <a:p>
+            <a:pPr algn="ctr"/>
+          </a:p>
+        </p:txBody>
+      </p:sp>
+      <p:sp>
+        <p:nvSpPr>
+          <p:cNvPr id="3" name="Rectangle 2"/>
+          <p:cNvSpPr/>
+          <p:nvPr/>
+        </p:nvSpPr>
+        <p:spPr>
+          <a:xfrm>
+            <a:off x="0" y="576000"/>
+            <a:ext cx="9144000" cy="36000"/>
+          </a:xfrm>
+          <a:prstGeom prst="rect">
+            <a:avLst/>
+          </a:prstGeom>
+          <a:solidFill>
+            <a:srgbClr val="B08A2D"/>
+          </a:solidFill>
+          <a:ln>
+            <a:noFill/>
+          </a:ln>
+          <a:effectLst/>
+        </p:spPr>
+        <p:style>
+          <a:lnRef idx="1">
+            <a:schemeClr val="accent1"/>
+          </a:lnRef>
+          <a:fillRef idx="3">
+            <a:schemeClr val="accent1"/>
+          </a:fillRef>
+          <a:effectRef idx="2">
+            <a:schemeClr val="accent1"/>
+          </a:effectRef>
+          <a:fontRef idx="minor">
+            <a:schemeClr val="lt1"/>
+          </a:fontRef>
+        </p:style>
+        <p:txBody>
+          <a:bodyPr rtlCol="0" anchor="ctr" wrap="square"/>
+          <a:lstStyle/>
+          <a:p>
+            <a:pPr algn="ctr"/>
+          </a:p>
+        </p:txBody>
+      </p:sp>
+      <p:sp>
+        <p:nvSpPr>
+          <p:cNvPr id="4" name="Rectangle 3"/>
+          <p:cNvSpPr/>
+          <p:nvPr/>
+        </p:nvSpPr>
+        <p:spPr>
+          <a:xfrm>
+            <a:off x="144000" y="72000"/>
+            <a:ext cx="468000" cy="432000"/>
+          </a:xfrm>
+          <a:prstGeom prst="rect">
+            <a:avLst/>
+          </a:prstGeom>
+          <a:solidFill>
+            <a:srgbClr val="FFFFFF"/>
+          </a:solidFill>
+          <a:ln>
+            <a:noFill/>
+          </a:ln>
+          <a:effectLst/>
+        </p:spPr>
+        <p:style>
+          <a:lnRef idx="1">
+            <a:schemeClr val="accent1"/>
+          </a:lnRef>
+          <a:fillRef idx="3">
+            <a:schemeClr val="accent1"/>
+          </a:fillRef>
+          <a:effectRef idx="2">
+            <a:schemeClr val="accent1"/>
+          </a:effectRef>
+          <a:fontRef idx="minor">
+            <a:schemeClr val="lt1"/>
+          </a:fontRef>
+        </p:style>
+        <p:txBody>
+          <a:bodyPr rtlCol="0" anchor="ctr" wrap="square"/>
+          <a:lstStyle/>
+          <a:p>
+            <a:pPr algn="ctr"/>
+          </a:p>
+        </p:txBody>
+      </p:sp>
+      <p:pic>
+        <p:nvPicPr>
+          <p:cNvPr id="5" name="Picture 4" descr="logo.png"/>
+          <p:cNvPicPr>
+            <a:picLocks noChangeAspect="1"/>
+          </p:cNvPicPr>
+          <p:nvPr/>
+        </p:nvPicPr>
+        <p:blipFill>
+          <a:blip r:embed="rId2"/>
+          <a:stretch>
+            <a:fillRect/>
+          </a:stretch>
+        </p:blipFill>
+        <p:spPr>
+          <a:xfrm>
+            <a:off x="200160" y="145440"/>
+            <a:ext cx="355680" cy="266417"/>
+          </a:xfrm>
+          <a:prstGeom prst="rect">
+            <a:avLst/>
+          </a:prstGeom>
+        </p:spPr>
+      </p:pic>
+      <p:sp>
+        <p:nvSpPr>
+          <p:cNvPr id="6" name="TextBox 5"/>
+          <p:cNvSpPr txBox="1"/>
+          <p:nvPr/>
+        </p:nvSpPr>
+        <p:spPr>
+          <a:xfrm>
+            <a:off x="792000" y="125999"/>
+            <a:ext cx="8172000" cy="360000"/>
+          </a:xfrm>
+          <a:prstGeom prst="rect">
+            <a:avLst/>
+          </a:prstGeom>
+          <a:noFill/>
+        </p:spPr>
+        <p:txBody>
+          <a:bodyPr wrap="square" lIns="0" rIns="0" tIns="0" bIns="0" anchor="ctr">
+            <a:spAutoFit/>
+          </a:bodyPr>
+          <a:lstStyle/>
+          <a:p>
+            <a:pPr algn="l"/>
+            <a:r>
+              <a:rPr sz="2000" b="1">
+                <a:solidFill>
+                  <a:srgbClr val="FFFFFF"/>
+                </a:solidFill>
+                <a:latin typeface="Calibri"/>
+              </a:rPr>
+              <a:t>El modelo original le gana al óptimo de las 112 por 0,012 de AUC</a:t>
+            </a:r>
+          </a:p>
+        </p:txBody>
+      </p:sp>
+      <p:sp>
+        <p:nvSpPr>
+          <p:cNvPr id="7" name="TextBox 6"/>
+          <p:cNvSpPr txBox="1"/>
+          <p:nvPr/>
+        </p:nvSpPr>
+        <p:spPr>
+          <a:xfrm>
+            <a:off x="468000" y="756000"/>
+            <a:ext cx="7308000" cy="251999"/>
+          </a:xfrm>
+          <a:prstGeom prst="rect">
+            <a:avLst/>
+          </a:prstGeom>
+          <a:noFill/>
+        </p:spPr>
+        <p:txBody>
+          <a:bodyPr wrap="square" lIns="0" rIns="0" tIns="0" bIns="0" anchor="t">
+            <a:spAutoFit/>
+          </a:bodyPr>
+          <a:lstStyle/>
+          <a:p>
+            <a:pPr algn="l"/>
+            <a:r>
+              <a:rPr sz="1200" b="1">
+                <a:solidFill>
+                  <a:srgbClr val="B08A2D"/>
+                </a:solidFill>
+                <a:latin typeface="Calibri"/>
+              </a:rPr>
+              <a:t>CRITERIO 6  ·  MODELO ORIGINAL (ENTREGABLE 3)</a:t>
+            </a:r>
+          </a:p>
+        </p:txBody>
+      </p:sp>
+      <p:sp>
+        <p:nvSpPr>
+          <p:cNvPr id="8" name="Rectangle 7"/>
+          <p:cNvSpPr/>
+          <p:nvPr/>
+        </p:nvSpPr>
+        <p:spPr>
+          <a:xfrm>
+            <a:off x="468000" y="1044000"/>
+            <a:ext cx="468000" cy="36000"/>
+          </a:xfrm>
+          <a:prstGeom prst="rect">
+            <a:avLst/>
+          </a:prstGeom>
+          <a:solidFill>
+            <a:srgbClr val="B08A2D"/>
+          </a:solidFill>
+          <a:ln>
+            <a:noFill/>
+          </a:ln>
+          <a:effectLst/>
+        </p:spPr>
+        <p:style>
+          <a:lnRef idx="1">
+            <a:schemeClr val="accent1"/>
+          </a:lnRef>
+          <a:fillRef idx="3">
+            <a:schemeClr val="accent1"/>
+          </a:fillRef>
+          <a:effectRef idx="2">
+            <a:schemeClr val="accent1"/>
+          </a:effectRef>
+          <a:fontRef idx="minor">
+            <a:schemeClr val="lt1"/>
+          </a:fontRef>
+        </p:style>
+        <p:txBody>
+          <a:bodyPr rtlCol="0" anchor="ctr" wrap="square"/>
+          <a:lstStyle/>
+          <a:p>
+            <a:pPr algn="ctr"/>
+          </a:p>
+        </p:txBody>
+      </p:sp>
+      <p:sp>
+        <p:nvSpPr>
+          <p:cNvPr id="9" name="TextBox 8"/>
+          <p:cNvSpPr txBox="1"/>
+          <p:nvPr/>
+        </p:nvSpPr>
+        <p:spPr>
+          <a:xfrm>
+            <a:off x="468000" y="1152000"/>
+            <a:ext cx="5220000" cy="216000"/>
+          </a:xfrm>
+          <a:prstGeom prst="rect">
+            <a:avLst/>
+          </a:prstGeom>
+          <a:noFill/>
+        </p:spPr>
+        <p:txBody>
+          <a:bodyPr wrap="square" lIns="0" rIns="0" tIns="0" bIns="0" anchor="t">
+            <a:spAutoFit/>
+          </a:bodyPr>
+          <a:lstStyle/>
+          <a:p>
+            <a:pPr algn="l"/>
+            <a:r>
+              <a:rPr sz="1200" b="1">
+                <a:solidFill>
+                  <a:srgbClr val="405731"/>
+                </a:solidFill>
+                <a:latin typeface="Calibri"/>
+              </a:rPr>
+              <a:t>Efectos por entidad sobre un boosting, con cortes ordenados</a:t>
+            </a:r>
+          </a:p>
+        </p:txBody>
+      </p:sp>
+      <p:pic>
+        <p:nvPicPr>
+          <p:cNvPr id="10" name="Picture 9" descr="f_original.png"/>
+          <p:cNvPicPr>
+            <a:picLocks noChangeAspect="1"/>
+          </p:cNvPicPr>
+          <p:nvPr/>
+        </p:nvPicPr>
+        <p:blipFill>
+          <a:blip r:embed="rId3"/>
+          <a:stretch>
+            <a:fillRect/>
+          </a:stretch>
+        </p:blipFill>
+        <p:spPr>
+          <a:xfrm>
+            <a:off x="503999" y="1404000"/>
+            <a:ext cx="5148000" cy="214756"/>
+          </a:xfrm>
+          <a:prstGeom prst="rect">
+            <a:avLst/>
+          </a:prstGeom>
+        </p:spPr>
+      </p:pic>
+      <p:sp>
+        <p:nvSpPr>
+          <p:cNvPr id="11" name="TextBox 10"/>
+          <p:cNvSpPr txBox="1"/>
+          <p:nvPr/>
+        </p:nvSpPr>
+        <p:spPr>
+          <a:xfrm>
+            <a:off x="468000" y="1692000"/>
+            <a:ext cx="5220000" cy="540000"/>
+          </a:xfrm>
+          <a:prstGeom prst="rect">
+            <a:avLst/>
+          </a:prstGeom>
+          <a:noFill/>
+        </p:spPr>
+        <p:txBody>
+          <a:bodyPr wrap="square" lIns="0" rIns="0" tIns="0" bIns="0" anchor="t">
+            <a:spAutoFit/>
+          </a:bodyPr>
+          <a:lstStyle/>
+          <a:p>
+            <a:pPr algn="l"/>
+            <a:r>
+              <a:rPr sz="950" b="0">
+                <a:solidFill>
+                  <a:srgbClr val="5A5A5A"/>
+                </a:solidFill>
+                <a:latin typeface="Calibri"/>
+              </a:rPr>
+              <a:t>d_i: días de retraso; se predice en c = 1 (y_tarde) y aprende también de cuánto se atrasó. b_e: intercepto aleatorio por proveedor, material, solicitante y comprador, encogido hacia 0 (σ²_e por EM). K3: los árboles ven efectos estimados solo con los semestres anteriores, como al predecir.</a:t>
+            </a:r>
+          </a:p>
+        </p:txBody>
+      </p:sp>
+      <p:sp>
+        <p:nvSpPr>
+          <p:cNvPr id="12" name="TextBox 11"/>
+          <p:cNvSpPr txBox="1"/>
+          <p:nvPr/>
+        </p:nvSpPr>
+        <p:spPr>
+          <a:xfrm>
+            <a:off x="468000" y="2232000"/>
+            <a:ext cx="5220000" cy="216000"/>
+          </a:xfrm>
+          <a:prstGeom prst="rect">
+            <a:avLst/>
+          </a:prstGeom>
+          <a:noFill/>
+        </p:spPr>
+        <p:txBody>
+          <a:bodyPr wrap="square" lIns="0" rIns="0" tIns="0" bIns="0" anchor="t">
+            <a:spAutoFit/>
+          </a:bodyPr>
+          <a:lstStyle/>
+          <a:p>
+            <a:pPr algn="l"/>
+            <a:r>
+              <a:rPr sz="1200" b="1">
+                <a:solidFill>
+                  <a:srgbClr val="405731"/>
+                </a:solidFill>
+                <a:latin typeface="Calibri"/>
+              </a:rPr>
+              <a:t>f es un LightGBM, no un XGBoost</a:t>
+            </a:r>
+          </a:p>
+        </p:txBody>
+      </p:sp>
+      <p:sp>
+        <p:nvSpPr>
+          <p:cNvPr id="13" name="TextBox 12"/>
+          <p:cNvSpPr txBox="1"/>
+          <p:nvPr/>
+        </p:nvSpPr>
+        <p:spPr>
+          <a:xfrm>
+            <a:off x="468000" y="2448000"/>
+            <a:ext cx="5220000" cy="540000"/>
+          </a:xfrm>
+          <a:prstGeom prst="rect">
+            <a:avLst/>
+          </a:prstGeom>
+          <a:noFill/>
+        </p:spPr>
+        <p:txBody>
+          <a:bodyPr wrap="square" lIns="0" rIns="0" tIns="0" bIns="0" anchor="t">
+            <a:spAutoFit/>
+          </a:bodyPr>
+          <a:lstStyle/>
+          <a:p>
+            <a:pPr algn="l"/>
+            <a:r>
+              <a:rPr sz="950" b="0">
+                <a:solidFill>
+                  <a:srgbClr val="5A5A5A"/>
+                </a:solidFill>
+                <a:latin typeface="Calibri"/>
+              </a:rPr>
+              <a:t>Misma suma de árboles, misma log-pérdida y mismo peso de hoja −G/(H + λ) (diapositiva 11). Difiere en cómo crece el árbol: por hoja, partiendo la de mayor ganancia hasta 110 hojas, y no por niveles (XGBoost: profundidad 10). Aquí toma Σ b_e como desplazamiento fijo del logit y es monótono decreciente en c.</a:t>
+            </a:r>
+          </a:p>
+        </p:txBody>
+      </p:sp>
+      <p:sp>
+        <p:nvSpPr>
+          <p:cNvPr id="14" name="TextBox 13"/>
+          <p:cNvSpPr txBox="1"/>
+          <p:nvPr/>
+        </p:nvSpPr>
+        <p:spPr>
+          <a:xfrm>
+            <a:off x="468000" y="3024000"/>
+            <a:ext cx="5220000" cy="216000"/>
+          </a:xfrm>
+          <a:prstGeom prst="rect">
+            <a:avLst/>
+          </a:prstGeom>
+          <a:noFill/>
+        </p:spPr>
+        <p:txBody>
+          <a:bodyPr wrap="square" lIns="0" rIns="0" tIns="0" bIns="0" anchor="t">
+            <a:spAutoFit/>
+          </a:bodyPr>
+          <a:lstStyle/>
+          <a:p>
+            <a:pPr algn="l"/>
+            <a:r>
+              <a:rPr sz="1200" b="1">
+                <a:solidFill>
+                  <a:srgbClr val="405731"/>
+                </a:solidFill>
+                <a:latin typeface="Calibri"/>
+              </a:rPr>
+              <a:t>Plazo log-normal y plazo real</a:t>
+            </a:r>
+          </a:p>
+        </p:txBody>
+      </p:sp>
+      <p:pic>
+        <p:nvPicPr>
+          <p:cNvPr id="15" name="Picture 14" descr="f_lognormal.png"/>
+          <p:cNvPicPr>
+            <a:picLocks noChangeAspect="1"/>
+          </p:cNvPicPr>
+          <p:nvPr/>
+        </p:nvPicPr>
+        <p:blipFill>
+          <a:blip r:embed="rId4"/>
+          <a:stretch>
+            <a:fillRect/>
+          </a:stretch>
+        </p:blipFill>
+        <p:spPr>
+          <a:xfrm>
+            <a:off x="503999" y="3240000"/>
+            <a:ext cx="4140000" cy="248777"/>
+          </a:xfrm>
+          <a:prstGeom prst="rect">
+            <a:avLst/>
+          </a:prstGeom>
+        </p:spPr>
+      </p:pic>
+      <p:sp>
+        <p:nvSpPr>
+          <p:cNvPr id="16" name="TextBox 15"/>
+          <p:cNvSpPr txBox="1"/>
+          <p:nvPr/>
+        </p:nvSpPr>
+        <p:spPr>
+          <a:xfrm>
+            <a:off x="468000" y="3546000"/>
+            <a:ext cx="5220000" cy="468000"/>
+          </a:xfrm>
+          <a:prstGeom prst="rect">
+            <a:avLst/>
+          </a:prstGeom>
+          <a:noFill/>
+        </p:spPr>
+        <p:txBody>
+          <a:bodyPr wrap="square" lIns="0" rIns="0" tIns="0" bIns="0" anchor="t">
+            <a:spAutoFit/>
+          </a:bodyPr>
+          <a:lstStyle/>
+          <a:p>
+            <a:pPr algn="l"/>
+            <a:r>
+              <a:rPr sz="950" b="0">
+                <a:solidFill>
+                  <a:srgbClr val="5A5A5A"/>
+                </a:solidFill>
+                <a:latin typeface="Calibri"/>
+              </a:rPr>
+              <a:t>z: cuánto alcanza la promesa frente al plazo real esperado (un LightGBM sin la promesa). Más 32 variables de plazo real: mediana y percentil 80 de las últimas 20 entregas, y la holgura empírica.</a:t>
+            </a:r>
+          </a:p>
+        </p:txBody>
+      </p:sp>
+      <p:graphicFrame>
+        <p:nvGraphicFramePr>
+          <p:cNvPr id="17" name="Table 16"/>
+          <p:cNvGraphicFramePr>
+            <a:graphicFrameLocks noGrp="1"/>
+          </p:cNvGraphicFramePr>
+          <p:nvPr/>
+        </p:nvGraphicFramePr>
+        <p:xfrm>
+          <a:off x="5832000" y="1188000"/>
+          <a:ext cx="2880000" cy="1296000"/>
+        </p:xfrm>
+        <a:graphic>
+          <a:graphicData uri="http://schemas.openxmlformats.org/drawingml/2006/table">
+            <a:tbl>
+              <a:tblPr firstRow="1" bandRow="1">
+                <a:tableStyleId>{5C22544A-7EE6-4342-B048-85BDC9FD1C3A}</a:tableStyleId>
+              </a:tblPr>
+              <a:tblGrid>
+                <a:gridCol w="936000"/>
+                <a:gridCol w="972000"/>
+                <a:gridCol w="972000"/>
+              </a:tblGrid>
+              <a:tr h="324000">
+                <a:tc>
+                  <a:txBody>
+                    <a:bodyPr wrap="square"/>
+                    <a:lstStyle/>
+                    <a:p>
+                      <a:pPr algn="l"/>
+                      <a:r>
+                        <a:rPr sz="1050" b="1">
+                          <a:solidFill>
+                            <a:srgbClr val="FFFFFF"/>
+                          </a:solidFill>
+                          <a:latin typeface="Calibri"/>
+                        </a:rPr>
+                        <a:t>2026, AUC [BCa 95 %]</a:t>
+                      </a:r>
+                    </a:p>
+                  </a:txBody>
+                  <a:tcPr marL="57600" marR="57600" marT="14400" marB="14400" anchor="ctr">
+                    <a:solidFill>
+                      <a:srgbClr val="405731"/>
+                    </a:solidFill>
+                  </a:tcPr>
+                </a:tc>
+                <a:tc>
+                  <a:txBody>
+                    <a:bodyPr wrap="square"/>
+                    <a:lstStyle/>
+                    <a:p>
+                      <a:pPr algn="ctr"/>
+                      <a:r>
+                        <a:rPr sz="1050" b="1">
+                          <a:solidFill>
+                            <a:srgbClr val="FFFFFF"/>
+                          </a:solidFill>
+                          <a:latin typeface="Calibri"/>
+                        </a:rPr>
+                        <a:t>136 del dataset</a:t>
+                      </a:r>
+                    </a:p>
+                  </a:txBody>
+                  <a:tcPr marL="57600" marR="57600" marT="14400" marB="14400" anchor="ctr">
+                    <a:solidFill>
+                      <a:srgbClr val="405731"/>
+                    </a:solidFill>
+                  </a:tcPr>
+                </a:tc>
+                <a:tc>
+                  <a:txBody>
+                    <a:bodyPr wrap="square"/>
+                    <a:lstStyle/>
+                    <a:p>
+                      <a:pPr algn="ctr"/>
+                      <a:r>
+                        <a:rPr sz="1050" b="1">
+                          <a:solidFill>
+                            <a:srgbClr val="FFFFFF"/>
+                          </a:solidFill>
+                          <a:latin typeface="Calibri"/>
+                        </a:rPr>
+                        <a:t>136 + 32 nuevas</a:t>
+                      </a:r>
+                    </a:p>
+                  </a:txBody>
+                  <a:tcPr marL="57600" marR="57600" marT="14400" marB="14400" anchor="ctr">
+                    <a:solidFill>
+                      <a:srgbClr val="405731"/>
+                    </a:solidFill>
+                  </a:tcPr>
+                </a:tc>
+              </a:tr>
+              <a:tr h="324000">
+                <a:tc>
+                  <a:txBody>
+                    <a:bodyPr wrap="square"/>
+                    <a:lstStyle/>
+                    <a:p>
+                      <a:pPr algn="l"/>
+                      <a:r>
+                        <a:rPr sz="900" b="1">
+                          <a:solidFill>
+                            <a:srgbClr val="1A1A1A"/>
+                          </a:solidFill>
+                          <a:latin typeface="Calibri"/>
+                        </a:rPr>
+                        <a:t>XGBoost</a:t>
+                      </a:r>
+                    </a:p>
+                  </a:txBody>
+                  <a:tcPr marL="57600" marR="57600" marT="14400" marB="14400" anchor="ctr">
+                    <a:solidFill>
+                      <a:srgbClr val="FFFFFF"/>
+                    </a:solidFill>
+                  </a:tcPr>
+                </a:tc>
+                <a:tc>
+                  <a:txBody>
+                    <a:bodyPr wrap="square"/>
+                    <a:lstStyle/>
+                    <a:p>
+                      <a:pPr algn="ctr"/>
+                      <a:r>
+                        <a:rPr sz="900" b="0">
+                          <a:solidFill>
+                            <a:srgbClr val="1A1A1A"/>
+                          </a:solidFill>
+                          <a:latin typeface="Calibri"/>
+                        </a:rPr>
+                        <a:t>0,848 [0,835; 0,860]</a:t>
+                      </a:r>
+                    </a:p>
+                  </a:txBody>
+                  <a:tcPr marL="57600" marR="57600" marT="14400" marB="14400" anchor="ctr">
+                    <a:solidFill>
+                      <a:srgbClr val="FFFFFF"/>
+                    </a:solidFill>
+                  </a:tcPr>
+                </a:tc>
+                <a:tc>
+                  <a:txBody>
+                    <a:bodyPr wrap="square"/>
+                    <a:lstStyle/>
+                    <a:p>
+                      <a:pPr algn="ctr"/>
+                      <a:r>
+                        <a:rPr sz="900" b="0">
+                          <a:solidFill>
+                            <a:srgbClr val="1A1A1A"/>
+                          </a:solidFill>
+                          <a:latin typeface="Calibri"/>
+                        </a:rPr>
+                        <a:t>0,858 [0,846; 0,869]</a:t>
+                      </a:r>
+                    </a:p>
+                  </a:txBody>
+                  <a:tcPr marL="57600" marR="57600" marT="14400" marB="14400" anchor="ctr">
+                    <a:solidFill>
+                      <a:srgbClr val="FFFFFF"/>
+                    </a:solidFill>
+                  </a:tcPr>
+                </a:tc>
+              </a:tr>
+              <a:tr h="324000">
+                <a:tc>
+                  <a:txBody>
+                    <a:bodyPr wrap="square"/>
+                    <a:lstStyle/>
+                    <a:p>
+                      <a:pPr algn="l"/>
+                      <a:r>
+                        <a:rPr sz="900" b="1">
+                          <a:solidFill>
+                            <a:srgbClr val="1A1A1A"/>
+                          </a:solidFill>
+                          <a:latin typeface="Calibri"/>
+                        </a:rPr>
+                        <a:t>K3, sin log-normal</a:t>
+                      </a:r>
+                    </a:p>
+                  </a:txBody>
+                  <a:tcPr marL="57600" marR="57600" marT="14400" marB="14400" anchor="ctr">
+                    <a:solidFill>
+                      <a:srgbClr val="EEF2EA"/>
+                    </a:solidFill>
+                  </a:tcPr>
+                </a:tc>
+                <a:tc>
+                  <a:txBody>
+                    <a:bodyPr wrap="square"/>
+                    <a:lstStyle/>
+                    <a:p>
+                      <a:pPr algn="ctr"/>
+                      <a:r>
+                        <a:rPr sz="900" b="0">
+                          <a:solidFill>
+                            <a:srgbClr val="1A1A1A"/>
+                          </a:solidFill>
+                          <a:latin typeface="Calibri"/>
+                        </a:rPr>
+                        <a:t>0,854 [0,841; 0,865]</a:t>
+                      </a:r>
+                    </a:p>
+                  </a:txBody>
+                  <a:tcPr marL="57600" marR="57600" marT="14400" marB="14400" anchor="ctr">
+                    <a:solidFill>
+                      <a:srgbClr val="EEF2EA"/>
+                    </a:solidFill>
+                  </a:tcPr>
+                </a:tc>
+                <a:tc>
+                  <a:txBody>
+                    <a:bodyPr wrap="square"/>
+                    <a:lstStyle/>
+                    <a:p>
+                      <a:pPr algn="ctr"/>
+                      <a:r>
+                        <a:rPr sz="900" b="0">
+                          <a:solidFill>
+                            <a:srgbClr val="1A1A1A"/>
+                          </a:solidFill>
+                          <a:latin typeface="Calibri"/>
+                        </a:rPr>
+                        <a:t>0,858 [0,844; 0,869]</a:t>
+                      </a:r>
+                    </a:p>
+                  </a:txBody>
+                  <a:tcPr marL="57600" marR="57600" marT="14400" marB="14400" anchor="ctr">
+                    <a:solidFill>
+                      <a:srgbClr val="EEF2EA"/>
+                    </a:solidFill>
+                  </a:tcPr>
+                </a:tc>
+              </a:tr>
+              <a:tr h="324000">
+                <a:tc>
+                  <a:txBody>
+                    <a:bodyPr wrap="square"/>
+                    <a:lstStyle/>
+                    <a:p>
+                      <a:pPr algn="l"/>
+                      <a:r>
+                        <a:rPr sz="900" b="1">
+                          <a:solidFill>
+                            <a:srgbClr val="1A1A1A"/>
+                          </a:solidFill>
+                          <a:latin typeface="Calibri"/>
+                        </a:rPr>
+                        <a:t>Propuesta</a:t>
+                      </a:r>
+                    </a:p>
+                  </a:txBody>
+                  <a:tcPr marL="57600" marR="57600" marT="14400" marB="14400" anchor="ctr">
+                    <a:solidFill>
+                      <a:srgbClr val="FFFFFF"/>
+                    </a:solidFill>
+                  </a:tcPr>
+                </a:tc>
+                <a:tc>
+                  <a:txBody>
+                    <a:bodyPr wrap="square"/>
+                    <a:lstStyle/>
+                    <a:p>
+                      <a:pPr algn="ctr"/>
+                      <a:r>
+                        <a:rPr sz="900" b="0">
+                          <a:solidFill>
+                            <a:srgbClr val="1A1A1A"/>
+                          </a:solidFill>
+                          <a:latin typeface="Calibri"/>
+                        </a:rPr>
+                        <a:t>0,856 [0,843; 0,868]</a:t>
+                      </a:r>
+                    </a:p>
+                  </a:txBody>
+                  <a:tcPr marL="57600" marR="57600" marT="14400" marB="14400" anchor="ctr">
+                    <a:solidFill>
+                      <a:srgbClr val="FFFFFF"/>
+                    </a:solidFill>
+                  </a:tcPr>
+                </a:tc>
+                <a:tc>
+                  <a:txBody>
+                    <a:bodyPr wrap="square"/>
+                    <a:lstStyle/>
+                    <a:p>
+                      <a:pPr algn="ctr"/>
+                      <a:r>
+                        <a:rPr sz="900" b="0">
+                          <a:solidFill>
+                            <a:srgbClr val="1A1A1A"/>
+                          </a:solidFill>
+                          <a:latin typeface="Calibri"/>
+                        </a:rPr>
+                        <a:t>0,860 [0,847; 0,871]</a:t>
+                      </a:r>
+                    </a:p>
+                  </a:txBody>
+                  <a:tcPr marL="57600" marR="57600" marT="14400" marB="14400" anchor="ctr">
+                    <a:solidFill>
+                      <a:srgbClr val="FFFFFF"/>
+                    </a:solidFill>
+                  </a:tcPr>
+                </a:tc>
+              </a:tr>
+            </a:tbl>
+          </a:graphicData>
+        </a:graphic>
+      </p:graphicFrame>
+      <p:sp>
+        <p:nvSpPr>
+          <p:cNvPr id="18" name="Rectangle 17"/>
+          <p:cNvSpPr/>
+          <p:nvPr/>
+        </p:nvSpPr>
+        <p:spPr>
+          <a:xfrm>
+            <a:off x="5832000" y="2556000"/>
+            <a:ext cx="2880000" cy="1404000"/>
+          </a:xfrm>
+          <a:prstGeom prst="rect">
+            <a:avLst/>
+          </a:prstGeom>
+          <a:solidFill>
+            <a:srgbClr val="E8F0EB"/>
+          </a:solidFill>
+          <a:ln>
+            <a:noFill/>
+          </a:ln>
+          <a:effectLst/>
+        </p:spPr>
+        <p:style>
+          <a:lnRef idx="1">
+            <a:schemeClr val="accent1"/>
+          </a:lnRef>
+          <a:fillRef idx="3">
+            <a:schemeClr val="accent1"/>
+          </a:fillRef>
+          <a:effectRef idx="2">
+            <a:schemeClr val="accent1"/>
+          </a:effectRef>
+          <a:fontRef idx="minor">
+            <a:schemeClr val="lt1"/>
+          </a:fontRef>
+        </p:style>
+        <p:txBody>
+          <a:bodyPr rtlCol="0" anchor="ctr" wrap="square"/>
+          <a:lstStyle/>
+          <a:p>
+            <a:pPr algn="ctr"/>
+          </a:p>
+        </p:txBody>
+      </p:sp>
+      <p:sp>
+        <p:nvSpPr>
+          <p:cNvPr id="19" name="TextBox 18"/>
+          <p:cNvSpPr txBox="1"/>
+          <p:nvPr/>
+        </p:nvSpPr>
+        <p:spPr>
+          <a:xfrm>
+            <a:off x="5993999" y="2664000"/>
+            <a:ext cx="2556000" cy="288000"/>
+          </a:xfrm>
+          <a:prstGeom prst="rect">
+            <a:avLst/>
+          </a:prstGeom>
+          <a:noFill/>
+        </p:spPr>
+        <p:txBody>
+          <a:bodyPr wrap="square" lIns="0" rIns="0" tIns="0" bIns="0" anchor="t">
+            <a:spAutoFit/>
+          </a:bodyPr>
+          <a:lstStyle/>
+          <a:p>
+            <a:pPr algn="l"/>
+            <a:r>
+              <a:rPr sz="1300" b="1">
+                <a:solidFill>
+                  <a:srgbClr val="405731"/>
+                </a:solidFill>
+                <a:latin typeface="Calibri"/>
+              </a:rPr>
+              <a:t>Lectura de la 2 × 2</a:t>
+            </a:r>
+          </a:p>
+        </p:txBody>
+      </p:sp>
+      <p:sp>
+        <p:nvSpPr>
+          <p:cNvPr id="20" name="TextBox 19"/>
+          <p:cNvSpPr txBox="1"/>
+          <p:nvPr/>
+        </p:nvSpPr>
+        <p:spPr>
+          <a:xfrm>
+            <a:off x="5993999" y="2923199"/>
+            <a:ext cx="2556000" cy="990000"/>
+          </a:xfrm>
+          <a:prstGeom prst="rect">
+            <a:avLst/>
+          </a:prstGeom>
+          <a:noFill/>
+        </p:spPr>
+        <p:txBody>
+          <a:bodyPr wrap="square" lIns="0" rIns="0" tIns="0" bIns="0" anchor="t">
+            <a:spAutoFit/>
+          </a:bodyPr>
+          <a:lstStyle/>
+          <a:p>
+            <a:pPr algn="l"/>
+            <a:r>
+              <a:rPr sz="900" b="0">
+                <a:solidFill>
+                  <a:srgbClr val="1A1A1A"/>
+                </a:solidFill>
+                <a:latin typeface="Calibri"/>
+              </a:rPr>
+              <a:t>Con las 136, la estructura suma 0,008 [0,003; 0,014].</a:t>
+            </a:r>
+          </a:p>
+          <a:p>
+            <a:pPr algn="l"/>
+            <a:r>
+              <a:rPr sz="900" b="0">
+                <a:solidFill>
+                  <a:srgbClr val="1A1A1A"/>
+                </a:solidFill>
+                <a:latin typeface="Calibri"/>
+              </a:rPr>
+              <a:t>El plazo real le da a XGBoost 0,010 [0,006; 0,014]; con él, la ventaja de la estructura baja a 0,002, sin significancia.</a:t>
+            </a:r>
+          </a:p>
+          <a:p>
+            <a:pPr algn="l"/>
+            <a:r>
+              <a:rPr sz="900" b="0">
+                <a:solidFill>
+                  <a:srgbClr val="1A1A1A"/>
+                </a:solidFill>
+                <a:latin typeface="Calibri"/>
+              </a:rPr>
+              <a:t>El log-normal suma 0,003; su intervalo toca el cero.</a:t>
+            </a:r>
+          </a:p>
+        </p:txBody>
+      </p:sp>
+      <p:sp>
+        <p:nvSpPr>
+          <p:cNvPr id="21" name="Rectangle 20"/>
+          <p:cNvSpPr/>
+          <p:nvPr/>
+        </p:nvSpPr>
+        <p:spPr>
+          <a:xfrm>
+            <a:off x="468000" y="4031999"/>
+            <a:ext cx="8243999" cy="684000"/>
+          </a:xfrm>
+          <a:prstGeom prst="rect">
+            <a:avLst/>
+          </a:prstGeom>
+          <a:solidFill>
+            <a:srgbClr val="405731"/>
+          </a:solidFill>
+          <a:ln>
+            <a:noFill/>
+          </a:ln>
+          <a:effectLst/>
+        </p:spPr>
+        <p:style>
+          <a:lnRef idx="1">
+            <a:schemeClr val="accent1"/>
+          </a:lnRef>
+          <a:fillRef idx="3">
+            <a:schemeClr val="accent1"/>
+          </a:fillRef>
+          <a:effectRef idx="2">
+            <a:schemeClr val="accent1"/>
+          </a:effectRef>
+          <a:fontRef idx="minor">
+            <a:schemeClr val="lt1"/>
+          </a:fontRef>
+        </p:style>
+        <p:txBody>
+          <a:bodyPr rtlCol="0" anchor="ctr" wrap="square"/>
+          <a:lstStyle/>
+          <a:p>
+            <a:pPr algn="ctr"/>
+          </a:p>
+        </p:txBody>
+      </p:sp>
+      <p:sp>
+        <p:nvSpPr>
+          <p:cNvPr id="22" name="TextBox 21"/>
+          <p:cNvSpPr txBox="1"/>
+          <p:nvPr/>
+        </p:nvSpPr>
+        <p:spPr>
+          <a:xfrm>
+            <a:off x="648000" y="4096799"/>
+            <a:ext cx="7883999" cy="576000"/>
+          </a:xfrm>
+          <a:prstGeom prst="rect">
+            <a:avLst/>
+          </a:prstGeom>
+          <a:noFill/>
+        </p:spPr>
+        <p:txBody>
+          <a:bodyPr wrap="square" lIns="0" rIns="0" tIns="0" bIns="0">
+            <a:spAutoFit/>
+          </a:bodyPr>
+          <a:lstStyle/>
+          <a:p>
+            <a:r>
+              <a:rPr sz="1050" b="1">
+                <a:solidFill>
+                  <a:srgbClr val="F2E3BE"/>
+                </a:solidFill>
+                <a:latin typeface="Calibri"/>
+              </a:rPr>
+              <a:t>Por qué el tablero sirve XGBoost:  </a:t>
+            </a:r>
+            <a:r>
+              <a:rPr sz="1050" b="0">
+                <a:solidFill>
+                  <a:srgbClr val="FFFFFF"/>
+                </a:solidFill>
+                <a:latin typeface="Calibri"/>
+              </a:rPr>
+              <a:t>la propuesta necesita la historia de entregas de cada entidad, que no se publica. Es la tercera mirada a 2026: exploratoria. En las órdenes con alguna entidad nueva no gana: el arranque en frío sigue abierto.</a:t>
+            </a:r>
+          </a:p>
+        </p:txBody>
+      </p:sp>
+      <p:sp>
+        <p:nvSpPr>
+          <p:cNvPr id="23" name="Rectangle 22"/>
+          <p:cNvSpPr/>
+          <p:nvPr/>
+        </p:nvSpPr>
+        <p:spPr>
+          <a:xfrm>
+            <a:off x="468000" y="4842000"/>
+            <a:ext cx="8243999" cy="14400"/>
+          </a:xfrm>
+          <a:prstGeom prst="rect">
+            <a:avLst/>
+          </a:prstGeom>
+          <a:solidFill>
+            <a:srgbClr val="DDD5C0"/>
+          </a:solidFill>
+          <a:ln>
+            <a:noFill/>
+          </a:ln>
+          <a:effectLst/>
+        </p:spPr>
+        <p:style>
+          <a:lnRef idx="1">
+            <a:schemeClr val="accent1"/>
+          </a:lnRef>
+          <a:fillRef idx="3">
+            <a:schemeClr val="accent1"/>
+          </a:fillRef>
+          <a:effectRef idx="2">
+            <a:schemeClr val="accent1"/>
+          </a:effectRef>
+          <a:fontRef idx="minor">
+            <a:schemeClr val="lt1"/>
+          </a:fontRef>
+        </p:style>
+        <p:txBody>
+          <a:bodyPr rtlCol="0" anchor="ctr" wrap="square"/>
+          <a:lstStyle/>
+          <a:p>
+            <a:pPr algn="ctr"/>
+          </a:p>
+        </p:txBody>
+      </p:sp>
+      <p:sp>
+        <p:nvSpPr>
+          <p:cNvPr id="24" name="TextBox 23"/>
+          <p:cNvSpPr txBox="1"/>
+          <p:nvPr/>
+        </p:nvSpPr>
+        <p:spPr>
+          <a:xfrm>
+            <a:off x="468000" y="4896000"/>
+            <a:ext cx="5940000" cy="180000"/>
+          </a:xfrm>
+          <a:prstGeom prst="rect">
+            <a:avLst/>
+          </a:prstGeom>
+          <a:noFill/>
+        </p:spPr>
+        <p:txBody>
+          <a:bodyPr wrap="square" lIns="0" rIns="0" tIns="0" bIns="0" anchor="t">
+            <a:spAutoFit/>
+          </a:bodyPr>
+          <a:lstStyle/>
+          <a:p>
+            <a:pPr algn="l"/>
+            <a:r>
+              <a:rPr sz="850" b="0">
+                <a:solidFill>
+                  <a:srgbClr val="8C8C8C"/>
+                </a:solidFill>
+                <a:latin typeface="Calibri"/>
+              </a:rPr>
+              <a:t>Fuente: libro, capítulo 9: resultados/prueba_2026/dos_por_dos.csv y contrastes.csv; tablero: Modelos → Modelo original</a:t>
+            </a:r>
+          </a:p>
+        </p:txBody>
+      </p:sp>
+      <p:sp>
+        <p:nvSpPr>
+          <p:cNvPr id="25" name="TextBox 24"/>
+          <p:cNvSpPr txBox="1"/>
+          <p:nvPr/>
+        </p:nvSpPr>
+        <p:spPr>
+          <a:xfrm>
+            <a:off x="6408000" y="4896000"/>
+            <a:ext cx="2304000" cy="180000"/>
+          </a:xfrm>
+          <a:prstGeom prst="rect">
+            <a:avLst/>
+          </a:prstGeom>
+          <a:noFill/>
+        </p:spPr>
+        <p:txBody>
+          <a:bodyPr wrap="square" lIns="0" rIns="0" tIns="0" bIns="0" anchor="t">
+            <a:spAutoFit/>
+          </a:bodyPr>
+          <a:lstStyle/>
+          <a:p>
+            <a:pPr algn="r"/>
+            <a:r>
+              <a:rPr sz="850" b="0">
+                <a:solidFill>
+                  <a:srgbClr val="8C8C8C"/>
+                </a:solidFill>
+                <a:latin typeface="Calibri"/>
+              </a:rPr>
+              <a:t>19 / 22</a:t>
+            </a:r>
+          </a:p>
+        </p:txBody>
+      </p:sp>
+    </p:spTree>
+  </p:cSld>
+  <p:clrMapOvr>
+    <a:masterClrMapping/>
+  </p:clrMapOvr>
+</p:sld>
+</file>
+
+<file path=ppt/slides/slide2.xml><?xml version="1.0" encoding="utf-8"?>
+<p:sld xmlns:a="http://schemas.openxmlformats.org/drawingml/2006/main" xmlns:p="http://schemas.openxmlformats.org/presentationml/2006/main" xmlns:r="http://schemas.openxmlformats.org/officeDocument/2006/relationships">
+  <p:cSld>
+    <p:bg>
+      <p:bgPr>
+        <a:solidFill>
+          <a:srgbClr val="FFFFFF"/>
+        </a:solidFill>
+        <a:effectLst/>
+      </p:bgPr>
+    </p:bg>
+    <p:spTree>
+      <p:nvGrpSpPr>
+        <p:cNvPr id="1" name=""/>
+        <p:cNvGrpSpPr/>
+        <p:nvPr/>
+      </p:nvGrpSpPr>
+      <p:grpSpPr/>
+      <p:sp>
+        <p:nvSpPr>
+          <p:cNvPr id="2" name="Rectangle 1"/>
+          <p:cNvSpPr/>
+          <p:nvPr/>
+        </p:nvSpPr>
+        <p:spPr>
+          <a:xfrm>
+            <a:off x="0" y="0"/>
+            <a:ext cx="9144000" cy="576000"/>
+          </a:xfrm>
+          <a:prstGeom prst="rect">
+            <a:avLst/>
+          </a:prstGeom>
+          <a:solidFill>
+            <a:srgbClr val="405731"/>
+          </a:solidFill>
+          <a:ln>
+            <a:noFill/>
+          </a:ln>
+          <a:effectLst/>
+        </p:spPr>
+        <p:style>
+          <a:lnRef idx="1">
+            <a:schemeClr val="accent1"/>
+          </a:lnRef>
+          <a:fillRef idx="3">
+            <a:schemeClr val="accent1"/>
+          </a:fillRef>
+          <a:effectRef idx="2">
+            <a:schemeClr val="accent1"/>
+          </a:effectRef>
+          <a:fontRef idx="minor">
+            <a:schemeClr val="lt1"/>
+          </a:fontRef>
+        </p:style>
+        <p:txBody>
+          <a:bodyPr rtlCol="0" anchor="ctr" wrap="square"/>
+          <a:lstStyle/>
+          <a:p>
+            <a:pPr algn="ctr"/>
+          </a:p>
+        </p:txBody>
+      </p:sp>
+      <p:sp>
+        <p:nvSpPr>
+          <p:cNvPr id="3" name="Rectangle 2"/>
+          <p:cNvSpPr/>
+          <p:nvPr/>
+        </p:nvSpPr>
+        <p:spPr>
+          <a:xfrm>
+            <a:off x="0" y="576000"/>
+            <a:ext cx="9144000" cy="36000"/>
+          </a:xfrm>
+          <a:prstGeom prst="rect">
+            <a:avLst/>
+          </a:prstGeom>
+          <a:solidFill>
+            <a:srgbClr val="B08A2D"/>
+          </a:solidFill>
+          <a:ln>
+            <a:noFill/>
+          </a:ln>
+          <a:effectLst/>
+        </p:spPr>
+        <p:style>
+          <a:lnRef idx="1">
+            <a:schemeClr val="accent1"/>
+          </a:lnRef>
+          <a:fillRef idx="3">
+            <a:schemeClr val="accent1"/>
+          </a:fillRef>
+          <a:effectRef idx="2">
+            <a:schemeClr val="accent1"/>
+          </a:effectRef>
+          <a:fontRef idx="minor">
+            <a:schemeClr val="lt1"/>
+          </a:fontRef>
+        </p:style>
+        <p:txBody>
+          <a:bodyPr rtlCol="0" anchor="ctr" wrap="square"/>
+          <a:lstStyle/>
+          <a:p>
+            <a:pPr algn="ctr"/>
+          </a:p>
+        </p:txBody>
+      </p:sp>
+      <p:sp>
+        <p:nvSpPr>
+          <p:cNvPr id="4" name="Rectangle 3"/>
+          <p:cNvSpPr/>
+          <p:nvPr/>
+        </p:nvSpPr>
+        <p:spPr>
+          <a:xfrm>
+            <a:off x="144000" y="72000"/>
+            <a:ext cx="468000" cy="432000"/>
+          </a:xfrm>
+          <a:prstGeom prst="rect">
+            <a:avLst/>
+          </a:prstGeom>
+          <a:solidFill>
+            <a:srgbClr val="FFFFFF"/>
+          </a:solidFill>
+          <a:ln>
+            <a:noFill/>
+          </a:ln>
+          <a:effectLst/>
+        </p:spPr>
+        <p:style>
+          <a:lnRef idx="1">
+            <a:schemeClr val="accent1"/>
+          </a:lnRef>
+          <a:fillRef idx="3">
+            <a:schemeClr val="accent1"/>
+          </a:fillRef>
+          <a:effectRef idx="2">
+            <a:schemeClr val="accent1"/>
+          </a:effectRef>
+          <a:fontRef idx="minor">
+            <a:schemeClr val="lt1"/>
+          </a:fontRef>
+        </p:style>
+        <p:txBody>
+          <a:bodyPr rtlCol="0" anchor="ctr" wrap="square"/>
+          <a:lstStyle/>
+          <a:p>
+            <a:pPr algn="ctr"/>
+          </a:p>
+        </p:txBody>
+      </p:sp>
+      <p:pic>
+        <p:nvPicPr>
+          <p:cNvPr id="5" name="Picture 4" descr="logo.png"/>
+          <p:cNvPicPr>
+            <a:picLocks noChangeAspect="1"/>
+          </p:cNvPicPr>
+          <p:nvPr/>
+        </p:nvPicPr>
+        <p:blipFill>
+          <a:blip r:embed="rId2"/>
+          <a:stretch>
+            <a:fillRect/>
+          </a:stretch>
+        </p:blipFill>
+        <p:spPr>
+          <a:xfrm>
+            <a:off x="200160" y="145440"/>
+            <a:ext cx="355680" cy="266417"/>
+          </a:xfrm>
+          <a:prstGeom prst="rect">
+            <a:avLst/>
+          </a:prstGeom>
+        </p:spPr>
+      </p:pic>
+      <p:sp>
+        <p:nvSpPr>
+          <p:cNvPr id="6" name="TextBox 5"/>
+          <p:cNvSpPr txBox="1"/>
+          <p:nvPr/>
+        </p:nvSpPr>
+        <p:spPr>
+          <a:xfrm>
+            <a:off x="792000" y="125999"/>
+            <a:ext cx="8172000" cy="360000"/>
+          </a:xfrm>
+          <a:prstGeom prst="rect">
+            <a:avLst/>
+          </a:prstGeom>
+          <a:noFill/>
+        </p:spPr>
+        <p:txBody>
+          <a:bodyPr wrap="square" lIns="0" rIns="0" tIns="0" bIns="0" anchor="ctr">
+            <a:spAutoFit/>
+          </a:bodyPr>
+          <a:lstStyle/>
+          <a:p>
+            <a:pPr algn="l"/>
+            <a:r>
+              <a:rPr sz="2000" b="1">
+                <a:solidFill>
+                  <a:srgbClr val="FFFFFF"/>
+                </a:solidFill>
+                <a:latin typeface="Calibri"/>
+              </a:rPr>
+              <a:t>Uno de cada tres pedidos llega tarde, y se sabe cuando ya pasó</a:t>
+            </a:r>
+          </a:p>
+        </p:txBody>
+      </p:sp>
+      <p:sp>
+        <p:nvSpPr>
+          <p:cNvPr id="7" name="TextBox 6"/>
+          <p:cNvSpPr txBox="1"/>
+          <p:nvPr/>
+        </p:nvSpPr>
+        <p:spPr>
+          <a:xfrm>
+            <a:off x="468000" y="756000"/>
+            <a:ext cx="7308000" cy="251999"/>
+          </a:xfrm>
+          <a:prstGeom prst="rect">
+            <a:avLst/>
+          </a:prstGeom>
+          <a:noFill/>
+        </p:spPr>
+        <p:txBody>
+          <a:bodyPr wrap="square" lIns="0" rIns="0" tIns="0" bIns="0" anchor="t">
+            <a:spAutoFit/>
+          </a:bodyPr>
+          <a:lstStyle/>
+          <a:p>
+            <a:pPr algn="l"/>
+            <a:r>
+              <a:rPr sz="1200" b="1">
+                <a:solidFill>
+                  <a:srgbClr val="B08A2D"/>
+                </a:solidFill>
+                <a:latin typeface="Calibri"/>
+              </a:rPr>
+              <a:t>CRITERIO 1  ·  EL PROBLEMA</a:t>
+            </a:r>
+          </a:p>
+        </p:txBody>
+      </p:sp>
+      <p:sp>
+        <p:nvSpPr>
+          <p:cNvPr id="8" name="Rectangle 7"/>
+          <p:cNvSpPr/>
+          <p:nvPr/>
+        </p:nvSpPr>
+        <p:spPr>
+          <a:xfrm>
+            <a:off x="468000" y="1044000"/>
+            <a:ext cx="468000" cy="36000"/>
+          </a:xfrm>
+          <a:prstGeom prst="rect">
+            <a:avLst/>
+          </a:prstGeom>
+          <a:solidFill>
+            <a:srgbClr val="B08A2D"/>
+          </a:solidFill>
+          <a:ln>
+            <a:noFill/>
+          </a:ln>
+          <a:effectLst/>
+        </p:spPr>
+        <p:style>
+          <a:lnRef idx="1">
+            <a:schemeClr val="accent1"/>
+          </a:lnRef>
+          <a:fillRef idx="3">
+            <a:schemeClr val="accent1"/>
+          </a:fillRef>
+          <a:effectRef idx="2">
+            <a:schemeClr val="accent1"/>
+          </a:effectRef>
+          <a:fontRef idx="minor">
+            <a:schemeClr val="lt1"/>
+          </a:fontRef>
+        </p:style>
+        <p:txBody>
+          <a:bodyPr rtlCol="0" anchor="ctr" wrap="square"/>
+          <a:lstStyle/>
+          <a:p>
+            <a:pPr algn="ctr"/>
+          </a:p>
+        </p:txBody>
+      </p:sp>
+      <p:sp>
+        <p:nvSpPr>
+          <p:cNvPr id="9" name="Rectangle 8"/>
+          <p:cNvSpPr/>
+          <p:nvPr/>
+        </p:nvSpPr>
+        <p:spPr>
+          <a:xfrm>
+            <a:off x="468000" y="1224000"/>
+            <a:ext cx="1944000" cy="972000"/>
+          </a:xfrm>
+          <a:prstGeom prst="rect">
+            <a:avLst/>
+          </a:prstGeom>
+          <a:solidFill>
+            <a:srgbClr val="E8F0EB"/>
+          </a:solidFill>
+          <a:ln>
+            <a:noFill/>
+          </a:ln>
+          <a:effectLst/>
+        </p:spPr>
+        <p:style>
+          <a:lnRef idx="1">
+            <a:schemeClr val="accent1"/>
+          </a:lnRef>
+          <a:fillRef idx="3">
+            <a:schemeClr val="accent1"/>
+          </a:fillRef>
+          <a:effectRef idx="2">
+            <a:schemeClr val="accent1"/>
+          </a:effectRef>
+          <a:fontRef idx="minor">
+            <a:schemeClr val="lt1"/>
+          </a:fontRef>
+        </p:style>
+        <p:txBody>
+          <a:bodyPr rtlCol="0" anchor="ctr" wrap="square"/>
+          <a:lstStyle/>
+          <a:p>
+            <a:pPr algn="ctr"/>
+          </a:p>
+        </p:txBody>
+      </p:sp>
+      <p:sp>
+        <p:nvSpPr>
+          <p:cNvPr id="10" name="Rectangle 9"/>
+          <p:cNvSpPr/>
+          <p:nvPr/>
+        </p:nvSpPr>
+        <p:spPr>
+          <a:xfrm>
+            <a:off x="558000" y="1224000"/>
+            <a:ext cx="1764000" cy="36000"/>
+          </a:xfrm>
+          <a:prstGeom prst="rect">
+            <a:avLst/>
+          </a:prstGeom>
+          <a:solidFill>
+            <a:srgbClr val="B08A2D"/>
+          </a:solidFill>
+          <a:ln>
+            <a:noFill/>
+          </a:ln>
+          <a:effectLst/>
+        </p:spPr>
+        <p:style>
+          <a:lnRef idx="1">
+            <a:schemeClr val="accent1"/>
+          </a:lnRef>
+          <a:fillRef idx="3">
+            <a:schemeClr val="accent1"/>
+          </a:fillRef>
+          <a:effectRef idx="2">
+            <a:schemeClr val="accent1"/>
+          </a:effectRef>
+          <a:fontRef idx="minor">
+            <a:schemeClr val="lt1"/>
+          </a:fontRef>
+        </p:style>
+        <p:txBody>
+          <a:bodyPr rtlCol="0" anchor="ctr" wrap="square"/>
+          <a:lstStyle/>
+          <a:p>
+            <a:pPr algn="ctr"/>
+          </a:p>
+        </p:txBody>
+      </p:sp>
+      <p:sp>
+        <p:nvSpPr>
+          <p:cNvPr id="11" name="TextBox 10"/>
+          <p:cNvSpPr txBox="1"/>
+          <p:nvPr/>
+        </p:nvSpPr>
+        <p:spPr>
+          <a:xfrm>
+            <a:off x="468000" y="1350000"/>
+            <a:ext cx="1944000" cy="468000"/>
+          </a:xfrm>
+          <a:prstGeom prst="rect">
+            <a:avLst/>
+          </a:prstGeom>
+          <a:noFill/>
+        </p:spPr>
+        <p:txBody>
+          <a:bodyPr wrap="square" lIns="0" rIns="0" tIns="0" bIns="0" anchor="t">
+            <a:spAutoFit/>
+          </a:bodyPr>
+          <a:lstStyle/>
+          <a:p>
+            <a:pPr algn="ctr"/>
+            <a:r>
+              <a:rPr sz="3400" b="1">
+                <a:solidFill>
+                  <a:srgbClr val="405731"/>
+                </a:solidFill>
+                <a:latin typeface="Calibri"/>
+              </a:rPr>
+              <a:t>33,0 %</a:t>
+            </a:r>
+          </a:p>
+        </p:txBody>
+      </p:sp>
+      <p:sp>
+        <p:nvSpPr>
+          <p:cNvPr id="12" name="TextBox 11"/>
+          <p:cNvSpPr txBox="1"/>
+          <p:nvPr/>
+        </p:nvSpPr>
+        <p:spPr>
+          <a:xfrm>
+            <a:off x="468000" y="1854000"/>
+            <a:ext cx="1944000" cy="288000"/>
+          </a:xfrm>
+          <a:prstGeom prst="rect">
+            <a:avLst/>
+          </a:prstGeom>
+          <a:noFill/>
+        </p:spPr>
+        <p:txBody>
+          <a:bodyPr wrap="square" lIns="0" rIns="0" tIns="0" bIns="0" anchor="t">
+            <a:spAutoFit/>
+          </a:bodyPr>
+          <a:lstStyle/>
+          <a:p>
+            <a:pPr algn="ctr"/>
+            <a:r>
+              <a:rPr sz="1050" b="0">
+                <a:solidFill>
+                  <a:srgbClr val="5A5A5A"/>
+                </a:solidFill>
+                <a:latin typeface="Calibri"/>
+              </a:rPr>
+              <a:t>de las posiciones llega tarde</a:t>
+            </a:r>
+          </a:p>
+        </p:txBody>
+      </p:sp>
+      <p:sp>
+        <p:nvSpPr>
+          <p:cNvPr id="13" name="Rectangle 12"/>
+          <p:cNvSpPr/>
+          <p:nvPr/>
+        </p:nvSpPr>
+        <p:spPr>
+          <a:xfrm>
+            <a:off x="468000" y="2304000"/>
+            <a:ext cx="1944000" cy="972000"/>
+          </a:xfrm>
+          <a:prstGeom prst="rect">
+            <a:avLst/>
+          </a:prstGeom>
+          <a:solidFill>
+            <a:srgbClr val="F5EDE0"/>
+          </a:solidFill>
+          <a:ln>
+            <a:noFill/>
+          </a:ln>
+          <a:effectLst/>
+        </p:spPr>
+        <p:style>
+          <a:lnRef idx="1">
+            <a:schemeClr val="accent1"/>
+          </a:lnRef>
+          <a:fillRef idx="3">
+            <a:schemeClr val="accent1"/>
+          </a:fillRef>
+          <a:effectRef idx="2">
+            <a:schemeClr val="accent1"/>
+          </a:effectRef>
+          <a:fontRef idx="minor">
+            <a:schemeClr val="lt1"/>
+          </a:fontRef>
+        </p:style>
+        <p:txBody>
+          <a:bodyPr rtlCol="0" anchor="ctr" wrap="square"/>
+          <a:lstStyle/>
+          <a:p>
+            <a:pPr algn="ctr"/>
+          </a:p>
+        </p:txBody>
+      </p:sp>
+      <p:sp>
+        <p:nvSpPr>
+          <p:cNvPr id="14" name="Rectangle 13"/>
+          <p:cNvSpPr/>
+          <p:nvPr/>
+        </p:nvSpPr>
+        <p:spPr>
+          <a:xfrm>
+            <a:off x="558000" y="2304000"/>
+            <a:ext cx="1764000" cy="36000"/>
+          </a:xfrm>
+          <a:prstGeom prst="rect">
+            <a:avLst/>
+          </a:prstGeom>
+          <a:solidFill>
+            <a:srgbClr val="B08A2D"/>
+          </a:solidFill>
+          <a:ln>
+            <a:noFill/>
+          </a:ln>
+          <a:effectLst/>
+        </p:spPr>
+        <p:style>
+          <a:lnRef idx="1">
+            <a:schemeClr val="accent1"/>
+          </a:lnRef>
+          <a:fillRef idx="3">
+            <a:schemeClr val="accent1"/>
+          </a:fillRef>
+          <a:effectRef idx="2">
+            <a:schemeClr val="accent1"/>
+          </a:effectRef>
+          <a:fontRef idx="minor">
+            <a:schemeClr val="lt1"/>
+          </a:fontRef>
+        </p:style>
+        <p:txBody>
+          <a:bodyPr rtlCol="0" anchor="ctr" wrap="square"/>
+          <a:lstStyle/>
+          <a:p>
+            <a:pPr algn="ctr"/>
+          </a:p>
+        </p:txBody>
+      </p:sp>
+      <p:sp>
+        <p:nvSpPr>
+          <p:cNvPr id="15" name="TextBox 14"/>
+          <p:cNvSpPr txBox="1"/>
+          <p:nvPr/>
+        </p:nvSpPr>
+        <p:spPr>
+          <a:xfrm>
+            <a:off x="468000" y="2430000"/>
+            <a:ext cx="1944000" cy="468000"/>
+          </a:xfrm>
+          <a:prstGeom prst="rect">
+            <a:avLst/>
+          </a:prstGeom>
+          <a:noFill/>
+        </p:spPr>
+        <p:txBody>
+          <a:bodyPr wrap="square" lIns="0" rIns="0" tIns="0" bIns="0" anchor="t">
+            <a:spAutoFit/>
+          </a:bodyPr>
+          <a:lstStyle/>
+          <a:p>
+            <a:pPr algn="ctr"/>
+            <a:r>
+              <a:rPr sz="3400" b="1">
+                <a:solidFill>
+                  <a:srgbClr val="405731"/>
+                </a:solidFill>
+                <a:latin typeface="Calibri"/>
+              </a:rPr>
+              <a:t>41 %</a:t>
+            </a:r>
+          </a:p>
+        </p:txBody>
+      </p:sp>
+      <p:sp>
+        <p:nvSpPr>
+          <p:cNvPr id="16" name="TextBox 15"/>
+          <p:cNvSpPr txBox="1"/>
+          <p:nvPr/>
+        </p:nvSpPr>
+        <p:spPr>
+          <a:xfrm>
+            <a:off x="468000" y="2934000"/>
+            <a:ext cx="1944000" cy="288000"/>
+          </a:xfrm>
+          <a:prstGeom prst="rect">
+            <a:avLst/>
+          </a:prstGeom>
+          <a:noFill/>
+        </p:spPr>
+        <p:txBody>
+          <a:bodyPr wrap="square" lIns="0" rIns="0" tIns="0" bIns="0" anchor="t">
+            <a:spAutoFit/>
+          </a:bodyPr>
+          <a:lstStyle/>
+          <a:p>
+            <a:pPr algn="ctr"/>
+            <a:r>
+              <a:rPr sz="1050" b="0">
+                <a:solidFill>
+                  <a:srgbClr val="5A5A5A"/>
+                </a:solidFill>
+                <a:latin typeface="Calibri"/>
+              </a:rPr>
+              <a:t>en industrial; 25 % en ganaderia</a:t>
+            </a:r>
+          </a:p>
+        </p:txBody>
+      </p:sp>
+      <p:sp>
+        <p:nvSpPr>
+          <p:cNvPr id="17" name="Rectangle 16"/>
+          <p:cNvSpPr/>
+          <p:nvPr/>
+        </p:nvSpPr>
+        <p:spPr>
+          <a:xfrm>
+            <a:off x="468000" y="3384000"/>
+            <a:ext cx="1944000" cy="972000"/>
+          </a:xfrm>
+          <a:prstGeom prst="rect">
+            <a:avLst/>
+          </a:prstGeom>
+          <a:solidFill>
+            <a:srgbClr val="EEF2EA"/>
+          </a:solidFill>
+          <a:ln>
+            <a:noFill/>
+          </a:ln>
+          <a:effectLst/>
+        </p:spPr>
+        <p:style>
+          <a:lnRef idx="1">
+            <a:schemeClr val="accent1"/>
+          </a:lnRef>
+          <a:fillRef idx="3">
+            <a:schemeClr val="accent1"/>
+          </a:fillRef>
+          <a:effectRef idx="2">
+            <a:schemeClr val="accent1"/>
+          </a:effectRef>
+          <a:fontRef idx="minor">
+            <a:schemeClr val="lt1"/>
+          </a:fontRef>
+        </p:style>
+        <p:txBody>
+          <a:bodyPr rtlCol="0" anchor="ctr" wrap="square"/>
+          <a:lstStyle/>
+          <a:p>
+            <a:pPr algn="ctr"/>
+          </a:p>
+        </p:txBody>
+      </p:sp>
+      <p:sp>
+        <p:nvSpPr>
+          <p:cNvPr id="18" name="Rectangle 17"/>
+          <p:cNvSpPr/>
+          <p:nvPr/>
+        </p:nvSpPr>
+        <p:spPr>
+          <a:xfrm>
+            <a:off x="558000" y="3384000"/>
+            <a:ext cx="1764000" cy="36000"/>
+          </a:xfrm>
+          <a:prstGeom prst="rect">
+            <a:avLst/>
+          </a:prstGeom>
+          <a:solidFill>
+            <a:srgbClr val="B08A2D"/>
+          </a:solidFill>
+          <a:ln>
+            <a:noFill/>
+          </a:ln>
+          <a:effectLst/>
+        </p:spPr>
+        <p:style>
+          <a:lnRef idx="1">
+            <a:schemeClr val="accent1"/>
+          </a:lnRef>
+          <a:fillRef idx="3">
+            <a:schemeClr val="accent1"/>
+          </a:fillRef>
+          <a:effectRef idx="2">
+            <a:schemeClr val="accent1"/>
+          </a:effectRef>
+          <a:fontRef idx="minor">
+            <a:schemeClr val="lt1"/>
+          </a:fontRef>
+        </p:style>
+        <p:txBody>
+          <a:bodyPr rtlCol="0" anchor="ctr" wrap="square"/>
+          <a:lstStyle/>
+          <a:p>
+            <a:pPr algn="ctr"/>
+          </a:p>
+        </p:txBody>
+      </p:sp>
+      <p:sp>
+        <p:nvSpPr>
+          <p:cNvPr id="19" name="TextBox 18"/>
+          <p:cNvSpPr txBox="1"/>
+          <p:nvPr/>
+        </p:nvSpPr>
+        <p:spPr>
+          <a:xfrm>
+            <a:off x="468000" y="3510000"/>
+            <a:ext cx="1944000" cy="468000"/>
+          </a:xfrm>
+          <a:prstGeom prst="rect">
+            <a:avLst/>
+          </a:prstGeom>
+          <a:noFill/>
+        </p:spPr>
+        <p:txBody>
+          <a:bodyPr wrap="square" lIns="0" rIns="0" tIns="0" bIns="0" anchor="t">
+            <a:spAutoFit/>
+          </a:bodyPr>
+          <a:lstStyle/>
+          <a:p>
+            <a:pPr algn="ctr"/>
+            <a:r>
+              <a:rPr sz="3400" b="1">
+                <a:solidFill>
+                  <a:srgbClr val="405731"/>
+                </a:solidFill>
+                <a:latin typeface="Calibri"/>
+              </a:rPr>
+              <a:t>71 %</a:t>
+            </a:r>
+          </a:p>
+        </p:txBody>
+      </p:sp>
+      <p:sp>
+        <p:nvSpPr>
+          <p:cNvPr id="20" name="TextBox 19"/>
+          <p:cNvSpPr txBox="1"/>
+          <p:nvPr/>
+        </p:nvSpPr>
+        <p:spPr>
+          <a:xfrm>
+            <a:off x="468000" y="4014000"/>
+            <a:ext cx="1944000" cy="288000"/>
+          </a:xfrm>
+          <a:prstGeom prst="rect">
+            <a:avLst/>
+          </a:prstGeom>
+          <a:noFill/>
+        </p:spPr>
+        <p:txBody>
+          <a:bodyPr wrap="square" lIns="0" rIns="0" tIns="0" bIns="0" anchor="t">
+            <a:spAutoFit/>
+          </a:bodyPr>
+          <a:lstStyle/>
+          <a:p>
+            <a:pPr algn="ctr"/>
+            <a:r>
+              <a:rPr sz="1050" b="0">
+                <a:solidFill>
+                  <a:srgbClr val="5A5A5A"/>
+                </a:solidFill>
+                <a:latin typeface="Calibri"/>
+              </a:rPr>
+              <a:t>de las tardías de 2026, marcando el 38 %</a:t>
+            </a:r>
+          </a:p>
+        </p:txBody>
+      </p:sp>
+      <p:sp>
+        <p:nvSpPr>
+          <p:cNvPr id="21" name="TextBox 20"/>
+          <p:cNvSpPr txBox="1"/>
+          <p:nvPr/>
+        </p:nvSpPr>
+        <p:spPr>
+          <a:xfrm>
+            <a:off x="2736000" y="1188000"/>
+            <a:ext cx="3311999" cy="216000"/>
+          </a:xfrm>
+          <a:prstGeom prst="rect">
+            <a:avLst/>
+          </a:prstGeom>
+          <a:noFill/>
+        </p:spPr>
+        <p:txBody>
+          <a:bodyPr wrap="square" lIns="0" rIns="0" tIns="0" bIns="0" anchor="t">
+            <a:spAutoFit/>
+          </a:bodyPr>
+          <a:lstStyle/>
+          <a:p>
+            <a:pPr algn="l"/>
+            <a:r>
+              <a:rPr sz="1250" b="1">
+                <a:solidFill>
+                  <a:srgbClr val="405731"/>
+                </a:solidFill>
+                <a:latin typeface="Calibri"/>
+              </a:rPr>
+              <a:t>Por qué importa</a:t>
+            </a:r>
+          </a:p>
+        </p:txBody>
+      </p:sp>
+      <p:sp>
+        <p:nvSpPr>
+          <p:cNvPr id="22" name="TextBox 21"/>
+          <p:cNvSpPr txBox="1"/>
+          <p:nvPr/>
+        </p:nvSpPr>
+        <p:spPr>
+          <a:xfrm>
+            <a:off x="2736000" y="1440000"/>
+            <a:ext cx="3311999" cy="1296000"/>
+          </a:xfrm>
+          <a:prstGeom prst="rect">
+            <a:avLst/>
+          </a:prstGeom>
+          <a:noFill/>
+        </p:spPr>
+        <p:txBody>
+          <a:bodyPr wrap="square" lIns="0" rIns="0" tIns="0" bIns="0" anchor="t">
+            <a:spAutoFit/>
+          </a:bodyPr>
+          <a:lstStyle/>
+          <a:p>
+            <a:pPr algn="l"/>
+            <a:r>
+              <a:rPr sz="1100" b="0">
+                <a:solidFill>
+                  <a:srgbClr val="1A1A1A"/>
+                </a:solidFill>
+                <a:latin typeface="Calibri"/>
+              </a:rPr>
+              <a:t>El comprador hoy se entera del retraso cuando la mercancía no llega. Con miles de posiciones abiertas, no puede seguirlas todas: necesita saber, el día en que libera la orden, cuáles vigilar.</a:t>
+            </a:r>
+          </a:p>
+        </p:txBody>
+      </p:sp>
+      <p:sp>
+        <p:nvSpPr>
+          <p:cNvPr id="23" name="TextBox 22"/>
+          <p:cNvSpPr txBox="1"/>
+          <p:nvPr/>
+        </p:nvSpPr>
+        <p:spPr>
+          <a:xfrm>
+            <a:off x="2736000" y="2628000"/>
+            <a:ext cx="3311999" cy="216000"/>
+          </a:xfrm>
+          <a:prstGeom prst="rect">
+            <a:avLst/>
+          </a:prstGeom>
+          <a:noFill/>
+        </p:spPr>
+        <p:txBody>
+          <a:bodyPr wrap="square" lIns="0" rIns="0" tIns="0" bIns="0" anchor="t">
+            <a:spAutoFit/>
+          </a:bodyPr>
+          <a:lstStyle/>
+          <a:p>
+            <a:pPr algn="l"/>
+            <a:r>
+              <a:rPr sz="1250" b="1">
+                <a:solidFill>
+                  <a:srgbClr val="405731"/>
+                </a:solidFill>
+                <a:latin typeface="Calibri"/>
+              </a:rPr>
+              <a:t>Qué dice la literatura</a:t>
+            </a:r>
+          </a:p>
+        </p:txBody>
+      </p:sp>
+      <p:sp>
+        <p:nvSpPr>
+          <p:cNvPr id="24" name="TextBox 23"/>
+          <p:cNvSpPr txBox="1"/>
+          <p:nvPr/>
+        </p:nvSpPr>
+        <p:spPr>
+          <a:xfrm>
+            <a:off x="2736000" y="2880000"/>
+            <a:ext cx="3311999" cy="1800000"/>
+          </a:xfrm>
+          <a:prstGeom prst="rect">
+            <a:avLst/>
+          </a:prstGeom>
+          <a:noFill/>
+        </p:spPr>
+        <p:txBody>
+          <a:bodyPr wrap="square" lIns="0" rIns="0" tIns="0" bIns="0" anchor="t">
+            <a:spAutoFit/>
+          </a:bodyPr>
+          <a:lstStyle/>
+          <a:p>
+            <a:pPr algn="l"/>
+            <a:r>
+              <a:rPr sz="1050" b="0">
+                <a:solidFill>
+                  <a:srgbClr val="5A5A5A"/>
+                </a:solidFill>
+                <a:latin typeface="Calibri"/>
+              </a:rPr>
+              <a:t>En fabricantes de maquinaria y equipos llega tarde del 13 % al 14 % de los pedidos (Brintrup y otros, 2020; Steinberg y otros, 2023): aquí es más del doble.</a:t>
+            </a:r>
+          </a:p>
+          <a:p>
+            <a:pPr algn="l">
+              <a:spcBef>
+                <a:spcPts val="600"/>
+              </a:spcBef>
+            </a:pPr>
+            <a:r>
+              <a:rPr sz="1050" b="0">
+                <a:solidFill>
+                  <a:srgbClr val="5A5A5A"/>
+                </a:solidFill>
+                <a:latin typeface="Calibri"/>
+              </a:rPr>
+              <a:t>Una revisión de 26 estudios encuentra que 16 parten las filas al azar; reevaluado sin fuga y en el tiempo, un AUC de 0,96 baja a 0,73 (Raval, 2026). Este trabajo evalúa siempre hacia adelante.</a:t>
+            </a:r>
+          </a:p>
+        </p:txBody>
+      </p:sp>
+      <p:sp>
+        <p:nvSpPr>
+          <p:cNvPr id="25" name="Rectangle 24"/>
+          <p:cNvSpPr/>
+          <p:nvPr/>
+        </p:nvSpPr>
+        <p:spPr>
+          <a:xfrm>
+            <a:off x="6263999" y="1224000"/>
+            <a:ext cx="2448000" cy="3491999"/>
+          </a:xfrm>
+          <a:prstGeom prst="rect">
+            <a:avLst/>
+          </a:prstGeom>
+          <a:solidFill>
+            <a:srgbClr val="E8F0EB"/>
+          </a:solidFill>
+          <a:ln>
+            <a:noFill/>
+          </a:ln>
+          <a:effectLst/>
+        </p:spPr>
+        <p:style>
+          <a:lnRef idx="1">
+            <a:schemeClr val="accent1"/>
+          </a:lnRef>
+          <a:fillRef idx="3">
+            <a:schemeClr val="accent1"/>
+          </a:fillRef>
+          <a:effectRef idx="2">
+            <a:schemeClr val="accent1"/>
+          </a:effectRef>
+          <a:fontRef idx="minor">
+            <a:schemeClr val="lt1"/>
+          </a:fontRef>
+        </p:style>
+        <p:txBody>
+          <a:bodyPr rtlCol="0" anchor="ctr" wrap="square"/>
+          <a:lstStyle/>
+          <a:p>
+            <a:pPr algn="ctr"/>
+          </a:p>
+        </p:txBody>
+      </p:sp>
+      <p:sp>
+        <p:nvSpPr>
+          <p:cNvPr id="26" name="TextBox 25"/>
+          <p:cNvSpPr txBox="1"/>
+          <p:nvPr/>
+        </p:nvSpPr>
+        <p:spPr>
+          <a:xfrm>
+            <a:off x="6425999" y="1332000"/>
+            <a:ext cx="2124000" cy="288000"/>
+          </a:xfrm>
+          <a:prstGeom prst="rect">
+            <a:avLst/>
+          </a:prstGeom>
+          <a:noFill/>
+        </p:spPr>
+        <p:txBody>
+          <a:bodyPr wrap="square" lIns="0" rIns="0" tIns="0" bIns="0" anchor="t">
+            <a:spAutoFit/>
+          </a:bodyPr>
+          <a:lstStyle/>
+          <a:p>
+            <a:pPr algn="l"/>
+            <a:r>
+              <a:rPr sz="1300" b="1">
+                <a:solidFill>
+                  <a:srgbClr val="405731"/>
+                </a:solidFill>
+                <a:latin typeface="Calibri"/>
+              </a:rPr>
+              <a:t>Objetivos</a:t>
+            </a:r>
+          </a:p>
+        </p:txBody>
+      </p:sp>
+      <p:sp>
+        <p:nvSpPr>
+          <p:cNvPr id="27" name="TextBox 26"/>
+          <p:cNvSpPr txBox="1"/>
+          <p:nvPr/>
+        </p:nvSpPr>
+        <p:spPr>
+          <a:xfrm>
+            <a:off x="6425999" y="1591200"/>
+            <a:ext cx="2124000" cy="3077999"/>
+          </a:xfrm>
+          <a:prstGeom prst="rect">
+            <a:avLst/>
+          </a:prstGeom>
+          <a:noFill/>
+        </p:spPr>
+        <p:txBody>
+          <a:bodyPr wrap="square" lIns="0" rIns="0" tIns="0" bIns="0" anchor="t">
+            <a:spAutoFit/>
+          </a:bodyPr>
+          <a:lstStyle/>
+          <a:p>
+            <a:pPr algn="l"/>
+            <a:r>
+              <a:rPr sz="1050" b="0">
+                <a:solidFill>
+                  <a:srgbClr val="1A1A1A"/>
+                </a:solidFill>
+                <a:latin typeface="Calibri"/>
+              </a:rPr>
+              <a:t>General: ordenar las posiciones por riesgo de retraso el día de la liberación y señalar cuáles seguir.</a:t>
+            </a:r>
+          </a:p>
+          <a:p>
+            <a:pPr algn="l"/>
+            <a:r>
+              <a:rPr sz="1050" b="0">
+                <a:solidFill>
+                  <a:srgbClr val="1A1A1A"/>
+                </a:solidFill>
+                <a:latin typeface="Calibri"/>
+              </a:rPr>
+              <a:t>Específico 1: comparar 7 modelos × 4 balanceos × 4 optimizadores con el mismo presupuesto.</a:t>
+            </a:r>
+          </a:p>
+          <a:p>
+            <a:pPr algn="l"/>
+            <a:r>
+              <a:rPr sz="1050" b="0">
+                <a:solidFill>
+                  <a:srgbClr val="1A1A1A"/>
+                </a:solidFill>
+                <a:latin typeface="Calibri"/>
+              </a:rPr>
+              <a:t>Específico 2: medir cuánto cuesta decidir con entidades nuevas (proveedor o material sin historia).</a:t>
+            </a:r>
+          </a:p>
+          <a:p>
+            <a:pPr algn="l"/>
+            <a:r>
+              <a:rPr sz="1050" b="0">
+                <a:solidFill>
+                  <a:srgbClr val="1A1A1A"/>
+                </a:solidFill>
+                <a:latin typeface="Calibri"/>
+              </a:rPr>
+              <a:t>Específico 3: dejar el modelo servido en un tablero con predicción en vivo.</a:t>
+            </a:r>
+          </a:p>
+        </p:txBody>
+      </p:sp>
+      <p:sp>
+        <p:nvSpPr>
+          <p:cNvPr id="28" name="Rectangle 27"/>
+          <p:cNvSpPr/>
+          <p:nvPr/>
+        </p:nvSpPr>
+        <p:spPr>
+          <a:xfrm>
+            <a:off x="468000" y="4842000"/>
+            <a:ext cx="8243999" cy="14400"/>
+          </a:xfrm>
+          <a:prstGeom prst="rect">
+            <a:avLst/>
+          </a:prstGeom>
+          <a:solidFill>
+            <a:srgbClr val="DDD5C0"/>
+          </a:solidFill>
+          <a:ln>
+            <a:noFill/>
+          </a:ln>
+          <a:effectLst/>
+        </p:spPr>
+        <p:style>
+          <a:lnRef idx="1">
+            <a:schemeClr val="accent1"/>
+          </a:lnRef>
+          <a:fillRef idx="3">
+            <a:schemeClr val="accent1"/>
+          </a:fillRef>
+          <a:effectRef idx="2">
+            <a:schemeClr val="accent1"/>
+          </a:effectRef>
+          <a:fontRef idx="minor">
+            <a:schemeClr val="lt1"/>
+          </a:fontRef>
+        </p:style>
+        <p:txBody>
+          <a:bodyPr rtlCol="0" anchor="ctr" wrap="square"/>
+          <a:lstStyle/>
+          <a:p>
+            <a:pPr algn="ctr"/>
+          </a:p>
+        </p:txBody>
+      </p:sp>
+      <p:sp>
+        <p:nvSpPr>
+          <p:cNvPr id="29" name="TextBox 28"/>
+          <p:cNvSpPr txBox="1"/>
+          <p:nvPr/>
+        </p:nvSpPr>
+        <p:spPr>
+          <a:xfrm>
+            <a:off x="468000" y="4896000"/>
+            <a:ext cx="5940000" cy="180000"/>
+          </a:xfrm>
+          <a:prstGeom prst="rect">
+            <a:avLst/>
+          </a:prstGeom>
+          <a:noFill/>
+        </p:spPr>
+        <p:txBody>
+          <a:bodyPr wrap="square" lIns="0" rIns="0" tIns="0" bIns="0" anchor="t">
+            <a:spAutoFit/>
+          </a:bodyPr>
+          <a:lstStyle/>
+          <a:p>
+            <a:pPr algn="l"/>
+            <a:r>
+              <a:rPr sz="850" b="0">
+                <a:solidFill>
+                  <a:srgbClr val="8C8C8C"/>
+                </a:solidFill>
+                <a:latin typeface="Calibri"/>
+              </a:rPr>
+              <a:t>Fuente: libro, introducción y literatura; capítulo 5 (modelo base): data/modelos/metricas.csv</a:t>
+            </a:r>
+          </a:p>
+        </p:txBody>
+      </p:sp>
+      <p:sp>
+        <p:nvSpPr>
+          <p:cNvPr id="30" name="TextBox 29"/>
+          <p:cNvSpPr txBox="1"/>
+          <p:nvPr/>
+        </p:nvSpPr>
+        <p:spPr>
+          <a:xfrm>
+            <a:off x="6408000" y="4896000"/>
+            <a:ext cx="2304000" cy="180000"/>
+          </a:xfrm>
+          <a:prstGeom prst="rect">
+            <a:avLst/>
+          </a:prstGeom>
+          <a:noFill/>
+        </p:spPr>
+        <p:txBody>
+          <a:bodyPr wrap="square" lIns="0" rIns="0" tIns="0" bIns="0" anchor="t">
+            <a:spAutoFit/>
+          </a:bodyPr>
+          <a:lstStyle/>
+          <a:p>
+            <a:pPr algn="r"/>
+            <a:r>
+              <a:rPr sz="850" b="0">
+                <a:solidFill>
+                  <a:srgbClr val="8C8C8C"/>
+                </a:solidFill>
+                <a:latin typeface="Calibri"/>
+              </a:rPr>
+              <a:t>2 / 22</a:t>
+            </a:r>
+          </a:p>
+        </p:txBody>
+      </p:sp>
+    </p:spTree>
+  </p:cSld>
+  <p:clrMapOvr>
+    <a:masterClrMapping/>
+  </p:clrMapOvr>
+</p:sld>
+</file>
+
+<file path=ppt/slides/slide20.xml><?xml version="1.0" encoding="utf-8"?>
 <p:sld xmlns:a="http://schemas.openxmlformats.org/drawingml/2006/main" xmlns:p="http://schemas.openxmlformats.org/presentationml/2006/main" xmlns:r="http://schemas.openxmlformats.org/officeDocument/2006/relationships">
   <p:cSld>
     <p:bg>
@@ -18078,7 +20543,7 @@
                 </a:solidFill>
                 <a:latin typeface="Calibri"/>
               </a:rPr>
-              <a:t>19 / 21</a:t>
+              <a:t>20 / 22</a:t>
             </a:r>
           </a:p>
         </p:txBody>
@@ -18091,1197 +20556,7 @@
 </p:sld>
 </file>
 
-<file path=ppt/slides/slide2.xml><?xml version="1.0" encoding="utf-8"?>
-<p:sld xmlns:a="http://schemas.openxmlformats.org/drawingml/2006/main" xmlns:p="http://schemas.openxmlformats.org/presentationml/2006/main" xmlns:r="http://schemas.openxmlformats.org/officeDocument/2006/relationships">
-  <p:cSld>
-    <p:bg>
-      <p:bgPr>
-        <a:solidFill>
-          <a:srgbClr val="FFFFFF"/>
-        </a:solidFill>
-        <a:effectLst/>
-      </p:bgPr>
-    </p:bg>
-    <p:spTree>
-      <p:nvGrpSpPr>
-        <p:cNvPr id="1" name=""/>
-        <p:cNvGrpSpPr/>
-        <p:nvPr/>
-      </p:nvGrpSpPr>
-      <p:grpSpPr/>
-      <p:sp>
-        <p:nvSpPr>
-          <p:cNvPr id="2" name="Rectangle 1"/>
-          <p:cNvSpPr/>
-          <p:nvPr/>
-        </p:nvSpPr>
-        <p:spPr>
-          <a:xfrm>
-            <a:off x="0" y="0"/>
-            <a:ext cx="9144000" cy="576000"/>
-          </a:xfrm>
-          <a:prstGeom prst="rect">
-            <a:avLst/>
-          </a:prstGeom>
-          <a:solidFill>
-            <a:srgbClr val="405731"/>
-          </a:solidFill>
-          <a:ln>
-            <a:noFill/>
-          </a:ln>
-          <a:effectLst/>
-        </p:spPr>
-        <p:style>
-          <a:lnRef idx="1">
-            <a:schemeClr val="accent1"/>
-          </a:lnRef>
-          <a:fillRef idx="3">
-            <a:schemeClr val="accent1"/>
-          </a:fillRef>
-          <a:effectRef idx="2">
-            <a:schemeClr val="accent1"/>
-          </a:effectRef>
-          <a:fontRef idx="minor">
-            <a:schemeClr val="lt1"/>
-          </a:fontRef>
-        </p:style>
-        <p:txBody>
-          <a:bodyPr rtlCol="0" anchor="ctr" wrap="square"/>
-          <a:lstStyle/>
-          <a:p>
-            <a:pPr algn="ctr"/>
-          </a:p>
-        </p:txBody>
-      </p:sp>
-      <p:sp>
-        <p:nvSpPr>
-          <p:cNvPr id="3" name="Rectangle 2"/>
-          <p:cNvSpPr/>
-          <p:nvPr/>
-        </p:nvSpPr>
-        <p:spPr>
-          <a:xfrm>
-            <a:off x="0" y="576000"/>
-            <a:ext cx="9144000" cy="36000"/>
-          </a:xfrm>
-          <a:prstGeom prst="rect">
-            <a:avLst/>
-          </a:prstGeom>
-          <a:solidFill>
-            <a:srgbClr val="B08A2D"/>
-          </a:solidFill>
-          <a:ln>
-            <a:noFill/>
-          </a:ln>
-          <a:effectLst/>
-        </p:spPr>
-        <p:style>
-          <a:lnRef idx="1">
-            <a:schemeClr val="accent1"/>
-          </a:lnRef>
-          <a:fillRef idx="3">
-            <a:schemeClr val="accent1"/>
-          </a:fillRef>
-          <a:effectRef idx="2">
-            <a:schemeClr val="accent1"/>
-          </a:effectRef>
-          <a:fontRef idx="minor">
-            <a:schemeClr val="lt1"/>
-          </a:fontRef>
-        </p:style>
-        <p:txBody>
-          <a:bodyPr rtlCol="0" anchor="ctr" wrap="square"/>
-          <a:lstStyle/>
-          <a:p>
-            <a:pPr algn="ctr"/>
-          </a:p>
-        </p:txBody>
-      </p:sp>
-      <p:sp>
-        <p:nvSpPr>
-          <p:cNvPr id="4" name="Rectangle 3"/>
-          <p:cNvSpPr/>
-          <p:nvPr/>
-        </p:nvSpPr>
-        <p:spPr>
-          <a:xfrm>
-            <a:off x="144000" y="72000"/>
-            <a:ext cx="468000" cy="432000"/>
-          </a:xfrm>
-          <a:prstGeom prst="rect">
-            <a:avLst/>
-          </a:prstGeom>
-          <a:solidFill>
-            <a:srgbClr val="FFFFFF"/>
-          </a:solidFill>
-          <a:ln>
-            <a:noFill/>
-          </a:ln>
-          <a:effectLst/>
-        </p:spPr>
-        <p:style>
-          <a:lnRef idx="1">
-            <a:schemeClr val="accent1"/>
-          </a:lnRef>
-          <a:fillRef idx="3">
-            <a:schemeClr val="accent1"/>
-          </a:fillRef>
-          <a:effectRef idx="2">
-            <a:schemeClr val="accent1"/>
-          </a:effectRef>
-          <a:fontRef idx="minor">
-            <a:schemeClr val="lt1"/>
-          </a:fontRef>
-        </p:style>
-        <p:txBody>
-          <a:bodyPr rtlCol="0" anchor="ctr" wrap="square"/>
-          <a:lstStyle/>
-          <a:p>
-            <a:pPr algn="ctr"/>
-          </a:p>
-        </p:txBody>
-      </p:sp>
-      <p:pic>
-        <p:nvPicPr>
-          <p:cNvPr id="5" name="Picture 4" descr="logo.png"/>
-          <p:cNvPicPr>
-            <a:picLocks noChangeAspect="1"/>
-          </p:cNvPicPr>
-          <p:nvPr/>
-        </p:nvPicPr>
-        <p:blipFill>
-          <a:blip r:embed="rId2"/>
-          <a:stretch>
-            <a:fillRect/>
-          </a:stretch>
-        </p:blipFill>
-        <p:spPr>
-          <a:xfrm>
-            <a:off x="200160" y="145440"/>
-            <a:ext cx="355680" cy="266417"/>
-          </a:xfrm>
-          <a:prstGeom prst="rect">
-            <a:avLst/>
-          </a:prstGeom>
-        </p:spPr>
-      </p:pic>
-      <p:sp>
-        <p:nvSpPr>
-          <p:cNvPr id="6" name="TextBox 5"/>
-          <p:cNvSpPr txBox="1"/>
-          <p:nvPr/>
-        </p:nvSpPr>
-        <p:spPr>
-          <a:xfrm>
-            <a:off x="792000" y="125999"/>
-            <a:ext cx="8172000" cy="360000"/>
-          </a:xfrm>
-          <a:prstGeom prst="rect">
-            <a:avLst/>
-          </a:prstGeom>
-          <a:noFill/>
-        </p:spPr>
-        <p:txBody>
-          <a:bodyPr wrap="square" lIns="0" rIns="0" tIns="0" bIns="0" anchor="ctr">
-            <a:spAutoFit/>
-          </a:bodyPr>
-          <a:lstStyle/>
-          <a:p>
-            <a:pPr algn="l"/>
-            <a:r>
-              <a:rPr sz="2000" b="1">
-                <a:solidFill>
-                  <a:srgbClr val="FFFFFF"/>
-                </a:solidFill>
-                <a:latin typeface="Calibri"/>
-              </a:rPr>
-              <a:t>Uno de cada tres pedidos llega tarde, y se sabe cuando ya pasó</a:t>
-            </a:r>
-          </a:p>
-        </p:txBody>
-      </p:sp>
-      <p:sp>
-        <p:nvSpPr>
-          <p:cNvPr id="7" name="TextBox 6"/>
-          <p:cNvSpPr txBox="1"/>
-          <p:nvPr/>
-        </p:nvSpPr>
-        <p:spPr>
-          <a:xfrm>
-            <a:off x="468000" y="756000"/>
-            <a:ext cx="7308000" cy="251999"/>
-          </a:xfrm>
-          <a:prstGeom prst="rect">
-            <a:avLst/>
-          </a:prstGeom>
-          <a:noFill/>
-        </p:spPr>
-        <p:txBody>
-          <a:bodyPr wrap="square" lIns="0" rIns="0" tIns="0" bIns="0" anchor="t">
-            <a:spAutoFit/>
-          </a:bodyPr>
-          <a:lstStyle/>
-          <a:p>
-            <a:pPr algn="l"/>
-            <a:r>
-              <a:rPr sz="1200" b="1">
-                <a:solidFill>
-                  <a:srgbClr val="B08A2D"/>
-                </a:solidFill>
-                <a:latin typeface="Calibri"/>
-              </a:rPr>
-              <a:t>CRITERIO 1  ·  EL PROBLEMA</a:t>
-            </a:r>
-          </a:p>
-        </p:txBody>
-      </p:sp>
-      <p:sp>
-        <p:nvSpPr>
-          <p:cNvPr id="8" name="Rectangle 7"/>
-          <p:cNvSpPr/>
-          <p:nvPr/>
-        </p:nvSpPr>
-        <p:spPr>
-          <a:xfrm>
-            <a:off x="468000" y="1044000"/>
-            <a:ext cx="468000" cy="36000"/>
-          </a:xfrm>
-          <a:prstGeom prst="rect">
-            <a:avLst/>
-          </a:prstGeom>
-          <a:solidFill>
-            <a:srgbClr val="B08A2D"/>
-          </a:solidFill>
-          <a:ln>
-            <a:noFill/>
-          </a:ln>
-          <a:effectLst/>
-        </p:spPr>
-        <p:style>
-          <a:lnRef idx="1">
-            <a:schemeClr val="accent1"/>
-          </a:lnRef>
-          <a:fillRef idx="3">
-            <a:schemeClr val="accent1"/>
-          </a:fillRef>
-          <a:effectRef idx="2">
-            <a:schemeClr val="accent1"/>
-          </a:effectRef>
-          <a:fontRef idx="minor">
-            <a:schemeClr val="lt1"/>
-          </a:fontRef>
-        </p:style>
-        <p:txBody>
-          <a:bodyPr rtlCol="0" anchor="ctr" wrap="square"/>
-          <a:lstStyle/>
-          <a:p>
-            <a:pPr algn="ctr"/>
-          </a:p>
-        </p:txBody>
-      </p:sp>
-      <p:sp>
-        <p:nvSpPr>
-          <p:cNvPr id="9" name="Rectangle 8"/>
-          <p:cNvSpPr/>
-          <p:nvPr/>
-        </p:nvSpPr>
-        <p:spPr>
-          <a:xfrm>
-            <a:off x="468000" y="1224000"/>
-            <a:ext cx="1944000" cy="972000"/>
-          </a:xfrm>
-          <a:prstGeom prst="rect">
-            <a:avLst/>
-          </a:prstGeom>
-          <a:solidFill>
-            <a:srgbClr val="E8F0EB"/>
-          </a:solidFill>
-          <a:ln>
-            <a:noFill/>
-          </a:ln>
-          <a:effectLst/>
-        </p:spPr>
-        <p:style>
-          <a:lnRef idx="1">
-            <a:schemeClr val="accent1"/>
-          </a:lnRef>
-          <a:fillRef idx="3">
-            <a:schemeClr val="accent1"/>
-          </a:fillRef>
-          <a:effectRef idx="2">
-            <a:schemeClr val="accent1"/>
-          </a:effectRef>
-          <a:fontRef idx="minor">
-            <a:schemeClr val="lt1"/>
-          </a:fontRef>
-        </p:style>
-        <p:txBody>
-          <a:bodyPr rtlCol="0" anchor="ctr" wrap="square"/>
-          <a:lstStyle/>
-          <a:p>
-            <a:pPr algn="ctr"/>
-          </a:p>
-        </p:txBody>
-      </p:sp>
-      <p:sp>
-        <p:nvSpPr>
-          <p:cNvPr id="10" name="Rectangle 9"/>
-          <p:cNvSpPr/>
-          <p:nvPr/>
-        </p:nvSpPr>
-        <p:spPr>
-          <a:xfrm>
-            <a:off x="558000" y="1224000"/>
-            <a:ext cx="1764000" cy="36000"/>
-          </a:xfrm>
-          <a:prstGeom prst="rect">
-            <a:avLst/>
-          </a:prstGeom>
-          <a:solidFill>
-            <a:srgbClr val="B08A2D"/>
-          </a:solidFill>
-          <a:ln>
-            <a:noFill/>
-          </a:ln>
-          <a:effectLst/>
-        </p:spPr>
-        <p:style>
-          <a:lnRef idx="1">
-            <a:schemeClr val="accent1"/>
-          </a:lnRef>
-          <a:fillRef idx="3">
-            <a:schemeClr val="accent1"/>
-          </a:fillRef>
-          <a:effectRef idx="2">
-            <a:schemeClr val="accent1"/>
-          </a:effectRef>
-          <a:fontRef idx="minor">
-            <a:schemeClr val="lt1"/>
-          </a:fontRef>
-        </p:style>
-        <p:txBody>
-          <a:bodyPr rtlCol="0" anchor="ctr" wrap="square"/>
-          <a:lstStyle/>
-          <a:p>
-            <a:pPr algn="ctr"/>
-          </a:p>
-        </p:txBody>
-      </p:sp>
-      <p:sp>
-        <p:nvSpPr>
-          <p:cNvPr id="11" name="TextBox 10"/>
-          <p:cNvSpPr txBox="1"/>
-          <p:nvPr/>
-        </p:nvSpPr>
-        <p:spPr>
-          <a:xfrm>
-            <a:off x="468000" y="1350000"/>
-            <a:ext cx="1944000" cy="468000"/>
-          </a:xfrm>
-          <a:prstGeom prst="rect">
-            <a:avLst/>
-          </a:prstGeom>
-          <a:noFill/>
-        </p:spPr>
-        <p:txBody>
-          <a:bodyPr wrap="square" lIns="0" rIns="0" tIns="0" bIns="0" anchor="t">
-            <a:spAutoFit/>
-          </a:bodyPr>
-          <a:lstStyle/>
-          <a:p>
-            <a:pPr algn="ctr"/>
-            <a:r>
-              <a:rPr sz="3400" b="1">
-                <a:solidFill>
-                  <a:srgbClr val="405731"/>
-                </a:solidFill>
-                <a:latin typeface="Calibri"/>
-              </a:rPr>
-              <a:t>33,0 %</a:t>
-            </a:r>
-          </a:p>
-        </p:txBody>
-      </p:sp>
-      <p:sp>
-        <p:nvSpPr>
-          <p:cNvPr id="12" name="TextBox 11"/>
-          <p:cNvSpPr txBox="1"/>
-          <p:nvPr/>
-        </p:nvSpPr>
-        <p:spPr>
-          <a:xfrm>
-            <a:off x="468000" y="1854000"/>
-            <a:ext cx="1944000" cy="288000"/>
-          </a:xfrm>
-          <a:prstGeom prst="rect">
-            <a:avLst/>
-          </a:prstGeom>
-          <a:noFill/>
-        </p:spPr>
-        <p:txBody>
-          <a:bodyPr wrap="square" lIns="0" rIns="0" tIns="0" bIns="0" anchor="t">
-            <a:spAutoFit/>
-          </a:bodyPr>
-          <a:lstStyle/>
-          <a:p>
-            <a:pPr algn="ctr"/>
-            <a:r>
-              <a:rPr sz="1050" b="0">
-                <a:solidFill>
-                  <a:srgbClr val="5A5A5A"/>
-                </a:solidFill>
-                <a:latin typeface="Calibri"/>
-              </a:rPr>
-              <a:t>de las posiciones llega tarde</a:t>
-            </a:r>
-          </a:p>
-        </p:txBody>
-      </p:sp>
-      <p:sp>
-        <p:nvSpPr>
-          <p:cNvPr id="13" name="Rectangle 12"/>
-          <p:cNvSpPr/>
-          <p:nvPr/>
-        </p:nvSpPr>
-        <p:spPr>
-          <a:xfrm>
-            <a:off x="468000" y="2304000"/>
-            <a:ext cx="1944000" cy="972000"/>
-          </a:xfrm>
-          <a:prstGeom prst="rect">
-            <a:avLst/>
-          </a:prstGeom>
-          <a:solidFill>
-            <a:srgbClr val="F5EDE0"/>
-          </a:solidFill>
-          <a:ln>
-            <a:noFill/>
-          </a:ln>
-          <a:effectLst/>
-        </p:spPr>
-        <p:style>
-          <a:lnRef idx="1">
-            <a:schemeClr val="accent1"/>
-          </a:lnRef>
-          <a:fillRef idx="3">
-            <a:schemeClr val="accent1"/>
-          </a:fillRef>
-          <a:effectRef idx="2">
-            <a:schemeClr val="accent1"/>
-          </a:effectRef>
-          <a:fontRef idx="minor">
-            <a:schemeClr val="lt1"/>
-          </a:fontRef>
-        </p:style>
-        <p:txBody>
-          <a:bodyPr rtlCol="0" anchor="ctr" wrap="square"/>
-          <a:lstStyle/>
-          <a:p>
-            <a:pPr algn="ctr"/>
-          </a:p>
-        </p:txBody>
-      </p:sp>
-      <p:sp>
-        <p:nvSpPr>
-          <p:cNvPr id="14" name="Rectangle 13"/>
-          <p:cNvSpPr/>
-          <p:nvPr/>
-        </p:nvSpPr>
-        <p:spPr>
-          <a:xfrm>
-            <a:off x="558000" y="2304000"/>
-            <a:ext cx="1764000" cy="36000"/>
-          </a:xfrm>
-          <a:prstGeom prst="rect">
-            <a:avLst/>
-          </a:prstGeom>
-          <a:solidFill>
-            <a:srgbClr val="B08A2D"/>
-          </a:solidFill>
-          <a:ln>
-            <a:noFill/>
-          </a:ln>
-          <a:effectLst/>
-        </p:spPr>
-        <p:style>
-          <a:lnRef idx="1">
-            <a:schemeClr val="accent1"/>
-          </a:lnRef>
-          <a:fillRef idx="3">
-            <a:schemeClr val="accent1"/>
-          </a:fillRef>
-          <a:effectRef idx="2">
-            <a:schemeClr val="accent1"/>
-          </a:effectRef>
-          <a:fontRef idx="minor">
-            <a:schemeClr val="lt1"/>
-          </a:fontRef>
-        </p:style>
-        <p:txBody>
-          <a:bodyPr rtlCol="0" anchor="ctr" wrap="square"/>
-          <a:lstStyle/>
-          <a:p>
-            <a:pPr algn="ctr"/>
-          </a:p>
-        </p:txBody>
-      </p:sp>
-      <p:sp>
-        <p:nvSpPr>
-          <p:cNvPr id="15" name="TextBox 14"/>
-          <p:cNvSpPr txBox="1"/>
-          <p:nvPr/>
-        </p:nvSpPr>
-        <p:spPr>
-          <a:xfrm>
-            <a:off x="468000" y="2430000"/>
-            <a:ext cx="1944000" cy="468000"/>
-          </a:xfrm>
-          <a:prstGeom prst="rect">
-            <a:avLst/>
-          </a:prstGeom>
-          <a:noFill/>
-        </p:spPr>
-        <p:txBody>
-          <a:bodyPr wrap="square" lIns="0" rIns="0" tIns="0" bIns="0" anchor="t">
-            <a:spAutoFit/>
-          </a:bodyPr>
-          <a:lstStyle/>
-          <a:p>
-            <a:pPr algn="ctr"/>
-            <a:r>
-              <a:rPr sz="3400" b="1">
-                <a:solidFill>
-                  <a:srgbClr val="405731"/>
-                </a:solidFill>
-                <a:latin typeface="Calibri"/>
-              </a:rPr>
-              <a:t>41 %</a:t>
-            </a:r>
-          </a:p>
-        </p:txBody>
-      </p:sp>
-      <p:sp>
-        <p:nvSpPr>
-          <p:cNvPr id="16" name="TextBox 15"/>
-          <p:cNvSpPr txBox="1"/>
-          <p:nvPr/>
-        </p:nvSpPr>
-        <p:spPr>
-          <a:xfrm>
-            <a:off x="468000" y="2934000"/>
-            <a:ext cx="1944000" cy="288000"/>
-          </a:xfrm>
-          <a:prstGeom prst="rect">
-            <a:avLst/>
-          </a:prstGeom>
-          <a:noFill/>
-        </p:spPr>
-        <p:txBody>
-          <a:bodyPr wrap="square" lIns="0" rIns="0" tIns="0" bIns="0" anchor="t">
-            <a:spAutoFit/>
-          </a:bodyPr>
-          <a:lstStyle/>
-          <a:p>
-            <a:pPr algn="ctr"/>
-            <a:r>
-              <a:rPr sz="1050" b="0">
-                <a:solidFill>
-                  <a:srgbClr val="5A5A5A"/>
-                </a:solidFill>
-                <a:latin typeface="Calibri"/>
-              </a:rPr>
-              <a:t>en industrial; 25 % en ganaderia</a:t>
-            </a:r>
-          </a:p>
-        </p:txBody>
-      </p:sp>
-      <p:sp>
-        <p:nvSpPr>
-          <p:cNvPr id="17" name="Rectangle 16"/>
-          <p:cNvSpPr/>
-          <p:nvPr/>
-        </p:nvSpPr>
-        <p:spPr>
-          <a:xfrm>
-            <a:off x="468000" y="3384000"/>
-            <a:ext cx="1944000" cy="972000"/>
-          </a:xfrm>
-          <a:prstGeom prst="rect">
-            <a:avLst/>
-          </a:prstGeom>
-          <a:solidFill>
-            <a:srgbClr val="EEF2EA"/>
-          </a:solidFill>
-          <a:ln>
-            <a:noFill/>
-          </a:ln>
-          <a:effectLst/>
-        </p:spPr>
-        <p:style>
-          <a:lnRef idx="1">
-            <a:schemeClr val="accent1"/>
-          </a:lnRef>
-          <a:fillRef idx="3">
-            <a:schemeClr val="accent1"/>
-          </a:fillRef>
-          <a:effectRef idx="2">
-            <a:schemeClr val="accent1"/>
-          </a:effectRef>
-          <a:fontRef idx="minor">
-            <a:schemeClr val="lt1"/>
-          </a:fontRef>
-        </p:style>
-        <p:txBody>
-          <a:bodyPr rtlCol="0" anchor="ctr" wrap="square"/>
-          <a:lstStyle/>
-          <a:p>
-            <a:pPr algn="ctr"/>
-          </a:p>
-        </p:txBody>
-      </p:sp>
-      <p:sp>
-        <p:nvSpPr>
-          <p:cNvPr id="18" name="Rectangle 17"/>
-          <p:cNvSpPr/>
-          <p:nvPr/>
-        </p:nvSpPr>
-        <p:spPr>
-          <a:xfrm>
-            <a:off x="558000" y="3384000"/>
-            <a:ext cx="1764000" cy="36000"/>
-          </a:xfrm>
-          <a:prstGeom prst="rect">
-            <a:avLst/>
-          </a:prstGeom>
-          <a:solidFill>
-            <a:srgbClr val="B08A2D"/>
-          </a:solidFill>
-          <a:ln>
-            <a:noFill/>
-          </a:ln>
-          <a:effectLst/>
-        </p:spPr>
-        <p:style>
-          <a:lnRef idx="1">
-            <a:schemeClr val="accent1"/>
-          </a:lnRef>
-          <a:fillRef idx="3">
-            <a:schemeClr val="accent1"/>
-          </a:fillRef>
-          <a:effectRef idx="2">
-            <a:schemeClr val="accent1"/>
-          </a:effectRef>
-          <a:fontRef idx="minor">
-            <a:schemeClr val="lt1"/>
-          </a:fontRef>
-        </p:style>
-        <p:txBody>
-          <a:bodyPr rtlCol="0" anchor="ctr" wrap="square"/>
-          <a:lstStyle/>
-          <a:p>
-            <a:pPr algn="ctr"/>
-          </a:p>
-        </p:txBody>
-      </p:sp>
-      <p:sp>
-        <p:nvSpPr>
-          <p:cNvPr id="19" name="TextBox 18"/>
-          <p:cNvSpPr txBox="1"/>
-          <p:nvPr/>
-        </p:nvSpPr>
-        <p:spPr>
-          <a:xfrm>
-            <a:off x="468000" y="3510000"/>
-            <a:ext cx="1944000" cy="468000"/>
-          </a:xfrm>
-          <a:prstGeom prst="rect">
-            <a:avLst/>
-          </a:prstGeom>
-          <a:noFill/>
-        </p:spPr>
-        <p:txBody>
-          <a:bodyPr wrap="square" lIns="0" rIns="0" tIns="0" bIns="0" anchor="t">
-            <a:spAutoFit/>
-          </a:bodyPr>
-          <a:lstStyle/>
-          <a:p>
-            <a:pPr algn="ctr"/>
-            <a:r>
-              <a:rPr sz="3400" b="1">
-                <a:solidFill>
-                  <a:srgbClr val="405731"/>
-                </a:solidFill>
-                <a:latin typeface="Calibri"/>
-              </a:rPr>
-              <a:t>71 %</a:t>
-            </a:r>
-          </a:p>
-        </p:txBody>
-      </p:sp>
-      <p:sp>
-        <p:nvSpPr>
-          <p:cNvPr id="20" name="TextBox 19"/>
-          <p:cNvSpPr txBox="1"/>
-          <p:nvPr/>
-        </p:nvSpPr>
-        <p:spPr>
-          <a:xfrm>
-            <a:off x="468000" y="4014000"/>
-            <a:ext cx="1944000" cy="288000"/>
-          </a:xfrm>
-          <a:prstGeom prst="rect">
-            <a:avLst/>
-          </a:prstGeom>
-          <a:noFill/>
-        </p:spPr>
-        <p:txBody>
-          <a:bodyPr wrap="square" lIns="0" rIns="0" tIns="0" bIns="0" anchor="t">
-            <a:spAutoFit/>
-          </a:bodyPr>
-          <a:lstStyle/>
-          <a:p>
-            <a:pPr algn="ctr"/>
-            <a:r>
-              <a:rPr sz="1050" b="0">
-                <a:solidFill>
-                  <a:srgbClr val="5A5A5A"/>
-                </a:solidFill>
-                <a:latin typeface="Calibri"/>
-              </a:rPr>
-              <a:t>de las tardías de 2026, marcando el 38 %</a:t>
-            </a:r>
-          </a:p>
-        </p:txBody>
-      </p:sp>
-      <p:sp>
-        <p:nvSpPr>
-          <p:cNvPr id="21" name="TextBox 20"/>
-          <p:cNvSpPr txBox="1"/>
-          <p:nvPr/>
-        </p:nvSpPr>
-        <p:spPr>
-          <a:xfrm>
-            <a:off x="2736000" y="1188000"/>
-            <a:ext cx="3311999" cy="216000"/>
-          </a:xfrm>
-          <a:prstGeom prst="rect">
-            <a:avLst/>
-          </a:prstGeom>
-          <a:noFill/>
-        </p:spPr>
-        <p:txBody>
-          <a:bodyPr wrap="square" lIns="0" rIns="0" tIns="0" bIns="0" anchor="t">
-            <a:spAutoFit/>
-          </a:bodyPr>
-          <a:lstStyle/>
-          <a:p>
-            <a:pPr algn="l"/>
-            <a:r>
-              <a:rPr sz="1250" b="1">
-                <a:solidFill>
-                  <a:srgbClr val="405731"/>
-                </a:solidFill>
-                <a:latin typeface="Calibri"/>
-              </a:rPr>
-              <a:t>Por qué importa</a:t>
-            </a:r>
-          </a:p>
-        </p:txBody>
-      </p:sp>
-      <p:sp>
-        <p:nvSpPr>
-          <p:cNvPr id="22" name="TextBox 21"/>
-          <p:cNvSpPr txBox="1"/>
-          <p:nvPr/>
-        </p:nvSpPr>
-        <p:spPr>
-          <a:xfrm>
-            <a:off x="2736000" y="1440000"/>
-            <a:ext cx="3311999" cy="1296000"/>
-          </a:xfrm>
-          <a:prstGeom prst="rect">
-            <a:avLst/>
-          </a:prstGeom>
-          <a:noFill/>
-        </p:spPr>
-        <p:txBody>
-          <a:bodyPr wrap="square" lIns="0" rIns="0" tIns="0" bIns="0" anchor="t">
-            <a:spAutoFit/>
-          </a:bodyPr>
-          <a:lstStyle/>
-          <a:p>
-            <a:pPr algn="l"/>
-            <a:r>
-              <a:rPr sz="1100" b="0">
-                <a:solidFill>
-                  <a:srgbClr val="1A1A1A"/>
-                </a:solidFill>
-                <a:latin typeface="Calibri"/>
-              </a:rPr>
-              <a:t>El comprador hoy se entera del retraso cuando la mercancía no llega. Con miles de posiciones abiertas, no puede seguirlas todas: necesita saber, el día en que libera la orden, cuáles vigilar.</a:t>
-            </a:r>
-          </a:p>
-        </p:txBody>
-      </p:sp>
-      <p:sp>
-        <p:nvSpPr>
-          <p:cNvPr id="23" name="TextBox 22"/>
-          <p:cNvSpPr txBox="1"/>
-          <p:nvPr/>
-        </p:nvSpPr>
-        <p:spPr>
-          <a:xfrm>
-            <a:off x="2736000" y="2628000"/>
-            <a:ext cx="3311999" cy="216000"/>
-          </a:xfrm>
-          <a:prstGeom prst="rect">
-            <a:avLst/>
-          </a:prstGeom>
-          <a:noFill/>
-        </p:spPr>
-        <p:txBody>
-          <a:bodyPr wrap="square" lIns="0" rIns="0" tIns="0" bIns="0" anchor="t">
-            <a:spAutoFit/>
-          </a:bodyPr>
-          <a:lstStyle/>
-          <a:p>
-            <a:pPr algn="l"/>
-            <a:r>
-              <a:rPr sz="1250" b="1">
-                <a:solidFill>
-                  <a:srgbClr val="405731"/>
-                </a:solidFill>
-                <a:latin typeface="Calibri"/>
-              </a:rPr>
-              <a:t>Qué dice la literatura</a:t>
-            </a:r>
-          </a:p>
-        </p:txBody>
-      </p:sp>
-      <p:sp>
-        <p:nvSpPr>
-          <p:cNvPr id="24" name="TextBox 23"/>
-          <p:cNvSpPr txBox="1"/>
-          <p:nvPr/>
-        </p:nvSpPr>
-        <p:spPr>
-          <a:xfrm>
-            <a:off x="2736000" y="2880000"/>
-            <a:ext cx="3311999" cy="1800000"/>
-          </a:xfrm>
-          <a:prstGeom prst="rect">
-            <a:avLst/>
-          </a:prstGeom>
-          <a:noFill/>
-        </p:spPr>
-        <p:txBody>
-          <a:bodyPr wrap="square" lIns="0" rIns="0" tIns="0" bIns="0" anchor="t">
-            <a:spAutoFit/>
-          </a:bodyPr>
-          <a:lstStyle/>
-          <a:p>
-            <a:pPr algn="l"/>
-            <a:r>
-              <a:rPr sz="1050" b="0">
-                <a:solidFill>
-                  <a:srgbClr val="5A5A5A"/>
-                </a:solidFill>
-                <a:latin typeface="Calibri"/>
-              </a:rPr>
-              <a:t>En fabricantes de maquinaria y equipos llega tarde del 13 % al 14 % de los pedidos (Brintrup y otros, 2020; Steinberg y otros, 2023): aquí es más del doble.</a:t>
-            </a:r>
-          </a:p>
-          <a:p>
-            <a:pPr algn="l">
-              <a:spcBef>
-                <a:spcPts val="600"/>
-              </a:spcBef>
-            </a:pPr>
-            <a:r>
-              <a:rPr sz="1050" b="0">
-                <a:solidFill>
-                  <a:srgbClr val="5A5A5A"/>
-                </a:solidFill>
-                <a:latin typeface="Calibri"/>
-              </a:rPr>
-              <a:t>Una revisión de 26 estudios encuentra que 16 parten las filas al azar; reevaluado sin fuga y en el tiempo, un AUC de 0,96 baja a 0,73 (Raval, 2026). Este trabajo evalúa siempre hacia adelante.</a:t>
-            </a:r>
-          </a:p>
-        </p:txBody>
-      </p:sp>
-      <p:sp>
-        <p:nvSpPr>
-          <p:cNvPr id="25" name="Rectangle 24"/>
-          <p:cNvSpPr/>
-          <p:nvPr/>
-        </p:nvSpPr>
-        <p:spPr>
-          <a:xfrm>
-            <a:off x="6263999" y="1224000"/>
-            <a:ext cx="2448000" cy="3491999"/>
-          </a:xfrm>
-          <a:prstGeom prst="rect">
-            <a:avLst/>
-          </a:prstGeom>
-          <a:solidFill>
-            <a:srgbClr val="E8F0EB"/>
-          </a:solidFill>
-          <a:ln>
-            <a:noFill/>
-          </a:ln>
-          <a:effectLst/>
-        </p:spPr>
-        <p:style>
-          <a:lnRef idx="1">
-            <a:schemeClr val="accent1"/>
-          </a:lnRef>
-          <a:fillRef idx="3">
-            <a:schemeClr val="accent1"/>
-          </a:fillRef>
-          <a:effectRef idx="2">
-            <a:schemeClr val="accent1"/>
-          </a:effectRef>
-          <a:fontRef idx="minor">
-            <a:schemeClr val="lt1"/>
-          </a:fontRef>
-        </p:style>
-        <p:txBody>
-          <a:bodyPr rtlCol="0" anchor="ctr" wrap="square"/>
-          <a:lstStyle/>
-          <a:p>
-            <a:pPr algn="ctr"/>
-          </a:p>
-        </p:txBody>
-      </p:sp>
-      <p:sp>
-        <p:nvSpPr>
-          <p:cNvPr id="26" name="TextBox 25"/>
-          <p:cNvSpPr txBox="1"/>
-          <p:nvPr/>
-        </p:nvSpPr>
-        <p:spPr>
-          <a:xfrm>
-            <a:off x="6425999" y="1332000"/>
-            <a:ext cx="2124000" cy="288000"/>
-          </a:xfrm>
-          <a:prstGeom prst="rect">
-            <a:avLst/>
-          </a:prstGeom>
-          <a:noFill/>
-        </p:spPr>
-        <p:txBody>
-          <a:bodyPr wrap="square" lIns="0" rIns="0" tIns="0" bIns="0" anchor="t">
-            <a:spAutoFit/>
-          </a:bodyPr>
-          <a:lstStyle/>
-          <a:p>
-            <a:pPr algn="l"/>
-            <a:r>
-              <a:rPr sz="1300" b="1">
-                <a:solidFill>
-                  <a:srgbClr val="405731"/>
-                </a:solidFill>
-                <a:latin typeface="Calibri"/>
-              </a:rPr>
-              <a:t>Objetivos</a:t>
-            </a:r>
-          </a:p>
-        </p:txBody>
-      </p:sp>
-      <p:sp>
-        <p:nvSpPr>
-          <p:cNvPr id="27" name="TextBox 26"/>
-          <p:cNvSpPr txBox="1"/>
-          <p:nvPr/>
-        </p:nvSpPr>
-        <p:spPr>
-          <a:xfrm>
-            <a:off x="6425999" y="1591200"/>
-            <a:ext cx="2124000" cy="3077999"/>
-          </a:xfrm>
-          <a:prstGeom prst="rect">
-            <a:avLst/>
-          </a:prstGeom>
-          <a:noFill/>
-        </p:spPr>
-        <p:txBody>
-          <a:bodyPr wrap="square" lIns="0" rIns="0" tIns="0" bIns="0" anchor="t">
-            <a:spAutoFit/>
-          </a:bodyPr>
-          <a:lstStyle/>
-          <a:p>
-            <a:pPr algn="l"/>
-            <a:r>
-              <a:rPr sz="1050" b="0">
-                <a:solidFill>
-                  <a:srgbClr val="1A1A1A"/>
-                </a:solidFill>
-                <a:latin typeface="Calibri"/>
-              </a:rPr>
-              <a:t>General: ordenar las posiciones por riesgo de retraso el día de la liberación y señalar cuáles seguir.</a:t>
-            </a:r>
-          </a:p>
-          <a:p>
-            <a:pPr algn="l"/>
-            <a:r>
-              <a:rPr sz="1050" b="0">
-                <a:solidFill>
-                  <a:srgbClr val="1A1A1A"/>
-                </a:solidFill>
-                <a:latin typeface="Calibri"/>
-              </a:rPr>
-              <a:t>Específico 1: comparar 7 modelos × 4 balanceos × 4 optimizadores con el mismo presupuesto.</a:t>
-            </a:r>
-          </a:p>
-          <a:p>
-            <a:pPr algn="l"/>
-            <a:r>
-              <a:rPr sz="1050" b="0">
-                <a:solidFill>
-                  <a:srgbClr val="1A1A1A"/>
-                </a:solidFill>
-                <a:latin typeface="Calibri"/>
-              </a:rPr>
-              <a:t>Específico 2: medir cuánto cuesta decidir con entidades nuevas (proveedor o material sin historia).</a:t>
-            </a:r>
-          </a:p>
-          <a:p>
-            <a:pPr algn="l"/>
-            <a:r>
-              <a:rPr sz="1050" b="0">
-                <a:solidFill>
-                  <a:srgbClr val="1A1A1A"/>
-                </a:solidFill>
-                <a:latin typeface="Calibri"/>
-              </a:rPr>
-              <a:t>Específico 3: dejar el modelo servido en un tablero con predicción en vivo.</a:t>
-            </a:r>
-          </a:p>
-        </p:txBody>
-      </p:sp>
-      <p:sp>
-        <p:nvSpPr>
-          <p:cNvPr id="28" name="Rectangle 27"/>
-          <p:cNvSpPr/>
-          <p:nvPr/>
-        </p:nvSpPr>
-        <p:spPr>
-          <a:xfrm>
-            <a:off x="468000" y="4842000"/>
-            <a:ext cx="8243999" cy="14400"/>
-          </a:xfrm>
-          <a:prstGeom prst="rect">
-            <a:avLst/>
-          </a:prstGeom>
-          <a:solidFill>
-            <a:srgbClr val="DDD5C0"/>
-          </a:solidFill>
-          <a:ln>
-            <a:noFill/>
-          </a:ln>
-          <a:effectLst/>
-        </p:spPr>
-        <p:style>
-          <a:lnRef idx="1">
-            <a:schemeClr val="accent1"/>
-          </a:lnRef>
-          <a:fillRef idx="3">
-            <a:schemeClr val="accent1"/>
-          </a:fillRef>
-          <a:effectRef idx="2">
-            <a:schemeClr val="accent1"/>
-          </a:effectRef>
-          <a:fontRef idx="minor">
-            <a:schemeClr val="lt1"/>
-          </a:fontRef>
-        </p:style>
-        <p:txBody>
-          <a:bodyPr rtlCol="0" anchor="ctr" wrap="square"/>
-          <a:lstStyle/>
-          <a:p>
-            <a:pPr algn="ctr"/>
-          </a:p>
-        </p:txBody>
-      </p:sp>
-      <p:sp>
-        <p:nvSpPr>
-          <p:cNvPr id="29" name="TextBox 28"/>
-          <p:cNvSpPr txBox="1"/>
-          <p:nvPr/>
-        </p:nvSpPr>
-        <p:spPr>
-          <a:xfrm>
-            <a:off x="468000" y="4896000"/>
-            <a:ext cx="5940000" cy="180000"/>
-          </a:xfrm>
-          <a:prstGeom prst="rect">
-            <a:avLst/>
-          </a:prstGeom>
-          <a:noFill/>
-        </p:spPr>
-        <p:txBody>
-          <a:bodyPr wrap="square" lIns="0" rIns="0" tIns="0" bIns="0" anchor="t">
-            <a:spAutoFit/>
-          </a:bodyPr>
-          <a:lstStyle/>
-          <a:p>
-            <a:pPr algn="l"/>
-            <a:r>
-              <a:rPr sz="850" b="0">
-                <a:solidFill>
-                  <a:srgbClr val="8C8C8C"/>
-                </a:solidFill>
-                <a:latin typeface="Calibri"/>
-              </a:rPr>
-              <a:t>Fuente: libro, introducción y literatura; capítulo 5 (modelo base): data/modelos/metricas.csv</a:t>
-            </a:r>
-          </a:p>
-        </p:txBody>
-      </p:sp>
-      <p:sp>
-        <p:nvSpPr>
-          <p:cNvPr id="30" name="TextBox 29"/>
-          <p:cNvSpPr txBox="1"/>
-          <p:nvPr/>
-        </p:nvSpPr>
-        <p:spPr>
-          <a:xfrm>
-            <a:off x="6408000" y="4896000"/>
-            <a:ext cx="2304000" cy="180000"/>
-          </a:xfrm>
-          <a:prstGeom prst="rect">
-            <a:avLst/>
-          </a:prstGeom>
-          <a:noFill/>
-        </p:spPr>
-        <p:txBody>
-          <a:bodyPr wrap="square" lIns="0" rIns="0" tIns="0" bIns="0" anchor="t">
-            <a:spAutoFit/>
-          </a:bodyPr>
-          <a:lstStyle/>
-          <a:p>
-            <a:pPr algn="r"/>
-            <a:r>
-              <a:rPr sz="850" b="0">
-                <a:solidFill>
-                  <a:srgbClr val="8C8C8C"/>
-                </a:solidFill>
-                <a:latin typeface="Calibri"/>
-              </a:rPr>
-              <a:t>2 / 21</a:t>
-            </a:r>
-          </a:p>
-        </p:txBody>
-      </p:sp>
-    </p:spTree>
-  </p:cSld>
-  <p:clrMapOvr>
-    <a:masterClrMapping/>
-  </p:clrMapOvr>
-</p:sld>
-</file>
-
-<file path=ppt/slides/slide20.xml><?xml version="1.0" encoding="utf-8"?>
+<file path=ppt/slides/slide21.xml><?xml version="1.0" encoding="utf-8"?>
 <p:sld xmlns:a="http://schemas.openxmlformats.org/drawingml/2006/main" xmlns:p="http://schemas.openxmlformats.org/presentationml/2006/main" xmlns:r="http://schemas.openxmlformats.org/officeDocument/2006/relationships">
   <p:cSld>
     <p:bg>
@@ -20312,7 +21587,7 @@
                 </a:solidFill>
                 <a:latin typeface="Calibri"/>
               </a:rPr>
-              <a:t>marcando el 33 % de las posiciones, XGBoost ve venir el 69 % de las tardías de 2026. El comprador puede concentrar el seguimiento en un tercio de las órdenes.</a:t>
+              <a:t>marcando el 33 % de las posiciones, XGBoost ve venir el 69 % de las tardías de 2026. Por órdenes: siguiendo el 39 % se ve venir el 69 % de las órdenes con retraso.</a:t>
             </a:r>
           </a:p>
         </p:txBody>
@@ -20426,7 +21701,7 @@
                 </a:solidFill>
                 <a:latin typeface="Calibri"/>
               </a:rPr>
-              <a:t>20 / 21</a:t>
+              <a:t>21 / 22</a:t>
             </a:r>
           </a:p>
         </p:txBody>
@@ -20439,7 +21714,7 @@
 </p:sld>
 </file>
 
-<file path=ppt/slides/slide21.xml><?xml version="1.0" encoding="utf-8"?>
+<file path=ppt/slides/slide22.xml><?xml version="1.0" encoding="utf-8"?>
 <p:sld xmlns:a="http://schemas.openxmlformats.org/drawingml/2006/main" xmlns:p="http://schemas.openxmlformats.org/presentationml/2006/main" xmlns:r="http://schemas.openxmlformats.org/officeDocument/2006/relationships">
   <p:cSld>
     <p:bg>
@@ -21286,7 +22561,7 @@
                 </a:solidFill>
                 <a:latin typeface="Calibri"/>
               </a:rPr>
-              <a:t>21 / 21</a:t>
+              <a:t>22 / 22</a:t>
             </a:r>
           </a:p>
         </p:txBody>
@@ -21299,7 +22574,7 @@
 </p:sld>
 </file>
 
-<file path=ppt/slides/slide22.xml><?xml version="1.0" encoding="utf-8"?>
+<file path=ppt/slides/slide23.xml><?xml version="1.0" encoding="utf-8"?>
 <p:sld xmlns:a="http://schemas.openxmlformats.org/drawingml/2006/main" xmlns:p="http://schemas.openxmlformats.org/presentationml/2006/main" xmlns:r="http://schemas.openxmlformats.org/officeDocument/2006/relationships">
   <p:cSld>
     <p:bg>
@@ -22470,7 +23745,7 @@
                 </a:solidFill>
                 <a:latin typeface="Calibri"/>
               </a:rPr>
-              <a:t>3 / 21</a:t>
+              <a:t>3 / 22</a:t>
             </a:r>
           </a:p>
         </p:txBody>
@@ -23140,7 +24415,7 @@
                 </a:solidFill>
                 <a:latin typeface="Calibri"/>
               </a:rPr>
-              <a:t>4 / 21</a:t>
+              <a:t>4 / 22</a:t>
             </a:r>
           </a:p>
         </p:txBody>
@@ -24822,7 +26097,7 @@
                 </a:solidFill>
                 <a:latin typeface="Calibri"/>
               </a:rPr>
-              <a:t>5 / 21</a:t>
+              <a:t>5 / 22</a:t>
             </a:r>
           </a:p>
         </p:txBody>
@@ -26705,7 +27980,7 @@
                 </a:solidFill>
                 <a:latin typeface="Calibri"/>
               </a:rPr>
-              <a:t>6 / 21</a:t>
+              <a:t>6 / 22</a:t>
             </a:r>
           </a:p>
         </p:txBody>
@@ -27394,7 +28669,7 @@
                 </a:solidFill>
                 <a:latin typeface="Calibri"/>
               </a:rPr>
-              <a:t>7 / 21</a:t>
+              <a:t>7 / 22</a:t>
             </a:r>
           </a:p>
         </p:txBody>
@@ -27958,7 +29233,7 @@
                 </a:solidFill>
                 <a:latin typeface="Calibri"/>
               </a:rPr>
-              <a:t>8 / 21</a:t>
+              <a:t>8 / 22</a:t>
             </a:r>
           </a:p>
         </p:txBody>
@@ -28854,7 +30129,7 @@
                 </a:solidFill>
                 <a:latin typeface="Calibri"/>
               </a:rPr>
-              <a:t>9 / 21</a:t>
+              <a:t>9 / 22</a:t>
             </a:r>
           </a:p>
         </p:txBody>

</xml_diff>

<commit_message>
Entregable 3: prueba 2026 de BOREAL con el aprendiz propio, validacion estadistica, SHAP comparado, conclusiones
</commit_message>
<xml_diff>
--- a/presentacion/sustentacion_otif.pptx
+++ b/presentacion/sustentacion_otif.pptx
@@ -1084,7 +1084,7 @@
           <a:lstStyle/>
           <a:p>
             <a:r>
-              <a:t>[1:00 · criterio 5 · expone A] En vivo: la predicción la sirve XGBoost con Platt, con sus contribuciones SHAP exactas. Pruebas: Friedman rechaza la igualdad; Nemenyi es conservador con 8 bloques; el Wilcoxon pareado con Holm separa porque XGBoost gana en cada bloque. DeLong mira dentro de cada bloque (validado contra pROC); como supone filas independientes, se lee con el BCa que remuestrea órdenes. Cliff con el bosque: pequeño (0,25).</a:t>
+              <a:t>[1:00 · criterio 5 · expone A] En vivo: la predicción sirve el modelo original y, para comparar, XGBoost, los dos con Platt y contribuciones SHAP exactas. Pruebas: Friedman rechaza la igualdad; Nemenyi es conservador con 8 bloques; el Wilcoxon pareado con Holm separa porque XGBoost gana en cada bloque. DeLong mira dentro de cada bloque (validado contra pROC); como supone filas independientes, se lee con el BCa que remuestrea órdenes. Cliff con el bosque: pequeño (0,25).</a:t>
             </a:r>
           </a:p>
         </p:txBody>
@@ -1224,7 +1224,7 @@
           <a:lstStyle/>
           <a:p>
             <a:r>
-              <a:t>[1:00 · criterio 6 · expone A] Qué es la propuesta y qué aporta cada parte. La 2 × 2 separa modelo de información: los efectos por entidad y el plazo real son dos caminos a la misma ganancia. Decir que es la tercera mirada a 2026 y que por eso se lee como exploratoria.</a:t>
+              <a:t>[1:00 · criterio 6 · expone A] Qué es la propuesta y qué aporta cada parte. La 2 × 2 separa modelo de información: los efectos por entidad y el plazo real son dos caminos a la misma ganancia. Decir que es la cuarta mirada a 2026 y que por eso se lee como exploratoria.</a:t>
             </a:r>
           </a:p>
         </p:txBody>
@@ -1364,7 +1364,7 @@
           <a:lstStyle/>
           <a:p>
             <a:r>
-              <a:t>[1:00 · criterio 6 · expone A] Responde «¿y en otros datos?». La ganancia de la propuesta en OTIF (0,012) depende de rasgos del caso: entidades con historia en el tiempo, desenlace continuo y plazo prometido. Airlines no trae el año: su partición es por mes. No decir que generaliza: es una hipótesis con apoyo.</a:t>
+              <a:t>[1:00 · criterio 6 · expone A] Responde «¿y en otros datos?». La ganancia de la propuesta en OTIF (0,011) depende de rasgos del caso: entidades con historia en el tiempo, desenlace continuo y plazo prometido. Airlines no trae el año: su partición es por mes. No decir que generaliza: es una hipótesis con apoyo.</a:t>
             </a:r>
           </a:p>
         </p:txBody>
@@ -1434,7 +1434,7 @@
           <a:lstStyle/>
           <a:p>
             <a:r>
-              <a:t>[1:00 · criterio 6 · expone A] Responder la pregunta con cifras y el veredicto de cada objetivo. El modelo original del Entregable 3 le gana al óptimo de las 112 por 0,012 en 2026 (pestaña Modelo original del tablero); el tablero sirve el XGBoost porque la propuesta necesita la historia de entregas de cada entidad, que no se publica.</a:t>
+              <a:t>[1:00 · criterio 6 · expone A] Responder la pregunta con cifras y el veredicto de cada objetivo. El modelo original del Entregable 3 le gana al óptimo de las 112 por 0,011 en 2026 (pestaña Modelo original del tablero); la pestaña Predicción lo sirve en vivo, con XGBoost al lado para comparar.</a:t>
             </a:r>
           </a:p>
         </p:txBody>
@@ -16546,7 +16546,7 @@
                 </a:solidFill>
                 <a:latin typeface="Calibri"/>
               </a:rPr>
-              <a:t>El modelo original le gana al óptimo de las 112 por 0,012 de AUC</a:t>
+              <a:t>El modelo original le gana al óptimo de las 112 por 0,011 de AUC</a:t>
             </a:r>
           </a:p>
         </p:txBody>
@@ -16660,7 +16660,7 @@
                 </a:solidFill>
                 <a:latin typeface="Calibri"/>
               </a:rPr>
-              <a:t>Efectos por entidad sobre un boosting, con cortes ordenados</a:t>
+              <a:t>BOREAL: efectos por entidad sobre un boosting, con cortes ordenados</a:t>
             </a:r>
           </a:p>
         </p:txBody>
@@ -16719,7 +16719,7 @@
                 </a:solidFill>
                 <a:latin typeface="Calibri"/>
               </a:rPr>
-              <a:t>d_i: días de retraso; se predice en c = 1 (y_tarde) y aprende también de cuánto se atrasó. b_e: intercepto aleatorio por proveedor, material, solicitante y comprador, encogido hacia 0 (σ²_e por EM). K3: los árboles ven efectos estimados solo con los semestres anteriores, como al predecir.</a:t>
+              <a:t>d_i: días de retraso; se predice en c = 1 (y_tarde) y aprende también de cuánto se atrasó. b_e: intercepto aleatorio por proveedor, material, solicitante y comprador, encogido hacia 0 (σ²_e por EM). Al entrenar, los árboles ven efectos estimados solo con los semestres anteriores, como al predecir.</a:t>
             </a:r>
           </a:p>
         </p:txBody>
@@ -16789,7 +16789,7 @@
                 </a:solidFill>
                 <a:latin typeface="Calibri"/>
               </a:rPr>
-              <a:t>Misma suma de árboles, misma log-pérdida y mismo peso de hoja −G/(H + λ) (diapositiva 11). Difiere en cómo crece el árbol: por hoja, partiendo la de mayor ganancia hasta 110 hojas, y no por niveles (XGBoost: profundidad 10). Aquí toma Σ b_e como desplazamiento fijo del logit y es monótono decreciente en c.</a:t>
+              <a:t>Misma suma de árboles, misma log-pérdida y mismo peso de hoja −G/(H + λ) (diapositiva 11). Difiere en cómo crece el árbol: por hoja, partiendo la de mayor ganancia hasta 154 hojas, y no por niveles (XGBoost: profundidad 10). Aquí toma Σ b_e como desplazamiento fijo del logit y es monótono decreciente en c.</a:t>
             </a:r>
           </a:p>
         </p:txBody>
@@ -17067,7 +17067,7 @@
                           </a:solidFill>
                           <a:latin typeface="Calibri"/>
                         </a:rPr>
-                        <a:t>K3, sin log-normal</a:t>
+                        <a:t>BOREAL sin log-normal</a:t>
                       </a:r>
                     </a:p>
                   </a:txBody>
@@ -17113,7 +17113,7 @@
                           </a:solidFill>
                           <a:latin typeface="Calibri"/>
                         </a:rPr>
-                        <a:t>0,858 [0,844; 0,869]</a:t>
+                        <a:t>0,857 [0,843; 0,868]</a:t>
                       </a:r>
                     </a:p>
                   </a:txBody>
@@ -17161,7 +17161,7 @@
                           </a:solidFill>
                           <a:latin typeface="Calibri"/>
                         </a:rPr>
-                        <a:t>0,856 [0,843; 0,868]</a:t>
+                        <a:t>0,858 [0,845; 0,868]</a:t>
                       </a:r>
                     </a:p>
                   </a:txBody>
@@ -17308,7 +17308,7 @@
                 </a:solidFill>
                 <a:latin typeface="Calibri"/>
               </a:rPr>
-              <a:t>Con las 136, la estructura suma 0,008 [0,003; 0,014].</a:t>
+              <a:t>Con las 136, la estructura suma 0,009 [0,003; 0,015].</a:t>
             </a:r>
           </a:p>
           <a:p>
@@ -17320,7 +17320,7 @@
                 </a:solidFill>
                 <a:latin typeface="Calibri"/>
               </a:rPr>
-              <a:t>El plazo real le da a XGBoost 0,010 [0,006; 0,014]; con él, la ventaja de la estructura baja a 0,002, sin significancia.</a:t>
+              <a:t>El plazo real le da a XGBoost 0,010 [0,006; 0,014]; con él, la ventaja de la estructura baja a 0,001, sin significancia.</a:t>
             </a:r>
           </a:p>
           <a:p>
@@ -17410,7 +17410,7 @@
                 </a:solidFill>
                 <a:latin typeface="Calibri"/>
               </a:rPr>
-              <a:t>Por qué el tablero sirve XGBoost:  </a:t>
+              <a:t>En el tablero:  </a:t>
             </a:r>
             <a:r>
               <a:rPr sz="1050" b="0">
@@ -17419,7 +17419,7 @@
                 </a:solidFill>
                 <a:latin typeface="Calibri"/>
               </a:rPr>
-              <a:t>la propuesta necesita la historia de entregas de cada entidad, que no se publica. Es la tercera mirada a 2026: exploratoria. En las órdenes con alguna entidad nueva no gana: el arranque en frío sigue abierto.</a:t>
+              <a:t>la pestaña Predicción lo sirve con posiciones reales de 2026, sin códigos de entidad. Es la cuarta mirada a 2026: exploratoria. En las órdenes con alguna entidad nueva no gana: el arranque en frío sigue abierto.</a:t>
             </a:r>
           </a:p>
         </p:txBody>
@@ -17498,7 +17498,7 @@
                 </a:solidFill>
                 <a:latin typeface="Calibri"/>
               </a:rPr>
-              <a:t>Fuente: libro, capítulo 9: resultados/prueba_2026/dos_por_dos.csv y contrastes.csv; tablero: Modelos → Modelo original</a:t>
+              <a:t>Fuente: libro, capítulo 11: resultados/prueba_2026/dos_por_dos.csv y contrastes.csv; tablero: Modelos → Modelo original</a:t>
             </a:r>
           </a:p>
         </p:txBody>
@@ -19110,7 +19110,7 @@
                           </a:solidFill>
                           <a:latin typeface="Calibri"/>
                         </a:rPr>
-                        <a:t>AUC K3</a:t>
+                        <a:t>AUC boosting mixto</a:t>
                       </a:r>
                     </a:p>
                   </a:txBody>
@@ -19227,7 +19227,7 @@
                           </a:solidFill>
                           <a:latin typeface="Calibri"/>
                         </a:rPr>
-                        <a:t>0,635</a:t>
+                        <a:t>0,637</a:t>
                       </a:r>
                     </a:p>
                   </a:txBody>
@@ -19250,7 +19250,7 @@
                           </a:solidFill>
                           <a:latin typeface="Calibri"/>
                         </a:rPr>
-                        <a:t>0,634</a:t>
+                        <a:t>0,633</a:t>
                       </a:r>
                     </a:p>
                   </a:txBody>
@@ -19273,7 +19273,7 @@
                           </a:solidFill>
                           <a:latin typeface="Calibri"/>
                         </a:rPr>
-                        <a:t>-0,002 [-0,006; 0,003]</a:t>
+                        <a:t>-0,004 [-0,009; 0,001]</a:t>
                       </a:r>
                     </a:p>
                   </a:txBody>
@@ -19296,7 +19296,7 @@
                           </a:solidFill>
                           <a:latin typeface="Calibri"/>
                         </a:rPr>
-                        <a:t>0,965</a:t>
+                        <a:t>0,217</a:t>
                       </a:r>
                     </a:p>
                   </a:txBody>
@@ -19367,7 +19367,7 @@
                           </a:solidFill>
                           <a:latin typeface="Calibri"/>
                         </a:rPr>
-                        <a:t>0,870</a:t>
+                        <a:t>0,867</a:t>
                       </a:r>
                     </a:p>
                   </a:txBody>
@@ -19390,7 +19390,7 @@
                           </a:solidFill>
                           <a:latin typeface="Calibri"/>
                         </a:rPr>
-                        <a:t>0,856</a:t>
+                        <a:t>0,859</a:t>
                       </a:r>
                     </a:p>
                   </a:txBody>
@@ -19413,7 +19413,7 @@
                           </a:solidFill>
                           <a:latin typeface="Calibri"/>
                         </a:rPr>
-                        <a:t>-0,013 [-0,022; -0,004]</a:t>
+                        <a:t>-0,008 [-0,017; 0,001]</a:t>
                       </a:r>
                     </a:p>
                   </a:txBody>
@@ -19436,7 +19436,7 @@
                           </a:solidFill>
                           <a:latin typeface="Calibri"/>
                         </a:rPr>
-                        <a:t>0,038</a:t>
+                        <a:t>0,217</a:t>
                       </a:r>
                     </a:p>
                   </a:txBody>
@@ -19459,7 +19459,7 @@
                           </a:solidFill>
                           <a:latin typeface="Calibri"/>
                         </a:rPr>
-                        <a:t>K3 pierde</a:t>
+                        <a:t>empate</a:t>
                       </a:r>
                     </a:p>
                   </a:txBody>
@@ -19553,7 +19553,7 @@
                           </a:solidFill>
                           <a:latin typeface="Calibri"/>
                         </a:rPr>
-                        <a:t>-0,008 [-0,014; -0,002]</a:t>
+                        <a:t>-0,007 [-0,013; -0,002]</a:t>
                       </a:r>
                     </a:p>
                   </a:txBody>
@@ -19576,287 +19576,7 @@
                           </a:solidFill>
                           <a:latin typeface="Calibri"/>
                         </a:rPr>
-                        <a:t>0,043</a:t>
-                      </a:r>
-                    </a:p>
-                  </a:txBody>
-                  <a:tcPr marL="57600" marR="57600" marT="14400" marB="14400" anchor="ctr">
-                    <a:solidFill>
-                      <a:srgbClr val="FFFFFF"/>
-                    </a:solidFill>
-                  </a:tcPr>
-                </a:tc>
-                <a:tc>
-                  <a:txBody>
-                    <a:bodyPr wrap="square"/>
-                    <a:lstStyle/>
-                    <a:p>
-                      <a:pPr algn="ctr"/>
-                      <a:r>
-                        <a:rPr sz="950" b="0">
-                          <a:solidFill>
-                            <a:srgbClr val="1A1A1A"/>
-                          </a:solidFill>
-                          <a:latin typeface="Calibri"/>
-                        </a:rPr>
-                        <a:t>K3 pierde</a:t>
-                      </a:r>
-                    </a:p>
-                  </a:txBody>
-                  <a:tcPr marL="57600" marR="57600" marT="14400" marB="14400" anchor="ctr">
-                    <a:solidFill>
-                      <a:srgbClr val="FFFFFF"/>
-                    </a:solidFill>
-                  </a:tcPr>
-                </a:tc>
-              </a:tr>
-              <a:tr h="324000">
-                <a:tc>
-                  <a:txBody>
-                    <a:bodyPr wrap="square"/>
-                    <a:lstStyle/>
-                    <a:p>
-                      <a:pPr algn="l"/>
-                      <a:r>
-                        <a:rPr sz="950" b="1">
-                          <a:solidFill>
-                            <a:srgbClr val="1A1A1A"/>
-                          </a:solidFill>
-                          <a:latin typeface="Calibri"/>
-                        </a:rPr>
-                        <a:t>Buses de Nueva York</a:t>
-                      </a:r>
-                    </a:p>
-                  </a:txBody>
-                  <a:tcPr marL="57600" marR="57600" marT="14400" marB="14400" anchor="ctr">
-                    <a:solidFill>
-                      <a:srgbClr val="EEF2EA"/>
-                    </a:solidFill>
-                  </a:tcPr>
-                </a:tc>
-                <a:tc>
-                  <a:txBody>
-                    <a:bodyPr wrap="square"/>
-                    <a:lstStyle/>
-                    <a:p>
-                      <a:pPr algn="ctr"/>
-                      <a:r>
-                        <a:rPr sz="950" b="0">
-                          <a:solidFill>
-                            <a:srgbClr val="1A1A1A"/>
-                          </a:solidFill>
-                          <a:latin typeface="Calibri"/>
-                        </a:rPr>
-                        <a:t>0,846</a:t>
-                      </a:r>
-                    </a:p>
-                  </a:txBody>
-                  <a:tcPr marL="57600" marR="57600" marT="14400" marB="14400" anchor="ctr">
-                    <a:solidFill>
-                      <a:srgbClr val="EEF2EA"/>
-                    </a:solidFill>
-                  </a:tcPr>
-                </a:tc>
-                <a:tc>
-                  <a:txBody>
-                    <a:bodyPr wrap="square"/>
-                    <a:lstStyle/>
-                    <a:p>
-                      <a:pPr algn="ctr"/>
-                      <a:r>
-                        <a:rPr sz="950" b="0">
-                          <a:solidFill>
-                            <a:srgbClr val="1A1A1A"/>
-                          </a:solidFill>
-                          <a:latin typeface="Calibri"/>
-                        </a:rPr>
-                        <a:t>0,844</a:t>
-                      </a:r>
-                    </a:p>
-                  </a:txBody>
-                  <a:tcPr marL="57600" marR="57600" marT="14400" marB="14400" anchor="ctr">
-                    <a:solidFill>
-                      <a:srgbClr val="EEF2EA"/>
-                    </a:solidFill>
-                  </a:tcPr>
-                </a:tc>
-                <a:tc>
-                  <a:txBody>
-                    <a:bodyPr wrap="square"/>
-                    <a:lstStyle/>
-                    <a:p>
-                      <a:pPr algn="ctr"/>
-                      <a:r>
-                        <a:rPr sz="950" b="0">
-                          <a:solidFill>
-                            <a:srgbClr val="1A1A1A"/>
-                          </a:solidFill>
-                          <a:latin typeface="Calibri"/>
-                        </a:rPr>
-                        <a:t>-0,002 [-0,004; 0,001]</a:t>
-                      </a:r>
-                    </a:p>
-                  </a:txBody>
-                  <a:tcPr marL="57600" marR="57600" marT="14400" marB="14400" anchor="ctr">
-                    <a:solidFill>
-                      <a:srgbClr val="EEF2EA"/>
-                    </a:solidFill>
-                  </a:tcPr>
-                </a:tc>
-                <a:tc>
-                  <a:txBody>
-                    <a:bodyPr wrap="square"/>
-                    <a:lstStyle/>
-                    <a:p>
-                      <a:pPr algn="ctr"/>
-                      <a:r>
-                        <a:rPr sz="950" b="0">
-                          <a:solidFill>
-                            <a:srgbClr val="1A1A1A"/>
-                          </a:solidFill>
-                          <a:latin typeface="Calibri"/>
-                        </a:rPr>
-                        <a:t>0,632</a:t>
-                      </a:r>
-                    </a:p>
-                  </a:txBody>
-                  <a:tcPr marL="57600" marR="57600" marT="14400" marB="14400" anchor="ctr">
-                    <a:solidFill>
-                      <a:srgbClr val="EEF2EA"/>
-                    </a:solidFill>
-                  </a:tcPr>
-                </a:tc>
-                <a:tc>
-                  <a:txBody>
-                    <a:bodyPr wrap="square"/>
-                    <a:lstStyle/>
-                    <a:p>
-                      <a:pPr algn="ctr"/>
-                      <a:r>
-                        <a:rPr sz="950" b="0">
-                          <a:solidFill>
-                            <a:srgbClr val="1A1A1A"/>
-                          </a:solidFill>
-                          <a:latin typeface="Calibri"/>
-                        </a:rPr>
-                        <a:t>empate</a:t>
-                      </a:r>
-                    </a:p>
-                  </a:txBody>
-                  <a:tcPr marL="57600" marR="57600" marT="14400" marB="14400" anchor="ctr">
-                    <a:solidFill>
-                      <a:srgbClr val="EEF2EA"/>
-                    </a:solidFill>
-                  </a:tcPr>
-                </a:tc>
-              </a:tr>
-              <a:tr h="324000">
-                <a:tc>
-                  <a:txBody>
-                    <a:bodyPr wrap="square"/>
-                    <a:lstStyle/>
-                    <a:p>
-                      <a:pPr algn="l"/>
-                      <a:r>
-                        <a:rPr sz="950" b="1">
-                          <a:solidFill>
-                            <a:srgbClr val="1A1A1A"/>
-                          </a:solidFill>
-                          <a:latin typeface="Calibri"/>
-                        </a:rPr>
-                        <a:t>Transporte de Zúrich</a:t>
-                      </a:r>
-                    </a:p>
-                  </a:txBody>
-                  <a:tcPr marL="57600" marR="57600" marT="14400" marB="14400" anchor="ctr">
-                    <a:solidFill>
-                      <a:srgbClr val="FFFFFF"/>
-                    </a:solidFill>
-                  </a:tcPr>
-                </a:tc>
-                <a:tc>
-                  <a:txBody>
-                    <a:bodyPr wrap="square"/>
-                    <a:lstStyle/>
-                    <a:p>
-                      <a:pPr algn="ctr"/>
-                      <a:r>
-                        <a:rPr sz="950" b="0">
-                          <a:solidFill>
-                            <a:srgbClr val="1A1A1A"/>
-                          </a:solidFill>
-                          <a:latin typeface="Calibri"/>
-                        </a:rPr>
-                        <a:t>0,832</a:t>
-                      </a:r>
-                    </a:p>
-                  </a:txBody>
-                  <a:tcPr marL="57600" marR="57600" marT="14400" marB="14400" anchor="ctr">
-                    <a:solidFill>
-                      <a:srgbClr val="FFFFFF"/>
-                    </a:solidFill>
-                  </a:tcPr>
-                </a:tc>
-                <a:tc>
-                  <a:txBody>
-                    <a:bodyPr wrap="square"/>
-                    <a:lstStyle/>
-                    <a:p>
-                      <a:pPr algn="ctr"/>
-                      <a:r>
-                        <a:rPr sz="950" b="0">
-                          <a:solidFill>
-                            <a:srgbClr val="1A1A1A"/>
-                          </a:solidFill>
-                          <a:latin typeface="Calibri"/>
-                        </a:rPr>
-                        <a:t>0,833</a:t>
-                      </a:r>
-                    </a:p>
-                  </a:txBody>
-                  <a:tcPr marL="57600" marR="57600" marT="14400" marB="14400" anchor="ctr">
-                    <a:solidFill>
-                      <a:srgbClr val="FFFFFF"/>
-                    </a:solidFill>
-                  </a:tcPr>
-                </a:tc>
-                <a:tc>
-                  <a:txBody>
-                    <a:bodyPr wrap="square"/>
-                    <a:lstStyle/>
-                    <a:p>
-                      <a:pPr algn="ctr"/>
-                      <a:r>
-                        <a:rPr sz="950" b="0">
-                          <a:solidFill>
-                            <a:srgbClr val="1A1A1A"/>
-                          </a:solidFill>
-                          <a:latin typeface="Calibri"/>
-                        </a:rPr>
-                        <a:t>0,001 [-0,008; 0,008]</a:t>
-                      </a:r>
-                    </a:p>
-                  </a:txBody>
-                  <a:tcPr marL="57600" marR="57600" marT="14400" marB="14400" anchor="ctr">
-                    <a:solidFill>
-                      <a:srgbClr val="FFFFFF"/>
-                    </a:solidFill>
-                  </a:tcPr>
-                </a:tc>
-                <a:tc>
-                  <a:txBody>
-                    <a:bodyPr wrap="square"/>
-                    <a:lstStyle/>
-                    <a:p>
-                      <a:pPr algn="ctr"/>
-                      <a:r>
-                        <a:rPr sz="950" b="0">
-                          <a:solidFill>
-                            <a:srgbClr val="1A1A1A"/>
-                          </a:solidFill>
-                          <a:latin typeface="Calibri"/>
-                        </a:rPr>
-                        <a:t>0,965</a:t>
+                        <a:t>0,057</a:t>
                       </a:r>
                     </a:p>
                   </a:txBody>
@@ -19950,7 +19670,7 @@
                           </a:solidFill>
                           <a:latin typeface="Calibri"/>
                         </a:rPr>
-                        <a:t>0,675</a:t>
+                        <a:t>0,676</a:t>
                       </a:r>
                     </a:p>
                   </a:txBody>
@@ -19973,7 +19693,7 @@
                           </a:solidFill>
                           <a:latin typeface="Calibri"/>
                         </a:rPr>
-                        <a:t>0,016 [0,008; 0,024]</a:t>
+                        <a:t>0,017 [0,009; 0,025]</a:t>
                       </a:r>
                     </a:p>
                   </a:txBody>
@@ -19996,7 +19716,7 @@
                           </a:solidFill>
                           <a:latin typeface="Calibri"/>
                         </a:rPr>
-                        <a:t>0,001</a:t>
+                        <a:t>&lt; 0,001</a:t>
                       </a:r>
                     </a:p>
                   </a:txBody>
@@ -20019,7 +19739,7 @@
                           </a:solidFill>
                           <a:latin typeface="Calibri"/>
                         </a:rPr>
-                        <a:t>K3 gana</a:t>
+                        <a:t>boosting mixto gana</a:t>
                       </a:r>
                     </a:p>
                   </a:txBody>
@@ -20067,7 +19787,7 @@
                           </a:solidFill>
                           <a:latin typeface="Calibri"/>
                         </a:rPr>
-                        <a:t>0,732</a:t>
+                        <a:t>0,730</a:t>
                       </a:r>
                     </a:p>
                   </a:txBody>
@@ -20090,7 +19810,7 @@
                           </a:solidFill>
                           <a:latin typeface="Calibri"/>
                         </a:rPr>
-                        <a:t>0,737</a:t>
+                        <a:t>0,735</a:t>
                       </a:r>
                     </a:p>
                   </a:txBody>
@@ -20113,7 +19833,7 @@
                           </a:solidFill>
                           <a:latin typeface="Calibri"/>
                         </a:rPr>
-                        <a:t>0,005 [0,003; 0,008]</a:t>
+                        <a:t>0,005 [0,002; 0,007]</a:t>
                       </a:r>
                     </a:p>
                   </a:txBody>
@@ -20136,7 +19856,7 @@
                           </a:solidFill>
                           <a:latin typeface="Calibri"/>
                         </a:rPr>
-                        <a:t>&lt; 0,001</a:t>
+                        <a:t>0,002</a:t>
                       </a:r>
                     </a:p>
                   </a:txBody>
@@ -20159,7 +19879,287 @@
                           </a:solidFill>
                           <a:latin typeface="Calibri"/>
                         </a:rPr>
-                        <a:t>K3 gana</a:t>
+                        <a:t>boosting mixto gana</a:t>
+                      </a:r>
+                    </a:p>
+                  </a:txBody>
+                  <a:tcPr marL="57600" marR="57600" marT="14400" marB="14400" anchor="ctr">
+                    <a:solidFill>
+                      <a:srgbClr val="FFFFFF"/>
+                    </a:solidFill>
+                  </a:tcPr>
+                </a:tc>
+              </a:tr>
+              <a:tr h="324000">
+                <a:tc>
+                  <a:txBody>
+                    <a:bodyPr wrap="square"/>
+                    <a:lstStyle/>
+                    <a:p>
+                      <a:pPr algn="l"/>
+                      <a:r>
+                        <a:rPr sz="950" b="1">
+                          <a:solidFill>
+                            <a:srgbClr val="1A1A1A"/>
+                          </a:solidFill>
+                          <a:latin typeface="Calibri"/>
+                        </a:rPr>
+                        <a:t>Buses de Nueva York</a:t>
+                      </a:r>
+                    </a:p>
+                  </a:txBody>
+                  <a:tcPr marL="57600" marR="57600" marT="14400" marB="14400" anchor="ctr">
+                    <a:solidFill>
+                      <a:srgbClr val="EEF2EA"/>
+                    </a:solidFill>
+                  </a:tcPr>
+                </a:tc>
+                <a:tc>
+                  <a:txBody>
+                    <a:bodyPr wrap="square"/>
+                    <a:lstStyle/>
+                    <a:p>
+                      <a:pPr algn="ctr"/>
+                      <a:r>
+                        <a:rPr sz="950" b="0">
+                          <a:solidFill>
+                            <a:srgbClr val="1A1A1A"/>
+                          </a:solidFill>
+                          <a:latin typeface="Calibri"/>
+                        </a:rPr>
+                        <a:t>0,844</a:t>
+                      </a:r>
+                    </a:p>
+                  </a:txBody>
+                  <a:tcPr marL="57600" marR="57600" marT="14400" marB="14400" anchor="ctr">
+                    <a:solidFill>
+                      <a:srgbClr val="EEF2EA"/>
+                    </a:solidFill>
+                  </a:tcPr>
+                </a:tc>
+                <a:tc>
+                  <a:txBody>
+                    <a:bodyPr wrap="square"/>
+                    <a:lstStyle/>
+                    <a:p>
+                      <a:pPr algn="ctr"/>
+                      <a:r>
+                        <a:rPr sz="950" b="0">
+                          <a:solidFill>
+                            <a:srgbClr val="1A1A1A"/>
+                          </a:solidFill>
+                          <a:latin typeface="Calibri"/>
+                        </a:rPr>
+                        <a:t>0,852</a:t>
+                      </a:r>
+                    </a:p>
+                  </a:txBody>
+                  <a:tcPr marL="57600" marR="57600" marT="14400" marB="14400" anchor="ctr">
+                    <a:solidFill>
+                      <a:srgbClr val="EEF2EA"/>
+                    </a:solidFill>
+                  </a:tcPr>
+                </a:tc>
+                <a:tc>
+                  <a:txBody>
+                    <a:bodyPr wrap="square"/>
+                    <a:lstStyle/>
+                    <a:p>
+                      <a:pPr algn="ctr"/>
+                      <a:r>
+                        <a:rPr sz="950" b="0">
+                          <a:solidFill>
+                            <a:srgbClr val="1A1A1A"/>
+                          </a:solidFill>
+                          <a:latin typeface="Calibri"/>
+                        </a:rPr>
+                        <a:t>0,008 [0,005; 0,010]</a:t>
+                      </a:r>
+                    </a:p>
+                  </a:txBody>
+                  <a:tcPr marL="57600" marR="57600" marT="14400" marB="14400" anchor="ctr">
+                    <a:solidFill>
+                      <a:srgbClr val="EEF2EA"/>
+                    </a:solidFill>
+                  </a:tcPr>
+                </a:tc>
+                <a:tc>
+                  <a:txBody>
+                    <a:bodyPr wrap="square"/>
+                    <a:lstStyle/>
+                    <a:p>
+                      <a:pPr algn="ctr"/>
+                      <a:r>
+                        <a:rPr sz="950" b="0">
+                          <a:solidFill>
+                            <a:srgbClr val="1A1A1A"/>
+                          </a:solidFill>
+                          <a:latin typeface="Calibri"/>
+                        </a:rPr>
+                        <a:t>&lt; 0,001</a:t>
+                      </a:r>
+                    </a:p>
+                  </a:txBody>
+                  <a:tcPr marL="57600" marR="57600" marT="14400" marB="14400" anchor="ctr">
+                    <a:solidFill>
+                      <a:srgbClr val="EEF2EA"/>
+                    </a:solidFill>
+                  </a:tcPr>
+                </a:tc>
+                <a:tc>
+                  <a:txBody>
+                    <a:bodyPr wrap="square"/>
+                    <a:lstStyle/>
+                    <a:p>
+                      <a:pPr algn="ctr"/>
+                      <a:r>
+                        <a:rPr sz="950" b="0">
+                          <a:solidFill>
+                            <a:srgbClr val="1A1A1A"/>
+                          </a:solidFill>
+                          <a:latin typeface="Calibri"/>
+                        </a:rPr>
+                        <a:t>boosting mixto gana</a:t>
+                      </a:r>
+                    </a:p>
+                  </a:txBody>
+                  <a:tcPr marL="57600" marR="57600" marT="14400" marB="14400" anchor="ctr">
+                    <a:solidFill>
+                      <a:srgbClr val="EEF2EA"/>
+                    </a:solidFill>
+                  </a:tcPr>
+                </a:tc>
+              </a:tr>
+              <a:tr h="324000">
+                <a:tc>
+                  <a:txBody>
+                    <a:bodyPr wrap="square"/>
+                    <a:lstStyle/>
+                    <a:p>
+                      <a:pPr algn="l"/>
+                      <a:r>
+                        <a:rPr sz="950" b="1">
+                          <a:solidFill>
+                            <a:srgbClr val="1A1A1A"/>
+                          </a:solidFill>
+                          <a:latin typeface="Calibri"/>
+                        </a:rPr>
+                        <a:t>Transporte de Zúrich</a:t>
+                      </a:r>
+                    </a:p>
+                  </a:txBody>
+                  <a:tcPr marL="57600" marR="57600" marT="14400" marB="14400" anchor="ctr">
+                    <a:solidFill>
+                      <a:srgbClr val="FFFFFF"/>
+                    </a:solidFill>
+                  </a:tcPr>
+                </a:tc>
+                <a:tc>
+                  <a:txBody>
+                    <a:bodyPr wrap="square"/>
+                    <a:lstStyle/>
+                    <a:p>
+                      <a:pPr algn="ctr"/>
+                      <a:r>
+                        <a:rPr sz="950" b="0">
+                          <a:solidFill>
+                            <a:srgbClr val="1A1A1A"/>
+                          </a:solidFill>
+                          <a:latin typeface="Calibri"/>
+                        </a:rPr>
+                        <a:t>0,830</a:t>
+                      </a:r>
+                    </a:p>
+                  </a:txBody>
+                  <a:tcPr marL="57600" marR="57600" marT="14400" marB="14400" anchor="ctr">
+                    <a:solidFill>
+                      <a:srgbClr val="FFFFFF"/>
+                    </a:solidFill>
+                  </a:tcPr>
+                </a:tc>
+                <a:tc>
+                  <a:txBody>
+                    <a:bodyPr wrap="square"/>
+                    <a:lstStyle/>
+                    <a:p>
+                      <a:pPr algn="ctr"/>
+                      <a:r>
+                        <a:rPr sz="950" b="0">
+                          <a:solidFill>
+                            <a:srgbClr val="1A1A1A"/>
+                          </a:solidFill>
+                          <a:latin typeface="Calibri"/>
+                        </a:rPr>
+                        <a:t>0,836</a:t>
+                      </a:r>
+                    </a:p>
+                  </a:txBody>
+                  <a:tcPr marL="57600" marR="57600" marT="14400" marB="14400" anchor="ctr">
+                    <a:solidFill>
+                      <a:srgbClr val="FFFFFF"/>
+                    </a:solidFill>
+                  </a:tcPr>
+                </a:tc>
+                <a:tc>
+                  <a:txBody>
+                    <a:bodyPr wrap="square"/>
+                    <a:lstStyle/>
+                    <a:p>
+                      <a:pPr algn="ctr"/>
+                      <a:r>
+                        <a:rPr sz="950" b="0">
+                          <a:solidFill>
+                            <a:srgbClr val="1A1A1A"/>
+                          </a:solidFill>
+                          <a:latin typeface="Calibri"/>
+                        </a:rPr>
+                        <a:t>0,006 [-0,004; 0,018]</a:t>
+                      </a:r>
+                    </a:p>
+                  </a:txBody>
+                  <a:tcPr marL="57600" marR="57600" marT="14400" marB="14400" anchor="ctr">
+                    <a:solidFill>
+                      <a:srgbClr val="FFFFFF"/>
+                    </a:solidFill>
+                  </a:tcPr>
+                </a:tc>
+                <a:tc>
+                  <a:txBody>
+                    <a:bodyPr wrap="square"/>
+                    <a:lstStyle/>
+                    <a:p>
+                      <a:pPr algn="ctr"/>
+                      <a:r>
+                        <a:rPr sz="950" b="0">
+                          <a:solidFill>
+                            <a:srgbClr val="1A1A1A"/>
+                          </a:solidFill>
+                          <a:latin typeface="Calibri"/>
+                        </a:rPr>
+                        <a:t>0,217</a:t>
+                      </a:r>
+                    </a:p>
+                  </a:txBody>
+                  <a:tcPr marL="57600" marR="57600" marT="14400" marB="14400" anchor="ctr">
+                    <a:solidFill>
+                      <a:srgbClr val="FFFFFF"/>
+                    </a:solidFill>
+                  </a:tcPr>
+                </a:tc>
+                <a:tc>
+                  <a:txBody>
+                    <a:bodyPr wrap="square"/>
+                    <a:lstStyle/>
+                    <a:p>
+                      <a:pPr algn="ctr"/>
+                      <a:r>
+                        <a:rPr sz="950" b="0">
+                          <a:solidFill>
+                            <a:srgbClr val="1A1A1A"/>
+                          </a:solidFill>
+                          <a:latin typeface="Calibri"/>
+                        </a:rPr>
+                        <a:t>empate</a:t>
                       </a:r>
                     </a:p>
                   </a:txBody>
@@ -20318,7 +20318,7 @@
                 </a:solidFill>
                 <a:latin typeface="Calibri"/>
               </a:rPr>
-              <a:t>Gana 2, empata 3, pierde 2; Wilcoxon p = 0,81: no hay superioridad general.</a:t>
+              <a:t>Gana 3, empata 4, pierde 0; Wilcoxon p = 0,69: no hay superioridad general.</a:t>
             </a:r>
           </a:p>
           <a:p>
@@ -20330,7 +20330,7 @@
                 </a:solidFill>
                 <a:latin typeface="Calibri"/>
               </a:rPr>
-              <a:t>Gana donde la entidad vuelve (el paciente), como el proveedor en OTIF.</a:t>
+              <a:t>Gana donde la entidad vuelve (el paciente, el bus), como el proveedor en OTIF.</a:t>
             </a:r>
           </a:p>
           <a:p>
@@ -20342,7 +20342,7 @@
                 </a:solidFill>
                 <a:latin typeface="Calibri"/>
               </a:rPr>
-              <a:t>Empata en transporte; pierde sin tiempo ni desenlace continuo.</a:t>
+              <a:t>Empata con entidades pocas y estables, o sin tiempo ni desenlace continuo.</a:t>
             </a:r>
           </a:p>
         </p:txBody>
@@ -20429,7 +20429,7 @@
                 </a:solidFill>
                 <a:latin typeface="Calibri"/>
               </a:rPr>
-              <a:t>esa separación se vio después de la segunda ronda; confirmarla pide una tercera fijada antes de correr.</a:t>
+              <a:t>la segunda ronda se eligió por parecerse a OTIF: dice dónde sirve, no que sea mejor en general.</a:t>
             </a:r>
           </a:p>
         </p:txBody>
@@ -20508,7 +20508,7 @@
                 </a:solidFill>
                 <a:latin typeface="Calibri"/>
               </a:rPr>
-              <a:t>Fuente: libro, capítulo 10: original/publicos_otif_resumen.csv (OpenML); tablero: Modelos → Modelo original</a:t>
+              <a:t>Fuente: libro, capítulo 12: original/publicos_otif_resumen.csv (OpenML); tablero: Modelos → Modelo original</a:t>
             </a:r>
           </a:p>
         </p:txBody>
@@ -21442,7 +21442,7 @@
                           </a:solidFill>
                           <a:latin typeface="Calibri"/>
                         </a:rPr>
-                        <a:t>sí, XGBoost</a:t>
+                        <a:t>sí, el original (y XGBoost)</a:t>
                       </a:r>
                     </a:p>
                   </a:txBody>
@@ -21490,7 +21490,7 @@
                           </a:solidFill>
                           <a:latin typeface="Calibri"/>
                         </a:rPr>
-                        <a:t>+0,012 de AUC [0,004; 0,018]</a:t>
+                        <a:t>+0,011 de AUC [0,003; 0,017]</a:t>
                       </a:r>
                     </a:p>
                   </a:txBody>

</xml_diff>